<commit_message>
Tighten deck: fix transactions overflow; add heritage timeline, probability-decay curve, sum-of-parts visual
</commit_message>
<xml_diff>
--- a/Athanase_Engaged_Ownership_Allocator_Deck.pptx
+++ b/Athanase_Engaged_Ownership_Allocator_Deck.pptx
@@ -134,6 +134,198 @@
 </file>
 
 <file path=ppt/charts/chart1.xml><?xml version="1.0" encoding="utf-8"?>
+<c:chartSpace xmlns:c="http://schemas.openxmlformats.org/drawingml/2006/chart" xmlns:a="http://schemas.openxmlformats.org/drawingml/2006/main" xmlns:r="http://schemas.openxmlformats.org/officeDocument/2006/relationships">
+  <c:date1904 val="0"/>
+  <c:chart>
+    <c:title>
+      <c:tx>
+        <c:rich>
+          <a:bodyPr/>
+          <a:lstStyle/>
+          <a:p>
+            <a:r>
+              <a:rPr sz="1100">
+                <a:solidFill>
+                  <a:srgbClr val="5A636E"/>
+                </a:solidFill>
+              </a:rPr>
+              <a:t>“Probability decay”: strategy efficiency over a CEO cycle (%)</a:t>
+            </a:r>
+          </a:p>
+        </c:rich>
+      </c:tx>
+      <c:layout/>
+      <c:overlay val="0"/>
+    </c:title>
+    <c:autoTitleDeleted val="0"/>
+    <c:plotArea>
+      <c:lineChart>
+        <c:grouping val="standard"/>
+        <c:varyColors val="0"/>
+        <c:ser>
+          <c:idx val="0"/>
+          <c:order val="0"/>
+          <c:tx>
+            <c:strRef>
+              <c:f>Sheet1!$B$1</c:f>
+              <c:strCache>
+                <c:ptCount val="1"/>
+                <c:pt idx="0">
+                  <c:v>Strategy efficiency</c:v>
+                </c:pt>
+              </c:strCache>
+            </c:strRef>
+          </c:tx>
+          <c:spPr>
+            <a:ln w="31750">
+              <a:solidFill>
+                <a:srgbClr val="14253B"/>
+              </a:solidFill>
+            </a:ln>
+          </c:spPr>
+          <c:cat>
+            <c:strRef>
+              <c:f>Sheet1!$A$2:$A$9</c:f>
+              <c:strCache>
+                <c:ptCount val="8"/>
+                <c:pt idx="0">
+                  <c:v>Yr 1</c:v>
+                </c:pt>
+                <c:pt idx="1">
+                  <c:v>Yr 2</c:v>
+                </c:pt>
+                <c:pt idx="2">
+                  <c:v>Yr 3</c:v>
+                </c:pt>
+                <c:pt idx="3">
+                  <c:v>Yr 4</c:v>
+                </c:pt>
+                <c:pt idx="4">
+                  <c:v>Yr 5</c:v>
+                </c:pt>
+                <c:pt idx="5">
+                  <c:v>Yr 6</c:v>
+                </c:pt>
+                <c:pt idx="6">
+                  <c:v>Yr 7</c:v>
+                </c:pt>
+                <c:pt idx="7">
+                  <c:v>Yr 8</c:v>
+                </c:pt>
+              </c:strCache>
+            </c:strRef>
+          </c:cat>
+          <c:val>
+            <c:numRef>
+              <c:f>Sheet1!$B$2:$B$9</c:f>
+              <c:numCache>
+                <c:formatCode>General</c:formatCode>
+                <c:ptCount val="8"/>
+                <c:pt idx="0">
+                  <c:v>80</c:v>
+                </c:pt>
+                <c:pt idx="1">
+                  <c:v>76</c:v>
+                </c:pt>
+                <c:pt idx="2">
+                  <c:v>71</c:v>
+                </c:pt>
+                <c:pt idx="3">
+                  <c:v>65</c:v>
+                </c:pt>
+                <c:pt idx="4">
+                  <c:v>60</c:v>
+                </c:pt>
+                <c:pt idx="5">
+                  <c:v>55</c:v>
+                </c:pt>
+                <c:pt idx="6">
+                  <c:v>52</c:v>
+                </c:pt>
+                <c:pt idx="7">
+                  <c:v>50</c:v>
+                </c:pt>
+              </c:numCache>
+            </c:numRef>
+          </c:val>
+          <c:smooth/>
+        </c:ser>
+        <c:marker val="1"/>
+        <c:smooth val="0"/>
+        <c:axId val="2118791784"/>
+        <c:axId val="2140495176"/>
+      </c:lineChart>
+      <c:catAx>
+        <c:axId val="2118791784"/>
+        <c:scaling>
+          <c:orientation val="minMax"/>
+        </c:scaling>
+        <c:delete val="0"/>
+        <c:axPos val="b"/>
+        <c:majorTickMark val="out"/>
+        <c:minorTickMark val="none"/>
+        <c:tickLblPos val="nextTo"/>
+        <c:txPr>
+          <a:bodyPr/>
+          <a:lstStyle/>
+          <a:p>
+            <a:pPr>
+              <a:defRPr sz="900"/>
+            </a:pPr>
+          </a:p>
+        </c:txPr>
+        <c:crossAx val="2140495176"/>
+        <c:crosses val="autoZero"/>
+        <c:auto val="1"/>
+        <c:lblAlgn val="ctr"/>
+        <c:lblOffset val="100"/>
+        <c:noMultiLvlLbl val="0"/>
+      </c:catAx>
+      <c:valAx>
+        <c:axId val="2140495176"/>
+        <c:scaling>
+          <c:max val="100.0"/>
+          <c:min val="0.0"/>
+        </c:scaling>
+        <c:delete val="0"/>
+        <c:axPos val="l"/>
+        <c:majorTickMark val="out"/>
+        <c:minorTickMark val="none"/>
+        <c:tickLblPos val="nextTo"/>
+        <c:txPr>
+          <a:bodyPr/>
+          <a:lstStyle/>
+          <a:p>
+            <a:pPr>
+              <a:defRPr sz="900"/>
+            </a:pPr>
+          </a:p>
+        </c:txPr>
+        <c:crossAx val="2118791784"/>
+        <c:crosses val="autoZero"/>
+      </c:valAx>
+    </c:plotArea>
+    <c:plotVisOnly val="1"/>
+    <c:dispBlanksAs val="gap"/>
+    <c:showDLblsOverMax val="0"/>
+  </c:chart>
+  <c:txPr>
+    <a:bodyPr/>
+    <a:lstStyle/>
+    <a:p>
+      <a:pPr>
+        <a:defRPr sz="1800"/>
+      </a:pPr>
+      <a:endParaRPr lang="en-US"/>
+    </a:p>
+  </c:txPr>
+  <c:externalData r:id="rId1">
+    <c:autoUpdate val="0"/>
+  </c:externalData>
+</c:chartSpace>
+</file>
+
+<file path=ppt/charts/chart2.xml><?xml version="1.0" encoding="utf-8"?>
 <c:chartSpace xmlns:c="http://schemas.openxmlformats.org/drawingml/2006/chart" xmlns:a="http://schemas.openxmlformats.org/drawingml/2006/main" xmlns:r="http://schemas.openxmlformats.org/officeDocument/2006/relationships">
   <c:date1904 val="0"/>
   <c:chart>
@@ -491,7 +683,7 @@
 </c:chartSpace>
 </file>
 
-<file path=ppt/charts/chart2.xml><?xml version="1.0" encoding="utf-8"?>
+<file path=ppt/charts/chart3.xml><?xml version="1.0" encoding="utf-8"?>
 <c:chartSpace xmlns:c="http://schemas.openxmlformats.org/drawingml/2006/chart" xmlns:a="http://schemas.openxmlformats.org/drawingml/2006/main" xmlns:r="http://schemas.openxmlformats.org/officeDocument/2006/relationships">
   <c:date1904 val="0"/>
   <c:chart>
@@ -5145,14 +5337,58 @@
       </p:sp>
       <p:sp>
         <p:nvSpPr>
-          <p:cNvPr id="9" name="TextBox 8"/>
-          <p:cNvSpPr txBox="1"/>
-          <p:nvPr/>
-        </p:nvSpPr>
-        <p:spPr>
-          <a:xfrm>
-            <a:off x="685800" y="2148840"/>
-            <a:ext cx="10789920" cy="548640"/>
+          <p:cNvPr id="9" name="Rectangle 8"/>
+          <p:cNvSpPr/>
+          <p:nvPr/>
+        </p:nvSpPr>
+        <p:spPr>
+          <a:xfrm>
+            <a:off x="1463040" y="2532888"/>
+            <a:ext cx="9052560" cy="20320"/>
+          </a:xfrm>
+          <a:prstGeom prst="rect">
+            <a:avLst/>
+          </a:prstGeom>
+          <a:solidFill>
+            <a:srgbClr val="8A99AB"/>
+          </a:solidFill>
+          <a:ln>
+            <a:noFill/>
+          </a:ln>
+          <a:effectLst/>
+        </p:spPr>
+        <p:style>
+          <a:lnRef idx="1">
+            <a:schemeClr val="accent1"/>
+          </a:lnRef>
+          <a:fillRef idx="3">
+            <a:schemeClr val="accent1"/>
+          </a:fillRef>
+          <a:effectRef idx="2">
+            <a:schemeClr val="accent1"/>
+          </a:effectRef>
+          <a:fontRef idx="minor">
+            <a:schemeClr val="lt1"/>
+          </a:fontRef>
+        </p:style>
+        <p:txBody>
+          <a:bodyPr rtlCol="0" anchor="ctr"/>
+          <a:lstStyle/>
+          <a:p>
+            <a:pPr algn="ctr"/>
+          </a:p>
+        </p:txBody>
+      </p:sp>
+      <p:sp>
+        <p:nvSpPr>
+          <p:cNvPr id="10" name="TextBox 9"/>
+          <p:cNvSpPr txBox="1"/>
+          <p:nvPr/>
+        </p:nvSpPr>
+        <p:spPr>
+          <a:xfrm>
+            <a:off x="548640" y="2148840"/>
+            <a:ext cx="1828800" cy="320040"/>
           </a:xfrm>
           <a:prstGeom prst="rect">
             <a:avLst/>
@@ -5165,7 +5401,7 @@
           </a:bodyPr>
           <a:lstStyle/>
           <a:p>
-            <a:pPr algn="l">
+            <a:pPr algn="ctr">
               <a:lnSpc>
                 <a:spcPct val="110000"/>
               </a:lnSpc>
@@ -5174,26 +5410,504 @@
               </a:spcAft>
             </a:pPr>
             <a:r>
-              <a:rPr sz="1400" b="1" i="0">
+              <a:rPr sz="1500" b="1" i="0">
+                <a:solidFill>
+                  <a:srgbClr val="1E334E"/>
+                </a:solidFill>
+                <a:latin typeface="Times New Roman"/>
+              </a:rPr>
+              <a:t>1992</a:t>
+            </a:r>
+          </a:p>
+        </p:txBody>
+      </p:sp>
+      <p:sp>
+        <p:nvSpPr>
+          <p:cNvPr id="11" name="Oval 10"/>
+          <p:cNvSpPr/>
+          <p:nvPr/>
+        </p:nvSpPr>
+        <p:spPr>
+          <a:xfrm>
+            <a:off x="1380744" y="2468880"/>
+            <a:ext cx="164592" cy="164592"/>
+          </a:xfrm>
+          <a:prstGeom prst="ellipse">
+            <a:avLst/>
+          </a:prstGeom>
+          <a:solidFill>
+            <a:srgbClr val="14253B"/>
+          </a:solidFill>
+          <a:ln w="19050">
+            <a:solidFill>
+              <a:srgbClr val="FFFFFF"/>
+            </a:solidFill>
+          </a:ln>
+          <a:effectLst/>
+        </p:spPr>
+        <p:style>
+          <a:lnRef idx="1">
+            <a:schemeClr val="accent1"/>
+          </a:lnRef>
+          <a:fillRef idx="3">
+            <a:schemeClr val="accent1"/>
+          </a:fillRef>
+          <a:effectRef idx="2">
+            <a:schemeClr val="accent1"/>
+          </a:effectRef>
+          <a:fontRef idx="minor">
+            <a:schemeClr val="lt1"/>
+          </a:fontRef>
+        </p:style>
+        <p:txBody>
+          <a:bodyPr rtlCol="0" anchor="ctr"/>
+          <a:lstStyle/>
+          <a:p>
+            <a:pPr algn="ctr"/>
+          </a:p>
+        </p:txBody>
+      </p:sp>
+      <p:sp>
+        <p:nvSpPr>
+          <p:cNvPr id="12" name="TextBox 11"/>
+          <p:cNvSpPr txBox="1"/>
+          <p:nvPr/>
+        </p:nvSpPr>
+        <p:spPr>
+          <a:xfrm>
+            <a:off x="457200" y="2679192"/>
+            <a:ext cx="2011680" cy="274320"/>
+          </a:xfrm>
+          <a:prstGeom prst="rect">
+            <a:avLst/>
+          </a:prstGeom>
+          <a:noFill/>
+        </p:spPr>
+        <p:txBody>
+          <a:bodyPr wrap="square" anchor="t" lIns="0" rIns="0" tIns="0" bIns="0">
+            <a:spAutoFit/>
+          </a:bodyPr>
+          <a:lstStyle/>
+          <a:p>
+            <a:pPr algn="ctr">
+              <a:lnSpc>
+                <a:spcPct val="110000"/>
+              </a:lnSpc>
+              <a:spcAft>
+                <a:spcPts val="0"/>
+              </a:spcAft>
+            </a:pPr>
+            <a:r>
+              <a:rPr sz="1200" b="0" i="0">
                 <a:solidFill>
                   <a:srgbClr val="4A5D75"/>
                 </a:solidFill>
+                <a:latin typeface="Calibri"/>
+              </a:rPr>
+              <a:t>Öresund</a:t>
+            </a:r>
+          </a:p>
+        </p:txBody>
+      </p:sp>
+      <p:sp>
+        <p:nvSpPr>
+          <p:cNvPr id="13" name="TextBox 12"/>
+          <p:cNvSpPr txBox="1"/>
+          <p:nvPr/>
+        </p:nvSpPr>
+        <p:spPr>
+          <a:xfrm>
+            <a:off x="3566160" y="2148840"/>
+            <a:ext cx="1828800" cy="320040"/>
+          </a:xfrm>
+          <a:prstGeom prst="rect">
+            <a:avLst/>
+          </a:prstGeom>
+          <a:noFill/>
+        </p:spPr>
+        <p:txBody>
+          <a:bodyPr wrap="square" anchor="t" lIns="0" rIns="0" tIns="0" bIns="0">
+            <a:spAutoFit/>
+          </a:bodyPr>
+          <a:lstStyle/>
+          <a:p>
+            <a:pPr algn="ctr">
+              <a:lnSpc>
+                <a:spcPct val="110000"/>
+              </a:lnSpc>
+              <a:spcAft>
+                <a:spcPts val="0"/>
+              </a:spcAft>
+            </a:pPr>
+            <a:r>
+              <a:rPr sz="1500" b="1" i="0">
+                <a:solidFill>
+                  <a:srgbClr val="1E334E"/>
+                </a:solidFill>
                 <a:latin typeface="Times New Roman"/>
               </a:rPr>
-              <a:t>Heritage:  Öresund (1992)  →  Custos (1996)  →  Creades  →  Athanase Industrial Partner (2015)</a:t>
-            </a:r>
-          </a:p>
-        </p:txBody>
-      </p:sp>
-      <p:sp>
-        <p:nvSpPr>
-          <p:cNvPr id="10" name="TextBox 9"/>
-          <p:cNvSpPr txBox="1"/>
-          <p:nvPr/>
-        </p:nvSpPr>
-        <p:spPr>
-          <a:xfrm>
-            <a:off x="685800" y="2788920"/>
+              <a:t>1996</a:t>
+            </a:r>
+          </a:p>
+        </p:txBody>
+      </p:sp>
+      <p:sp>
+        <p:nvSpPr>
+          <p:cNvPr id="14" name="Oval 13"/>
+          <p:cNvSpPr/>
+          <p:nvPr/>
+        </p:nvSpPr>
+        <p:spPr>
+          <a:xfrm>
+            <a:off x="4398264" y="2468880"/>
+            <a:ext cx="164592" cy="164592"/>
+          </a:xfrm>
+          <a:prstGeom prst="ellipse">
+            <a:avLst/>
+          </a:prstGeom>
+          <a:solidFill>
+            <a:srgbClr val="14253B"/>
+          </a:solidFill>
+          <a:ln w="19050">
+            <a:solidFill>
+              <a:srgbClr val="FFFFFF"/>
+            </a:solidFill>
+          </a:ln>
+          <a:effectLst/>
+        </p:spPr>
+        <p:style>
+          <a:lnRef idx="1">
+            <a:schemeClr val="accent1"/>
+          </a:lnRef>
+          <a:fillRef idx="3">
+            <a:schemeClr val="accent1"/>
+          </a:fillRef>
+          <a:effectRef idx="2">
+            <a:schemeClr val="accent1"/>
+          </a:effectRef>
+          <a:fontRef idx="minor">
+            <a:schemeClr val="lt1"/>
+          </a:fontRef>
+        </p:style>
+        <p:txBody>
+          <a:bodyPr rtlCol="0" anchor="ctr"/>
+          <a:lstStyle/>
+          <a:p>
+            <a:pPr algn="ctr"/>
+          </a:p>
+        </p:txBody>
+      </p:sp>
+      <p:sp>
+        <p:nvSpPr>
+          <p:cNvPr id="15" name="TextBox 14"/>
+          <p:cNvSpPr txBox="1"/>
+          <p:nvPr/>
+        </p:nvSpPr>
+        <p:spPr>
+          <a:xfrm>
+            <a:off x="3474720" y="2679192"/>
+            <a:ext cx="2011680" cy="274320"/>
+          </a:xfrm>
+          <a:prstGeom prst="rect">
+            <a:avLst/>
+          </a:prstGeom>
+          <a:noFill/>
+        </p:spPr>
+        <p:txBody>
+          <a:bodyPr wrap="square" anchor="t" lIns="0" rIns="0" tIns="0" bIns="0">
+            <a:spAutoFit/>
+          </a:bodyPr>
+          <a:lstStyle/>
+          <a:p>
+            <a:pPr algn="ctr">
+              <a:lnSpc>
+                <a:spcPct val="110000"/>
+              </a:lnSpc>
+              <a:spcAft>
+                <a:spcPts val="0"/>
+              </a:spcAft>
+            </a:pPr>
+            <a:r>
+              <a:rPr sz="1200" b="0" i="0">
+                <a:solidFill>
+                  <a:srgbClr val="4A5D75"/>
+                </a:solidFill>
+                <a:latin typeface="Calibri"/>
+              </a:rPr>
+              <a:t>Custos</a:t>
+            </a:r>
+          </a:p>
+        </p:txBody>
+      </p:sp>
+      <p:sp>
+        <p:nvSpPr>
+          <p:cNvPr id="16" name="TextBox 15"/>
+          <p:cNvSpPr txBox="1"/>
+          <p:nvPr/>
+        </p:nvSpPr>
+        <p:spPr>
+          <a:xfrm>
+            <a:off x="6583680" y="2148840"/>
+            <a:ext cx="1828800" cy="320040"/>
+          </a:xfrm>
+          <a:prstGeom prst="rect">
+            <a:avLst/>
+          </a:prstGeom>
+          <a:noFill/>
+        </p:spPr>
+        <p:txBody>
+          <a:bodyPr wrap="square" anchor="t" lIns="0" rIns="0" tIns="0" bIns="0">
+            <a:spAutoFit/>
+          </a:bodyPr>
+          <a:lstStyle/>
+          <a:p>
+            <a:pPr algn="ctr">
+              <a:lnSpc>
+                <a:spcPct val="110000"/>
+              </a:lnSpc>
+              <a:spcAft>
+                <a:spcPts val="0"/>
+              </a:spcAft>
+            </a:pPr>
+            <a:r>
+              <a:rPr sz="1500" b="1" i="0">
+                <a:solidFill>
+                  <a:srgbClr val="1E334E"/>
+                </a:solidFill>
+                <a:latin typeface="Times New Roman"/>
+              </a:rPr>
+              <a:t>2006</a:t>
+            </a:r>
+          </a:p>
+        </p:txBody>
+      </p:sp>
+      <p:sp>
+        <p:nvSpPr>
+          <p:cNvPr id="17" name="Oval 16"/>
+          <p:cNvSpPr/>
+          <p:nvPr/>
+        </p:nvSpPr>
+        <p:spPr>
+          <a:xfrm>
+            <a:off x="7415784" y="2468880"/>
+            <a:ext cx="164592" cy="164592"/>
+          </a:xfrm>
+          <a:prstGeom prst="ellipse">
+            <a:avLst/>
+          </a:prstGeom>
+          <a:solidFill>
+            <a:srgbClr val="14253B"/>
+          </a:solidFill>
+          <a:ln w="19050">
+            <a:solidFill>
+              <a:srgbClr val="FFFFFF"/>
+            </a:solidFill>
+          </a:ln>
+          <a:effectLst/>
+        </p:spPr>
+        <p:style>
+          <a:lnRef idx="1">
+            <a:schemeClr val="accent1"/>
+          </a:lnRef>
+          <a:fillRef idx="3">
+            <a:schemeClr val="accent1"/>
+          </a:fillRef>
+          <a:effectRef idx="2">
+            <a:schemeClr val="accent1"/>
+          </a:effectRef>
+          <a:fontRef idx="minor">
+            <a:schemeClr val="lt1"/>
+          </a:fontRef>
+        </p:style>
+        <p:txBody>
+          <a:bodyPr rtlCol="0" anchor="ctr"/>
+          <a:lstStyle/>
+          <a:p>
+            <a:pPr algn="ctr"/>
+          </a:p>
+        </p:txBody>
+      </p:sp>
+      <p:sp>
+        <p:nvSpPr>
+          <p:cNvPr id="18" name="TextBox 17"/>
+          <p:cNvSpPr txBox="1"/>
+          <p:nvPr/>
+        </p:nvSpPr>
+        <p:spPr>
+          <a:xfrm>
+            <a:off x="6492240" y="2679192"/>
+            <a:ext cx="2011680" cy="274320"/>
+          </a:xfrm>
+          <a:prstGeom prst="rect">
+            <a:avLst/>
+          </a:prstGeom>
+          <a:noFill/>
+        </p:spPr>
+        <p:txBody>
+          <a:bodyPr wrap="square" anchor="t" lIns="0" rIns="0" tIns="0" bIns="0">
+            <a:spAutoFit/>
+          </a:bodyPr>
+          <a:lstStyle/>
+          <a:p>
+            <a:pPr algn="ctr">
+              <a:lnSpc>
+                <a:spcPct val="110000"/>
+              </a:lnSpc>
+              <a:spcAft>
+                <a:spcPts val="0"/>
+              </a:spcAft>
+            </a:pPr>
+            <a:r>
+              <a:rPr sz="1200" b="0" i="0">
+                <a:solidFill>
+                  <a:srgbClr val="4A5D75"/>
+                </a:solidFill>
+                <a:latin typeface="Calibri"/>
+              </a:rPr>
+              <a:t>Creades</a:t>
+            </a:r>
+          </a:p>
+        </p:txBody>
+      </p:sp>
+      <p:sp>
+        <p:nvSpPr>
+          <p:cNvPr id="19" name="TextBox 18"/>
+          <p:cNvSpPr txBox="1"/>
+          <p:nvPr/>
+        </p:nvSpPr>
+        <p:spPr>
+          <a:xfrm>
+            <a:off x="9601200" y="2148840"/>
+            <a:ext cx="1828800" cy="320040"/>
+          </a:xfrm>
+          <a:prstGeom prst="rect">
+            <a:avLst/>
+          </a:prstGeom>
+          <a:noFill/>
+        </p:spPr>
+        <p:txBody>
+          <a:bodyPr wrap="square" anchor="t" lIns="0" rIns="0" tIns="0" bIns="0">
+            <a:spAutoFit/>
+          </a:bodyPr>
+          <a:lstStyle/>
+          <a:p>
+            <a:pPr algn="ctr">
+              <a:lnSpc>
+                <a:spcPct val="110000"/>
+              </a:lnSpc>
+              <a:spcAft>
+                <a:spcPts val="0"/>
+              </a:spcAft>
+            </a:pPr>
+            <a:r>
+              <a:rPr sz="1500" b="1" i="0">
+                <a:solidFill>
+                  <a:srgbClr val="1E334E"/>
+                </a:solidFill>
+                <a:latin typeface="Times New Roman"/>
+              </a:rPr>
+              <a:t>2015</a:t>
+            </a:r>
+          </a:p>
+        </p:txBody>
+      </p:sp>
+      <p:sp>
+        <p:nvSpPr>
+          <p:cNvPr id="20" name="Oval 19"/>
+          <p:cNvSpPr/>
+          <p:nvPr/>
+        </p:nvSpPr>
+        <p:spPr>
+          <a:xfrm>
+            <a:off x="10433304" y="2468880"/>
+            <a:ext cx="164592" cy="164592"/>
+          </a:xfrm>
+          <a:prstGeom prst="ellipse">
+            <a:avLst/>
+          </a:prstGeom>
+          <a:solidFill>
+            <a:srgbClr val="14253B"/>
+          </a:solidFill>
+          <a:ln w="19050">
+            <a:solidFill>
+              <a:srgbClr val="FFFFFF"/>
+            </a:solidFill>
+          </a:ln>
+          <a:effectLst/>
+        </p:spPr>
+        <p:style>
+          <a:lnRef idx="1">
+            <a:schemeClr val="accent1"/>
+          </a:lnRef>
+          <a:fillRef idx="3">
+            <a:schemeClr val="accent1"/>
+          </a:fillRef>
+          <a:effectRef idx="2">
+            <a:schemeClr val="accent1"/>
+          </a:effectRef>
+          <a:fontRef idx="minor">
+            <a:schemeClr val="lt1"/>
+          </a:fontRef>
+        </p:style>
+        <p:txBody>
+          <a:bodyPr rtlCol="0" anchor="ctr"/>
+          <a:lstStyle/>
+          <a:p>
+            <a:pPr algn="ctr"/>
+          </a:p>
+        </p:txBody>
+      </p:sp>
+      <p:sp>
+        <p:nvSpPr>
+          <p:cNvPr id="21" name="TextBox 20"/>
+          <p:cNvSpPr txBox="1"/>
+          <p:nvPr/>
+        </p:nvSpPr>
+        <p:spPr>
+          <a:xfrm>
+            <a:off x="9509760" y="2679192"/>
+            <a:ext cx="2011680" cy="274320"/>
+          </a:xfrm>
+          <a:prstGeom prst="rect">
+            <a:avLst/>
+          </a:prstGeom>
+          <a:noFill/>
+        </p:spPr>
+        <p:txBody>
+          <a:bodyPr wrap="square" anchor="t" lIns="0" rIns="0" tIns="0" bIns="0">
+            <a:spAutoFit/>
+          </a:bodyPr>
+          <a:lstStyle/>
+          <a:p>
+            <a:pPr algn="ctr">
+              <a:lnSpc>
+                <a:spcPct val="110000"/>
+              </a:lnSpc>
+              <a:spcAft>
+                <a:spcPts val="0"/>
+              </a:spcAft>
+            </a:pPr>
+            <a:r>
+              <a:rPr sz="1200" b="0" i="0">
+                <a:solidFill>
+                  <a:srgbClr val="4A5D75"/>
+                </a:solidFill>
+                <a:latin typeface="Calibri"/>
+              </a:rPr>
+              <a:t>Athanase</a:t>
+            </a:r>
+          </a:p>
+        </p:txBody>
+      </p:sp>
+      <p:sp>
+        <p:nvSpPr>
+          <p:cNvPr id="22" name="TextBox 21"/>
+          <p:cNvSpPr txBox="1"/>
+          <p:nvPr/>
+        </p:nvSpPr>
+        <p:spPr>
+          <a:xfrm>
+            <a:off x="685800" y="3291840"/>
             <a:ext cx="10881360" cy="4297680"/>
           </a:xfrm>
           <a:prstGeom prst="rect">
@@ -5212,11 +5926,11 @@
                 <a:spcPct val="112000"/>
               </a:lnSpc>
               <a:spcAft>
-                <a:spcPts val="1100"/>
-              </a:spcAft>
-            </a:pPr>
-            <a:r>
-              <a:rPr sz="1500" b="1">
+                <a:spcPts val="1000"/>
+              </a:spcAft>
+            </a:pPr>
+            <a:r>
+              <a:rPr sz="1450" b="1">
                 <a:solidFill>
                   <a:srgbClr val="4A5D75"/>
                 </a:solidFill>
@@ -5225,7 +5939,7 @@
               <a:t>›  </a:t>
             </a:r>
             <a:r>
-              <a:rPr sz="1500" b="1">
+              <a:rPr sz="1450" b="1">
                 <a:solidFill>
                   <a:srgbClr val="1E334E"/>
                 </a:solidFill>
@@ -5234,7 +5948,7 @@
               <a:t>40+ companies managed,</a:t>
             </a:r>
             <a:r>
-              <a:rPr sz="1500">
+              <a:rPr sz="1450">
                 <a:solidFill>
                   <a:srgbClr val="333840"/>
                 </a:solidFill>
@@ -5249,11 +5963,11 @@
                 <a:spcPct val="112000"/>
               </a:lnSpc>
               <a:spcAft>
-                <a:spcPts val="1100"/>
-              </a:spcAft>
-            </a:pPr>
-            <a:r>
-              <a:rPr sz="1500" b="1">
+                <a:spcPts val="1000"/>
+              </a:spcAft>
+            </a:pPr>
+            <a:r>
+              <a:rPr sz="1450" b="1">
                 <a:solidFill>
                   <a:srgbClr val="4A5D75"/>
                 </a:solidFill>
@@ -5262,7 +5976,7 @@
               <a:t>›  </a:t>
             </a:r>
             <a:r>
-              <a:rPr sz="1500" b="1">
+              <a:rPr sz="1450" b="1">
                 <a:solidFill>
                   <a:srgbClr val="1E334E"/>
                 </a:solidFill>
@@ -5271,7 +5985,7 @@
               <a:t>30+ public board seats</a:t>
             </a:r>
             <a:r>
-              <a:rPr sz="1500">
+              <a:rPr sz="1450">
                 <a:solidFill>
                   <a:srgbClr val="333840"/>
                 </a:solidFill>
@@ -5286,11 +6000,11 @@
                 <a:spcPct val="112000"/>
               </a:lnSpc>
               <a:spcAft>
-                <a:spcPts val="1100"/>
-              </a:spcAft>
-            </a:pPr>
-            <a:r>
-              <a:rPr sz="1500" b="1">
+                <a:spcPts val="1000"/>
+              </a:spcAft>
+            </a:pPr>
+            <a:r>
+              <a:rPr sz="1450" b="1">
                 <a:solidFill>
                   <a:srgbClr val="4A5D75"/>
                 </a:solidFill>
@@ -5299,7 +6013,7 @@
               <a:t>›  </a:t>
             </a:r>
             <a:r>
-              <a:rPr sz="1500" b="1">
+              <a:rPr sz="1450" b="1">
                 <a:solidFill>
                   <a:srgbClr val="1E334E"/>
                 </a:solidFill>
@@ -5308,7 +6022,7 @@
               <a:t>A dual lens:</a:t>
             </a:r>
             <a:r>
-              <a:rPr sz="1500">
+              <a:rPr sz="1450">
                 <a:solidFill>
                   <a:srgbClr val="333840"/>
                 </a:solidFill>
@@ -5323,11 +6037,11 @@
                 <a:spcPct val="112000"/>
               </a:lnSpc>
               <a:spcAft>
-                <a:spcPts val="1100"/>
-              </a:spcAft>
-            </a:pPr>
-            <a:r>
-              <a:rPr sz="1500" b="1">
+                <a:spcPts val="1000"/>
+              </a:spcAft>
+            </a:pPr>
+            <a:r>
+              <a:rPr sz="1450" b="1">
                 <a:solidFill>
                   <a:srgbClr val="4A5D75"/>
                 </a:solidFill>
@@ -5336,7 +6050,7 @@
               <a:t>›  </a:t>
             </a:r>
             <a:r>
-              <a:rPr sz="1500" b="1">
+              <a:rPr sz="1450" b="1">
                 <a:solidFill>
                   <a:srgbClr val="1E334E"/>
                 </a:solidFill>
@@ -5345,7 +6059,7 @@
               <a:t>Skin in the game.</a:t>
             </a:r>
             <a:r>
-              <a:rPr sz="1500">
+              <a:rPr sz="1450">
                 <a:solidFill>
                   <a:srgbClr val="333840"/>
                 </a:solidFill>
@@ -5360,11 +6074,11 @@
                 <a:spcPct val="112000"/>
               </a:lnSpc>
               <a:spcAft>
-                <a:spcPts val="1100"/>
-              </a:spcAft>
-            </a:pPr>
-            <a:r>
-              <a:rPr sz="1500" b="1">
+                <a:spcPts val="1000"/>
+              </a:spcAft>
+            </a:pPr>
+            <a:r>
+              <a:rPr sz="1450" b="1">
                 <a:solidFill>
                   <a:srgbClr val="4A5D75"/>
                 </a:solidFill>
@@ -5373,7 +6087,7 @@
               <a:t>›  </a:t>
             </a:r>
             <a:r>
-              <a:rPr sz="1500" b="1">
+              <a:rPr sz="1450" b="1">
                 <a:solidFill>
                   <a:srgbClr val="1E334E"/>
                 </a:solidFill>
@@ -5382,7 +6096,7 @@
               <a:t>Institutional memory.</a:t>
             </a:r>
             <a:r>
-              <a:rPr sz="1500">
+              <a:rPr sz="1450">
                 <a:solidFill>
                   <a:srgbClr val="333840"/>
                 </a:solidFill>
@@ -5699,8 +6413,8 @@
         </p:nvSpPr>
         <p:spPr>
           <a:xfrm>
-            <a:off x="685800" y="2148840"/>
-            <a:ext cx="10881360" cy="4297680"/>
+            <a:off x="640080" y="2148840"/>
+            <a:ext cx="5760720" cy="4297680"/>
           </a:xfrm>
           <a:prstGeom prst="rect">
             <a:avLst/>
@@ -5718,11 +6432,11 @@
                 <a:spcPct val="112000"/>
               </a:lnSpc>
               <a:spcAft>
-                <a:spcPts val="1300"/>
-              </a:spcAft>
-            </a:pPr>
-            <a:r>
-              <a:rPr sz="1550" b="1">
+                <a:spcPts val="1400"/>
+              </a:spcAft>
+            </a:pPr>
+            <a:r>
+              <a:rPr sz="1350" b="1">
                 <a:solidFill>
                   <a:srgbClr val="4A5D75"/>
                 </a:solidFill>
@@ -5731,7 +6445,7 @@
               <a:t>›  </a:t>
             </a:r>
             <a:r>
-              <a:rPr sz="1550" b="1">
+              <a:rPr sz="1350" b="1">
                 <a:solidFill>
                   <a:srgbClr val="1E334E"/>
                 </a:solidFill>
@@ -5740,7 +6454,7 @@
               <a:t>Duration mismatch.</a:t>
             </a:r>
             <a:r>
-              <a:rPr sz="1550">
+              <a:rPr sz="1350">
                 <a:solidFill>
                   <a:srgbClr val="333840"/>
                 </a:solidFill>
@@ -5755,11 +6469,11 @@
                 <a:spcPct val="112000"/>
               </a:lnSpc>
               <a:spcAft>
-                <a:spcPts val="1300"/>
-              </a:spcAft>
-            </a:pPr>
-            <a:r>
-              <a:rPr sz="1550" b="1">
+                <a:spcPts val="1400"/>
+              </a:spcAft>
+            </a:pPr>
+            <a:r>
+              <a:rPr sz="1350" b="1">
                 <a:solidFill>
                   <a:srgbClr val="4A5D75"/>
                 </a:solidFill>
@@ -5768,7 +6482,7 @@
               <a:t>›  </a:t>
             </a:r>
             <a:r>
-              <a:rPr sz="1550" b="1">
+              <a:rPr sz="1350" b="1">
                 <a:solidFill>
                   <a:srgbClr val="1E334E"/>
                 </a:solidFill>
@@ -5777,7 +6491,7 @@
               <a:t>The prestige trap.</a:t>
             </a:r>
             <a:r>
-              <a:rPr sz="1550">
+              <a:rPr sz="1350">
                 <a:solidFill>
                   <a:srgbClr val="333840"/>
                 </a:solidFill>
@@ -5792,11 +6506,11 @@
                 <a:spcPct val="112000"/>
               </a:lnSpc>
               <a:spcAft>
-                <a:spcPts val="1300"/>
-              </a:spcAft>
-            </a:pPr>
-            <a:r>
-              <a:rPr sz="1550" b="1">
+                <a:spcPts val="1400"/>
+              </a:spcAft>
+            </a:pPr>
+            <a:r>
+              <a:rPr sz="1350" b="1">
                 <a:solidFill>
                   <a:srgbClr val="4A5D75"/>
                 </a:solidFill>
@@ -5805,7 +6519,7 @@
               <a:t>›  </a:t>
             </a:r>
             <a:r>
-              <a:rPr sz="1550" b="1">
+              <a:rPr sz="1350" b="1">
                 <a:solidFill>
                   <a:srgbClr val="1E334E"/>
                 </a:solidFill>
@@ -5814,7 +6528,7 @@
               <a:t>Shareholder exhaustion.</a:t>
             </a:r>
             <a:r>
-              <a:rPr sz="1550">
+              <a:rPr sz="1350">
                 <a:solidFill>
                   <a:srgbClr val="333840"/>
                 </a:solidFill>
@@ -5829,11 +6543,11 @@
                 <a:spcPct val="112000"/>
               </a:lnSpc>
               <a:spcAft>
-                <a:spcPts val="1300"/>
-              </a:spcAft>
-            </a:pPr>
-            <a:r>
-              <a:rPr sz="1550" b="1">
+                <a:spcPts val="1400"/>
+              </a:spcAft>
+            </a:pPr>
+            <a:r>
+              <a:rPr sz="1350" b="1">
                 <a:solidFill>
                   <a:srgbClr val="4A5D75"/>
                 </a:solidFill>
@@ -5842,7 +6556,7 @@
               <a:t>›  </a:t>
             </a:r>
             <a:r>
-              <a:rPr sz="1550" b="1">
+              <a:rPr sz="1350" b="1">
                 <a:solidFill>
                   <a:srgbClr val="1E334E"/>
                 </a:solidFill>
@@ -5851,13 +6565,73 @@
               <a:t>Low competition.</a:t>
             </a:r>
             <a:r>
-              <a:rPr sz="1550">
+              <a:rPr sz="1350">
                 <a:solidFill>
                   <a:srgbClr val="333840"/>
                 </a:solidFill>
                 <a:latin typeface="Calibri"/>
               </a:rPr>
               <a:t>  Passive buys the most expensive names; active managers wait for proof; PE needs 10x the capital — leaving these bargains open.</a:t>
+            </a:r>
+          </a:p>
+        </p:txBody>
+      </p:sp>
+      <p:graphicFrame>
+        <p:nvGraphicFramePr>
+          <p:cNvPr id="10" name="Chart 9"/>
+          <p:cNvGraphicFramePr>
+            <a:graphicFrameLocks noGrp="1"/>
+          </p:cNvGraphicFramePr>
+          <p:nvPr/>
+        </p:nvGraphicFramePr>
+        <p:xfrm>
+          <a:off x="6537960" y="2331720"/>
+          <a:ext cx="5212080" cy="3291840"/>
+        </p:xfrm>
+        <a:graphic>
+          <a:graphicData uri="http://schemas.openxmlformats.org/drawingml/2006/chart">
+            <c:chart xmlns:c="http://schemas.openxmlformats.org/drawingml/2006/chart" r:id="rId3"/>
+          </a:graphicData>
+        </a:graphic>
+      </p:graphicFrame>
+      <p:sp>
+        <p:nvSpPr>
+          <p:cNvPr id="11" name="TextBox 10"/>
+          <p:cNvSpPr txBox="1"/>
+          <p:nvPr/>
+        </p:nvSpPr>
+        <p:spPr>
+          <a:xfrm>
+            <a:off x="6537960" y="5669280"/>
+            <a:ext cx="5212080" cy="365760"/>
+          </a:xfrm>
+          <a:prstGeom prst="rect">
+            <a:avLst/>
+          </a:prstGeom>
+          <a:noFill/>
+        </p:spPr>
+        <p:txBody>
+          <a:bodyPr wrap="square" anchor="t" lIns="0" rIns="0" tIns="0" bIns="0">
+            <a:spAutoFit/>
+          </a:bodyPr>
+          <a:lstStyle/>
+          <a:p>
+            <a:pPr algn="l">
+              <a:lnSpc>
+                <a:spcPct val="110000"/>
+              </a:lnSpc>
+              <a:spcAft>
+                <a:spcPts val="0"/>
+              </a:spcAft>
+            </a:pPr>
+            <a:r>
+              <a:rPr sz="1000" b="0" i="1">
+                <a:solidFill>
+                  <a:srgbClr val="9AA4B0"/>
+                </a:solidFill>
+                <a:latin typeface="Calibri"/>
+              </a:rPr>
+              <a:t>Even an excellent team’s edge erodes as the external environment shifts.</a:t>
             </a:r>
           </a:p>
         </p:txBody>
@@ -6169,7 +6943,7 @@
         <p:spPr>
           <a:xfrm>
             <a:off x="640080" y="2148840"/>
-            <a:ext cx="10881360" cy="4297680"/>
+            <a:ext cx="5852160" cy="4297680"/>
           </a:xfrm>
           <a:prstGeom prst="rect">
             <a:avLst/>
@@ -6187,7 +6961,7 @@
                 <a:spcPct val="112000"/>
               </a:lnSpc>
               <a:spcAft>
-                <a:spcPts val="900"/>
+                <a:spcPts val="1300"/>
               </a:spcAft>
             </a:pPr>
             <a:r>
@@ -6215,7 +6989,7 @@
                 </a:solidFill>
                 <a:latin typeface="Calibri"/>
               </a:rPr>
-              <a:t>  Buy “cheap and troubled” and you select for lemons — businesses in structural decline that are worse than they look. The market discounted them for a reason.</a:t>
+              <a:t>  Buy “cheap and troubled” and you select for lemons — worse than they look. The market discounted them for a reason.</a:t>
             </a:r>
           </a:p>
           <a:p>
@@ -6224,7 +6998,7 @@
                 <a:spcPct val="112000"/>
               </a:lnSpc>
               <a:spcAft>
-                <a:spcPts val="900"/>
+                <a:spcPts val="1300"/>
               </a:spcAft>
             </a:pPr>
             <a:r>
@@ -6252,7 +7026,7 @@
                 </a:solidFill>
                 <a:latin typeface="Calibri"/>
               </a:rPr>
-              <a:t>  We invest only where the core is a market leader earning high returns on incremental capital — and only when it is attractive even if we change nothing. We do not underwrite turnarounds of structurally weak businesses.</a:t>
+              <a:t>  We invest only where the core is a market leader earning high returns on capital — attractive even if we change nothing. No structurally-weak turnarounds.</a:t>
             </a:r>
           </a:p>
           <a:p>
@@ -6261,7 +7035,7 @@
                 <a:spcPct val="112000"/>
               </a:lnSpc>
               <a:spcAft>
-                <a:spcPts val="900"/>
+                <a:spcPts val="1300"/>
               </a:spcAft>
             </a:pPr>
             <a:r>
@@ -6289,7 +7063,7 @@
                 </a:solidFill>
                 <a:latin typeface="Calibri"/>
               </a:rPr>
-              <a:t>  Our targets are profitable leaders whose management pivoted into weak adjacencies — chasing growth as the core matured, or something new and “sexy.” The drag is a capital-allocation overlay on a good asset, not a bad asset.</a:t>
+              <a:t>  Profitable leaders whose management pivoted into weak adjacencies — chasing growth as the core matured. A capital-allocation overlay on a good asset, not a bad asset.</a:t>
             </a:r>
           </a:p>
           <a:p>
@@ -6298,7 +7072,7 @@
                 <a:spcPct val="112000"/>
               </a:lnSpc>
               <a:spcAft>
-                <a:spcPts val="900"/>
+                <a:spcPts val="1300"/>
               </a:spcAft>
             </a:pPr>
             <a:r>
@@ -6326,21 +7100,168 @@
                 </a:solidFill>
                 <a:latin typeface="Calibri"/>
               </a:rPr>
-              <a:t>  Blended results make the company look mediocre, so it is priced as mediocre. Forensic separation reveals a strong core subsidising a loss-making periphery — the appearance understates reality.</a:t>
-            </a:r>
-          </a:p>
-        </p:txBody>
-      </p:sp>
-      <p:sp>
-        <p:nvSpPr>
-          <p:cNvPr id="10" name="Rectangle 9"/>
+              <a:t>  Blended results make it look mediocre, so it is priced mediocre. The appearance understates reality.</a:t>
+            </a:r>
+          </a:p>
+        </p:txBody>
+      </p:sp>
+      <p:sp>
+        <p:nvSpPr>
+          <p:cNvPr id="10" name="TextBox 9"/>
+          <p:cNvSpPr txBox="1"/>
+          <p:nvPr/>
+        </p:nvSpPr>
+        <p:spPr>
+          <a:xfrm>
+            <a:off x="6675120" y="2103120"/>
+            <a:ext cx="4937760" cy="274320"/>
+          </a:xfrm>
+          <a:prstGeom prst="rect">
+            <a:avLst/>
+          </a:prstGeom>
+          <a:noFill/>
+        </p:spPr>
+        <p:txBody>
+          <a:bodyPr wrap="square" anchor="t" lIns="0" rIns="0" tIns="0" bIns="0">
+            <a:spAutoFit/>
+          </a:bodyPr>
+          <a:lstStyle/>
+          <a:p>
+            <a:pPr algn="ctr">
+              <a:lnSpc>
+                <a:spcPct val="110000"/>
+              </a:lnSpc>
+              <a:spcAft>
+                <a:spcPts val="0"/>
+              </a:spcAft>
+            </a:pPr>
+            <a:r>
+              <a:rPr sz="1100" b="1" i="0">
+                <a:solidFill>
+                  <a:srgbClr val="4A5D75"/>
+                </a:solidFill>
+                <a:latin typeface="Calibri"/>
+              </a:rPr>
+              <a:t>SUM-OF-THE-PARTS (ILLUSTRATIVE)</a:t>
+            </a:r>
+          </a:p>
+        </p:txBody>
+      </p:sp>
+      <p:sp>
+        <p:nvSpPr>
+          <p:cNvPr id="11" name="Rectangle 10"/>
           <p:cNvSpPr/>
           <p:nvPr/>
         </p:nvSpPr>
         <p:spPr>
           <a:xfrm>
-            <a:off x="640080" y="4892040"/>
-            <a:ext cx="3154680" cy="868680"/>
+            <a:off x="7315200" y="3639312"/>
+            <a:ext cx="1463040" cy="1389888"/>
+          </a:xfrm>
+          <a:prstGeom prst="rect">
+            <a:avLst/>
+          </a:prstGeom>
+          <a:solidFill>
+            <a:srgbClr val="4A5D75"/>
+          </a:solidFill>
+          <a:ln>
+            <a:noFill/>
+          </a:ln>
+          <a:effectLst/>
+        </p:spPr>
+        <p:style>
+          <a:lnRef idx="1">
+            <a:schemeClr val="accent1"/>
+          </a:lnRef>
+          <a:fillRef idx="3">
+            <a:schemeClr val="accent1"/>
+          </a:fillRef>
+          <a:effectRef idx="2">
+            <a:schemeClr val="accent1"/>
+          </a:effectRef>
+          <a:fontRef idx="minor">
+            <a:schemeClr val="lt1"/>
+          </a:fontRef>
+        </p:style>
+        <p:txBody>
+          <a:bodyPr rtlCol="0" anchor="ctr"/>
+          <a:lstStyle/>
+          <a:p>
+            <a:pPr algn="ctr"/>
+          </a:p>
+        </p:txBody>
+      </p:sp>
+      <p:sp>
+        <p:nvSpPr>
+          <p:cNvPr id="12" name="TextBox 11"/>
+          <p:cNvSpPr txBox="1"/>
+          <p:nvPr/>
+        </p:nvSpPr>
+        <p:spPr>
+          <a:xfrm>
+            <a:off x="6949440" y="5120640"/>
+            <a:ext cx="2194560" cy="548640"/>
+          </a:xfrm>
+          <a:prstGeom prst="rect">
+            <a:avLst/>
+          </a:prstGeom>
+          <a:noFill/>
+        </p:spPr>
+        <p:txBody>
+          <a:bodyPr wrap="square" anchor="t" lIns="0" rIns="0" tIns="0" bIns="0">
+            <a:spAutoFit/>
+          </a:bodyPr>
+          <a:lstStyle/>
+          <a:p>
+            <a:pPr algn="ctr">
+              <a:lnSpc>
+                <a:spcPct val="100000"/>
+              </a:lnSpc>
+              <a:spcAft>
+                <a:spcPts val="0"/>
+              </a:spcAft>
+            </a:pPr>
+            <a:r>
+              <a:rPr sz="1150" b="1" i="0">
+                <a:solidFill>
+                  <a:srgbClr val="333840"/>
+                </a:solidFill>
+                <a:latin typeface="Calibri"/>
+              </a:rPr>
+              <a:t>Market price</a:t>
+            </a:r>
+          </a:p>
+          <a:p>
+            <a:pPr algn="ctr">
+              <a:lnSpc>
+                <a:spcPct val="100000"/>
+              </a:lnSpc>
+              <a:spcAft>
+                <a:spcPts val="0"/>
+              </a:spcAft>
+            </a:pPr>
+            <a:r>
+              <a:rPr sz="1000" b="0" i="0">
+                <a:solidFill>
+                  <a:srgbClr val="333840"/>
+                </a:solidFill>
+                <a:latin typeface="Calibri"/>
+              </a:rPr>
+              <a:t>(blended optics)</a:t>
+            </a:r>
+          </a:p>
+        </p:txBody>
+      </p:sp>
+      <p:sp>
+        <p:nvSpPr>
+          <p:cNvPr id="13" name="Rectangle 12"/>
+          <p:cNvSpPr/>
+          <p:nvPr/>
+        </p:nvSpPr>
+        <p:spPr>
+          <a:xfrm>
+            <a:off x="9692640" y="2770632"/>
+            <a:ext cx="1463040" cy="2258568"/>
           </a:xfrm>
           <a:prstGeom prst="rect">
             <a:avLst/>
@@ -6377,75 +7298,119 @@
       </p:sp>
       <p:sp>
         <p:nvSpPr>
-          <p:cNvPr id="11" name="TextBox 10"/>
-          <p:cNvSpPr txBox="1"/>
-          <p:nvPr/>
-        </p:nvSpPr>
-        <p:spPr>
-          <a:xfrm>
-            <a:off x="640080" y="4892040"/>
-            <a:ext cx="3154680" cy="868680"/>
-          </a:xfrm>
-          <a:prstGeom prst="rect">
-            <a:avLst/>
-          </a:prstGeom>
-          <a:noFill/>
-        </p:spPr>
-        <p:txBody>
-          <a:bodyPr wrap="square" anchor="ctr" lIns="0" rIns="0" tIns="0" bIns="0">
+          <p:cNvPr id="14" name="TextBox 13"/>
+          <p:cNvSpPr txBox="1"/>
+          <p:nvPr/>
+        </p:nvSpPr>
+        <p:spPr>
+          <a:xfrm>
+            <a:off x="9326880" y="5120640"/>
+            <a:ext cx="2194560" cy="548640"/>
+          </a:xfrm>
+          <a:prstGeom prst="rect">
+            <a:avLst/>
+          </a:prstGeom>
+          <a:noFill/>
+        </p:spPr>
+        <p:txBody>
+          <a:bodyPr wrap="square" anchor="t" lIns="0" rIns="0" tIns="0" bIns="0">
             <a:spAutoFit/>
           </a:bodyPr>
           <a:lstStyle/>
           <a:p>
             <a:pPr algn="ctr">
               <a:lnSpc>
-                <a:spcPct val="105000"/>
+                <a:spcPct val="100000"/>
               </a:lnSpc>
               <a:spcAft>
                 <a:spcPts val="0"/>
               </a:spcAft>
             </a:pPr>
             <a:r>
-              <a:rPr sz="1250" b="1" i="0">
-                <a:solidFill>
-                  <a:srgbClr val="FFFFFF"/>
-                </a:solidFill>
-                <a:latin typeface="Calibri"/>
-              </a:rPr>
-              <a:t>Market-leading core</a:t>
+              <a:rPr sz="1150" b="1" i="0">
+                <a:solidFill>
+                  <a:srgbClr val="333840"/>
+                </a:solidFill>
+                <a:latin typeface="Calibri"/>
+              </a:rPr>
+              <a:t>Core alone</a:t>
             </a:r>
           </a:p>
           <a:p>
             <a:pPr algn="ctr">
               <a:lnSpc>
-                <a:spcPct val="105000"/>
+                <a:spcPct val="100000"/>
               </a:lnSpc>
               <a:spcAft>
                 <a:spcPts val="0"/>
               </a:spcAft>
             </a:pPr>
             <a:r>
-              <a:rPr sz="1100" b="0" i="0">
-                <a:solidFill>
-                  <a:srgbClr val="FFFFFF"/>
-                </a:solidFill>
-                <a:latin typeface="Calibri"/>
-              </a:rPr>
-              <a:t>high ROIIC, very profitable</a:t>
-            </a:r>
-          </a:p>
-        </p:txBody>
-      </p:sp>
-      <p:sp>
-        <p:nvSpPr>
-          <p:cNvPr id="12" name="Rectangle 11"/>
+              <a:rPr sz="1000" b="0" i="0">
+                <a:solidFill>
+                  <a:srgbClr val="333840"/>
+                </a:solidFill>
+                <a:latin typeface="Calibri"/>
+              </a:rPr>
+              <a:t>(high ROIIC)</a:t>
+            </a:r>
+          </a:p>
+        </p:txBody>
+      </p:sp>
+      <p:sp>
+        <p:nvSpPr>
+          <p:cNvPr id="15" name="Rectangle 14"/>
           <p:cNvSpPr/>
           <p:nvPr/>
         </p:nvSpPr>
         <p:spPr>
           <a:xfrm>
-            <a:off x="4297680" y="4892040"/>
-            <a:ext cx="3154680" cy="868680"/>
+            <a:off x="7315200" y="3639312"/>
+            <a:ext cx="3108960" cy="15240"/>
+          </a:xfrm>
+          <a:prstGeom prst="rect">
+            <a:avLst/>
+          </a:prstGeom>
+          <a:solidFill>
+            <a:srgbClr val="8A99AB"/>
+          </a:solidFill>
+          <a:ln>
+            <a:noFill/>
+          </a:ln>
+          <a:effectLst/>
+        </p:spPr>
+        <p:style>
+          <a:lnRef idx="1">
+            <a:schemeClr val="accent1"/>
+          </a:lnRef>
+          <a:fillRef idx="3">
+            <a:schemeClr val="accent1"/>
+          </a:fillRef>
+          <a:effectRef idx="2">
+            <a:schemeClr val="accent1"/>
+          </a:effectRef>
+          <a:fontRef idx="minor">
+            <a:schemeClr val="lt1"/>
+          </a:fontRef>
+        </p:style>
+        <p:txBody>
+          <a:bodyPr rtlCol="0" anchor="ctr"/>
+          <a:lstStyle/>
+          <a:p>
+            <a:pPr algn="ctr"/>
+          </a:p>
+        </p:txBody>
+      </p:sp>
+      <p:sp>
+        <p:nvSpPr>
+          <p:cNvPr id="16" name="Rectangle 15"/>
+          <p:cNvSpPr/>
+          <p:nvPr/>
+        </p:nvSpPr>
+        <p:spPr>
+          <a:xfrm>
+            <a:off x="10927080" y="2770632"/>
+            <a:ext cx="25400" cy="868680"/>
           </a:xfrm>
           <a:prstGeom prst="rect">
             <a:avLst/>
@@ -6482,173 +7447,49 @@
       </p:sp>
       <p:sp>
         <p:nvSpPr>
-          <p:cNvPr id="13" name="TextBox 12"/>
-          <p:cNvSpPr txBox="1"/>
-          <p:nvPr/>
-        </p:nvSpPr>
-        <p:spPr>
-          <a:xfrm>
-            <a:off x="4297680" y="4892040"/>
-            <a:ext cx="3154680" cy="868680"/>
-          </a:xfrm>
-          <a:prstGeom prst="rect">
-            <a:avLst/>
-          </a:prstGeom>
-          <a:noFill/>
-        </p:spPr>
-        <p:txBody>
-          <a:bodyPr wrap="square" anchor="ctr" lIns="0" rIns="0" tIns="0" bIns="0">
-            <a:spAutoFit/>
-          </a:bodyPr>
-          <a:lstStyle/>
-          <a:p>
-            <a:pPr algn="ctr">
-              <a:lnSpc>
-                <a:spcPct val="105000"/>
+          <p:cNvPr id="17" name="TextBox 16"/>
+          <p:cNvSpPr txBox="1"/>
+          <p:nvPr/>
+        </p:nvSpPr>
+        <p:spPr>
+          <a:xfrm>
+            <a:off x="7452360" y="2816352"/>
+            <a:ext cx="3291840" cy="548640"/>
+          </a:xfrm>
+          <a:prstGeom prst="rect">
+            <a:avLst/>
+          </a:prstGeom>
+          <a:noFill/>
+        </p:spPr>
+        <p:txBody>
+          <a:bodyPr wrap="square" anchor="t" lIns="0" rIns="0" tIns="0" bIns="0">
+            <a:spAutoFit/>
+          </a:bodyPr>
+          <a:lstStyle/>
+          <a:p>
+            <a:pPr algn="l">
+              <a:lnSpc>
+                <a:spcPct val="110000"/>
               </a:lnSpc>
               <a:spcAft>
                 <a:spcPts val="0"/>
               </a:spcAft>
             </a:pPr>
             <a:r>
-              <a:rPr sz="1250" b="1" i="0">
-                <a:solidFill>
-                  <a:srgbClr val="FFFFFF"/>
-                </a:solidFill>
-                <a:latin typeface="Calibri"/>
-              </a:rPr>
-              <a:t>−  weak “growth” adjacencies</a:t>
-            </a:r>
-          </a:p>
-          <a:p>
-            <a:pPr algn="ctr">
-              <a:lnSpc>
-                <a:spcPct val="105000"/>
-              </a:lnSpc>
-              <a:spcAft>
-                <a:spcPts val="0"/>
-              </a:spcAft>
-            </a:pPr>
-            <a:r>
-              <a:rPr sz="1100" b="0" i="0">
-                <a:solidFill>
-                  <a:srgbClr val="FFFFFF"/>
-                </a:solidFill>
-                <a:latin typeface="Calibri"/>
-              </a:rPr>
-              <a:t>bolted on by management</a:t>
-            </a:r>
-          </a:p>
-        </p:txBody>
-      </p:sp>
-      <p:sp>
-        <p:nvSpPr>
-          <p:cNvPr id="14" name="Rectangle 13"/>
-          <p:cNvSpPr/>
-          <p:nvPr/>
-        </p:nvSpPr>
-        <p:spPr>
-          <a:xfrm>
-            <a:off x="7955280" y="4892040"/>
-            <a:ext cx="3154680" cy="868680"/>
-          </a:xfrm>
-          <a:prstGeom prst="rect">
-            <a:avLst/>
-          </a:prstGeom>
-          <a:solidFill>
-            <a:srgbClr val="D8DCE2"/>
-          </a:solidFill>
-          <a:ln>
-            <a:noFill/>
-          </a:ln>
-          <a:effectLst/>
-        </p:spPr>
-        <p:style>
-          <a:lnRef idx="1">
-            <a:schemeClr val="accent1"/>
-          </a:lnRef>
-          <a:fillRef idx="3">
-            <a:schemeClr val="accent1"/>
-          </a:fillRef>
-          <a:effectRef idx="2">
-            <a:schemeClr val="accent1"/>
-          </a:effectRef>
-          <a:fontRef idx="minor">
-            <a:schemeClr val="lt1"/>
-          </a:fontRef>
-        </p:style>
-        <p:txBody>
-          <a:bodyPr rtlCol="0" anchor="ctr"/>
-          <a:lstStyle/>
-          <a:p>
-            <a:pPr algn="ctr"/>
-          </a:p>
-        </p:txBody>
-      </p:sp>
-      <p:sp>
-        <p:nvSpPr>
-          <p:cNvPr id="15" name="TextBox 14"/>
-          <p:cNvSpPr txBox="1"/>
-          <p:nvPr/>
-        </p:nvSpPr>
-        <p:spPr>
-          <a:xfrm>
-            <a:off x="7955280" y="4892040"/>
-            <a:ext cx="3154680" cy="868680"/>
-          </a:xfrm>
-          <a:prstGeom prst="rect">
-            <a:avLst/>
-          </a:prstGeom>
-          <a:noFill/>
-        </p:spPr>
-        <p:txBody>
-          <a:bodyPr wrap="square" anchor="ctr" lIns="0" rIns="0" tIns="0" bIns="0">
-            <a:spAutoFit/>
-          </a:bodyPr>
-          <a:lstStyle/>
-          <a:p>
-            <a:pPr algn="ctr">
-              <a:lnSpc>
-                <a:spcPct val="105000"/>
-              </a:lnSpc>
-              <a:spcAft>
-                <a:spcPts val="0"/>
-              </a:spcAft>
-            </a:pPr>
-            <a:r>
-              <a:rPr sz="1250" b="1" i="0">
-                <a:solidFill>
-                  <a:srgbClr val="1E334E"/>
-                </a:solidFill>
-                <a:latin typeface="Calibri"/>
-              </a:rPr>
-              <a:t>=  reported as mediocre</a:t>
-            </a:r>
-          </a:p>
-          <a:p>
-            <a:pPr algn="ctr">
-              <a:lnSpc>
-                <a:spcPct val="105000"/>
-              </a:lnSpc>
-              <a:spcAft>
-                <a:spcPts val="0"/>
-              </a:spcAft>
-            </a:pPr>
-            <a:r>
-              <a:rPr sz="1100" b="0" i="0">
-                <a:solidFill>
-                  <a:srgbClr val="1E334E"/>
-                </a:solidFill>
-                <a:latin typeface="Calibri"/>
-              </a:rPr>
-              <a:t>priced cheap</a:t>
-            </a:r>
-          </a:p>
-        </p:txBody>
-      </p:sp>
-      <p:sp>
-        <p:nvSpPr>
-          <p:cNvPr id="16" name="TextBox 15"/>
+              <a:rPr sz="1150" b="1" i="0">
+                <a:solidFill>
+                  <a:srgbClr val="A84A4A"/>
+                </a:solidFill>
+                <a:latin typeface="Calibri"/>
+              </a:rPr>
+              <a:t>hidden value ≈ 30–40%</a:t>
+            </a:r>
+          </a:p>
+        </p:txBody>
+      </p:sp>
+      <p:sp>
+        <p:nvSpPr>
+          <p:cNvPr id="18" name="TextBox 17"/>
           <p:cNvSpPr txBox="1"/>
           <p:nvPr/>
         </p:nvSpPr>
@@ -14377,7 +15218,7 @@
         <p:spPr>
           <a:xfrm>
             <a:off x="685800" y="2148840"/>
-            <a:ext cx="3017520" cy="233172"/>
+            <a:ext cx="3017520" cy="193852"/>
           </a:xfrm>
           <a:prstGeom prst="rect">
             <a:avLst/>
@@ -14421,7 +15262,7 @@
         <p:spPr>
           <a:xfrm>
             <a:off x="758952" y="2148840"/>
-            <a:ext cx="2907792" cy="233172"/>
+            <a:ext cx="2907792" cy="193852"/>
           </a:xfrm>
           <a:prstGeom prst="rect">
             <a:avLst/>
@@ -14443,7 +15284,7 @@
               </a:spcAft>
             </a:pPr>
             <a:r>
-              <a:rPr sz="1050" b="1" i="0">
+              <a:rPr sz="1000" b="1" i="0">
                 <a:solidFill>
                   <a:srgbClr val="FFFFFF"/>
                 </a:solidFill>
@@ -14463,7 +15304,7 @@
         <p:spPr>
           <a:xfrm>
             <a:off x="3703320" y="2148840"/>
-            <a:ext cx="1828800" cy="233172"/>
+            <a:ext cx="1828800" cy="193852"/>
           </a:xfrm>
           <a:prstGeom prst="rect">
             <a:avLst/>
@@ -14507,7 +15348,7 @@
         <p:spPr>
           <a:xfrm>
             <a:off x="3776472" y="2148840"/>
-            <a:ext cx="1719072" cy="233172"/>
+            <a:ext cx="1719072" cy="193852"/>
           </a:xfrm>
           <a:prstGeom prst="rect">
             <a:avLst/>
@@ -14529,7 +15370,7 @@
               </a:spcAft>
             </a:pPr>
             <a:r>
-              <a:rPr sz="1050" b="1" i="0">
+              <a:rPr sz="1000" b="1" i="0">
                 <a:solidFill>
                   <a:srgbClr val="FFFFFF"/>
                 </a:solidFill>
@@ -14549,7 +15390,7 @@
         <p:spPr>
           <a:xfrm>
             <a:off x="5532120" y="2148840"/>
-            <a:ext cx="1554480" cy="233172"/>
+            <a:ext cx="1554480" cy="193852"/>
           </a:xfrm>
           <a:prstGeom prst="rect">
             <a:avLst/>
@@ -14593,7 +15434,7 @@
         <p:spPr>
           <a:xfrm>
             <a:off x="5605272" y="2148840"/>
-            <a:ext cx="1444752" cy="233172"/>
+            <a:ext cx="1444752" cy="193852"/>
           </a:xfrm>
           <a:prstGeom prst="rect">
             <a:avLst/>
@@ -14615,7 +15456,7 @@
               </a:spcAft>
             </a:pPr>
             <a:r>
-              <a:rPr sz="1050" b="1" i="0">
+              <a:rPr sz="1000" b="1" i="0">
                 <a:solidFill>
                   <a:srgbClr val="FFFFFF"/>
                 </a:solidFill>
@@ -14635,7 +15476,7 @@
         <p:spPr>
           <a:xfrm>
             <a:off x="7086600" y="2148840"/>
-            <a:ext cx="1554480" cy="233172"/>
+            <a:ext cx="1554480" cy="193852"/>
           </a:xfrm>
           <a:prstGeom prst="rect">
             <a:avLst/>
@@ -14679,7 +15520,7 @@
         <p:spPr>
           <a:xfrm>
             <a:off x="7159752" y="2148840"/>
-            <a:ext cx="1444752" cy="233172"/>
+            <a:ext cx="1444752" cy="193852"/>
           </a:xfrm>
           <a:prstGeom prst="rect">
             <a:avLst/>
@@ -14701,7 +15542,7 @@
               </a:spcAft>
             </a:pPr>
             <a:r>
-              <a:rPr sz="1050" b="1" i="0">
+              <a:rPr sz="1000" b="1" i="0">
                 <a:solidFill>
                   <a:srgbClr val="FFFFFF"/>
                 </a:solidFill>
@@ -14721,7 +15562,7 @@
         <p:spPr>
           <a:xfrm>
             <a:off x="8641080" y="2148840"/>
-            <a:ext cx="1828800" cy="233172"/>
+            <a:ext cx="1828800" cy="193852"/>
           </a:xfrm>
           <a:prstGeom prst="rect">
             <a:avLst/>
@@ -14765,7 +15606,7 @@
         <p:spPr>
           <a:xfrm>
             <a:off x="8714232" y="2148840"/>
-            <a:ext cx="1719072" cy="233172"/>
+            <a:ext cx="1719072" cy="193852"/>
           </a:xfrm>
           <a:prstGeom prst="rect">
             <a:avLst/>
@@ -14787,7 +15628,7 @@
               </a:spcAft>
             </a:pPr>
             <a:r>
-              <a:rPr sz="1050" b="1" i="0">
+              <a:rPr sz="1000" b="1" i="0">
                 <a:solidFill>
                   <a:srgbClr val="FFFFFF"/>
                 </a:solidFill>
@@ -14806,8 +15647,8 @@
         </p:nvSpPr>
         <p:spPr>
           <a:xfrm>
-            <a:off x="685800" y="2382012"/>
-            <a:ext cx="3017520" cy="233172"/>
+            <a:off x="685800" y="2342692"/>
+            <a:ext cx="3017520" cy="193852"/>
           </a:xfrm>
           <a:prstGeom prst="rect">
             <a:avLst/>
@@ -14850,8 +15691,8 @@
         </p:nvSpPr>
         <p:spPr>
           <a:xfrm>
-            <a:off x="758952" y="2382012"/>
-            <a:ext cx="2907792" cy="233172"/>
+            <a:off x="758952" y="2342692"/>
+            <a:ext cx="2907792" cy="193852"/>
           </a:xfrm>
           <a:prstGeom prst="rect">
             <a:avLst/>
@@ -14873,7 +15714,7 @@
               </a:spcAft>
             </a:pPr>
             <a:r>
-              <a:rPr sz="1050" b="1" i="0">
+              <a:rPr sz="1000" b="1" i="0">
                 <a:solidFill>
                   <a:srgbClr val="1E334E"/>
                 </a:solidFill>
@@ -14892,8 +15733,8 @@
         </p:nvSpPr>
         <p:spPr>
           <a:xfrm>
-            <a:off x="3703320" y="2382012"/>
-            <a:ext cx="1828800" cy="233172"/>
+            <a:off x="3703320" y="2342692"/>
+            <a:ext cx="1828800" cy="193852"/>
           </a:xfrm>
           <a:prstGeom prst="rect">
             <a:avLst/>
@@ -14936,8 +15777,8 @@
         </p:nvSpPr>
         <p:spPr>
           <a:xfrm>
-            <a:off x="3776472" y="2382012"/>
-            <a:ext cx="1719072" cy="233172"/>
+            <a:off x="3776472" y="2342692"/>
+            <a:ext cx="1719072" cy="193852"/>
           </a:xfrm>
           <a:prstGeom prst="rect">
             <a:avLst/>
@@ -14959,7 +15800,7 @@
               </a:spcAft>
             </a:pPr>
             <a:r>
-              <a:rPr sz="1050" b="0" i="0">
+              <a:rPr sz="1000" b="0" i="0">
                 <a:solidFill>
                   <a:srgbClr val="333840"/>
                 </a:solidFill>
@@ -14978,8 +15819,8 @@
         </p:nvSpPr>
         <p:spPr>
           <a:xfrm>
-            <a:off x="5532120" y="2382012"/>
-            <a:ext cx="1554480" cy="233172"/>
+            <a:off x="5532120" y="2342692"/>
+            <a:ext cx="1554480" cy="193852"/>
           </a:xfrm>
           <a:prstGeom prst="rect">
             <a:avLst/>
@@ -15022,8 +15863,8 @@
         </p:nvSpPr>
         <p:spPr>
           <a:xfrm>
-            <a:off x="5605272" y="2382012"/>
-            <a:ext cx="1444752" cy="233172"/>
+            <a:off x="5605272" y="2342692"/>
+            <a:ext cx="1444752" cy="193852"/>
           </a:xfrm>
           <a:prstGeom prst="rect">
             <a:avLst/>
@@ -15045,7 +15886,7 @@
               </a:spcAft>
             </a:pPr>
             <a:r>
-              <a:rPr sz="1050" b="0" i="0">
+              <a:rPr sz="1000" b="0" i="0">
                 <a:solidFill>
                   <a:srgbClr val="333840"/>
                 </a:solidFill>
@@ -15064,8 +15905,8 @@
         </p:nvSpPr>
         <p:spPr>
           <a:xfrm>
-            <a:off x="7086600" y="2382012"/>
-            <a:ext cx="1554480" cy="233172"/>
+            <a:off x="7086600" y="2342692"/>
+            <a:ext cx="1554480" cy="193852"/>
           </a:xfrm>
           <a:prstGeom prst="rect">
             <a:avLst/>
@@ -15108,8 +15949,8 @@
         </p:nvSpPr>
         <p:spPr>
           <a:xfrm>
-            <a:off x="7159752" y="2382012"/>
-            <a:ext cx="1444752" cy="233172"/>
+            <a:off x="7159752" y="2342692"/>
+            <a:ext cx="1444752" cy="193852"/>
           </a:xfrm>
           <a:prstGeom prst="rect">
             <a:avLst/>
@@ -15131,7 +15972,7 @@
               </a:spcAft>
             </a:pPr>
             <a:r>
-              <a:rPr sz="1050" b="0" i="0">
+              <a:rPr sz="1000" b="0" i="0">
                 <a:solidFill>
                   <a:srgbClr val="333840"/>
                 </a:solidFill>
@@ -15150,8 +15991,8 @@
         </p:nvSpPr>
         <p:spPr>
           <a:xfrm>
-            <a:off x="8641080" y="2382012"/>
-            <a:ext cx="1828800" cy="233172"/>
+            <a:off x="8641080" y="2342692"/>
+            <a:ext cx="1828800" cy="193852"/>
           </a:xfrm>
           <a:prstGeom prst="rect">
             <a:avLst/>
@@ -15194,8 +16035,8 @@
         </p:nvSpPr>
         <p:spPr>
           <a:xfrm>
-            <a:off x="8714232" y="2382012"/>
-            <a:ext cx="1719072" cy="233172"/>
+            <a:off x="8714232" y="2342692"/>
+            <a:ext cx="1719072" cy="193852"/>
           </a:xfrm>
           <a:prstGeom prst="rect">
             <a:avLst/>
@@ -15217,7 +16058,7 @@
               </a:spcAft>
             </a:pPr>
             <a:r>
-              <a:rPr sz="1050" b="0" i="0">
+              <a:rPr sz="1000" b="0" i="0">
                 <a:solidFill>
                   <a:srgbClr val="333840"/>
                 </a:solidFill>
@@ -15236,8 +16077,8 @@
         </p:nvSpPr>
         <p:spPr>
           <a:xfrm>
-            <a:off x="685800" y="2615184"/>
-            <a:ext cx="3017520" cy="233172"/>
+            <a:off x="685800" y="2536544"/>
+            <a:ext cx="3017520" cy="193852"/>
           </a:xfrm>
           <a:prstGeom prst="rect">
             <a:avLst/>
@@ -15280,8 +16121,8 @@
         </p:nvSpPr>
         <p:spPr>
           <a:xfrm>
-            <a:off x="758952" y="2615184"/>
-            <a:ext cx="2907792" cy="233172"/>
+            <a:off x="758952" y="2536544"/>
+            <a:ext cx="2907792" cy="193852"/>
           </a:xfrm>
           <a:prstGeom prst="rect">
             <a:avLst/>
@@ -15303,7 +16144,7 @@
               </a:spcAft>
             </a:pPr>
             <a:r>
-              <a:rPr sz="1050" b="1" i="0">
+              <a:rPr sz="1000" b="1" i="0">
                 <a:solidFill>
                   <a:srgbClr val="1E334E"/>
                 </a:solidFill>
@@ -15322,8 +16163,8 @@
         </p:nvSpPr>
         <p:spPr>
           <a:xfrm>
-            <a:off x="3703320" y="2615184"/>
-            <a:ext cx="1828800" cy="233172"/>
+            <a:off x="3703320" y="2536544"/>
+            <a:ext cx="1828800" cy="193852"/>
           </a:xfrm>
           <a:prstGeom prst="rect">
             <a:avLst/>
@@ -15366,8 +16207,8 @@
         </p:nvSpPr>
         <p:spPr>
           <a:xfrm>
-            <a:off x="3776472" y="2615184"/>
-            <a:ext cx="1719072" cy="233172"/>
+            <a:off x="3776472" y="2536544"/>
+            <a:ext cx="1719072" cy="193852"/>
           </a:xfrm>
           <a:prstGeom prst="rect">
             <a:avLst/>
@@ -15389,7 +16230,7 @@
               </a:spcAft>
             </a:pPr>
             <a:r>
-              <a:rPr sz="1050" b="0" i="0">
+              <a:rPr sz="1000" b="0" i="0">
                 <a:solidFill>
                   <a:srgbClr val="333840"/>
                 </a:solidFill>
@@ -15408,8 +16249,8 @@
         </p:nvSpPr>
         <p:spPr>
           <a:xfrm>
-            <a:off x="5532120" y="2615184"/>
-            <a:ext cx="1554480" cy="233172"/>
+            <a:off x="5532120" y="2536544"/>
+            <a:ext cx="1554480" cy="193852"/>
           </a:xfrm>
           <a:prstGeom prst="rect">
             <a:avLst/>
@@ -15452,8 +16293,8 @@
         </p:nvSpPr>
         <p:spPr>
           <a:xfrm>
-            <a:off x="5605272" y="2615184"/>
-            <a:ext cx="1444752" cy="233172"/>
+            <a:off x="5605272" y="2536544"/>
+            <a:ext cx="1444752" cy="193852"/>
           </a:xfrm>
           <a:prstGeom prst="rect">
             <a:avLst/>
@@ -15475,7 +16316,7 @@
               </a:spcAft>
             </a:pPr>
             <a:r>
-              <a:rPr sz="1050" b="0" i="0">
+              <a:rPr sz="1000" b="0" i="0">
                 <a:solidFill>
                   <a:srgbClr val="333840"/>
                 </a:solidFill>
@@ -15494,8 +16335,8 @@
         </p:nvSpPr>
         <p:spPr>
           <a:xfrm>
-            <a:off x="7086600" y="2615184"/>
-            <a:ext cx="1554480" cy="233172"/>
+            <a:off x="7086600" y="2536544"/>
+            <a:ext cx="1554480" cy="193852"/>
           </a:xfrm>
           <a:prstGeom prst="rect">
             <a:avLst/>
@@ -15538,8 +16379,8 @@
         </p:nvSpPr>
         <p:spPr>
           <a:xfrm>
-            <a:off x="7159752" y="2615184"/>
-            <a:ext cx="1444752" cy="233172"/>
+            <a:off x="7159752" y="2536544"/>
+            <a:ext cx="1444752" cy="193852"/>
           </a:xfrm>
           <a:prstGeom prst="rect">
             <a:avLst/>
@@ -15561,7 +16402,7 @@
               </a:spcAft>
             </a:pPr>
             <a:r>
-              <a:rPr sz="1050" b="0" i="0">
+              <a:rPr sz="1000" b="0" i="0">
                 <a:solidFill>
                   <a:srgbClr val="333840"/>
                 </a:solidFill>
@@ -15580,8 +16421,8 @@
         </p:nvSpPr>
         <p:spPr>
           <a:xfrm>
-            <a:off x="8641080" y="2615184"/>
-            <a:ext cx="1828800" cy="233172"/>
+            <a:off x="8641080" y="2536544"/>
+            <a:ext cx="1828800" cy="193852"/>
           </a:xfrm>
           <a:prstGeom prst="rect">
             <a:avLst/>
@@ -15624,8 +16465,8 @@
         </p:nvSpPr>
         <p:spPr>
           <a:xfrm>
-            <a:off x="8714232" y="2615184"/>
-            <a:ext cx="1719072" cy="233172"/>
+            <a:off x="8714232" y="2536544"/>
+            <a:ext cx="1719072" cy="193852"/>
           </a:xfrm>
           <a:prstGeom prst="rect">
             <a:avLst/>
@@ -15647,7 +16488,7 @@
               </a:spcAft>
             </a:pPr>
             <a:r>
-              <a:rPr sz="1050" b="0" i="0">
+              <a:rPr sz="1000" b="0" i="0">
                 <a:solidFill>
                   <a:srgbClr val="333840"/>
                 </a:solidFill>
@@ -15666,8 +16507,8 @@
         </p:nvSpPr>
         <p:spPr>
           <a:xfrm>
-            <a:off x="685800" y="2848356"/>
-            <a:ext cx="3017520" cy="233172"/>
+            <a:off x="685800" y="2730396"/>
+            <a:ext cx="3017520" cy="193852"/>
           </a:xfrm>
           <a:prstGeom prst="rect">
             <a:avLst/>
@@ -15710,8 +16551,8 @@
         </p:nvSpPr>
         <p:spPr>
           <a:xfrm>
-            <a:off x="758952" y="2848356"/>
-            <a:ext cx="2907792" cy="233172"/>
+            <a:off x="758952" y="2730396"/>
+            <a:ext cx="2907792" cy="193852"/>
           </a:xfrm>
           <a:prstGeom prst="rect">
             <a:avLst/>
@@ -15733,7 +16574,7 @@
               </a:spcAft>
             </a:pPr>
             <a:r>
-              <a:rPr sz="1050" b="1" i="0">
+              <a:rPr sz="1000" b="1" i="0">
                 <a:solidFill>
                   <a:srgbClr val="1E334E"/>
                 </a:solidFill>
@@ -15752,8 +16593,8 @@
         </p:nvSpPr>
         <p:spPr>
           <a:xfrm>
-            <a:off x="3703320" y="2848356"/>
-            <a:ext cx="1828800" cy="233172"/>
+            <a:off x="3703320" y="2730396"/>
+            <a:ext cx="1828800" cy="193852"/>
           </a:xfrm>
           <a:prstGeom prst="rect">
             <a:avLst/>
@@ -15796,8 +16637,8 @@
         </p:nvSpPr>
         <p:spPr>
           <a:xfrm>
-            <a:off x="3776472" y="2848356"/>
-            <a:ext cx="1719072" cy="233172"/>
+            <a:off x="3776472" y="2730396"/>
+            <a:ext cx="1719072" cy="193852"/>
           </a:xfrm>
           <a:prstGeom prst="rect">
             <a:avLst/>
@@ -15819,7 +16660,7 @@
               </a:spcAft>
             </a:pPr>
             <a:r>
-              <a:rPr sz="1050" b="0" i="0">
+              <a:rPr sz="1000" b="0" i="0">
                 <a:solidFill>
                   <a:srgbClr val="333840"/>
                 </a:solidFill>
@@ -15838,8 +16679,8 @@
         </p:nvSpPr>
         <p:spPr>
           <a:xfrm>
-            <a:off x="5532120" y="2848356"/>
-            <a:ext cx="1554480" cy="233172"/>
+            <a:off x="5532120" y="2730396"/>
+            <a:ext cx="1554480" cy="193852"/>
           </a:xfrm>
           <a:prstGeom prst="rect">
             <a:avLst/>
@@ -15882,8 +16723,8 @@
         </p:nvSpPr>
         <p:spPr>
           <a:xfrm>
-            <a:off x="5605272" y="2848356"/>
-            <a:ext cx="1444752" cy="233172"/>
+            <a:off x="5605272" y="2730396"/>
+            <a:ext cx="1444752" cy="193852"/>
           </a:xfrm>
           <a:prstGeom prst="rect">
             <a:avLst/>
@@ -15905,7 +16746,7 @@
               </a:spcAft>
             </a:pPr>
             <a:r>
-              <a:rPr sz="1050" b="0" i="0">
+              <a:rPr sz="1000" b="0" i="0">
                 <a:solidFill>
                   <a:srgbClr val="333840"/>
                 </a:solidFill>
@@ -15924,8 +16765,8 @@
         </p:nvSpPr>
         <p:spPr>
           <a:xfrm>
-            <a:off x="7086600" y="2848356"/>
-            <a:ext cx="1554480" cy="233172"/>
+            <a:off x="7086600" y="2730396"/>
+            <a:ext cx="1554480" cy="193852"/>
           </a:xfrm>
           <a:prstGeom prst="rect">
             <a:avLst/>
@@ -15968,8 +16809,8 @@
         </p:nvSpPr>
         <p:spPr>
           <a:xfrm>
-            <a:off x="7159752" y="2848356"/>
-            <a:ext cx="1444752" cy="233172"/>
+            <a:off x="7159752" y="2730396"/>
+            <a:ext cx="1444752" cy="193852"/>
           </a:xfrm>
           <a:prstGeom prst="rect">
             <a:avLst/>
@@ -15991,7 +16832,7 @@
               </a:spcAft>
             </a:pPr>
             <a:r>
-              <a:rPr sz="1050" b="0" i="0">
+              <a:rPr sz="1000" b="0" i="0">
                 <a:solidFill>
                   <a:srgbClr val="333840"/>
                 </a:solidFill>
@@ -16010,8 +16851,8 @@
         </p:nvSpPr>
         <p:spPr>
           <a:xfrm>
-            <a:off x="8641080" y="2848356"/>
-            <a:ext cx="1828800" cy="233172"/>
+            <a:off x="8641080" y="2730396"/>
+            <a:ext cx="1828800" cy="193852"/>
           </a:xfrm>
           <a:prstGeom prst="rect">
             <a:avLst/>
@@ -16054,8 +16895,8 @@
         </p:nvSpPr>
         <p:spPr>
           <a:xfrm>
-            <a:off x="8714232" y="2848356"/>
-            <a:ext cx="1719072" cy="233172"/>
+            <a:off x="8714232" y="2730396"/>
+            <a:ext cx="1719072" cy="193852"/>
           </a:xfrm>
           <a:prstGeom prst="rect">
             <a:avLst/>
@@ -16077,7 +16918,7 @@
               </a:spcAft>
             </a:pPr>
             <a:r>
-              <a:rPr sz="1050" b="0" i="0">
+              <a:rPr sz="1000" b="0" i="0">
                 <a:solidFill>
                   <a:srgbClr val="333840"/>
                 </a:solidFill>
@@ -16096,8 +16937,8 @@
         </p:nvSpPr>
         <p:spPr>
           <a:xfrm>
-            <a:off x="685800" y="3081528"/>
-            <a:ext cx="3017520" cy="233172"/>
+            <a:off x="685800" y="2924248"/>
+            <a:ext cx="3017520" cy="193852"/>
           </a:xfrm>
           <a:prstGeom prst="rect">
             <a:avLst/>
@@ -16140,8 +16981,8 @@
         </p:nvSpPr>
         <p:spPr>
           <a:xfrm>
-            <a:off x="758952" y="3081528"/>
-            <a:ext cx="2907792" cy="233172"/>
+            <a:off x="758952" y="2924248"/>
+            <a:ext cx="2907792" cy="193852"/>
           </a:xfrm>
           <a:prstGeom prst="rect">
             <a:avLst/>
@@ -16163,7 +17004,7 @@
               </a:spcAft>
             </a:pPr>
             <a:r>
-              <a:rPr sz="1050" b="1" i="0">
+              <a:rPr sz="1000" b="1" i="0">
                 <a:solidFill>
                   <a:srgbClr val="1E334E"/>
                 </a:solidFill>
@@ -16182,8 +17023,8 @@
         </p:nvSpPr>
         <p:spPr>
           <a:xfrm>
-            <a:off x="3703320" y="3081528"/>
-            <a:ext cx="1828800" cy="233172"/>
+            <a:off x="3703320" y="2924248"/>
+            <a:ext cx="1828800" cy="193852"/>
           </a:xfrm>
           <a:prstGeom prst="rect">
             <a:avLst/>
@@ -16226,8 +17067,8 @@
         </p:nvSpPr>
         <p:spPr>
           <a:xfrm>
-            <a:off x="3776472" y="3081528"/>
-            <a:ext cx="1719072" cy="233172"/>
+            <a:off x="3776472" y="2924248"/>
+            <a:ext cx="1719072" cy="193852"/>
           </a:xfrm>
           <a:prstGeom prst="rect">
             <a:avLst/>
@@ -16249,7 +17090,7 @@
               </a:spcAft>
             </a:pPr>
             <a:r>
-              <a:rPr sz="1050" b="0" i="0">
+              <a:rPr sz="1000" b="0" i="0">
                 <a:solidFill>
                   <a:srgbClr val="333840"/>
                 </a:solidFill>
@@ -16268,8 +17109,8 @@
         </p:nvSpPr>
         <p:spPr>
           <a:xfrm>
-            <a:off x="5532120" y="3081528"/>
-            <a:ext cx="1554480" cy="233172"/>
+            <a:off x="5532120" y="2924248"/>
+            <a:ext cx="1554480" cy="193852"/>
           </a:xfrm>
           <a:prstGeom prst="rect">
             <a:avLst/>
@@ -16312,8 +17153,8 @@
         </p:nvSpPr>
         <p:spPr>
           <a:xfrm>
-            <a:off x="5605272" y="3081528"/>
-            <a:ext cx="1444752" cy="233172"/>
+            <a:off x="5605272" y="2924248"/>
+            <a:ext cx="1444752" cy="193852"/>
           </a:xfrm>
           <a:prstGeom prst="rect">
             <a:avLst/>
@@ -16335,7 +17176,7 @@
               </a:spcAft>
             </a:pPr>
             <a:r>
-              <a:rPr sz="1050" b="0" i="0">
+              <a:rPr sz="1000" b="0" i="0">
                 <a:solidFill>
                   <a:srgbClr val="333840"/>
                 </a:solidFill>
@@ -16354,8 +17195,8 @@
         </p:nvSpPr>
         <p:spPr>
           <a:xfrm>
-            <a:off x="7086600" y="3081528"/>
-            <a:ext cx="1554480" cy="233172"/>
+            <a:off x="7086600" y="2924248"/>
+            <a:ext cx="1554480" cy="193852"/>
           </a:xfrm>
           <a:prstGeom prst="rect">
             <a:avLst/>
@@ -16398,8 +17239,8 @@
         </p:nvSpPr>
         <p:spPr>
           <a:xfrm>
-            <a:off x="7159752" y="3081528"/>
-            <a:ext cx="1444752" cy="233172"/>
+            <a:off x="7159752" y="2924248"/>
+            <a:ext cx="1444752" cy="193852"/>
           </a:xfrm>
           <a:prstGeom prst="rect">
             <a:avLst/>
@@ -16421,7 +17262,7 @@
               </a:spcAft>
             </a:pPr>
             <a:r>
-              <a:rPr sz="1050" b="0" i="0">
+              <a:rPr sz="1000" b="0" i="0">
                 <a:solidFill>
                   <a:srgbClr val="333840"/>
                 </a:solidFill>
@@ -16440,8 +17281,8 @@
         </p:nvSpPr>
         <p:spPr>
           <a:xfrm>
-            <a:off x="8641080" y="3081528"/>
-            <a:ext cx="1828800" cy="233172"/>
+            <a:off x="8641080" y="2924248"/>
+            <a:ext cx="1828800" cy="193852"/>
           </a:xfrm>
           <a:prstGeom prst="rect">
             <a:avLst/>
@@ -16484,8 +17325,8 @@
         </p:nvSpPr>
         <p:spPr>
           <a:xfrm>
-            <a:off x="8714232" y="3081528"/>
-            <a:ext cx="1719072" cy="233172"/>
+            <a:off x="8714232" y="2924248"/>
+            <a:ext cx="1719072" cy="193852"/>
           </a:xfrm>
           <a:prstGeom prst="rect">
             <a:avLst/>
@@ -16507,7 +17348,7 @@
               </a:spcAft>
             </a:pPr>
             <a:r>
-              <a:rPr sz="1050" b="0" i="0">
+              <a:rPr sz="1000" b="0" i="0">
                 <a:solidFill>
                   <a:srgbClr val="333840"/>
                 </a:solidFill>
@@ -16526,8 +17367,8 @@
         </p:nvSpPr>
         <p:spPr>
           <a:xfrm>
-            <a:off x="685800" y="3314700"/>
-            <a:ext cx="3017520" cy="233172"/>
+            <a:off x="685800" y="3118100"/>
+            <a:ext cx="3017520" cy="193852"/>
           </a:xfrm>
           <a:prstGeom prst="rect">
             <a:avLst/>
@@ -16570,8 +17411,8 @@
         </p:nvSpPr>
         <p:spPr>
           <a:xfrm>
-            <a:off x="758952" y="3314700"/>
-            <a:ext cx="2907792" cy="233172"/>
+            <a:off x="758952" y="3118100"/>
+            <a:ext cx="2907792" cy="193852"/>
           </a:xfrm>
           <a:prstGeom prst="rect">
             <a:avLst/>
@@ -16593,7 +17434,7 @@
               </a:spcAft>
             </a:pPr>
             <a:r>
-              <a:rPr sz="1050" b="1" i="0">
+              <a:rPr sz="1000" b="1" i="0">
                 <a:solidFill>
                   <a:srgbClr val="1E334E"/>
                 </a:solidFill>
@@ -16612,8 +17453,8 @@
         </p:nvSpPr>
         <p:spPr>
           <a:xfrm>
-            <a:off x="3703320" y="3314700"/>
-            <a:ext cx="1828800" cy="233172"/>
+            <a:off x="3703320" y="3118100"/>
+            <a:ext cx="1828800" cy="193852"/>
           </a:xfrm>
           <a:prstGeom prst="rect">
             <a:avLst/>
@@ -16656,8 +17497,8 @@
         </p:nvSpPr>
         <p:spPr>
           <a:xfrm>
-            <a:off x="3776472" y="3314700"/>
-            <a:ext cx="1719072" cy="233172"/>
+            <a:off x="3776472" y="3118100"/>
+            <a:ext cx="1719072" cy="193852"/>
           </a:xfrm>
           <a:prstGeom prst="rect">
             <a:avLst/>
@@ -16679,7 +17520,7 @@
               </a:spcAft>
             </a:pPr>
             <a:r>
-              <a:rPr sz="1050" b="0" i="0">
+              <a:rPr sz="1000" b="0" i="0">
                 <a:solidFill>
                   <a:srgbClr val="333840"/>
                 </a:solidFill>
@@ -16698,8 +17539,8 @@
         </p:nvSpPr>
         <p:spPr>
           <a:xfrm>
-            <a:off x="5532120" y="3314700"/>
-            <a:ext cx="1554480" cy="233172"/>
+            <a:off x="5532120" y="3118100"/>
+            <a:ext cx="1554480" cy="193852"/>
           </a:xfrm>
           <a:prstGeom prst="rect">
             <a:avLst/>
@@ -16742,8 +17583,8 @@
         </p:nvSpPr>
         <p:spPr>
           <a:xfrm>
-            <a:off x="5605272" y="3314700"/>
-            <a:ext cx="1444752" cy="233172"/>
+            <a:off x="5605272" y="3118100"/>
+            <a:ext cx="1444752" cy="193852"/>
           </a:xfrm>
           <a:prstGeom prst="rect">
             <a:avLst/>
@@ -16765,7 +17606,7 @@
               </a:spcAft>
             </a:pPr>
             <a:r>
-              <a:rPr sz="1050" b="0" i="0">
+              <a:rPr sz="1000" b="0" i="0">
                 <a:solidFill>
                   <a:srgbClr val="333840"/>
                 </a:solidFill>
@@ -16784,8 +17625,8 @@
         </p:nvSpPr>
         <p:spPr>
           <a:xfrm>
-            <a:off x="7086600" y="3314700"/>
-            <a:ext cx="1554480" cy="233172"/>
+            <a:off x="7086600" y="3118100"/>
+            <a:ext cx="1554480" cy="193852"/>
           </a:xfrm>
           <a:prstGeom prst="rect">
             <a:avLst/>
@@ -16828,8 +17669,8 @@
         </p:nvSpPr>
         <p:spPr>
           <a:xfrm>
-            <a:off x="7159752" y="3314700"/>
-            <a:ext cx="1444752" cy="233172"/>
+            <a:off x="7159752" y="3118100"/>
+            <a:ext cx="1444752" cy="193852"/>
           </a:xfrm>
           <a:prstGeom prst="rect">
             <a:avLst/>
@@ -16851,7 +17692,7 @@
               </a:spcAft>
             </a:pPr>
             <a:r>
-              <a:rPr sz="1050" b="0" i="0">
+              <a:rPr sz="1000" b="0" i="0">
                 <a:solidFill>
                   <a:srgbClr val="333840"/>
                 </a:solidFill>
@@ -16870,8 +17711,8 @@
         </p:nvSpPr>
         <p:spPr>
           <a:xfrm>
-            <a:off x="8641080" y="3314700"/>
-            <a:ext cx="1828800" cy="233172"/>
+            <a:off x="8641080" y="3118100"/>
+            <a:ext cx="1828800" cy="193852"/>
           </a:xfrm>
           <a:prstGeom prst="rect">
             <a:avLst/>
@@ -16914,8 +17755,8 @@
         </p:nvSpPr>
         <p:spPr>
           <a:xfrm>
-            <a:off x="8714232" y="3314700"/>
-            <a:ext cx="1719072" cy="233172"/>
+            <a:off x="8714232" y="3118100"/>
+            <a:ext cx="1719072" cy="193852"/>
           </a:xfrm>
           <a:prstGeom prst="rect">
             <a:avLst/>
@@ -16937,7 +17778,7 @@
               </a:spcAft>
             </a:pPr>
             <a:r>
-              <a:rPr sz="1050" b="0" i="0">
+              <a:rPr sz="1000" b="0" i="0">
                 <a:solidFill>
                   <a:srgbClr val="333840"/>
                 </a:solidFill>
@@ -16956,8 +17797,8 @@
         </p:nvSpPr>
         <p:spPr>
           <a:xfrm>
-            <a:off x="685800" y="3547872"/>
-            <a:ext cx="3017520" cy="233172"/>
+            <a:off x="685800" y="3311952"/>
+            <a:ext cx="3017520" cy="193852"/>
           </a:xfrm>
           <a:prstGeom prst="rect">
             <a:avLst/>
@@ -17000,8 +17841,8 @@
         </p:nvSpPr>
         <p:spPr>
           <a:xfrm>
-            <a:off x="758952" y="3547872"/>
-            <a:ext cx="2907792" cy="233172"/>
+            <a:off x="758952" y="3311952"/>
+            <a:ext cx="2907792" cy="193852"/>
           </a:xfrm>
           <a:prstGeom prst="rect">
             <a:avLst/>
@@ -17023,7 +17864,7 @@
               </a:spcAft>
             </a:pPr>
             <a:r>
-              <a:rPr sz="1050" b="1" i="0">
+              <a:rPr sz="1000" b="1" i="0">
                 <a:solidFill>
                   <a:srgbClr val="1E334E"/>
                 </a:solidFill>
@@ -17042,8 +17883,8 @@
         </p:nvSpPr>
         <p:spPr>
           <a:xfrm>
-            <a:off x="3703320" y="3547872"/>
-            <a:ext cx="1828800" cy="233172"/>
+            <a:off x="3703320" y="3311952"/>
+            <a:ext cx="1828800" cy="193852"/>
           </a:xfrm>
           <a:prstGeom prst="rect">
             <a:avLst/>
@@ -17086,8 +17927,8 @@
         </p:nvSpPr>
         <p:spPr>
           <a:xfrm>
-            <a:off x="3776472" y="3547872"/>
-            <a:ext cx="1719072" cy="233172"/>
+            <a:off x="3776472" y="3311952"/>
+            <a:ext cx="1719072" cy="193852"/>
           </a:xfrm>
           <a:prstGeom prst="rect">
             <a:avLst/>
@@ -17109,7 +17950,7 @@
               </a:spcAft>
             </a:pPr>
             <a:r>
-              <a:rPr sz="1050" b="0" i="0">
+              <a:rPr sz="1000" b="0" i="0">
                 <a:solidFill>
                   <a:srgbClr val="333840"/>
                 </a:solidFill>
@@ -17128,8 +17969,8 @@
         </p:nvSpPr>
         <p:spPr>
           <a:xfrm>
-            <a:off x="5532120" y="3547872"/>
-            <a:ext cx="1554480" cy="233172"/>
+            <a:off x="5532120" y="3311952"/>
+            <a:ext cx="1554480" cy="193852"/>
           </a:xfrm>
           <a:prstGeom prst="rect">
             <a:avLst/>
@@ -17172,8 +18013,8 @@
         </p:nvSpPr>
         <p:spPr>
           <a:xfrm>
-            <a:off x="5605272" y="3547872"/>
-            <a:ext cx="1444752" cy="233172"/>
+            <a:off x="5605272" y="3311952"/>
+            <a:ext cx="1444752" cy="193852"/>
           </a:xfrm>
           <a:prstGeom prst="rect">
             <a:avLst/>
@@ -17195,7 +18036,7 @@
               </a:spcAft>
             </a:pPr>
             <a:r>
-              <a:rPr sz="1050" b="0" i="0">
+              <a:rPr sz="1000" b="0" i="0">
                 <a:solidFill>
                   <a:srgbClr val="333840"/>
                 </a:solidFill>
@@ -17214,8 +18055,8 @@
         </p:nvSpPr>
         <p:spPr>
           <a:xfrm>
-            <a:off x="7086600" y="3547872"/>
-            <a:ext cx="1554480" cy="233172"/>
+            <a:off x="7086600" y="3311952"/>
+            <a:ext cx="1554480" cy="193852"/>
           </a:xfrm>
           <a:prstGeom prst="rect">
             <a:avLst/>
@@ -17258,8 +18099,8 @@
         </p:nvSpPr>
         <p:spPr>
           <a:xfrm>
-            <a:off x="7159752" y="3547872"/>
-            <a:ext cx="1444752" cy="233172"/>
+            <a:off x="7159752" y="3311952"/>
+            <a:ext cx="1444752" cy="193852"/>
           </a:xfrm>
           <a:prstGeom prst="rect">
             <a:avLst/>
@@ -17281,7 +18122,7 @@
               </a:spcAft>
             </a:pPr>
             <a:r>
-              <a:rPr sz="1050" b="0" i="0">
+              <a:rPr sz="1000" b="0" i="0">
                 <a:solidFill>
                   <a:srgbClr val="333840"/>
                 </a:solidFill>
@@ -17300,8 +18141,8 @@
         </p:nvSpPr>
         <p:spPr>
           <a:xfrm>
-            <a:off x="8641080" y="3547872"/>
-            <a:ext cx="1828800" cy="233172"/>
+            <a:off x="8641080" y="3311952"/>
+            <a:ext cx="1828800" cy="193852"/>
           </a:xfrm>
           <a:prstGeom prst="rect">
             <a:avLst/>
@@ -17344,8 +18185,8 @@
         </p:nvSpPr>
         <p:spPr>
           <a:xfrm>
-            <a:off x="8714232" y="3547872"/>
-            <a:ext cx="1719072" cy="233172"/>
+            <a:off x="8714232" y="3311952"/>
+            <a:ext cx="1719072" cy="193852"/>
           </a:xfrm>
           <a:prstGeom prst="rect">
             <a:avLst/>
@@ -17367,7 +18208,7 @@
               </a:spcAft>
             </a:pPr>
             <a:r>
-              <a:rPr sz="1050" b="0" i="0">
+              <a:rPr sz="1000" b="0" i="0">
                 <a:solidFill>
                   <a:srgbClr val="333840"/>
                 </a:solidFill>
@@ -17386,8 +18227,8 @@
         </p:nvSpPr>
         <p:spPr>
           <a:xfrm>
-            <a:off x="685800" y="3781044"/>
-            <a:ext cx="3017520" cy="233172"/>
+            <a:off x="685800" y="3505804"/>
+            <a:ext cx="3017520" cy="193852"/>
           </a:xfrm>
           <a:prstGeom prst="rect">
             <a:avLst/>
@@ -17430,8 +18271,8 @@
         </p:nvSpPr>
         <p:spPr>
           <a:xfrm>
-            <a:off x="758952" y="3781044"/>
-            <a:ext cx="2907792" cy="233172"/>
+            <a:off x="758952" y="3505804"/>
+            <a:ext cx="2907792" cy="193852"/>
           </a:xfrm>
           <a:prstGeom prst="rect">
             <a:avLst/>
@@ -17453,7 +18294,7 @@
               </a:spcAft>
             </a:pPr>
             <a:r>
-              <a:rPr sz="1050" b="1" i="0">
+              <a:rPr sz="1000" b="1" i="0">
                 <a:solidFill>
                   <a:srgbClr val="1E334E"/>
                 </a:solidFill>
@@ -17472,8 +18313,8 @@
         </p:nvSpPr>
         <p:spPr>
           <a:xfrm>
-            <a:off x="3703320" y="3781044"/>
-            <a:ext cx="1828800" cy="233172"/>
+            <a:off x="3703320" y="3505804"/>
+            <a:ext cx="1828800" cy="193852"/>
           </a:xfrm>
           <a:prstGeom prst="rect">
             <a:avLst/>
@@ -17516,8 +18357,8 @@
         </p:nvSpPr>
         <p:spPr>
           <a:xfrm>
-            <a:off x="3776472" y="3781044"/>
-            <a:ext cx="1719072" cy="233172"/>
+            <a:off x="3776472" y="3505804"/>
+            <a:ext cx="1719072" cy="193852"/>
           </a:xfrm>
           <a:prstGeom prst="rect">
             <a:avLst/>
@@ -17539,7 +18380,7 @@
               </a:spcAft>
             </a:pPr>
             <a:r>
-              <a:rPr sz="1050" b="0" i="0">
+              <a:rPr sz="1000" b="0" i="0">
                 <a:solidFill>
                   <a:srgbClr val="333840"/>
                 </a:solidFill>
@@ -17558,8 +18399,8 @@
         </p:nvSpPr>
         <p:spPr>
           <a:xfrm>
-            <a:off x="5532120" y="3781044"/>
-            <a:ext cx="1554480" cy="233172"/>
+            <a:off x="5532120" y="3505804"/>
+            <a:ext cx="1554480" cy="193852"/>
           </a:xfrm>
           <a:prstGeom prst="rect">
             <a:avLst/>
@@ -17602,8 +18443,8 @@
         </p:nvSpPr>
         <p:spPr>
           <a:xfrm>
-            <a:off x="5605272" y="3781044"/>
-            <a:ext cx="1444752" cy="233172"/>
+            <a:off x="5605272" y="3505804"/>
+            <a:ext cx="1444752" cy="193852"/>
           </a:xfrm>
           <a:prstGeom prst="rect">
             <a:avLst/>
@@ -17625,7 +18466,7 @@
               </a:spcAft>
             </a:pPr>
             <a:r>
-              <a:rPr sz="1050" b="0" i="0">
+              <a:rPr sz="1000" b="0" i="0">
                 <a:solidFill>
                   <a:srgbClr val="333840"/>
                 </a:solidFill>
@@ -17644,8 +18485,8 @@
         </p:nvSpPr>
         <p:spPr>
           <a:xfrm>
-            <a:off x="7086600" y="3781044"/>
-            <a:ext cx="1554480" cy="233172"/>
+            <a:off x="7086600" y="3505804"/>
+            <a:ext cx="1554480" cy="193852"/>
           </a:xfrm>
           <a:prstGeom prst="rect">
             <a:avLst/>
@@ -17688,8 +18529,8 @@
         </p:nvSpPr>
         <p:spPr>
           <a:xfrm>
-            <a:off x="7159752" y="3781044"/>
-            <a:ext cx="1444752" cy="233172"/>
+            <a:off x="7159752" y="3505804"/>
+            <a:ext cx="1444752" cy="193852"/>
           </a:xfrm>
           <a:prstGeom prst="rect">
             <a:avLst/>
@@ -17711,7 +18552,7 @@
               </a:spcAft>
             </a:pPr>
             <a:r>
-              <a:rPr sz="1050" b="0" i="0">
+              <a:rPr sz="1000" b="0" i="0">
                 <a:solidFill>
                   <a:srgbClr val="333840"/>
                 </a:solidFill>
@@ -17730,8 +18571,8 @@
         </p:nvSpPr>
         <p:spPr>
           <a:xfrm>
-            <a:off x="8641080" y="3781044"/>
-            <a:ext cx="1828800" cy="233172"/>
+            <a:off x="8641080" y="3505804"/>
+            <a:ext cx="1828800" cy="193852"/>
           </a:xfrm>
           <a:prstGeom prst="rect">
             <a:avLst/>
@@ -17774,8 +18615,8 @@
         </p:nvSpPr>
         <p:spPr>
           <a:xfrm>
-            <a:off x="8714232" y="3781044"/>
-            <a:ext cx="1719072" cy="233172"/>
+            <a:off x="8714232" y="3505804"/>
+            <a:ext cx="1719072" cy="193852"/>
           </a:xfrm>
           <a:prstGeom prst="rect">
             <a:avLst/>
@@ -17797,7 +18638,7 @@
               </a:spcAft>
             </a:pPr>
             <a:r>
-              <a:rPr sz="1050" b="0" i="0">
+              <a:rPr sz="1000" b="0" i="0">
                 <a:solidFill>
                   <a:srgbClr val="333840"/>
                 </a:solidFill>
@@ -17816,8 +18657,8 @@
         </p:nvSpPr>
         <p:spPr>
           <a:xfrm>
-            <a:off x="685800" y="4014216"/>
-            <a:ext cx="3017520" cy="233172"/>
+            <a:off x="685800" y="3699656"/>
+            <a:ext cx="3017520" cy="193852"/>
           </a:xfrm>
           <a:prstGeom prst="rect">
             <a:avLst/>
@@ -17860,8 +18701,8 @@
         </p:nvSpPr>
         <p:spPr>
           <a:xfrm>
-            <a:off x="758952" y="4014216"/>
-            <a:ext cx="2907792" cy="233172"/>
+            <a:off x="758952" y="3699656"/>
+            <a:ext cx="2907792" cy="193852"/>
           </a:xfrm>
           <a:prstGeom prst="rect">
             <a:avLst/>
@@ -17883,7 +18724,7 @@
               </a:spcAft>
             </a:pPr>
             <a:r>
-              <a:rPr sz="1050" b="1" i="0">
+              <a:rPr sz="1000" b="1" i="0">
                 <a:solidFill>
                   <a:srgbClr val="1E334E"/>
                 </a:solidFill>
@@ -17902,8 +18743,8 @@
         </p:nvSpPr>
         <p:spPr>
           <a:xfrm>
-            <a:off x="3703320" y="4014216"/>
-            <a:ext cx="1828800" cy="233172"/>
+            <a:off x="3703320" y="3699656"/>
+            <a:ext cx="1828800" cy="193852"/>
           </a:xfrm>
           <a:prstGeom prst="rect">
             <a:avLst/>
@@ -17946,8 +18787,8 @@
         </p:nvSpPr>
         <p:spPr>
           <a:xfrm>
-            <a:off x="3776472" y="4014216"/>
-            <a:ext cx="1719072" cy="233172"/>
+            <a:off x="3776472" y="3699656"/>
+            <a:ext cx="1719072" cy="193852"/>
           </a:xfrm>
           <a:prstGeom prst="rect">
             <a:avLst/>
@@ -17969,7 +18810,7 @@
               </a:spcAft>
             </a:pPr>
             <a:r>
-              <a:rPr sz="1050" b="0" i="0">
+              <a:rPr sz="1000" b="0" i="0">
                 <a:solidFill>
                   <a:srgbClr val="333840"/>
                 </a:solidFill>
@@ -17988,8 +18829,8 @@
         </p:nvSpPr>
         <p:spPr>
           <a:xfrm>
-            <a:off x="5532120" y="4014216"/>
-            <a:ext cx="1554480" cy="233172"/>
+            <a:off x="5532120" y="3699656"/>
+            <a:ext cx="1554480" cy="193852"/>
           </a:xfrm>
           <a:prstGeom prst="rect">
             <a:avLst/>
@@ -18032,8 +18873,8 @@
         </p:nvSpPr>
         <p:spPr>
           <a:xfrm>
-            <a:off x="5605272" y="4014216"/>
-            <a:ext cx="1444752" cy="233172"/>
+            <a:off x="5605272" y="3699656"/>
+            <a:ext cx="1444752" cy="193852"/>
           </a:xfrm>
           <a:prstGeom prst="rect">
             <a:avLst/>
@@ -18055,7 +18896,7 @@
               </a:spcAft>
             </a:pPr>
             <a:r>
-              <a:rPr sz="1050" b="0" i="0">
+              <a:rPr sz="1000" b="0" i="0">
                 <a:solidFill>
                   <a:srgbClr val="333840"/>
                 </a:solidFill>
@@ -18074,8 +18915,8 @@
         </p:nvSpPr>
         <p:spPr>
           <a:xfrm>
-            <a:off x="7086600" y="4014216"/>
-            <a:ext cx="1554480" cy="233172"/>
+            <a:off x="7086600" y="3699656"/>
+            <a:ext cx="1554480" cy="193852"/>
           </a:xfrm>
           <a:prstGeom prst="rect">
             <a:avLst/>
@@ -18118,8 +18959,8 @@
         </p:nvSpPr>
         <p:spPr>
           <a:xfrm>
-            <a:off x="7159752" y="4014216"/>
-            <a:ext cx="1444752" cy="233172"/>
+            <a:off x="7159752" y="3699656"/>
+            <a:ext cx="1444752" cy="193852"/>
           </a:xfrm>
           <a:prstGeom prst="rect">
             <a:avLst/>
@@ -18141,7 +18982,7 @@
               </a:spcAft>
             </a:pPr>
             <a:r>
-              <a:rPr sz="1050" b="0" i="0">
+              <a:rPr sz="1000" b="0" i="0">
                 <a:solidFill>
                   <a:srgbClr val="333840"/>
                 </a:solidFill>
@@ -18160,8 +19001,8 @@
         </p:nvSpPr>
         <p:spPr>
           <a:xfrm>
-            <a:off x="8641080" y="4014216"/>
-            <a:ext cx="1828800" cy="233172"/>
+            <a:off x="8641080" y="3699656"/>
+            <a:ext cx="1828800" cy="193852"/>
           </a:xfrm>
           <a:prstGeom prst="rect">
             <a:avLst/>
@@ -18204,8 +19045,8 @@
         </p:nvSpPr>
         <p:spPr>
           <a:xfrm>
-            <a:off x="8714232" y="4014216"/>
-            <a:ext cx="1719072" cy="233172"/>
+            <a:off x="8714232" y="3699656"/>
+            <a:ext cx="1719072" cy="193852"/>
           </a:xfrm>
           <a:prstGeom prst="rect">
             <a:avLst/>
@@ -18227,7 +19068,7 @@
               </a:spcAft>
             </a:pPr>
             <a:r>
-              <a:rPr sz="1050" b="0" i="0">
+              <a:rPr sz="1000" b="0" i="0">
                 <a:solidFill>
                   <a:srgbClr val="333840"/>
                 </a:solidFill>
@@ -18246,8 +19087,8 @@
         </p:nvSpPr>
         <p:spPr>
           <a:xfrm>
-            <a:off x="685800" y="4247388"/>
-            <a:ext cx="3017520" cy="233172"/>
+            <a:off x="685800" y="3893508"/>
+            <a:ext cx="3017520" cy="193852"/>
           </a:xfrm>
           <a:prstGeom prst="rect">
             <a:avLst/>
@@ -18290,8 +19131,8 @@
         </p:nvSpPr>
         <p:spPr>
           <a:xfrm>
-            <a:off x="758952" y="4247388"/>
-            <a:ext cx="2907792" cy="233172"/>
+            <a:off x="758952" y="3893508"/>
+            <a:ext cx="2907792" cy="193852"/>
           </a:xfrm>
           <a:prstGeom prst="rect">
             <a:avLst/>
@@ -18313,7 +19154,7 @@
               </a:spcAft>
             </a:pPr>
             <a:r>
-              <a:rPr sz="1050" b="1" i="0">
+              <a:rPr sz="1000" b="1" i="0">
                 <a:solidFill>
                   <a:srgbClr val="1E334E"/>
                 </a:solidFill>
@@ -18332,8 +19173,8 @@
         </p:nvSpPr>
         <p:spPr>
           <a:xfrm>
-            <a:off x="3703320" y="4247388"/>
-            <a:ext cx="1828800" cy="233172"/>
+            <a:off x="3703320" y="3893508"/>
+            <a:ext cx="1828800" cy="193852"/>
           </a:xfrm>
           <a:prstGeom prst="rect">
             <a:avLst/>
@@ -18376,8 +19217,8 @@
         </p:nvSpPr>
         <p:spPr>
           <a:xfrm>
-            <a:off x="3776472" y="4247388"/>
-            <a:ext cx="1719072" cy="233172"/>
+            <a:off x="3776472" y="3893508"/>
+            <a:ext cx="1719072" cy="193852"/>
           </a:xfrm>
           <a:prstGeom prst="rect">
             <a:avLst/>
@@ -18399,7 +19240,7 @@
               </a:spcAft>
             </a:pPr>
             <a:r>
-              <a:rPr sz="1050" b="0" i="0">
+              <a:rPr sz="1000" b="0" i="0">
                 <a:solidFill>
                   <a:srgbClr val="333840"/>
                 </a:solidFill>
@@ -18418,8 +19259,8 @@
         </p:nvSpPr>
         <p:spPr>
           <a:xfrm>
-            <a:off x="5532120" y="4247388"/>
-            <a:ext cx="1554480" cy="233172"/>
+            <a:off x="5532120" y="3893508"/>
+            <a:ext cx="1554480" cy="193852"/>
           </a:xfrm>
           <a:prstGeom prst="rect">
             <a:avLst/>
@@ -18462,8 +19303,8 @@
         </p:nvSpPr>
         <p:spPr>
           <a:xfrm>
-            <a:off x="5605272" y="4247388"/>
-            <a:ext cx="1444752" cy="233172"/>
+            <a:off x="5605272" y="3893508"/>
+            <a:ext cx="1444752" cy="193852"/>
           </a:xfrm>
           <a:prstGeom prst="rect">
             <a:avLst/>
@@ -18485,7 +19326,7 @@
               </a:spcAft>
             </a:pPr>
             <a:r>
-              <a:rPr sz="1050" b="0" i="0">
+              <a:rPr sz="1000" b="0" i="0">
                 <a:solidFill>
                   <a:srgbClr val="333840"/>
                 </a:solidFill>
@@ -18504,8 +19345,8 @@
         </p:nvSpPr>
         <p:spPr>
           <a:xfrm>
-            <a:off x="7086600" y="4247388"/>
-            <a:ext cx="1554480" cy="233172"/>
+            <a:off x="7086600" y="3893508"/>
+            <a:ext cx="1554480" cy="193852"/>
           </a:xfrm>
           <a:prstGeom prst="rect">
             <a:avLst/>
@@ -18548,8 +19389,8 @@
         </p:nvSpPr>
         <p:spPr>
           <a:xfrm>
-            <a:off x="7159752" y="4247388"/>
-            <a:ext cx="1444752" cy="233172"/>
+            <a:off x="7159752" y="3893508"/>
+            <a:ext cx="1444752" cy="193852"/>
           </a:xfrm>
           <a:prstGeom prst="rect">
             <a:avLst/>
@@ -18571,7 +19412,7 @@
               </a:spcAft>
             </a:pPr>
             <a:r>
-              <a:rPr sz="1050" b="0" i="0">
+              <a:rPr sz="1000" b="0" i="0">
                 <a:solidFill>
                   <a:srgbClr val="333840"/>
                 </a:solidFill>
@@ -18590,8 +19431,8 @@
         </p:nvSpPr>
         <p:spPr>
           <a:xfrm>
-            <a:off x="8641080" y="4247388"/>
-            <a:ext cx="1828800" cy="233172"/>
+            <a:off x="8641080" y="3893508"/>
+            <a:ext cx="1828800" cy="193852"/>
           </a:xfrm>
           <a:prstGeom prst="rect">
             <a:avLst/>
@@ -18634,8 +19475,8 @@
         </p:nvSpPr>
         <p:spPr>
           <a:xfrm>
-            <a:off x="8714232" y="4247388"/>
-            <a:ext cx="1719072" cy="233172"/>
+            <a:off x="8714232" y="3893508"/>
+            <a:ext cx="1719072" cy="193852"/>
           </a:xfrm>
           <a:prstGeom prst="rect">
             <a:avLst/>
@@ -18657,7 +19498,7 @@
               </a:spcAft>
             </a:pPr>
             <a:r>
-              <a:rPr sz="1050" b="0" i="0">
+              <a:rPr sz="1000" b="0" i="0">
                 <a:solidFill>
                   <a:srgbClr val="333840"/>
                 </a:solidFill>
@@ -18676,8 +19517,8 @@
         </p:nvSpPr>
         <p:spPr>
           <a:xfrm>
-            <a:off x="685800" y="4480560"/>
-            <a:ext cx="3017520" cy="233172"/>
+            <a:off x="685800" y="4087360"/>
+            <a:ext cx="3017520" cy="193852"/>
           </a:xfrm>
           <a:prstGeom prst="rect">
             <a:avLst/>
@@ -18720,8 +19561,8 @@
         </p:nvSpPr>
         <p:spPr>
           <a:xfrm>
-            <a:off x="758952" y="4480560"/>
-            <a:ext cx="2907792" cy="233172"/>
+            <a:off x="758952" y="4087360"/>
+            <a:ext cx="2907792" cy="193852"/>
           </a:xfrm>
           <a:prstGeom prst="rect">
             <a:avLst/>
@@ -18743,7 +19584,7 @@
               </a:spcAft>
             </a:pPr>
             <a:r>
-              <a:rPr sz="1050" b="1" i="0">
+              <a:rPr sz="1000" b="1" i="0">
                 <a:solidFill>
                   <a:srgbClr val="1E334E"/>
                 </a:solidFill>
@@ -18762,8 +19603,8 @@
         </p:nvSpPr>
         <p:spPr>
           <a:xfrm>
-            <a:off x="3703320" y="4480560"/>
-            <a:ext cx="1828800" cy="233172"/>
+            <a:off x="3703320" y="4087360"/>
+            <a:ext cx="1828800" cy="193852"/>
           </a:xfrm>
           <a:prstGeom prst="rect">
             <a:avLst/>
@@ -18806,8 +19647,8 @@
         </p:nvSpPr>
         <p:spPr>
           <a:xfrm>
-            <a:off x="3776472" y="4480560"/>
-            <a:ext cx="1719072" cy="233172"/>
+            <a:off x="3776472" y="4087360"/>
+            <a:ext cx="1719072" cy="193852"/>
           </a:xfrm>
           <a:prstGeom prst="rect">
             <a:avLst/>
@@ -18829,7 +19670,7 @@
               </a:spcAft>
             </a:pPr>
             <a:r>
-              <a:rPr sz="1050" b="0" i="0">
+              <a:rPr sz="1000" b="0" i="0">
                 <a:solidFill>
                   <a:srgbClr val="333840"/>
                 </a:solidFill>
@@ -18848,8 +19689,8 @@
         </p:nvSpPr>
         <p:spPr>
           <a:xfrm>
-            <a:off x="5532120" y="4480560"/>
-            <a:ext cx="1554480" cy="233172"/>
+            <a:off x="5532120" y="4087360"/>
+            <a:ext cx="1554480" cy="193852"/>
           </a:xfrm>
           <a:prstGeom prst="rect">
             <a:avLst/>
@@ -18892,8 +19733,8 @@
         </p:nvSpPr>
         <p:spPr>
           <a:xfrm>
-            <a:off x="5605272" y="4480560"/>
-            <a:ext cx="1444752" cy="233172"/>
+            <a:off x="5605272" y="4087360"/>
+            <a:ext cx="1444752" cy="193852"/>
           </a:xfrm>
           <a:prstGeom prst="rect">
             <a:avLst/>
@@ -18915,7 +19756,7 @@
               </a:spcAft>
             </a:pPr>
             <a:r>
-              <a:rPr sz="1050" b="0" i="0">
+              <a:rPr sz="1000" b="0" i="0">
                 <a:solidFill>
                   <a:srgbClr val="333840"/>
                 </a:solidFill>
@@ -18934,8 +19775,8 @@
         </p:nvSpPr>
         <p:spPr>
           <a:xfrm>
-            <a:off x="7086600" y="4480560"/>
-            <a:ext cx="1554480" cy="233172"/>
+            <a:off x="7086600" y="4087360"/>
+            <a:ext cx="1554480" cy="193852"/>
           </a:xfrm>
           <a:prstGeom prst="rect">
             <a:avLst/>
@@ -18978,8 +19819,8 @@
         </p:nvSpPr>
         <p:spPr>
           <a:xfrm>
-            <a:off x="7159752" y="4480560"/>
-            <a:ext cx="1444752" cy="233172"/>
+            <a:off x="7159752" y="4087360"/>
+            <a:ext cx="1444752" cy="193852"/>
           </a:xfrm>
           <a:prstGeom prst="rect">
             <a:avLst/>
@@ -19001,7 +19842,7 @@
               </a:spcAft>
             </a:pPr>
             <a:r>
-              <a:rPr sz="1050" b="0" i="0">
+              <a:rPr sz="1000" b="0" i="0">
                 <a:solidFill>
                   <a:srgbClr val="333840"/>
                 </a:solidFill>
@@ -19020,8 +19861,8 @@
         </p:nvSpPr>
         <p:spPr>
           <a:xfrm>
-            <a:off x="8641080" y="4480560"/>
-            <a:ext cx="1828800" cy="233172"/>
+            <a:off x="8641080" y="4087360"/>
+            <a:ext cx="1828800" cy="193852"/>
           </a:xfrm>
           <a:prstGeom prst="rect">
             <a:avLst/>
@@ -19064,8 +19905,8 @@
         </p:nvSpPr>
         <p:spPr>
           <a:xfrm>
-            <a:off x="8714232" y="4480560"/>
-            <a:ext cx="1719072" cy="233172"/>
+            <a:off x="8714232" y="4087360"/>
+            <a:ext cx="1719072" cy="193852"/>
           </a:xfrm>
           <a:prstGeom prst="rect">
             <a:avLst/>
@@ -19087,7 +19928,7 @@
               </a:spcAft>
             </a:pPr>
             <a:r>
-              <a:rPr sz="1050" b="0" i="0">
+              <a:rPr sz="1000" b="0" i="0">
                 <a:solidFill>
                   <a:srgbClr val="333840"/>
                 </a:solidFill>
@@ -19106,8 +19947,8 @@
         </p:nvSpPr>
         <p:spPr>
           <a:xfrm>
-            <a:off x="685800" y="4713732"/>
-            <a:ext cx="3017520" cy="233172"/>
+            <a:off x="685800" y="4281212"/>
+            <a:ext cx="3017520" cy="193852"/>
           </a:xfrm>
           <a:prstGeom prst="rect">
             <a:avLst/>
@@ -19150,8 +19991,8 @@
         </p:nvSpPr>
         <p:spPr>
           <a:xfrm>
-            <a:off x="758952" y="4713732"/>
-            <a:ext cx="2907792" cy="233172"/>
+            <a:off x="758952" y="4281212"/>
+            <a:ext cx="2907792" cy="193852"/>
           </a:xfrm>
           <a:prstGeom prst="rect">
             <a:avLst/>
@@ -19173,7 +20014,7 @@
               </a:spcAft>
             </a:pPr>
             <a:r>
-              <a:rPr sz="1050" b="1" i="0">
+              <a:rPr sz="1000" b="1" i="0">
                 <a:solidFill>
                   <a:srgbClr val="1E334E"/>
                 </a:solidFill>
@@ -19192,8 +20033,8 @@
         </p:nvSpPr>
         <p:spPr>
           <a:xfrm>
-            <a:off x="3703320" y="4713732"/>
-            <a:ext cx="1828800" cy="233172"/>
+            <a:off x="3703320" y="4281212"/>
+            <a:ext cx="1828800" cy="193852"/>
           </a:xfrm>
           <a:prstGeom prst="rect">
             <a:avLst/>
@@ -19236,8 +20077,8 @@
         </p:nvSpPr>
         <p:spPr>
           <a:xfrm>
-            <a:off x="3776472" y="4713732"/>
-            <a:ext cx="1719072" cy="233172"/>
+            <a:off x="3776472" y="4281212"/>
+            <a:ext cx="1719072" cy="193852"/>
           </a:xfrm>
           <a:prstGeom prst="rect">
             <a:avLst/>
@@ -19259,7 +20100,7 @@
               </a:spcAft>
             </a:pPr>
             <a:r>
-              <a:rPr sz="1050" b="0" i="0">
+              <a:rPr sz="1000" b="0" i="0">
                 <a:solidFill>
                   <a:srgbClr val="333840"/>
                 </a:solidFill>
@@ -19278,8 +20119,8 @@
         </p:nvSpPr>
         <p:spPr>
           <a:xfrm>
-            <a:off x="5532120" y="4713732"/>
-            <a:ext cx="1554480" cy="233172"/>
+            <a:off x="5532120" y="4281212"/>
+            <a:ext cx="1554480" cy="193852"/>
           </a:xfrm>
           <a:prstGeom prst="rect">
             <a:avLst/>
@@ -19322,8 +20163,8 @@
         </p:nvSpPr>
         <p:spPr>
           <a:xfrm>
-            <a:off x="5605272" y="4713732"/>
-            <a:ext cx="1444752" cy="233172"/>
+            <a:off x="5605272" y="4281212"/>
+            <a:ext cx="1444752" cy="193852"/>
           </a:xfrm>
           <a:prstGeom prst="rect">
             <a:avLst/>
@@ -19345,7 +20186,7 @@
               </a:spcAft>
             </a:pPr>
             <a:r>
-              <a:rPr sz="1050" b="0" i="0">
+              <a:rPr sz="1000" b="0" i="0">
                 <a:solidFill>
                   <a:srgbClr val="333840"/>
                 </a:solidFill>
@@ -19364,8 +20205,8 @@
         </p:nvSpPr>
         <p:spPr>
           <a:xfrm>
-            <a:off x="7086600" y="4713732"/>
-            <a:ext cx="1554480" cy="233172"/>
+            <a:off x="7086600" y="4281212"/>
+            <a:ext cx="1554480" cy="193852"/>
           </a:xfrm>
           <a:prstGeom prst="rect">
             <a:avLst/>
@@ -19408,8 +20249,8 @@
         </p:nvSpPr>
         <p:spPr>
           <a:xfrm>
-            <a:off x="7159752" y="4713732"/>
-            <a:ext cx="1444752" cy="233172"/>
+            <a:off x="7159752" y="4281212"/>
+            <a:ext cx="1444752" cy="193852"/>
           </a:xfrm>
           <a:prstGeom prst="rect">
             <a:avLst/>
@@ -19431,7 +20272,7 @@
               </a:spcAft>
             </a:pPr>
             <a:r>
-              <a:rPr sz="1050" b="0" i="0">
+              <a:rPr sz="1000" b="0" i="0">
                 <a:solidFill>
                   <a:srgbClr val="333840"/>
                 </a:solidFill>
@@ -19450,8 +20291,8 @@
         </p:nvSpPr>
         <p:spPr>
           <a:xfrm>
-            <a:off x="8641080" y="4713732"/>
-            <a:ext cx="1828800" cy="233172"/>
+            <a:off x="8641080" y="4281212"/>
+            <a:ext cx="1828800" cy="193852"/>
           </a:xfrm>
           <a:prstGeom prst="rect">
             <a:avLst/>
@@ -19494,8 +20335,8 @@
         </p:nvSpPr>
         <p:spPr>
           <a:xfrm>
-            <a:off x="8714232" y="4713732"/>
-            <a:ext cx="1719072" cy="233172"/>
+            <a:off x="8714232" y="4281212"/>
+            <a:ext cx="1719072" cy="193852"/>
           </a:xfrm>
           <a:prstGeom prst="rect">
             <a:avLst/>
@@ -19517,7 +20358,7 @@
               </a:spcAft>
             </a:pPr>
             <a:r>
-              <a:rPr sz="1050" b="0" i="0">
+              <a:rPr sz="1000" b="0" i="0">
                 <a:solidFill>
                   <a:srgbClr val="333840"/>
                 </a:solidFill>
@@ -19536,8 +20377,8 @@
         </p:nvSpPr>
         <p:spPr>
           <a:xfrm>
-            <a:off x="685800" y="4946904"/>
-            <a:ext cx="3017520" cy="233172"/>
+            <a:off x="685800" y="4475064"/>
+            <a:ext cx="3017520" cy="193852"/>
           </a:xfrm>
           <a:prstGeom prst="rect">
             <a:avLst/>
@@ -19580,8 +20421,8 @@
         </p:nvSpPr>
         <p:spPr>
           <a:xfrm>
-            <a:off x="758952" y="4946904"/>
-            <a:ext cx="2907792" cy="233172"/>
+            <a:off x="758952" y="4475064"/>
+            <a:ext cx="2907792" cy="193852"/>
           </a:xfrm>
           <a:prstGeom prst="rect">
             <a:avLst/>
@@ -19603,7 +20444,7 @@
               </a:spcAft>
             </a:pPr>
             <a:r>
-              <a:rPr sz="1050" b="1" i="0">
+              <a:rPr sz="1000" b="1" i="0">
                 <a:solidFill>
                   <a:srgbClr val="1E334E"/>
                 </a:solidFill>
@@ -19622,8 +20463,8 @@
         </p:nvSpPr>
         <p:spPr>
           <a:xfrm>
-            <a:off x="3703320" y="4946904"/>
-            <a:ext cx="1828800" cy="233172"/>
+            <a:off x="3703320" y="4475064"/>
+            <a:ext cx="1828800" cy="193852"/>
           </a:xfrm>
           <a:prstGeom prst="rect">
             <a:avLst/>
@@ -19666,8 +20507,8 @@
         </p:nvSpPr>
         <p:spPr>
           <a:xfrm>
-            <a:off x="3776472" y="4946904"/>
-            <a:ext cx="1719072" cy="233172"/>
+            <a:off x="3776472" y="4475064"/>
+            <a:ext cx="1719072" cy="193852"/>
           </a:xfrm>
           <a:prstGeom prst="rect">
             <a:avLst/>
@@ -19689,7 +20530,7 @@
               </a:spcAft>
             </a:pPr>
             <a:r>
-              <a:rPr sz="1050" b="0" i="0">
+              <a:rPr sz="1000" b="0" i="0">
                 <a:solidFill>
                   <a:srgbClr val="333840"/>
                 </a:solidFill>
@@ -19708,8 +20549,8 @@
         </p:nvSpPr>
         <p:spPr>
           <a:xfrm>
-            <a:off x="5532120" y="4946904"/>
-            <a:ext cx="1554480" cy="233172"/>
+            <a:off x="5532120" y="4475064"/>
+            <a:ext cx="1554480" cy="193852"/>
           </a:xfrm>
           <a:prstGeom prst="rect">
             <a:avLst/>
@@ -19752,8 +20593,8 @@
         </p:nvSpPr>
         <p:spPr>
           <a:xfrm>
-            <a:off x="5605272" y="4946904"/>
-            <a:ext cx="1444752" cy="233172"/>
+            <a:off x="5605272" y="4475064"/>
+            <a:ext cx="1444752" cy="193852"/>
           </a:xfrm>
           <a:prstGeom prst="rect">
             <a:avLst/>
@@ -19775,7 +20616,7 @@
               </a:spcAft>
             </a:pPr>
             <a:r>
-              <a:rPr sz="1050" b="0" i="0">
+              <a:rPr sz="1000" b="0" i="0">
                 <a:solidFill>
                   <a:srgbClr val="A84A4A"/>
                 </a:solidFill>
@@ -19794,8 +20635,8 @@
         </p:nvSpPr>
         <p:spPr>
           <a:xfrm>
-            <a:off x="7086600" y="4946904"/>
-            <a:ext cx="1554480" cy="233172"/>
+            <a:off x="7086600" y="4475064"/>
+            <a:ext cx="1554480" cy="193852"/>
           </a:xfrm>
           <a:prstGeom prst="rect">
             <a:avLst/>
@@ -19838,8 +20679,8 @@
         </p:nvSpPr>
         <p:spPr>
           <a:xfrm>
-            <a:off x="7159752" y="4946904"/>
-            <a:ext cx="1444752" cy="233172"/>
+            <a:off x="7159752" y="4475064"/>
+            <a:ext cx="1444752" cy="193852"/>
           </a:xfrm>
           <a:prstGeom prst="rect">
             <a:avLst/>
@@ -19861,7 +20702,7 @@
               </a:spcAft>
             </a:pPr>
             <a:r>
-              <a:rPr sz="1050" b="0" i="0">
+              <a:rPr sz="1000" b="0" i="0">
                 <a:solidFill>
                   <a:srgbClr val="A84A4A"/>
                 </a:solidFill>
@@ -19880,8 +20721,8 @@
         </p:nvSpPr>
         <p:spPr>
           <a:xfrm>
-            <a:off x="8641080" y="4946904"/>
-            <a:ext cx="1828800" cy="233172"/>
+            <a:off x="8641080" y="4475064"/>
+            <a:ext cx="1828800" cy="193852"/>
           </a:xfrm>
           <a:prstGeom prst="rect">
             <a:avLst/>
@@ -19924,8 +20765,8 @@
         </p:nvSpPr>
         <p:spPr>
           <a:xfrm>
-            <a:off x="8714232" y="4946904"/>
-            <a:ext cx="1719072" cy="233172"/>
+            <a:off x="8714232" y="4475064"/>
+            <a:ext cx="1719072" cy="193852"/>
           </a:xfrm>
           <a:prstGeom prst="rect">
             <a:avLst/>
@@ -19947,7 +20788,7 @@
               </a:spcAft>
             </a:pPr>
             <a:r>
-              <a:rPr sz="1050" b="0" i="0">
+              <a:rPr sz="1000" b="0" i="0">
                 <a:solidFill>
                   <a:srgbClr val="A84A4A"/>
                 </a:solidFill>
@@ -19966,8 +20807,8 @@
         </p:nvSpPr>
         <p:spPr>
           <a:xfrm>
-            <a:off x="685800" y="5180076"/>
-            <a:ext cx="3017520" cy="233172"/>
+            <a:off x="685800" y="4668916"/>
+            <a:ext cx="3017520" cy="193852"/>
           </a:xfrm>
           <a:prstGeom prst="rect">
             <a:avLst/>
@@ -20010,8 +20851,8 @@
         </p:nvSpPr>
         <p:spPr>
           <a:xfrm>
-            <a:off x="758952" y="5180076"/>
-            <a:ext cx="2907792" cy="233172"/>
+            <a:off x="758952" y="4668916"/>
+            <a:ext cx="2907792" cy="193852"/>
           </a:xfrm>
           <a:prstGeom prst="rect">
             <a:avLst/>
@@ -20033,7 +20874,7 @@
               </a:spcAft>
             </a:pPr>
             <a:r>
-              <a:rPr sz="1050" b="1" i="0">
+              <a:rPr sz="1000" b="1" i="0">
                 <a:solidFill>
                   <a:srgbClr val="1E334E"/>
                 </a:solidFill>
@@ -20052,8 +20893,8 @@
         </p:nvSpPr>
         <p:spPr>
           <a:xfrm>
-            <a:off x="3703320" y="5180076"/>
-            <a:ext cx="1828800" cy="233172"/>
+            <a:off x="3703320" y="4668916"/>
+            <a:ext cx="1828800" cy="193852"/>
           </a:xfrm>
           <a:prstGeom prst="rect">
             <a:avLst/>
@@ -20096,8 +20937,8 @@
         </p:nvSpPr>
         <p:spPr>
           <a:xfrm>
-            <a:off x="3776472" y="5180076"/>
-            <a:ext cx="1719072" cy="233172"/>
+            <a:off x="3776472" y="4668916"/>
+            <a:ext cx="1719072" cy="193852"/>
           </a:xfrm>
           <a:prstGeom prst="rect">
             <a:avLst/>
@@ -20119,7 +20960,7 @@
               </a:spcAft>
             </a:pPr>
             <a:r>
-              <a:rPr sz="1050" b="0" i="0">
+              <a:rPr sz="1000" b="0" i="0">
                 <a:solidFill>
                   <a:srgbClr val="333840"/>
                 </a:solidFill>
@@ -20138,8 +20979,8 @@
         </p:nvSpPr>
         <p:spPr>
           <a:xfrm>
-            <a:off x="5532120" y="5180076"/>
-            <a:ext cx="1554480" cy="233172"/>
+            <a:off x="5532120" y="4668916"/>
+            <a:ext cx="1554480" cy="193852"/>
           </a:xfrm>
           <a:prstGeom prst="rect">
             <a:avLst/>
@@ -20182,8 +21023,8 @@
         </p:nvSpPr>
         <p:spPr>
           <a:xfrm>
-            <a:off x="5605272" y="5180076"/>
-            <a:ext cx="1444752" cy="233172"/>
+            <a:off x="5605272" y="4668916"/>
+            <a:ext cx="1444752" cy="193852"/>
           </a:xfrm>
           <a:prstGeom prst="rect">
             <a:avLst/>
@@ -20205,7 +21046,7 @@
               </a:spcAft>
             </a:pPr>
             <a:r>
-              <a:rPr sz="1050" b="0" i="0">
+              <a:rPr sz="1000" b="0" i="0">
                 <a:solidFill>
                   <a:srgbClr val="333840"/>
                 </a:solidFill>
@@ -20224,8 +21065,8 @@
         </p:nvSpPr>
         <p:spPr>
           <a:xfrm>
-            <a:off x="7086600" y="5180076"/>
-            <a:ext cx="1554480" cy="233172"/>
+            <a:off x="7086600" y="4668916"/>
+            <a:ext cx="1554480" cy="193852"/>
           </a:xfrm>
           <a:prstGeom prst="rect">
             <a:avLst/>
@@ -20268,8 +21109,8 @@
         </p:nvSpPr>
         <p:spPr>
           <a:xfrm>
-            <a:off x="7159752" y="5180076"/>
-            <a:ext cx="1444752" cy="233172"/>
+            <a:off x="7159752" y="4668916"/>
+            <a:ext cx="1444752" cy="193852"/>
           </a:xfrm>
           <a:prstGeom prst="rect">
             <a:avLst/>
@@ -20291,7 +21132,7 @@
               </a:spcAft>
             </a:pPr>
             <a:r>
-              <a:rPr sz="1050" b="0" i="0">
+              <a:rPr sz="1000" b="0" i="0">
                 <a:solidFill>
                   <a:srgbClr val="333840"/>
                 </a:solidFill>
@@ -20310,8 +21151,8 @@
         </p:nvSpPr>
         <p:spPr>
           <a:xfrm>
-            <a:off x="8641080" y="5180076"/>
-            <a:ext cx="1828800" cy="233172"/>
+            <a:off x="8641080" y="4668916"/>
+            <a:ext cx="1828800" cy="193852"/>
           </a:xfrm>
           <a:prstGeom prst="rect">
             <a:avLst/>
@@ -20354,8 +21195,8 @@
         </p:nvSpPr>
         <p:spPr>
           <a:xfrm>
-            <a:off x="8714232" y="5180076"/>
-            <a:ext cx="1719072" cy="233172"/>
+            <a:off x="8714232" y="4668916"/>
+            <a:ext cx="1719072" cy="193852"/>
           </a:xfrm>
           <a:prstGeom prst="rect">
             <a:avLst/>
@@ -20377,7 +21218,7 @@
               </a:spcAft>
             </a:pPr>
             <a:r>
-              <a:rPr sz="1050" b="0" i="0">
+              <a:rPr sz="1000" b="0" i="0">
                 <a:solidFill>
                   <a:srgbClr val="333840"/>
                 </a:solidFill>
@@ -20396,8 +21237,8 @@
         </p:nvSpPr>
         <p:spPr>
           <a:xfrm>
-            <a:off x="685800" y="5413248"/>
-            <a:ext cx="3017520" cy="233172"/>
+            <a:off x="685800" y="4862768"/>
+            <a:ext cx="3017520" cy="193852"/>
           </a:xfrm>
           <a:prstGeom prst="rect">
             <a:avLst/>
@@ -20440,8 +21281,8 @@
         </p:nvSpPr>
         <p:spPr>
           <a:xfrm>
-            <a:off x="758952" y="5413248"/>
-            <a:ext cx="2907792" cy="233172"/>
+            <a:off x="758952" y="4862768"/>
+            <a:ext cx="2907792" cy="193852"/>
           </a:xfrm>
           <a:prstGeom prst="rect">
             <a:avLst/>
@@ -20463,7 +21304,7 @@
               </a:spcAft>
             </a:pPr>
             <a:r>
-              <a:rPr sz="1050" b="1" i="0">
+              <a:rPr sz="1000" b="1" i="0">
                 <a:solidFill>
                   <a:srgbClr val="1E334E"/>
                 </a:solidFill>
@@ -20482,8 +21323,8 @@
         </p:nvSpPr>
         <p:spPr>
           <a:xfrm>
-            <a:off x="3703320" y="5413248"/>
-            <a:ext cx="1828800" cy="233172"/>
+            <a:off x="3703320" y="4862768"/>
+            <a:ext cx="1828800" cy="193852"/>
           </a:xfrm>
           <a:prstGeom prst="rect">
             <a:avLst/>
@@ -20526,8 +21367,8 @@
         </p:nvSpPr>
         <p:spPr>
           <a:xfrm>
-            <a:off x="3776472" y="5413248"/>
-            <a:ext cx="1719072" cy="233172"/>
+            <a:off x="3776472" y="4862768"/>
+            <a:ext cx="1719072" cy="193852"/>
           </a:xfrm>
           <a:prstGeom prst="rect">
             <a:avLst/>
@@ -20549,7 +21390,7 @@
               </a:spcAft>
             </a:pPr>
             <a:r>
-              <a:rPr sz="1050" b="0" i="0">
+              <a:rPr sz="1000" b="0" i="0">
                 <a:solidFill>
                   <a:srgbClr val="333840"/>
                 </a:solidFill>
@@ -20568,8 +21409,8 @@
         </p:nvSpPr>
         <p:spPr>
           <a:xfrm>
-            <a:off x="5532120" y="5413248"/>
-            <a:ext cx="1554480" cy="233172"/>
+            <a:off x="5532120" y="4862768"/>
+            <a:ext cx="1554480" cy="193852"/>
           </a:xfrm>
           <a:prstGeom prst="rect">
             <a:avLst/>
@@ -20612,8 +21453,8 @@
         </p:nvSpPr>
         <p:spPr>
           <a:xfrm>
-            <a:off x="5605272" y="5413248"/>
-            <a:ext cx="1444752" cy="233172"/>
+            <a:off x="5605272" y="4862768"/>
+            <a:ext cx="1444752" cy="193852"/>
           </a:xfrm>
           <a:prstGeom prst="rect">
             <a:avLst/>
@@ -20635,7 +21476,7 @@
               </a:spcAft>
             </a:pPr>
             <a:r>
-              <a:rPr sz="1050" b="0" i="0">
+              <a:rPr sz="1000" b="0" i="0">
                 <a:solidFill>
                   <a:srgbClr val="333840"/>
                 </a:solidFill>
@@ -20654,8 +21495,8 @@
         </p:nvSpPr>
         <p:spPr>
           <a:xfrm>
-            <a:off x="7086600" y="5413248"/>
-            <a:ext cx="1554480" cy="233172"/>
+            <a:off x="7086600" y="4862768"/>
+            <a:ext cx="1554480" cy="193852"/>
           </a:xfrm>
           <a:prstGeom prst="rect">
             <a:avLst/>
@@ -20698,8 +21539,8 @@
         </p:nvSpPr>
         <p:spPr>
           <a:xfrm>
-            <a:off x="7159752" y="5413248"/>
-            <a:ext cx="1444752" cy="233172"/>
+            <a:off x="7159752" y="4862768"/>
+            <a:ext cx="1444752" cy="193852"/>
           </a:xfrm>
           <a:prstGeom prst="rect">
             <a:avLst/>
@@ -20721,7 +21562,7 @@
               </a:spcAft>
             </a:pPr>
             <a:r>
-              <a:rPr sz="1050" b="0" i="0">
+              <a:rPr sz="1000" b="0" i="0">
                 <a:solidFill>
                   <a:srgbClr val="333840"/>
                 </a:solidFill>
@@ -20740,8 +21581,8 @@
         </p:nvSpPr>
         <p:spPr>
           <a:xfrm>
-            <a:off x="8641080" y="5413248"/>
-            <a:ext cx="1828800" cy="233172"/>
+            <a:off x="8641080" y="4862768"/>
+            <a:ext cx="1828800" cy="193852"/>
           </a:xfrm>
           <a:prstGeom prst="rect">
             <a:avLst/>
@@ -20784,8 +21625,8 @@
         </p:nvSpPr>
         <p:spPr>
           <a:xfrm>
-            <a:off x="8714232" y="5413248"/>
-            <a:ext cx="1719072" cy="233172"/>
+            <a:off x="8714232" y="4862768"/>
+            <a:ext cx="1719072" cy="193852"/>
           </a:xfrm>
           <a:prstGeom prst="rect">
             <a:avLst/>
@@ -20807,7 +21648,7 @@
               </a:spcAft>
             </a:pPr>
             <a:r>
-              <a:rPr sz="1050" b="0" i="0">
+              <a:rPr sz="1000" b="0" i="0">
                 <a:solidFill>
                   <a:srgbClr val="333840"/>
                 </a:solidFill>
@@ -20826,8 +21667,8 @@
         </p:nvSpPr>
         <p:spPr>
           <a:xfrm>
-            <a:off x="685800" y="5646420"/>
-            <a:ext cx="3017520" cy="233172"/>
+            <a:off x="685800" y="5056620"/>
+            <a:ext cx="3017520" cy="193852"/>
           </a:xfrm>
           <a:prstGeom prst="rect">
             <a:avLst/>
@@ -20870,8 +21711,8 @@
         </p:nvSpPr>
         <p:spPr>
           <a:xfrm>
-            <a:off x="758952" y="5646420"/>
-            <a:ext cx="2907792" cy="233172"/>
+            <a:off x="758952" y="5056620"/>
+            <a:ext cx="2907792" cy="193852"/>
           </a:xfrm>
           <a:prstGeom prst="rect">
             <a:avLst/>
@@ -20893,7 +21734,7 @@
               </a:spcAft>
             </a:pPr>
             <a:r>
-              <a:rPr sz="1050" b="1" i="0">
+              <a:rPr sz="1000" b="1" i="0">
                 <a:solidFill>
                   <a:srgbClr val="1E334E"/>
                 </a:solidFill>
@@ -20912,8 +21753,8 @@
         </p:nvSpPr>
         <p:spPr>
           <a:xfrm>
-            <a:off x="3703320" y="5646420"/>
-            <a:ext cx="1828800" cy="233172"/>
+            <a:off x="3703320" y="5056620"/>
+            <a:ext cx="1828800" cy="193852"/>
           </a:xfrm>
           <a:prstGeom prst="rect">
             <a:avLst/>
@@ -20956,8 +21797,8 @@
         </p:nvSpPr>
         <p:spPr>
           <a:xfrm>
-            <a:off x="3776472" y="5646420"/>
-            <a:ext cx="1719072" cy="233172"/>
+            <a:off x="3776472" y="5056620"/>
+            <a:ext cx="1719072" cy="193852"/>
           </a:xfrm>
           <a:prstGeom prst="rect">
             <a:avLst/>
@@ -20979,7 +21820,7 @@
               </a:spcAft>
             </a:pPr>
             <a:r>
-              <a:rPr sz="1050" b="0" i="0">
+              <a:rPr sz="1000" b="0" i="0">
                 <a:solidFill>
                   <a:srgbClr val="333840"/>
                 </a:solidFill>
@@ -20998,8 +21839,8 @@
         </p:nvSpPr>
         <p:spPr>
           <a:xfrm>
-            <a:off x="5532120" y="5646420"/>
-            <a:ext cx="1554480" cy="233172"/>
+            <a:off x="5532120" y="5056620"/>
+            <a:ext cx="1554480" cy="193852"/>
           </a:xfrm>
           <a:prstGeom prst="rect">
             <a:avLst/>
@@ -21042,8 +21883,8 @@
         </p:nvSpPr>
         <p:spPr>
           <a:xfrm>
-            <a:off x="5605272" y="5646420"/>
-            <a:ext cx="1444752" cy="233172"/>
+            <a:off x="5605272" y="5056620"/>
+            <a:ext cx="1444752" cy="193852"/>
           </a:xfrm>
           <a:prstGeom prst="rect">
             <a:avLst/>
@@ -21065,7 +21906,7 @@
               </a:spcAft>
             </a:pPr>
             <a:r>
-              <a:rPr sz="1050" b="0" i="0">
+              <a:rPr sz="1000" b="0" i="0">
                 <a:solidFill>
                   <a:srgbClr val="333840"/>
                 </a:solidFill>
@@ -21084,8 +21925,8 @@
         </p:nvSpPr>
         <p:spPr>
           <a:xfrm>
-            <a:off x="7086600" y="5646420"/>
-            <a:ext cx="1554480" cy="233172"/>
+            <a:off x="7086600" y="5056620"/>
+            <a:ext cx="1554480" cy="193852"/>
           </a:xfrm>
           <a:prstGeom prst="rect">
             <a:avLst/>
@@ -21128,8 +21969,8 @@
         </p:nvSpPr>
         <p:spPr>
           <a:xfrm>
-            <a:off x="7159752" y="5646420"/>
-            <a:ext cx="1444752" cy="233172"/>
+            <a:off x="7159752" y="5056620"/>
+            <a:ext cx="1444752" cy="193852"/>
           </a:xfrm>
           <a:prstGeom prst="rect">
             <a:avLst/>
@@ -21151,7 +21992,7 @@
               </a:spcAft>
             </a:pPr>
             <a:r>
-              <a:rPr sz="1050" b="0" i="0">
+              <a:rPr sz="1000" b="0" i="0">
                 <a:solidFill>
                   <a:srgbClr val="333840"/>
                 </a:solidFill>
@@ -21170,8 +22011,8 @@
         </p:nvSpPr>
         <p:spPr>
           <a:xfrm>
-            <a:off x="8641080" y="5646420"/>
-            <a:ext cx="1828800" cy="233172"/>
+            <a:off x="8641080" y="5056620"/>
+            <a:ext cx="1828800" cy="193852"/>
           </a:xfrm>
           <a:prstGeom prst="rect">
             <a:avLst/>
@@ -21214,8 +22055,8 @@
         </p:nvSpPr>
         <p:spPr>
           <a:xfrm>
-            <a:off x="8714232" y="5646420"/>
-            <a:ext cx="1719072" cy="233172"/>
+            <a:off x="8714232" y="5056620"/>
+            <a:ext cx="1719072" cy="193852"/>
           </a:xfrm>
           <a:prstGeom prst="rect">
             <a:avLst/>
@@ -21237,7 +22078,7 @@
               </a:spcAft>
             </a:pPr>
             <a:r>
-              <a:rPr sz="1050" b="0" i="0">
+              <a:rPr sz="1000" b="0" i="0">
                 <a:solidFill>
                   <a:srgbClr val="333840"/>
                 </a:solidFill>
@@ -21256,8 +22097,8 @@
         </p:nvSpPr>
         <p:spPr>
           <a:xfrm>
-            <a:off x="685800" y="5879592"/>
-            <a:ext cx="3017520" cy="233172"/>
+            <a:off x="685800" y="5250472"/>
+            <a:ext cx="3017520" cy="193852"/>
           </a:xfrm>
           <a:prstGeom prst="rect">
             <a:avLst/>
@@ -21300,8 +22141,8 @@
         </p:nvSpPr>
         <p:spPr>
           <a:xfrm>
-            <a:off x="758952" y="5879592"/>
-            <a:ext cx="2907792" cy="233172"/>
+            <a:off x="758952" y="5250472"/>
+            <a:ext cx="2907792" cy="193852"/>
           </a:xfrm>
           <a:prstGeom prst="rect">
             <a:avLst/>
@@ -21323,7 +22164,7 @@
               </a:spcAft>
             </a:pPr>
             <a:r>
-              <a:rPr sz="1050" b="1" i="0">
+              <a:rPr sz="1000" b="1" i="0">
                 <a:solidFill>
                   <a:srgbClr val="1E334E"/>
                 </a:solidFill>
@@ -21342,8 +22183,8 @@
         </p:nvSpPr>
         <p:spPr>
           <a:xfrm>
-            <a:off x="3703320" y="5879592"/>
-            <a:ext cx="1828800" cy="233172"/>
+            <a:off x="3703320" y="5250472"/>
+            <a:ext cx="1828800" cy="193852"/>
           </a:xfrm>
           <a:prstGeom prst="rect">
             <a:avLst/>
@@ -21386,8 +22227,8 @@
         </p:nvSpPr>
         <p:spPr>
           <a:xfrm>
-            <a:off x="3776472" y="5879592"/>
-            <a:ext cx="1719072" cy="233172"/>
+            <a:off x="3776472" y="5250472"/>
+            <a:ext cx="1719072" cy="193852"/>
           </a:xfrm>
           <a:prstGeom prst="rect">
             <a:avLst/>
@@ -21409,7 +22250,7 @@
               </a:spcAft>
             </a:pPr>
             <a:r>
-              <a:rPr sz="1050" b="0" i="0">
+              <a:rPr sz="1000" b="0" i="0">
                 <a:solidFill>
                   <a:srgbClr val="333840"/>
                 </a:solidFill>
@@ -21428,8 +22269,8 @@
         </p:nvSpPr>
         <p:spPr>
           <a:xfrm>
-            <a:off x="5532120" y="5879592"/>
-            <a:ext cx="1554480" cy="233172"/>
+            <a:off x="5532120" y="5250472"/>
+            <a:ext cx="1554480" cy="193852"/>
           </a:xfrm>
           <a:prstGeom prst="rect">
             <a:avLst/>
@@ -21472,8 +22313,8 @@
         </p:nvSpPr>
         <p:spPr>
           <a:xfrm>
-            <a:off x="5605272" y="5879592"/>
-            <a:ext cx="1444752" cy="233172"/>
+            <a:off x="5605272" y="5250472"/>
+            <a:ext cx="1444752" cy="193852"/>
           </a:xfrm>
           <a:prstGeom prst="rect">
             <a:avLst/>
@@ -21495,7 +22336,7 @@
               </a:spcAft>
             </a:pPr>
             <a:r>
-              <a:rPr sz="1050" b="0" i="0">
+              <a:rPr sz="1000" b="0" i="0">
                 <a:solidFill>
                   <a:srgbClr val="333840"/>
                 </a:solidFill>
@@ -21514,8 +22355,8 @@
         </p:nvSpPr>
         <p:spPr>
           <a:xfrm>
-            <a:off x="7086600" y="5879592"/>
-            <a:ext cx="1554480" cy="233172"/>
+            <a:off x="7086600" y="5250472"/>
+            <a:ext cx="1554480" cy="193852"/>
           </a:xfrm>
           <a:prstGeom prst="rect">
             <a:avLst/>
@@ -21558,8 +22399,8 @@
         </p:nvSpPr>
         <p:spPr>
           <a:xfrm>
-            <a:off x="7159752" y="5879592"/>
-            <a:ext cx="1444752" cy="233172"/>
+            <a:off x="7159752" y="5250472"/>
+            <a:ext cx="1444752" cy="193852"/>
           </a:xfrm>
           <a:prstGeom prst="rect">
             <a:avLst/>
@@ -21581,7 +22422,7 @@
               </a:spcAft>
             </a:pPr>
             <a:r>
-              <a:rPr sz="1050" b="0" i="0">
+              <a:rPr sz="1000" b="0" i="0">
                 <a:solidFill>
                   <a:srgbClr val="333840"/>
                 </a:solidFill>
@@ -21600,8 +22441,8 @@
         </p:nvSpPr>
         <p:spPr>
           <a:xfrm>
-            <a:off x="8641080" y="5879592"/>
-            <a:ext cx="1828800" cy="233172"/>
+            <a:off x="8641080" y="5250472"/>
+            <a:ext cx="1828800" cy="193852"/>
           </a:xfrm>
           <a:prstGeom prst="rect">
             <a:avLst/>
@@ -21644,8 +22485,8 @@
         </p:nvSpPr>
         <p:spPr>
           <a:xfrm>
-            <a:off x="8714232" y="5879592"/>
-            <a:ext cx="1719072" cy="233172"/>
+            <a:off x="8714232" y="5250472"/>
+            <a:ext cx="1719072" cy="193852"/>
           </a:xfrm>
           <a:prstGeom prst="rect">
             <a:avLst/>
@@ -21667,7 +22508,7 @@
               </a:spcAft>
             </a:pPr>
             <a:r>
-              <a:rPr sz="1050" b="0" i="0">
+              <a:rPr sz="1000" b="0" i="0">
                 <a:solidFill>
                   <a:srgbClr val="333840"/>
                 </a:solidFill>
@@ -21686,8 +22527,8 @@
         </p:nvSpPr>
         <p:spPr>
           <a:xfrm>
-            <a:off x="685800" y="6112764"/>
-            <a:ext cx="3017520" cy="233172"/>
+            <a:off x="685800" y="5444324"/>
+            <a:ext cx="3017520" cy="193852"/>
           </a:xfrm>
           <a:prstGeom prst="rect">
             <a:avLst/>
@@ -21730,8 +22571,8 @@
         </p:nvSpPr>
         <p:spPr>
           <a:xfrm>
-            <a:off x="758952" y="6112764"/>
-            <a:ext cx="2907792" cy="233172"/>
+            <a:off x="758952" y="5444324"/>
+            <a:ext cx="2907792" cy="193852"/>
           </a:xfrm>
           <a:prstGeom prst="rect">
             <a:avLst/>
@@ -21753,7 +22594,7 @@
               </a:spcAft>
             </a:pPr>
             <a:r>
-              <a:rPr sz="1050" b="1" i="0">
+              <a:rPr sz="1000" b="1" i="0">
                 <a:solidFill>
                   <a:srgbClr val="1E334E"/>
                 </a:solidFill>
@@ -21772,8 +22613,8 @@
         </p:nvSpPr>
         <p:spPr>
           <a:xfrm>
-            <a:off x="3703320" y="6112764"/>
-            <a:ext cx="1828800" cy="233172"/>
+            <a:off x="3703320" y="5444324"/>
+            <a:ext cx="1828800" cy="193852"/>
           </a:xfrm>
           <a:prstGeom prst="rect">
             <a:avLst/>
@@ -21816,8 +22657,8 @@
         </p:nvSpPr>
         <p:spPr>
           <a:xfrm>
-            <a:off x="3776472" y="6112764"/>
-            <a:ext cx="1719072" cy="233172"/>
+            <a:off x="3776472" y="5444324"/>
+            <a:ext cx="1719072" cy="193852"/>
           </a:xfrm>
           <a:prstGeom prst="rect">
             <a:avLst/>
@@ -21839,7 +22680,7 @@
               </a:spcAft>
             </a:pPr>
             <a:r>
-              <a:rPr sz="1050" b="0" i="0">
+              <a:rPr sz="1000" b="0" i="0">
                 <a:solidFill>
                   <a:srgbClr val="333840"/>
                 </a:solidFill>
@@ -21858,8 +22699,8 @@
         </p:nvSpPr>
         <p:spPr>
           <a:xfrm>
-            <a:off x="5532120" y="6112764"/>
-            <a:ext cx="1554480" cy="233172"/>
+            <a:off x="5532120" y="5444324"/>
+            <a:ext cx="1554480" cy="193852"/>
           </a:xfrm>
           <a:prstGeom prst="rect">
             <a:avLst/>
@@ -21902,8 +22743,8 @@
         </p:nvSpPr>
         <p:spPr>
           <a:xfrm>
-            <a:off x="5605272" y="6112764"/>
-            <a:ext cx="1444752" cy="233172"/>
+            <a:off x="5605272" y="5444324"/>
+            <a:ext cx="1444752" cy="193852"/>
           </a:xfrm>
           <a:prstGeom prst="rect">
             <a:avLst/>
@@ -21925,7 +22766,7 @@
               </a:spcAft>
             </a:pPr>
             <a:r>
-              <a:rPr sz="1050" b="0" i="0">
+              <a:rPr sz="1000" b="0" i="0">
                 <a:solidFill>
                   <a:srgbClr val="333840"/>
                 </a:solidFill>
@@ -21944,8 +22785,8 @@
         </p:nvSpPr>
         <p:spPr>
           <a:xfrm>
-            <a:off x="7086600" y="6112764"/>
-            <a:ext cx="1554480" cy="233172"/>
+            <a:off x="7086600" y="5444324"/>
+            <a:ext cx="1554480" cy="193852"/>
           </a:xfrm>
           <a:prstGeom prst="rect">
             <a:avLst/>
@@ -21988,8 +22829,8 @@
         </p:nvSpPr>
         <p:spPr>
           <a:xfrm>
-            <a:off x="7159752" y="6112764"/>
-            <a:ext cx="1444752" cy="233172"/>
+            <a:off x="7159752" y="5444324"/>
+            <a:ext cx="1444752" cy="193852"/>
           </a:xfrm>
           <a:prstGeom prst="rect">
             <a:avLst/>
@@ -22011,7 +22852,7 @@
               </a:spcAft>
             </a:pPr>
             <a:r>
-              <a:rPr sz="1050" b="0" i="0">
+              <a:rPr sz="1000" b="0" i="0">
                 <a:solidFill>
                   <a:srgbClr val="333840"/>
                 </a:solidFill>
@@ -22030,8 +22871,8 @@
         </p:nvSpPr>
         <p:spPr>
           <a:xfrm>
-            <a:off x="8641080" y="6112764"/>
-            <a:ext cx="1828800" cy="233172"/>
+            <a:off x="8641080" y="5444324"/>
+            <a:ext cx="1828800" cy="193852"/>
           </a:xfrm>
           <a:prstGeom prst="rect">
             <a:avLst/>
@@ -22074,8 +22915,8 @@
         </p:nvSpPr>
         <p:spPr>
           <a:xfrm>
-            <a:off x="8714232" y="6112764"/>
-            <a:ext cx="1719072" cy="233172"/>
+            <a:off x="8714232" y="5444324"/>
+            <a:ext cx="1719072" cy="193852"/>
           </a:xfrm>
           <a:prstGeom prst="rect">
             <a:avLst/>
@@ -22097,7 +22938,7 @@
               </a:spcAft>
             </a:pPr>
             <a:r>
-              <a:rPr sz="1050" b="0" i="0">
+              <a:rPr sz="1000" b="0" i="0">
                 <a:solidFill>
                   <a:srgbClr val="333840"/>
                 </a:solidFill>
@@ -22116,7 +22957,7 @@
         </p:nvSpPr>
         <p:spPr>
           <a:xfrm>
-            <a:off x="685800" y="6437376"/>
+            <a:off x="685800" y="5729616"/>
             <a:ext cx="9784080" cy="310896"/>
           </a:xfrm>
           <a:prstGeom prst="rect">
@@ -22160,7 +23001,7 @@
         </p:nvSpPr>
         <p:spPr>
           <a:xfrm>
-            <a:off x="822960" y="6437376"/>
+            <a:off x="822960" y="5729616"/>
             <a:ext cx="9509760" cy="310896"/>
           </a:xfrm>
           <a:prstGeom prst="rect">
@@ -22202,8 +23043,8 @@
         </p:nvSpPr>
         <p:spPr>
           <a:xfrm>
-            <a:off x="685800" y="6355080"/>
-            <a:ext cx="10789920" cy="365760"/>
+            <a:off x="685800" y="6113664"/>
+            <a:ext cx="10789920" cy="320040"/>
           </a:xfrm>
           <a:prstGeom prst="rect">
             <a:avLst/>

</xml_diff>

<commit_message>
Add numbered Contents page with section numbers and figure/table references
</commit_message>
<xml_diff>
--- a/Athanase_Engaged_Ownership_Allocator_Deck.pptx
+++ b/Athanase_Engaged_Ownership_Allocator_Deck.pptx
@@ -14744,7 +14744,7 @@
                 </a:solidFill>
                 <a:latin typeface="Times New Roman"/>
               </a:rPr>
-              <a:t>What this presentation covers</a:t>
+              <a:t>Contents</a:t>
             </a:r>
           </a:p>
         </p:txBody>
@@ -14799,8 +14799,8 @@
         </p:nvSpPr>
         <p:spPr>
           <a:xfrm>
-            <a:off x="685800" y="1783080"/>
-            <a:ext cx="10789920" cy="4206240"/>
+            <a:off x="640080" y="1783080"/>
+            <a:ext cx="5349240" cy="365760"/>
           </a:xfrm>
           <a:prstGeom prst="rect">
             <a:avLst/>
@@ -14813,97 +14813,807 @@
           </a:bodyPr>
           <a:lstStyle/>
           <a:p>
+            <a:pPr algn="l">
+              <a:lnSpc>
+                <a:spcPct val="110000"/>
+              </a:lnSpc>
+              <a:spcAft>
+                <a:spcPts val="0"/>
+              </a:spcAft>
+            </a:pPr>
+            <a:r>
+              <a:rPr sz="1400" b="1" i="0">
+                <a:solidFill>
+                  <a:srgbClr val="4A5D75"/>
+                </a:solidFill>
+                <a:latin typeface="Times New Roman"/>
+              </a:rPr>
+              <a:t>Part I  ·  Why allocate to engaged ownership</a:t>
+            </a:r>
+          </a:p>
+        </p:txBody>
+      </p:sp>
+      <p:sp>
+        <p:nvSpPr>
+          <p:cNvPr id="9" name="TextBox 8"/>
+          <p:cNvSpPr txBox="1"/>
+          <p:nvPr/>
+        </p:nvSpPr>
+        <p:spPr>
+          <a:xfrm>
+            <a:off x="640080" y="2240280"/>
+            <a:ext cx="5349240" cy="4297680"/>
+          </a:xfrm>
+          <a:prstGeom prst="rect">
+            <a:avLst/>
+          </a:prstGeom>
+          <a:noFill/>
+        </p:spPr>
+        <p:txBody>
+          <a:bodyPr wrap="square" anchor="t" lIns="0" rIns="0" tIns="0" bIns="0">
+            <a:spAutoFit/>
+          </a:bodyPr>
+          <a:lstStyle/>
+          <a:p>
             <a:pPr>
               <a:lnSpc>
-                <a:spcPct val="112000"/>
-              </a:lnSpc>
-              <a:spcAft>
-                <a:spcPts val="1000"/>
-              </a:spcAft>
-            </a:pPr>
-            <a:r>
-              <a:rPr sz="2000" b="1">
+                <a:spcPct val="104000"/>
+              </a:lnSpc>
+              <a:spcAft>
+                <a:spcPts val="700"/>
+              </a:spcAft>
+            </a:pPr>
+            <a:r>
+              <a:rPr sz="1150" b="1">
                 <a:solidFill>
                   <a:srgbClr val="4A5D75"/>
                 </a:solidFill>
+                <a:latin typeface="Calibri"/>
+              </a:rPr>
+              <a:t>1.1   </a:t>
+            </a:r>
+            <a:r>
+              <a:rPr sz="1150">
+                <a:solidFill>
+                  <a:srgbClr val="1E334E"/>
+                </a:solidFill>
+                <a:latin typeface="Calibri"/>
+              </a:rPr>
+              <a:t>A catalyst-driven source of return</a:t>
+            </a:r>
+          </a:p>
+          <a:p>
+            <a:pPr>
+              <a:lnSpc>
+                <a:spcPct val="104000"/>
+              </a:lnSpc>
+              <a:spcAft>
+                <a:spcPts val="700"/>
+              </a:spcAft>
+            </a:pPr>
+            <a:r>
+              <a:rPr sz="1150" b="1">
+                <a:solidFill>
+                  <a:srgbClr val="4A5D75"/>
+                </a:solidFill>
+                <a:latin typeface="Calibri"/>
+              </a:rPr>
+              <a:t>1.2   </a:t>
+            </a:r>
+            <a:r>
+              <a:rPr sz="1150">
+                <a:solidFill>
+                  <a:srgbClr val="1E334E"/>
+                </a:solidFill>
+                <a:latin typeface="Calibri"/>
+              </a:rPr>
+              <a:t>Aligned with horizon and fiduciary duty</a:t>
+            </a:r>
+          </a:p>
+          <a:p>
+            <a:pPr>
+              <a:lnSpc>
+                <a:spcPct val="104000"/>
+              </a:lnSpc>
+              <a:spcAft>
+                <a:spcPts val="700"/>
+              </a:spcAft>
+            </a:pPr>
+            <a:r>
+              <a:rPr sz="1150" b="1">
+                <a:solidFill>
+                  <a:srgbClr val="4A5D75"/>
+                </a:solidFill>
+                <a:latin typeface="Calibri"/>
+              </a:rPr>
+              <a:t>1.3   </a:t>
+            </a:r>
+            <a:r>
+              <a:rPr sz="1150">
+                <a:solidFill>
+                  <a:srgbClr val="1E334E"/>
+                </a:solidFill>
+                <a:latin typeface="Calibri"/>
+              </a:rPr>
+              <a:t>Diversification and the total-portfolio view</a:t>
+            </a:r>
+          </a:p>
+          <a:p>
+            <a:pPr>
+              <a:lnSpc>
+                <a:spcPct val="104000"/>
+              </a:lnSpc>
+              <a:spcAft>
+                <a:spcPts val="700"/>
+              </a:spcAft>
+            </a:pPr>
+            <a:r>
+              <a:rPr sz="1150" b="1">
+                <a:solidFill>
+                  <a:srgbClr val="4A5D75"/>
+                </a:solidFill>
+                <a:latin typeface="Calibri"/>
+              </a:rPr>
+              <a:t>1.4   </a:t>
+            </a:r>
+            <a:r>
+              <a:rPr sz="1150">
+                <a:solidFill>
+                  <a:srgbClr val="1E334E"/>
+                </a:solidFill>
+                <a:latin typeface="Calibri"/>
+              </a:rPr>
+              <a:t>Governance and the ESG synergy</a:t>
+            </a:r>
+          </a:p>
+          <a:p>
+            <a:pPr>
+              <a:lnSpc>
+                <a:spcPct val="104000"/>
+              </a:lnSpc>
+              <a:spcAft>
+                <a:spcPts val="700"/>
+              </a:spcAft>
+            </a:pPr>
+            <a:r>
+              <a:rPr sz="1150" b="1">
+                <a:solidFill>
+                  <a:srgbClr val="4A5D75"/>
+                </a:solidFill>
+                <a:latin typeface="Calibri"/>
+              </a:rPr>
+              <a:t>1.5   </a:t>
+            </a:r>
+            <a:r>
+              <a:rPr sz="1150">
+                <a:solidFill>
+                  <a:srgbClr val="1E334E"/>
+                </a:solidFill>
+                <a:latin typeface="Calibri"/>
+              </a:rPr>
+              <a:t>What separates a great engaged owner</a:t>
+            </a:r>
+          </a:p>
+        </p:txBody>
+      </p:sp>
+      <p:sp>
+        <p:nvSpPr>
+          <p:cNvPr id="10" name="TextBox 9"/>
+          <p:cNvSpPr txBox="1"/>
+          <p:nvPr/>
+        </p:nvSpPr>
+        <p:spPr>
+          <a:xfrm>
+            <a:off x="6446520" y="1783080"/>
+            <a:ext cx="5349240" cy="365760"/>
+          </a:xfrm>
+          <a:prstGeom prst="rect">
+            <a:avLst/>
+          </a:prstGeom>
+          <a:noFill/>
+        </p:spPr>
+        <p:txBody>
+          <a:bodyPr wrap="square" anchor="t" lIns="0" rIns="0" tIns="0" bIns="0">
+            <a:spAutoFit/>
+          </a:bodyPr>
+          <a:lstStyle/>
+          <a:p>
+            <a:pPr algn="l">
+              <a:lnSpc>
+                <a:spcPct val="110000"/>
+              </a:lnSpc>
+              <a:spcAft>
+                <a:spcPts val="0"/>
+              </a:spcAft>
+            </a:pPr>
+            <a:r>
+              <a:rPr sz="1400" b="1" i="0">
+                <a:solidFill>
+                  <a:srgbClr val="4A5D75"/>
+                </a:solidFill>
                 <a:latin typeface="Times New Roman"/>
               </a:rPr>
-              <a:t>Part I   </a:t>
-            </a:r>
-            <a:r>
-              <a:rPr sz="2000" b="1">
+              <a:t>Part II  ·  Why choose Athanase</a:t>
+            </a:r>
+          </a:p>
+        </p:txBody>
+      </p:sp>
+      <p:sp>
+        <p:nvSpPr>
+          <p:cNvPr id="11" name="TextBox 10"/>
+          <p:cNvSpPr txBox="1"/>
+          <p:nvPr/>
+        </p:nvSpPr>
+        <p:spPr>
+          <a:xfrm>
+            <a:off x="6446520" y="2240280"/>
+            <a:ext cx="5349240" cy="4297680"/>
+          </a:xfrm>
+          <a:prstGeom prst="rect">
+            <a:avLst/>
+          </a:prstGeom>
+          <a:noFill/>
+        </p:spPr>
+        <p:txBody>
+          <a:bodyPr wrap="square" anchor="t" lIns="0" rIns="0" tIns="0" bIns="0">
+            <a:spAutoFit/>
+          </a:bodyPr>
+          <a:lstStyle/>
+          <a:p>
+            <a:pPr>
+              <a:lnSpc>
+                <a:spcPct val="104000"/>
+              </a:lnSpc>
+              <a:spcAft>
+                <a:spcPts val="700"/>
+              </a:spcAft>
+            </a:pPr>
+            <a:r>
+              <a:rPr sz="1150" b="1">
+                <a:solidFill>
+                  <a:srgbClr val="4A5D75"/>
+                </a:solidFill>
+                <a:latin typeface="Calibri"/>
+              </a:rPr>
+              <a:t>2.1   </a:t>
+            </a:r>
+            <a:r>
+              <a:rPr sz="1150">
                 <a:solidFill>
                   <a:srgbClr val="1E334E"/>
                 </a:solidFill>
-                <a:latin typeface="Times New Roman"/>
-              </a:rPr>
-              <a:t>Why allocate to engaged ownership</a:t>
+                <a:latin typeface="Calibri"/>
+              </a:rPr>
+              <a:t>Athanase at a glance</a:t>
             </a:r>
           </a:p>
           <a:p>
             <a:pPr>
               <a:lnSpc>
-                <a:spcPct val="112000"/>
-              </a:lnSpc>
-              <a:spcAft>
-                <a:spcPts val="2000"/>
-              </a:spcAft>
-            </a:pPr>
-            <a:r>
-              <a:rPr sz="1500">
-                <a:solidFill>
-                  <a:srgbClr val="333840"/>
-                </a:solidFill>
-                <a:latin typeface="Calibri"/>
-              </a:rPr>
-              <a:t>The asset-class case: a catalyst-driven, diversifying source of equity return that fits a long-horizon, fiduciary mandate.</a:t>
+                <a:spcPct val="104000"/>
+              </a:lnSpc>
+              <a:spcAft>
+                <a:spcPts val="700"/>
+              </a:spcAft>
+            </a:pPr>
+            <a:r>
+              <a:rPr sz="1150" b="1">
+                <a:solidFill>
+                  <a:srgbClr val="4A5D75"/>
+                </a:solidFill>
+                <a:latin typeface="Calibri"/>
+              </a:rPr>
+              <a:t>2.2   </a:t>
+            </a:r>
+            <a:r>
+              <a:rPr sz="1150">
+                <a:solidFill>
+                  <a:srgbClr val="1E334E"/>
+                </a:solidFill>
+                <a:latin typeface="Calibri"/>
+              </a:rPr>
+              <a:t>An integrated team, 20 years together</a:t>
             </a:r>
           </a:p>
           <a:p>
             <a:pPr>
               <a:lnSpc>
-                <a:spcPct val="112000"/>
-              </a:lnSpc>
-              <a:spcAft>
-                <a:spcPts val="1000"/>
-              </a:spcAft>
-            </a:pPr>
-            <a:r>
-              <a:rPr sz="2000" b="1">
+                <a:spcPct val="104000"/>
+              </a:lnSpc>
+              <a:spcAft>
+                <a:spcPts val="700"/>
+              </a:spcAft>
+            </a:pPr>
+            <a:r>
+              <a:rPr sz="1150" b="1">
                 <a:solidFill>
                   <a:srgbClr val="4A5D75"/>
                 </a:solidFill>
-                <a:latin typeface="Times New Roman"/>
-              </a:rPr>
-              <a:t>Part II   </a:t>
-            </a:r>
-            <a:r>
-              <a:rPr sz="2000" b="1">
+                <a:latin typeface="Calibri"/>
+              </a:rPr>
+              <a:t>2.3   </a:t>
+            </a:r>
+            <a:r>
+              <a:rPr sz="1150">
                 <a:solidFill>
                   <a:srgbClr val="1E334E"/>
                 </a:solidFill>
-                <a:latin typeface="Times New Roman"/>
-              </a:rPr>
-              <a:t>Why choose Athanase</a:t>
+                <a:latin typeface="Calibri"/>
+              </a:rPr>
+              <a:t>The inefficiency Athanase harvests</a:t>
+            </a:r>
+            <a:r>
+              <a:rPr sz="950" i="1">
+                <a:solidFill>
+                  <a:srgbClr val="5A636E"/>
+                </a:solidFill>
+                <a:latin typeface="Calibri"/>
+              </a:rPr>
+              <a:t>   (Figure 1)</a:t>
             </a:r>
           </a:p>
           <a:p>
             <a:pPr>
               <a:lnSpc>
-                <a:spcPct val="112000"/>
-              </a:lnSpc>
-              <a:spcAft>
-                <a:spcPts val="2000"/>
-              </a:spcAft>
-            </a:pPr>
-            <a:r>
-              <a:rPr sz="1500">
-                <a:solidFill>
-                  <a:srgbClr val="333840"/>
-                </a:solidFill>
-                <a:latin typeface="Calibri"/>
-              </a:rPr>
-              <a:t>Among engaged owners, the team, opportunity set, margin-for-error and 20-year track record that distinguish Athanase Industrial Partner.</a:t>
+                <a:spcPct val="104000"/>
+              </a:lnSpc>
+              <a:spcAft>
+                <a:spcPts val="700"/>
+              </a:spcAft>
+            </a:pPr>
+            <a:r>
+              <a:rPr sz="1150" b="1">
+                <a:solidFill>
+                  <a:srgbClr val="4A5D75"/>
+                </a:solidFill>
+                <a:latin typeface="Calibri"/>
+              </a:rPr>
+              <a:t>2.4   </a:t>
+            </a:r>
+            <a:r>
+              <a:rPr sz="1150">
+                <a:solidFill>
+                  <a:srgbClr val="1E334E"/>
+                </a:solidFill>
+                <a:latin typeface="Calibri"/>
+              </a:rPr>
+              <a:t>We don’t buy broken companies — we buy hidden cores</a:t>
+            </a:r>
+            <a:r>
+              <a:rPr sz="950" i="1">
+                <a:solidFill>
+                  <a:srgbClr val="5A636E"/>
+                </a:solidFill>
+                <a:latin typeface="Calibri"/>
+              </a:rPr>
+              <a:t>   (Figure 2)</a:t>
+            </a:r>
+          </a:p>
+          <a:p>
+            <a:pPr>
+              <a:lnSpc>
+                <a:spcPct val="104000"/>
+              </a:lnSpc>
+              <a:spcAft>
+                <a:spcPts val="700"/>
+              </a:spcAft>
+            </a:pPr>
+            <a:r>
+              <a:rPr sz="1150" b="1">
+                <a:solidFill>
+                  <a:srgbClr val="4A5D75"/>
+                </a:solidFill>
+                <a:latin typeface="Calibri"/>
+              </a:rPr>
+              <a:t>2.5   </a:t>
+            </a:r>
+            <a:r>
+              <a:rPr sz="1150">
+                <a:solidFill>
+                  <a:srgbClr val="1E334E"/>
+                </a:solidFill>
+                <a:latin typeface="Calibri"/>
+              </a:rPr>
+              <a:t>Quality-core constructivism — how we differ</a:t>
+            </a:r>
+            <a:r>
+              <a:rPr sz="950" i="1">
+                <a:solidFill>
+                  <a:srgbClr val="5A636E"/>
+                </a:solidFill>
+                <a:latin typeface="Calibri"/>
+              </a:rPr>
+              <a:t>   (Table 1)</a:t>
+            </a:r>
+          </a:p>
+          <a:p>
+            <a:pPr>
+              <a:lnSpc>
+                <a:spcPct val="104000"/>
+              </a:lnSpc>
+              <a:spcAft>
+                <a:spcPts val="700"/>
+              </a:spcAft>
+            </a:pPr>
+            <a:r>
+              <a:rPr sz="1150" b="1">
+                <a:solidFill>
+                  <a:srgbClr val="4A5D75"/>
+                </a:solidFill>
+                <a:latin typeface="Calibri"/>
+              </a:rPr>
+              <a:t>2.6   </a:t>
+            </a:r>
+            <a:r>
+              <a:rPr sz="1150">
+                <a:solidFill>
+                  <a:srgbClr val="1E334E"/>
+                </a:solidFill>
+                <a:latin typeface="Calibri"/>
+              </a:rPr>
+              <a:t>We don’t need to be right more than ~50%</a:t>
+            </a:r>
+            <a:r>
+              <a:rPr sz="950" i="1">
+                <a:solidFill>
+                  <a:srgbClr val="5A636E"/>
+                </a:solidFill>
+                <a:latin typeface="Calibri"/>
+              </a:rPr>
+              <a:t>   (Table 2)</a:t>
+            </a:r>
+          </a:p>
+          <a:p>
+            <a:pPr>
+              <a:lnSpc>
+                <a:spcPct val="104000"/>
+              </a:lnSpc>
+              <a:spcAft>
+                <a:spcPts val="700"/>
+              </a:spcAft>
+            </a:pPr>
+            <a:r>
+              <a:rPr sz="1150" b="1">
+                <a:solidFill>
+                  <a:srgbClr val="4A5D75"/>
+                </a:solidFill>
+                <a:latin typeface="Calibri"/>
+              </a:rPr>
+              <a:t>2.7   </a:t>
+            </a:r>
+            <a:r>
+              <a:rPr sz="1150">
+                <a:solidFill>
+                  <a:srgbClr val="1E334E"/>
+                </a:solidFill>
+                <a:latin typeface="Calibri"/>
+              </a:rPr>
+              <a:t>A risk system built to avoid permanent loss</a:t>
+            </a:r>
+          </a:p>
+          <a:p>
+            <a:pPr>
+              <a:lnSpc>
+                <a:spcPct val="104000"/>
+              </a:lnSpc>
+              <a:spcAft>
+                <a:spcPts val="700"/>
+              </a:spcAft>
+            </a:pPr>
+            <a:r>
+              <a:rPr sz="1150" b="1">
+                <a:solidFill>
+                  <a:srgbClr val="4A5D75"/>
+                </a:solidFill>
+                <a:latin typeface="Calibri"/>
+              </a:rPr>
+              <a:t>2.8   </a:t>
+            </a:r>
+            <a:r>
+              <a:rPr sz="1150">
+                <a:solidFill>
+                  <a:srgbClr val="1E334E"/>
+                </a:solidFill>
+                <a:latin typeface="Calibri"/>
+              </a:rPr>
+              <a:t>The visible risks are the engine — not the cost</a:t>
+            </a:r>
+          </a:p>
+          <a:p>
+            <a:pPr>
+              <a:lnSpc>
+                <a:spcPct val="104000"/>
+              </a:lnSpc>
+              <a:spcAft>
+                <a:spcPts val="700"/>
+              </a:spcAft>
+            </a:pPr>
+            <a:r>
+              <a:rPr sz="1150" b="1">
+                <a:solidFill>
+                  <a:srgbClr val="4A5D75"/>
+                </a:solidFill>
+                <a:latin typeface="Calibri"/>
+              </a:rPr>
+              <a:t>2.9   </a:t>
+            </a:r>
+            <a:r>
+              <a:rPr sz="1150">
+                <a:solidFill>
+                  <a:srgbClr val="1E334E"/>
+                </a:solidFill>
+                <a:latin typeface="Calibri"/>
+              </a:rPr>
+              <a:t>A non-linear path — honestly priced</a:t>
+            </a:r>
+            <a:r>
+              <a:rPr sz="950" i="1">
+                <a:solidFill>
+                  <a:srgbClr val="5A636E"/>
+                </a:solidFill>
+                <a:latin typeface="Calibri"/>
+              </a:rPr>
+              <a:t>   (Figure 3)</a:t>
+            </a:r>
+          </a:p>
+          <a:p>
+            <a:pPr>
+              <a:lnSpc>
+                <a:spcPct val="104000"/>
+              </a:lnSpc>
+              <a:spcAft>
+                <a:spcPts val="700"/>
+              </a:spcAft>
+            </a:pPr>
+            <a:r>
+              <a:rPr sz="1150" b="1">
+                <a:solidFill>
+                  <a:srgbClr val="4A5D75"/>
+                </a:solidFill>
+                <a:latin typeface="Calibri"/>
+              </a:rPr>
+              <a:t>2.10   </a:t>
+            </a:r>
+            <a:r>
+              <a:rPr sz="1150">
+                <a:solidFill>
+                  <a:srgbClr val="1E334E"/>
+                </a:solidFill>
+                <a:latin typeface="Calibri"/>
+              </a:rPr>
+              <a:t>Risk reframing for the investment committee</a:t>
+            </a:r>
+            <a:r>
+              <a:rPr sz="950" i="1">
+                <a:solidFill>
+                  <a:srgbClr val="5A636E"/>
+                </a:solidFill>
+                <a:latin typeface="Calibri"/>
+              </a:rPr>
+              <a:t>   (Table 3)</a:t>
+            </a:r>
+          </a:p>
+          <a:p>
+            <a:pPr>
+              <a:lnSpc>
+                <a:spcPct val="104000"/>
+              </a:lnSpc>
+              <a:spcAft>
+                <a:spcPts val="700"/>
+              </a:spcAft>
+            </a:pPr>
+            <a:r>
+              <a:rPr sz="1150" b="1">
+                <a:solidFill>
+                  <a:srgbClr val="4A5D75"/>
+                </a:solidFill>
+                <a:latin typeface="Calibri"/>
+              </a:rPr>
+              <a:t>2.11   </a:t>
+            </a:r>
+            <a:r>
+              <a:rPr sz="1150">
+                <a:solidFill>
+                  <a:srgbClr val="1E334E"/>
+                </a:solidFill>
+                <a:latin typeface="Calibri"/>
+              </a:rPr>
+              <a:t>Proof: outperformance with downside protection</a:t>
+            </a:r>
+            <a:r>
+              <a:rPr sz="950" i="1">
+                <a:solidFill>
+                  <a:srgbClr val="5A636E"/>
+                </a:solidFill>
+                <a:latin typeface="Calibri"/>
+              </a:rPr>
+              <a:t>   (Figure 4)</a:t>
+            </a:r>
+          </a:p>
+          <a:p>
+            <a:pPr>
+              <a:lnSpc>
+                <a:spcPct val="104000"/>
+              </a:lnSpc>
+              <a:spcAft>
+                <a:spcPts val="700"/>
+              </a:spcAft>
+            </a:pPr>
+            <a:r>
+              <a:rPr sz="1150" b="1">
+                <a:solidFill>
+                  <a:srgbClr val="4A5D75"/>
+                </a:solidFill>
+                <a:latin typeface="Calibri"/>
+              </a:rPr>
+              <a:t>2.12   </a:t>
+            </a:r>
+            <a:r>
+              <a:rPr sz="1150">
+                <a:solidFill>
+                  <a:srgbClr val="1E334E"/>
+                </a:solidFill>
+                <a:latin typeface="Calibri"/>
+              </a:rPr>
+              <a:t>AIP Fund II — transactions (2015–present)</a:t>
+            </a:r>
+            <a:r>
+              <a:rPr sz="950" i="1">
+                <a:solidFill>
+                  <a:srgbClr val="5A636E"/>
+                </a:solidFill>
+                <a:latin typeface="Calibri"/>
+              </a:rPr>
+              <a:t>   (Table 4)</a:t>
+            </a:r>
+          </a:p>
+          <a:p>
+            <a:pPr>
+              <a:lnSpc>
+                <a:spcPct val="104000"/>
+              </a:lnSpc>
+              <a:spcAft>
+                <a:spcPts val="700"/>
+              </a:spcAft>
+            </a:pPr>
+            <a:r>
+              <a:rPr sz="1150" b="1">
+                <a:solidFill>
+                  <a:srgbClr val="4A5D75"/>
+                </a:solidFill>
+                <a:latin typeface="Calibri"/>
+              </a:rPr>
+              <a:t>2.13   </a:t>
+            </a:r>
+            <a:r>
+              <a:rPr sz="1150">
+                <a:solidFill>
+                  <a:srgbClr val="1E334E"/>
+                </a:solidFill>
+                <a:latin typeface="Calibri"/>
+              </a:rPr>
+              <a:t>Prior period — transactions (2006–2014)</a:t>
+            </a:r>
+            <a:r>
+              <a:rPr sz="950" i="1">
+                <a:solidFill>
+                  <a:srgbClr val="5A636E"/>
+                </a:solidFill>
+                <a:latin typeface="Calibri"/>
+              </a:rPr>
+              <a:t>   (Table 5)</a:t>
+            </a:r>
+          </a:p>
+          <a:p>
+            <a:pPr>
+              <a:lnSpc>
+                <a:spcPct val="104000"/>
+              </a:lnSpc>
+              <a:spcAft>
+                <a:spcPts val="700"/>
+              </a:spcAft>
+            </a:pPr>
+            <a:r>
+              <a:rPr sz="1150" b="1">
+                <a:solidFill>
+                  <a:srgbClr val="4A5D75"/>
+                </a:solidFill>
+                <a:latin typeface="Calibri"/>
+              </a:rPr>
+              <a:t>2.14   </a:t>
+            </a:r>
+            <a:r>
+              <a:rPr sz="1150">
+                <a:solidFill>
+                  <a:srgbClr val="1E334E"/>
+                </a:solidFill>
+                <a:latin typeface="Calibri"/>
+              </a:rPr>
+              <a:t>Independently validated: 20 years, net of every fee</a:t>
+            </a:r>
+          </a:p>
+          <a:p>
+            <a:pPr>
+              <a:lnSpc>
+                <a:spcPct val="104000"/>
+              </a:lnSpc>
+              <a:spcAft>
+                <a:spcPts val="700"/>
+              </a:spcAft>
+            </a:pPr>
+            <a:r>
+              <a:rPr sz="1150" b="1">
+                <a:solidFill>
+                  <a:srgbClr val="4A5D75"/>
+                </a:solidFill>
+                <a:latin typeface="Calibri"/>
+              </a:rPr>
+              <a:t>2.15   </a:t>
+            </a:r>
+            <a:r>
+              <a:rPr sz="1150">
+                <a:solidFill>
+                  <a:srgbClr val="1E334E"/>
+                </a:solidFill>
+                <a:latin typeface="Calibri"/>
+              </a:rPr>
+              <a:t>Repeatable and conviction-sized — not lucky</a:t>
+            </a:r>
+          </a:p>
+          <a:p>
+            <a:pPr>
+              <a:lnSpc>
+                <a:spcPct val="104000"/>
+              </a:lnSpc>
+              <a:spcAft>
+                <a:spcPts val="700"/>
+              </a:spcAft>
+            </a:pPr>
+            <a:r>
+              <a:rPr sz="1150" b="1">
+                <a:solidFill>
+                  <a:srgbClr val="4A5D75"/>
+                </a:solidFill>
+                <a:latin typeface="Calibri"/>
+              </a:rPr>
+              <a:t>2.16   </a:t>
+            </a:r>
+            <a:r>
+              <a:rPr sz="1150">
+                <a:solidFill>
+                  <a:srgbClr val="1E334E"/>
+                </a:solidFill>
+                <a:latin typeface="Calibri"/>
+              </a:rPr>
+              <a:t>Why a non-linear path won’t get you fired</a:t>
+            </a:r>
+          </a:p>
+          <a:p>
+            <a:pPr>
+              <a:lnSpc>
+                <a:spcPct val="104000"/>
+              </a:lnSpc>
+              <a:spcAft>
+                <a:spcPts val="700"/>
+              </a:spcAft>
+            </a:pPr>
+            <a:r>
+              <a:rPr sz="1150" b="1">
+                <a:solidFill>
+                  <a:srgbClr val="4A5D75"/>
+                </a:solidFill>
+                <a:latin typeface="Calibri"/>
+              </a:rPr>
+              <a:t>2.17   </a:t>
+            </a:r>
+            <a:r>
+              <a:rPr sz="1150">
+                <a:solidFill>
+                  <a:srgbClr val="1E334E"/>
+                </a:solidFill>
+                <a:latin typeface="Calibri"/>
+              </a:rPr>
+              <a:t>Responsible ownership, by construction</a:t>
             </a:r>
           </a:p>
         </p:txBody>

</xml_diff>

<commit_message>
Full brand compliance: in-palette loss treatment (italic Blue), brand-recolored theme scheme + fonts, fix footnote
</commit_message>
<xml_diff>
--- a/Athanase_Engaged_Ownership_Allocator_Deck.pptx
+++ b/Athanase_Engaged_Ownership_Allocator_Deck.pptx
@@ -7656,7 +7656,7 @@
             <a:avLst/>
           </a:prstGeom>
           <a:solidFill>
-            <a:srgbClr val="A84A4A"/>
+            <a:srgbClr val="314359"/>
           </a:solidFill>
           <a:ln>
             <a:noFill/>
@@ -7718,7 +7718,7 @@
             <a:r>
               <a:rPr sz="960" b="1" i="0">
                 <a:solidFill>
-                  <a:srgbClr val="A84A4A"/>
+                  <a:srgbClr val="314359"/>
                 </a:solidFill>
                 <a:latin typeface="Arial"/>
               </a:rPr>
@@ -21818,9 +21818,9 @@
               </a:spcAft>
             </a:pPr>
             <a:r>
-              <a:rPr sz="800" b="0" i="0">
-                <a:solidFill>
-                  <a:srgbClr val="A84A4A"/>
+              <a:rPr sz="800" b="0" i="1">
+                <a:solidFill>
+                  <a:srgbClr val="556A83"/>
                 </a:solidFill>
                 <a:latin typeface="Arial"/>
               </a:rPr>
@@ -21904,9 +21904,9 @@
               </a:spcAft>
             </a:pPr>
             <a:r>
-              <a:rPr sz="800" b="0" i="0">
-                <a:solidFill>
-                  <a:srgbClr val="A84A4A"/>
+              <a:rPr sz="800" b="0" i="1">
+                <a:solidFill>
+                  <a:srgbClr val="556A83"/>
                 </a:solidFill>
                 <a:latin typeface="Arial"/>
               </a:rPr>
@@ -21990,9 +21990,9 @@
               </a:spcAft>
             </a:pPr>
             <a:r>
-              <a:rPr sz="800" b="0" i="0">
-                <a:solidFill>
-                  <a:srgbClr val="A84A4A"/>
+              <a:rPr sz="800" b="0" i="1">
+                <a:solidFill>
+                  <a:srgbClr val="556A83"/>
                 </a:solidFill>
                 <a:latin typeface="Arial"/>
               </a:rPr>
@@ -28134,9 +28134,9 @@
               </a:spcAft>
             </a:pPr>
             <a:r>
-              <a:rPr sz="800" b="0" i="0">
-                <a:solidFill>
-                  <a:srgbClr val="A84A4A"/>
+              <a:rPr sz="800" b="0" i="1">
+                <a:solidFill>
+                  <a:srgbClr val="556A83"/>
                 </a:solidFill>
                 <a:latin typeface="Arial"/>
               </a:rPr>
@@ -28220,9 +28220,9 @@
               </a:spcAft>
             </a:pPr>
             <a:r>
-              <a:rPr sz="800" b="0" i="0">
-                <a:solidFill>
-                  <a:srgbClr val="A84A4A"/>
+              <a:rPr sz="800" b="0" i="1">
+                <a:solidFill>
+                  <a:srgbClr val="556A83"/>
                 </a:solidFill>
                 <a:latin typeface="Arial"/>
               </a:rPr>
@@ -30714,9 +30714,9 @@
               </a:spcAft>
             </a:pPr>
             <a:r>
-              <a:rPr sz="800" b="0" i="0">
-                <a:solidFill>
-                  <a:srgbClr val="A84A4A"/>
+              <a:rPr sz="800" b="0" i="1">
+                <a:solidFill>
+                  <a:srgbClr val="556A83"/>
                 </a:solidFill>
                 <a:latin typeface="Arial"/>
               </a:rPr>
@@ -30800,9 +30800,9 @@
               </a:spcAft>
             </a:pPr>
             <a:r>
-              <a:rPr sz="800" b="0" i="0">
-                <a:solidFill>
-                  <a:srgbClr val="A84A4A"/>
+              <a:rPr sz="800" b="0" i="1">
+                <a:solidFill>
+                  <a:srgbClr val="556A83"/>
                 </a:solidFill>
                 <a:latin typeface="Arial"/>
               </a:rPr>
@@ -30934,7 +30934,7 @@
                 </a:solidFill>
                 <a:latin typeface="Arial"/>
               </a:rPr>
-              <a:t>Selected larger deals of the investment team. Losses shown in red. Capital in SEK; ~$400M invested over the period.</a:t>
+              <a:t>Selected larger deals of the investment team. Losses shown in italic. Capital in SEK; ~$400M invested over the period.</a:t>
             </a:r>
           </a:p>
         </p:txBody>
@@ -36602,45 +36602,45 @@
   <a:themeElements>
     <a:clrScheme name="Office">
       <a:dk1>
-        <a:sysClr val="windowText" lastClr="000000"/>
+        <a:srgbClr val="152130"/>
       </a:dk1>
       <a:lt1>
-        <a:sysClr val="window" lastClr="FFFFFF"/>
+        <a:srgbClr val="FFFFFF"/>
       </a:lt1>
       <a:dk2>
-        <a:srgbClr val="1F497D"/>
+        <a:srgbClr val="0E1620"/>
       </a:dk2>
       <a:lt2>
-        <a:srgbClr val="EEECE1"/>
+        <a:srgbClr val="F6F7F9"/>
       </a:lt2>
       <a:accent1>
-        <a:srgbClr val="4F81BD"/>
+        <a:srgbClr val="152130"/>
       </a:accent1>
       <a:accent2>
-        <a:srgbClr val="C0504D"/>
+        <a:srgbClr val="314359"/>
       </a:accent2>
       <a:accent3>
-        <a:srgbClr val="9BBB59"/>
+        <a:srgbClr val="556A83"/>
       </a:accent3>
       <a:accent4>
-        <a:srgbClr val="8064A2"/>
+        <a:srgbClr val="0E1620"/>
       </a:accent4>
       <a:accent5>
-        <a:srgbClr val="4BACC6"/>
+        <a:srgbClr val="E2E5E9"/>
       </a:accent5>
       <a:accent6>
-        <a:srgbClr val="F79646"/>
+        <a:srgbClr val="F6F7F9"/>
       </a:accent6>
       <a:hlink>
-        <a:srgbClr val="0000FF"/>
+        <a:srgbClr val="314359"/>
       </a:hlink>
       <a:folHlink>
-        <a:srgbClr val="800080"/>
+        <a:srgbClr val="556A83"/>
       </a:folHlink>
     </a:clrScheme>
     <a:fontScheme name="Office">
       <a:majorFont>
-        <a:latin typeface="Calibri"/>
+        <a:latin typeface="Times New Roman"/>
         <a:ea typeface=""/>
         <a:cs typeface=""/>
         <a:font script="Jpan" typeface="ＭＳ Ｐゴシック"/>
@@ -36675,7 +36675,7 @@
         <a:font script="Geor" typeface="Sylfaen"/>
       </a:majorFont>
       <a:minorFont>
-        <a:latin typeface="Calibri"/>
+        <a:latin typeface="Arial"/>
         <a:ea typeface=""/>
         <a:cs typeface=""/>
         <a:font script="Jpan" typeface="ＭＳ Ｐゴシック"/>

</xml_diff>

<commit_message>
Add hanging indent to bullets so wrapped lines align with text, not under the marker
</commit_message>
<xml_diff>
--- a/Athanase_Engaged_Ownership_Allocator_Deck.pptx
+++ b/Athanase_Engaged_Ownership_Allocator_Deck.pptx
@@ -4955,7 +4955,7 @@
           </a:bodyPr>
           <a:lstStyle/>
           <a:p>
-            <a:pPr>
+            <a:pPr marL="175264" indent="-175264">
               <a:lnSpc>
                 <a:spcPct val="112000"/>
               </a:lnSpc>
@@ -4992,7 +4992,7 @@
             </a:r>
           </a:p>
           <a:p>
-            <a:pPr>
+            <a:pPr marL="175264" indent="-175264">
               <a:lnSpc>
                 <a:spcPct val="112000"/>
               </a:lnSpc>
@@ -5029,7 +5029,7 @@
             </a:r>
           </a:p>
           <a:p>
-            <a:pPr>
+            <a:pPr marL="175264" indent="-175264">
               <a:lnSpc>
                 <a:spcPct val="112000"/>
               </a:lnSpc>
@@ -5993,7 +5993,7 @@
           </a:bodyPr>
           <a:lstStyle/>
           <a:p>
-            <a:pPr>
+            <a:pPr marL="169422" indent="-169422">
               <a:lnSpc>
                 <a:spcPct val="112000"/>
               </a:lnSpc>
@@ -6030,7 +6030,7 @@
             </a:r>
           </a:p>
           <a:p>
-            <a:pPr>
+            <a:pPr marL="169422" indent="-169422">
               <a:lnSpc>
                 <a:spcPct val="112000"/>
               </a:lnSpc>
@@ -6067,7 +6067,7 @@
             </a:r>
           </a:p>
           <a:p>
-            <a:pPr>
+            <a:pPr marL="169422" indent="-169422">
               <a:lnSpc>
                 <a:spcPct val="112000"/>
               </a:lnSpc>
@@ -6104,7 +6104,7 @@
             </a:r>
           </a:p>
           <a:p>
-            <a:pPr>
+            <a:pPr marL="169422" indent="-169422">
               <a:lnSpc>
                 <a:spcPct val="112000"/>
               </a:lnSpc>
@@ -6141,7 +6141,7 @@
             </a:r>
           </a:p>
           <a:p>
-            <a:pPr>
+            <a:pPr marL="169422" indent="-169422">
               <a:lnSpc>
                 <a:spcPct val="112000"/>
               </a:lnSpc>
@@ -6541,7 +6541,7 @@
           </a:bodyPr>
           <a:lstStyle/>
           <a:p>
-            <a:pPr>
+            <a:pPr marL="157738" indent="-157738">
               <a:lnSpc>
                 <a:spcPct val="112000"/>
               </a:lnSpc>
@@ -6578,7 +6578,7 @@
             </a:r>
           </a:p>
           <a:p>
-            <a:pPr>
+            <a:pPr marL="157738" indent="-157738">
               <a:lnSpc>
                 <a:spcPct val="112000"/>
               </a:lnSpc>
@@ -6615,7 +6615,7 @@
             </a:r>
           </a:p>
           <a:p>
-            <a:pPr>
+            <a:pPr marL="157738" indent="-157738">
               <a:lnSpc>
                 <a:spcPct val="112000"/>
               </a:lnSpc>
@@ -6652,7 +6652,7 @@
             </a:r>
           </a:p>
           <a:p>
-            <a:pPr>
+            <a:pPr marL="157738" indent="-157738">
               <a:lnSpc>
                 <a:spcPct val="112000"/>
               </a:lnSpc>
@@ -7112,7 +7112,7 @@
           </a:bodyPr>
           <a:lstStyle/>
           <a:p>
-            <a:pPr>
+            <a:pPr marL="157738" indent="-157738">
               <a:lnSpc>
                 <a:spcPct val="112000"/>
               </a:lnSpc>
@@ -7149,7 +7149,7 @@
             </a:r>
           </a:p>
           <a:p>
-            <a:pPr>
+            <a:pPr marL="157738" indent="-157738">
               <a:lnSpc>
                 <a:spcPct val="112000"/>
               </a:lnSpc>
@@ -7186,7 +7186,7 @@
             </a:r>
           </a:p>
           <a:p>
-            <a:pPr>
+            <a:pPr marL="157738" indent="-157738">
               <a:lnSpc>
                 <a:spcPct val="112000"/>
               </a:lnSpc>
@@ -7223,7 +7223,7 @@
             </a:r>
           </a:p>
           <a:p>
-            <a:pPr>
+            <a:pPr marL="157738" indent="-157738">
               <a:lnSpc>
                 <a:spcPct val="112000"/>
               </a:lnSpc>
@@ -12229,7 +12229,7 @@
           </a:bodyPr>
           <a:lstStyle/>
           <a:p>
-            <a:pPr>
+            <a:pPr marL="169422" indent="-169422">
               <a:lnSpc>
                 <a:spcPct val="112000"/>
               </a:lnSpc>
@@ -12266,7 +12266,7 @@
             </a:r>
           </a:p>
           <a:p>
-            <a:pPr>
+            <a:pPr marL="169422" indent="-169422">
               <a:lnSpc>
                 <a:spcPct val="112000"/>
               </a:lnSpc>
@@ -12303,7 +12303,7 @@
             </a:r>
           </a:p>
           <a:p>
-            <a:pPr>
+            <a:pPr marL="169422" indent="-169422">
               <a:lnSpc>
                 <a:spcPct val="112000"/>
               </a:lnSpc>
@@ -12340,7 +12340,7 @@
             </a:r>
           </a:p>
           <a:p>
-            <a:pPr>
+            <a:pPr marL="169422" indent="-169422">
               <a:lnSpc>
                 <a:spcPct val="112000"/>
               </a:lnSpc>
@@ -12377,7 +12377,7 @@
             </a:r>
           </a:p>
           <a:p>
-            <a:pPr>
+            <a:pPr marL="169422" indent="-169422">
               <a:lnSpc>
                 <a:spcPct val="112000"/>
               </a:lnSpc>
@@ -12777,7 +12777,7 @@
           </a:bodyPr>
           <a:lstStyle/>
           <a:p>
-            <a:pPr>
+            <a:pPr marL="157738" indent="-157738">
               <a:lnSpc>
                 <a:spcPct val="112000"/>
               </a:lnSpc>
@@ -12814,7 +12814,7 @@
             </a:r>
           </a:p>
           <a:p>
-            <a:pPr>
+            <a:pPr marL="157738" indent="-157738">
               <a:lnSpc>
                 <a:spcPct val="112000"/>
               </a:lnSpc>
@@ -12851,7 +12851,7 @@
             </a:r>
           </a:p>
           <a:p>
-            <a:pPr>
+            <a:pPr marL="157738" indent="-157738">
               <a:lnSpc>
                 <a:spcPct val="112000"/>
               </a:lnSpc>
@@ -31755,7 +31755,7 @@
           </a:bodyPr>
           <a:lstStyle/>
           <a:p>
-            <a:pPr>
+            <a:pPr marL="163580" indent="-163580">
               <a:lnSpc>
                 <a:spcPct val="112000"/>
               </a:lnSpc>
@@ -31792,7 +31792,7 @@
             </a:r>
           </a:p>
           <a:p>
-            <a:pPr>
+            <a:pPr marL="163580" indent="-163580">
               <a:lnSpc>
                 <a:spcPct val="112000"/>
               </a:lnSpc>
@@ -31829,7 +31829,7 @@
             </a:r>
           </a:p>
           <a:p>
-            <a:pPr>
+            <a:pPr marL="163580" indent="-163580">
               <a:lnSpc>
                 <a:spcPct val="112000"/>
               </a:lnSpc>
@@ -33326,7 +33326,7 @@
           </a:bodyPr>
           <a:lstStyle/>
           <a:p>
-            <a:pPr>
+            <a:pPr marL="186949" indent="-186949">
               <a:lnSpc>
                 <a:spcPct val="112000"/>
               </a:lnSpc>
@@ -33363,7 +33363,7 @@
             </a:r>
           </a:p>
           <a:p>
-            <a:pPr>
+            <a:pPr marL="186949" indent="-186949">
               <a:lnSpc>
                 <a:spcPct val="112000"/>
               </a:lnSpc>
@@ -33400,7 +33400,7 @@
             </a:r>
           </a:p>
           <a:p>
-            <a:pPr>
+            <a:pPr marL="186949" indent="-186949">
               <a:lnSpc>
                 <a:spcPct val="112000"/>
               </a:lnSpc>
@@ -33437,7 +33437,7 @@
             </a:r>
           </a:p>
           <a:p>
-            <a:pPr>
+            <a:pPr marL="186949" indent="-186949">
               <a:lnSpc>
                 <a:spcPct val="112000"/>
               </a:lnSpc>
@@ -34360,7 +34360,7 @@
           </a:bodyPr>
           <a:lstStyle/>
           <a:p>
-            <a:pPr>
+            <a:pPr marL="181107" indent="-181107">
               <a:lnSpc>
                 <a:spcPct val="112000"/>
               </a:lnSpc>
@@ -34397,7 +34397,7 @@
             </a:r>
           </a:p>
           <a:p>
-            <a:pPr>
+            <a:pPr marL="181107" indent="-181107">
               <a:lnSpc>
                 <a:spcPct val="112000"/>
               </a:lnSpc>
@@ -34434,7 +34434,7 @@
             </a:r>
           </a:p>
           <a:p>
-            <a:pPr>
+            <a:pPr marL="181107" indent="-181107">
               <a:lnSpc>
                 <a:spcPct val="112000"/>
               </a:lnSpc>
@@ -34471,7 +34471,7 @@
             </a:r>
           </a:p>
           <a:p>
-            <a:pPr>
+            <a:pPr marL="181107" indent="-181107">
               <a:lnSpc>
                 <a:spcPct val="112000"/>
               </a:lnSpc>
@@ -34508,7 +34508,7 @@
             </a:r>
           </a:p>
           <a:p>
-            <a:pPr>
+            <a:pPr marL="181107" indent="-181107">
               <a:lnSpc>
                 <a:spcPct val="112000"/>
               </a:lnSpc>
@@ -34824,7 +34824,7 @@
           </a:bodyPr>
           <a:lstStyle/>
           <a:p>
-            <a:pPr>
+            <a:pPr marL="192790" indent="-192790">
               <a:lnSpc>
                 <a:spcPct val="112000"/>
               </a:lnSpc>
@@ -34861,7 +34861,7 @@
             </a:r>
           </a:p>
           <a:p>
-            <a:pPr>
+            <a:pPr marL="192790" indent="-192790">
               <a:lnSpc>
                 <a:spcPct val="112000"/>
               </a:lnSpc>
@@ -34898,7 +34898,7 @@
             </a:r>
           </a:p>
           <a:p>
-            <a:pPr>
+            <a:pPr marL="192790" indent="-192790">
               <a:lnSpc>
                 <a:spcPct val="112000"/>
               </a:lnSpc>
@@ -34935,7 +34935,7 @@
             </a:r>
           </a:p>
           <a:p>
-            <a:pPr>
+            <a:pPr marL="192790" indent="-192790">
               <a:lnSpc>
                 <a:spcPct val="112000"/>
               </a:lnSpc>
@@ -35251,7 +35251,7 @@
           </a:bodyPr>
           <a:lstStyle/>
           <a:p>
-            <a:pPr>
+            <a:pPr marL="192790" indent="-192790">
               <a:lnSpc>
                 <a:spcPct val="112000"/>
               </a:lnSpc>
@@ -35288,7 +35288,7 @@
             </a:r>
           </a:p>
           <a:p>
-            <a:pPr>
+            <a:pPr marL="192790" indent="-192790">
               <a:lnSpc>
                 <a:spcPct val="112000"/>
               </a:lnSpc>
@@ -35325,7 +35325,7 @@
             </a:r>
           </a:p>
           <a:p>
-            <a:pPr>
+            <a:pPr marL="192790" indent="-192790">
               <a:lnSpc>
                 <a:spcPct val="112000"/>
               </a:lnSpc>
@@ -35362,7 +35362,7 @@
             </a:r>
           </a:p>
           <a:p>
-            <a:pPr>
+            <a:pPr marL="192790" indent="-192790">
               <a:lnSpc>
                 <a:spcPct val="112000"/>
               </a:lnSpc>
@@ -35678,7 +35678,7 @@
           </a:bodyPr>
           <a:lstStyle/>
           <a:p>
-            <a:pPr>
+            <a:pPr marL="192790" indent="-192790">
               <a:lnSpc>
                 <a:spcPct val="112000"/>
               </a:lnSpc>
@@ -35715,7 +35715,7 @@
             </a:r>
           </a:p>
           <a:p>
-            <a:pPr>
+            <a:pPr marL="192790" indent="-192790">
               <a:lnSpc>
                 <a:spcPct val="112000"/>
               </a:lnSpc>
@@ -35752,7 +35752,7 @@
             </a:r>
           </a:p>
           <a:p>
-            <a:pPr>
+            <a:pPr marL="192790" indent="-192790">
               <a:lnSpc>
                 <a:spcPct val="112000"/>
               </a:lnSpc>
@@ -35789,7 +35789,7 @@
             </a:r>
           </a:p>
           <a:p>
-            <a:pPr>
+            <a:pPr marL="192790" indent="-192790">
               <a:lnSpc>
                 <a:spcPct val="112000"/>
               </a:lnSpc>
@@ -36147,7 +36147,7 @@
           </a:bodyPr>
           <a:lstStyle/>
           <a:p>
-            <a:pPr>
+            <a:pPr marL="181107" indent="-181107">
               <a:lnSpc>
                 <a:spcPct val="112000"/>
               </a:lnSpc>
@@ -36184,7 +36184,7 @@
             </a:r>
           </a:p>
           <a:p>
-            <a:pPr>
+            <a:pPr marL="181107" indent="-181107">
               <a:lnSpc>
                 <a:spcPct val="112000"/>
               </a:lnSpc>
@@ -36221,7 +36221,7 @@
             </a:r>
           </a:p>
           <a:p>
-            <a:pPr>
+            <a:pPr marL="181107" indent="-181107">
               <a:lnSpc>
                 <a:spcPct val="112000"/>
               </a:lnSpc>
@@ -36258,7 +36258,7 @@
             </a:r>
           </a:p>
           <a:p>
-            <a:pPr>
+            <a:pPr marL="181107" indent="-181107">
               <a:lnSpc>
                 <a:spcPct val="112000"/>
               </a:lnSpc>
@@ -36295,7 +36295,7 @@
             </a:r>
           </a:p>
           <a:p>
-            <a:pPr>
+            <a:pPr marL="181107" indent="-181107">
               <a:lnSpc>
                 <a:spcPct val="112000"/>
               </a:lnSpc>

</xml_diff>

<commit_message>
Add portfolio-impact slide: Athanase vs long-only / other activist across 3/5/8% sleeves
</commit_message>
<xml_diff>
--- a/Athanase_Engaged_Ownership_Allocator_Deck.pptx
+++ b/Athanase_Engaged_Ownership_Allocator_Deck.pptx
@@ -32,6 +32,7 @@
     <p:sldId id="280" r:id="rId31"/>
     <p:sldId id="281" r:id="rId32"/>
     <p:sldId id="282" r:id="rId33"/>
+    <p:sldId id="283" r:id="rId34"/>
   </p:sldIdLst>
   <p:sldSz cx="9753600" cy="7315200" type="screen4x3"/>
   <p:notesSz cx="6858000" cy="9144000"/>
@@ -985,6 +986,449 @@
 </c:chartSpace>
 </file>
 
+<file path=ppt/charts/chart4.xml><?xml version="1.0" encoding="utf-8"?>
+<c:chartSpace xmlns:c="http://schemas.openxmlformats.org/drawingml/2006/chart" xmlns:a="http://schemas.openxmlformats.org/drawingml/2006/main" xmlns:r="http://schemas.openxmlformats.org/officeDocument/2006/relationships">
+  <c:date1904 val="0"/>
+  <c:chart>
+    <c:title>
+      <c:tx>
+        <c:rich>
+          <a:bodyPr/>
+          <a:lstStyle/>
+          <a:p>
+            <a:r>
+              <a:rPr sz="880">
+                <a:solidFill>
+                  <a:srgbClr val="556A83"/>
+                </a:solidFill>
+              </a:rPr>
+              <a:t>Figure 5.  Growth of a 100 sleeve over 10 years (indexed)</a:t>
+            </a:r>
+          </a:p>
+        </c:rich>
+      </c:tx>
+      <c:layout/>
+      <c:overlay val="0"/>
+    </c:title>
+    <c:autoTitleDeleted val="0"/>
+    <c:plotArea>
+      <c:lineChart>
+        <c:grouping val="standard"/>
+        <c:varyColors val="0"/>
+        <c:ser>
+          <c:idx val="0"/>
+          <c:order val="0"/>
+          <c:tx>
+            <c:strRef>
+              <c:f>Sheet1!$B$1</c:f>
+              <c:strCache>
+                <c:ptCount val="1"/>
+                <c:pt idx="0">
+                  <c:v>Athanase (18%)</c:v>
+                </c:pt>
+              </c:strCache>
+            </c:strRef>
+          </c:tx>
+          <c:spPr>
+            <a:ln w="38100">
+              <a:solidFill>
+                <a:srgbClr val="152130"/>
+              </a:solidFill>
+            </a:ln>
+          </c:spPr>
+          <c:marker>
+            <c:symbol val="none"/>
+          </c:marker>
+          <c:cat>
+            <c:strRef>
+              <c:f>Sheet1!$A$2:$A$12</c:f>
+              <c:strCache>
+                <c:ptCount val="11"/>
+                <c:pt idx="0">
+                  <c:v>0</c:v>
+                </c:pt>
+                <c:pt idx="1">
+                  <c:v>1</c:v>
+                </c:pt>
+                <c:pt idx="2">
+                  <c:v>2</c:v>
+                </c:pt>
+                <c:pt idx="3">
+                  <c:v>3</c:v>
+                </c:pt>
+                <c:pt idx="4">
+                  <c:v>4</c:v>
+                </c:pt>
+                <c:pt idx="5">
+                  <c:v>5</c:v>
+                </c:pt>
+                <c:pt idx="6">
+                  <c:v>6</c:v>
+                </c:pt>
+                <c:pt idx="7">
+                  <c:v>7</c:v>
+                </c:pt>
+                <c:pt idx="8">
+                  <c:v>8</c:v>
+                </c:pt>
+                <c:pt idx="9">
+                  <c:v>9</c:v>
+                </c:pt>
+                <c:pt idx="10">
+                  <c:v>10</c:v>
+                </c:pt>
+              </c:strCache>
+            </c:strRef>
+          </c:cat>
+          <c:val>
+            <c:numRef>
+              <c:f>Sheet1!$B$2:$B$12</c:f>
+              <c:numCache>
+                <c:formatCode>General</c:formatCode>
+                <c:ptCount val="11"/>
+                <c:pt idx="0">
+                  <c:v>100</c:v>
+                </c:pt>
+                <c:pt idx="1">
+                  <c:v>118</c:v>
+                </c:pt>
+                <c:pt idx="2">
+                  <c:v>139</c:v>
+                </c:pt>
+                <c:pt idx="3">
+                  <c:v>164</c:v>
+                </c:pt>
+                <c:pt idx="4">
+                  <c:v>194</c:v>
+                </c:pt>
+                <c:pt idx="5">
+                  <c:v>229</c:v>
+                </c:pt>
+                <c:pt idx="6">
+                  <c:v>270</c:v>
+                </c:pt>
+                <c:pt idx="7">
+                  <c:v>319</c:v>
+                </c:pt>
+                <c:pt idx="8">
+                  <c:v>376</c:v>
+                </c:pt>
+                <c:pt idx="9">
+                  <c:v>444</c:v>
+                </c:pt>
+                <c:pt idx="10">
+                  <c:v>523</c:v>
+                </c:pt>
+              </c:numCache>
+            </c:numRef>
+          </c:val>
+          <c:smooth/>
+        </c:ser>
+        <c:ser>
+          <c:idx val="1"/>
+          <c:order val="1"/>
+          <c:tx>
+            <c:strRef>
+              <c:f>Sheet1!$C$1</c:f>
+              <c:strCache>
+                <c:ptCount val="1"/>
+                <c:pt idx="0">
+                  <c:v>Other activist (10.5%)</c:v>
+                </c:pt>
+              </c:strCache>
+            </c:strRef>
+          </c:tx>
+          <c:spPr>
+            <a:ln w="25400">
+              <a:solidFill>
+                <a:srgbClr val="556A83"/>
+              </a:solidFill>
+            </a:ln>
+          </c:spPr>
+          <c:marker>
+            <c:symbol val="none"/>
+          </c:marker>
+          <c:cat>
+            <c:strRef>
+              <c:f>Sheet1!$A$2:$A$12</c:f>
+              <c:strCache>
+                <c:ptCount val="11"/>
+                <c:pt idx="0">
+                  <c:v>0</c:v>
+                </c:pt>
+                <c:pt idx="1">
+                  <c:v>1</c:v>
+                </c:pt>
+                <c:pt idx="2">
+                  <c:v>2</c:v>
+                </c:pt>
+                <c:pt idx="3">
+                  <c:v>3</c:v>
+                </c:pt>
+                <c:pt idx="4">
+                  <c:v>4</c:v>
+                </c:pt>
+                <c:pt idx="5">
+                  <c:v>5</c:v>
+                </c:pt>
+                <c:pt idx="6">
+                  <c:v>6</c:v>
+                </c:pt>
+                <c:pt idx="7">
+                  <c:v>7</c:v>
+                </c:pt>
+                <c:pt idx="8">
+                  <c:v>8</c:v>
+                </c:pt>
+                <c:pt idx="9">
+                  <c:v>9</c:v>
+                </c:pt>
+                <c:pt idx="10">
+                  <c:v>10</c:v>
+                </c:pt>
+              </c:strCache>
+            </c:strRef>
+          </c:cat>
+          <c:val>
+            <c:numRef>
+              <c:f>Sheet1!$C$2:$C$12</c:f>
+              <c:numCache>
+                <c:formatCode>General</c:formatCode>
+                <c:ptCount val="11"/>
+                <c:pt idx="0">
+                  <c:v>100</c:v>
+                </c:pt>
+                <c:pt idx="1">
+                  <c:v>111</c:v>
+                </c:pt>
+                <c:pt idx="2">
+                  <c:v>122</c:v>
+                </c:pt>
+                <c:pt idx="3">
+                  <c:v>135</c:v>
+                </c:pt>
+                <c:pt idx="4">
+                  <c:v>149</c:v>
+                </c:pt>
+                <c:pt idx="5">
+                  <c:v>165</c:v>
+                </c:pt>
+                <c:pt idx="6">
+                  <c:v>182</c:v>
+                </c:pt>
+                <c:pt idx="7">
+                  <c:v>201</c:v>
+                </c:pt>
+                <c:pt idx="8">
+                  <c:v>222</c:v>
+                </c:pt>
+                <c:pt idx="9">
+                  <c:v>246</c:v>
+                </c:pt>
+                <c:pt idx="10">
+                  <c:v>271</c:v>
+                </c:pt>
+              </c:numCache>
+            </c:numRef>
+          </c:val>
+          <c:smooth/>
+        </c:ser>
+        <c:ser>
+          <c:idx val="2"/>
+          <c:order val="2"/>
+          <c:tx>
+            <c:strRef>
+              <c:f>Sheet1!$D$1</c:f>
+              <c:strCache>
+                <c:ptCount val="1"/>
+                <c:pt idx="0">
+                  <c:v>Long-only global (7.6%)</c:v>
+                </c:pt>
+              </c:strCache>
+            </c:strRef>
+          </c:tx>
+          <c:spPr>
+            <a:ln w="25400">
+              <a:solidFill>
+                <a:srgbClr val="E2E5E9"/>
+              </a:solidFill>
+              <a:prstDash val="sysDash"/>
+            </a:ln>
+          </c:spPr>
+          <c:marker>
+            <c:symbol val="none"/>
+          </c:marker>
+          <c:cat>
+            <c:strRef>
+              <c:f>Sheet1!$A$2:$A$12</c:f>
+              <c:strCache>
+                <c:ptCount val="11"/>
+                <c:pt idx="0">
+                  <c:v>0</c:v>
+                </c:pt>
+                <c:pt idx="1">
+                  <c:v>1</c:v>
+                </c:pt>
+                <c:pt idx="2">
+                  <c:v>2</c:v>
+                </c:pt>
+                <c:pt idx="3">
+                  <c:v>3</c:v>
+                </c:pt>
+                <c:pt idx="4">
+                  <c:v>4</c:v>
+                </c:pt>
+                <c:pt idx="5">
+                  <c:v>5</c:v>
+                </c:pt>
+                <c:pt idx="6">
+                  <c:v>6</c:v>
+                </c:pt>
+                <c:pt idx="7">
+                  <c:v>7</c:v>
+                </c:pt>
+                <c:pt idx="8">
+                  <c:v>8</c:v>
+                </c:pt>
+                <c:pt idx="9">
+                  <c:v>9</c:v>
+                </c:pt>
+                <c:pt idx="10">
+                  <c:v>10</c:v>
+                </c:pt>
+              </c:strCache>
+            </c:strRef>
+          </c:cat>
+          <c:val>
+            <c:numRef>
+              <c:f>Sheet1!$D$2:$D$12</c:f>
+              <c:numCache>
+                <c:formatCode>General</c:formatCode>
+                <c:ptCount val="11"/>
+                <c:pt idx="0">
+                  <c:v>100</c:v>
+                </c:pt>
+                <c:pt idx="1">
+                  <c:v>108</c:v>
+                </c:pt>
+                <c:pt idx="2">
+                  <c:v>116</c:v>
+                </c:pt>
+                <c:pt idx="3">
+                  <c:v>125</c:v>
+                </c:pt>
+                <c:pt idx="4">
+                  <c:v>134</c:v>
+                </c:pt>
+                <c:pt idx="5">
+                  <c:v>144</c:v>
+                </c:pt>
+                <c:pt idx="6">
+                  <c:v>155</c:v>
+                </c:pt>
+                <c:pt idx="7">
+                  <c:v>167</c:v>
+                </c:pt>
+                <c:pt idx="8">
+                  <c:v>180</c:v>
+                </c:pt>
+                <c:pt idx="9">
+                  <c:v>193</c:v>
+                </c:pt>
+                <c:pt idx="10">
+                  <c:v>208</c:v>
+                </c:pt>
+              </c:numCache>
+            </c:numRef>
+          </c:val>
+          <c:smooth/>
+        </c:ser>
+        <c:marker val="1"/>
+        <c:smooth val="0"/>
+        <c:axId val="2118791784"/>
+        <c:axId val="2140495176"/>
+      </c:lineChart>
+      <c:catAx>
+        <c:axId val="2118791784"/>
+        <c:scaling>
+          <c:orientation val="minMax"/>
+        </c:scaling>
+        <c:delete val="0"/>
+        <c:axPos val="b"/>
+        <c:majorTickMark val="out"/>
+        <c:minorTickMark val="none"/>
+        <c:tickLblPos val="nextTo"/>
+        <c:txPr>
+          <a:bodyPr/>
+          <a:lstStyle/>
+          <a:p>
+            <a:pPr>
+              <a:defRPr sz="720"/>
+            </a:pPr>
+          </a:p>
+        </c:txPr>
+        <c:crossAx val="2140495176"/>
+        <c:crosses val="autoZero"/>
+        <c:auto val="1"/>
+        <c:lblAlgn val="ctr"/>
+        <c:lblOffset val="100"/>
+        <c:noMultiLvlLbl val="0"/>
+      </c:catAx>
+      <c:valAx>
+        <c:axId val="2140495176"/>
+        <c:scaling/>
+        <c:delete val="0"/>
+        <c:axPos val="l"/>
+        <c:majorTickMark val="out"/>
+        <c:minorTickMark val="none"/>
+        <c:tickLblPos val="nextTo"/>
+        <c:txPr>
+          <a:bodyPr/>
+          <a:lstStyle/>
+          <a:p>
+            <a:pPr>
+              <a:defRPr sz="720"/>
+            </a:pPr>
+          </a:p>
+        </c:txPr>
+        <c:crossAx val="2118791784"/>
+        <c:crosses val="autoZero"/>
+      </c:valAx>
+    </c:plotArea>
+    <c:legend>
+      <c:legendPos val="b"/>
+      <c:layout/>
+      <c:overlay val="0"/>
+      <c:txPr>
+        <a:bodyPr/>
+        <a:lstStyle/>
+        <a:p>
+          <a:pPr>
+            <a:defRPr sz="800"/>
+          </a:pPr>
+        </a:p>
+      </c:txPr>
+    </c:legend>
+    <c:plotVisOnly val="1"/>
+    <c:dispBlanksAs val="gap"/>
+    <c:showDLblsOverMax val="0"/>
+  </c:chart>
+  <c:txPr>
+    <a:bodyPr/>
+    <a:lstStyle/>
+    <a:p>
+      <a:pPr>
+        <a:defRPr sz="1440"/>
+      </a:pPr>
+      <a:endParaRPr lang="en-US"/>
+    </a:p>
+  </c:txPr>
+  <c:externalData r:id="rId1">
+    <c:autoUpdate val="0"/>
+  </c:externalData>
+</c:chartSpace>
+</file>
+
 <file path=ppt/slideLayouts/slideLayout1.xml><?xml version="1.0" encoding="utf-8"?>
 <p:sldLayout xmlns:a="http://schemas.openxmlformats.org/drawingml/2006/main" xmlns:r="http://schemas.openxmlformats.org/officeDocument/2006/relationships" xmlns:p="http://schemas.openxmlformats.org/presentationml/2006/main" type="title" preserve="1">
   <p:cSld name="Title Slide">
@@ -15613,6 +16057,43 @@
                 </a:solidFill>
                 <a:latin typeface="Arial"/>
               </a:rPr>
+              <a:t>What it does to an allocator’s portfolio</a:t>
+            </a:r>
+            <a:r>
+              <a:rPr sz="760" i="1">
+                <a:solidFill>
+                  <a:srgbClr val="556A83"/>
+                </a:solidFill>
+                <a:latin typeface="Arial"/>
+              </a:rPr>
+              <a:t>   (Figure 5)</a:t>
+            </a:r>
+          </a:p>
+          <a:p>
+            <a:pPr>
+              <a:lnSpc>
+                <a:spcPct val="104000"/>
+              </a:lnSpc>
+              <a:spcAft>
+                <a:spcPts val="700"/>
+              </a:spcAft>
+            </a:pPr>
+            <a:r>
+              <a:rPr sz="919" b="1">
+                <a:solidFill>
+                  <a:srgbClr val="314359"/>
+                </a:solidFill>
+                <a:latin typeface="Arial"/>
+              </a:rPr>
+              <a:t>2.18   </a:t>
+            </a:r>
+            <a:r>
+              <a:rPr sz="919">
+                <a:solidFill>
+                  <a:srgbClr val="314359"/>
+                </a:solidFill>
+                <a:latin typeface="Arial"/>
+              </a:rPr>
               <a:t>Responsible ownership, by construction</a:t>
             </a:r>
           </a:p>
@@ -33171,21 +33652,63 @@
                 </a:solidFill>
                 <a:latin typeface="Arial"/>
               </a:rPr>
-              <a:t>Ownership Model</a:t>
-            </a:r>
-          </a:p>
-        </p:txBody>
-      </p:sp>
-      <p:sp>
-        <p:nvSpPr>
-          <p:cNvPr id="5" name="Rectangle 4"/>
+              <a:t>Portfolio Impact</a:t>
+            </a:r>
+          </a:p>
+        </p:txBody>
+      </p:sp>
+      <p:sp>
+        <p:nvSpPr>
+          <p:cNvPr id="5" name="TextBox 4"/>
+          <p:cNvSpPr txBox="1"/>
+          <p:nvPr/>
+        </p:nvSpPr>
+        <p:spPr>
+          <a:xfrm>
+            <a:off x="7242229" y="263347"/>
+            <a:ext cx="2084884" cy="292608"/>
+          </a:xfrm>
+          <a:prstGeom prst="rect">
+            <a:avLst/>
+          </a:prstGeom>
+          <a:noFill/>
+        </p:spPr>
+        <p:txBody>
+          <a:bodyPr wrap="square" anchor="t" lIns="0" rIns="0" tIns="0" bIns="0">
+            <a:spAutoFit/>
+          </a:bodyPr>
+          <a:lstStyle/>
+          <a:p>
+            <a:pPr algn="r">
+              <a:lnSpc>
+                <a:spcPct val="110000"/>
+              </a:lnSpc>
+              <a:spcAft>
+                <a:spcPts val="0"/>
+              </a:spcAft>
+            </a:pPr>
+            <a:r>
+              <a:rPr sz="880" b="1" i="0">
+                <a:solidFill>
+                  <a:srgbClr val="556A83"/>
+                </a:solidFill>
+                <a:latin typeface="Arial"/>
+              </a:rPr>
+              <a:t>Figure 5</a:t>
+            </a:r>
+          </a:p>
+        </p:txBody>
+      </p:sp>
+      <p:sp>
+        <p:nvSpPr>
+          <p:cNvPr id="6" name="Rectangle 5"/>
           <p:cNvSpPr/>
           <p:nvPr/>
         </p:nvSpPr>
         <p:spPr>
           <a:xfrm>
             <a:off x="0" y="604723"/>
-            <a:ext cx="9753600" cy="1024128"/>
+            <a:ext cx="9753600" cy="1414272"/>
           </a:xfrm>
           <a:prstGeom prst="rect">
             <a:avLst/>
@@ -33222,7 +33745,7 @@
       </p:sp>
       <p:sp>
         <p:nvSpPr>
-          <p:cNvPr id="6" name="TextBox 5"/>
+          <p:cNvPr id="7" name="TextBox 6"/>
           <p:cNvSpPr txBox="1"/>
           <p:nvPr/>
         </p:nvSpPr>
@@ -33257,14 +33780,56 @@
                 </a:solidFill>
                 <a:latin typeface="Times New Roman"/>
               </a:rPr>
-              <a:t>2.17 Responsible ownership, by construction</a:t>
-            </a:r>
-          </a:p>
-        </p:txBody>
-      </p:sp>
-      <p:sp>
-        <p:nvSpPr>
-          <p:cNvPr id="7" name="TextBox 6"/>
+              <a:t>2.17 What it does to an allocator’s portfolio</a:t>
+            </a:r>
+          </a:p>
+        </p:txBody>
+      </p:sp>
+      <p:sp>
+        <p:nvSpPr>
+          <p:cNvPr id="8" name="TextBox 7"/>
+          <p:cNvSpPr txBox="1"/>
+          <p:nvPr/>
+        </p:nvSpPr>
+        <p:spPr>
+          <a:xfrm>
+            <a:off x="453553" y="1511808"/>
+            <a:ext cx="8705305" cy="487680"/>
+          </a:xfrm>
+          <a:prstGeom prst="rect">
+            <a:avLst/>
+          </a:prstGeom>
+          <a:noFill/>
+        </p:spPr>
+        <p:txBody>
+          <a:bodyPr wrap="square" anchor="t" lIns="0" rIns="0" tIns="0" bIns="0">
+            <a:spAutoFit/>
+          </a:bodyPr>
+          <a:lstStyle/>
+          <a:p>
+            <a:pPr algn="l">
+              <a:lnSpc>
+                <a:spcPct val="110000"/>
+              </a:lnSpc>
+              <a:spcAft>
+                <a:spcPts val="0"/>
+              </a:spcAft>
+            </a:pPr>
+            <a:r>
+              <a:rPr sz="1040" b="0" i="1">
+                <a:solidFill>
+                  <a:srgbClr val="556A83"/>
+                </a:solidFill>
+                <a:latin typeface="Arial"/>
+              </a:rPr>
+              <a:t>Illustrative: redirecting a sleeve into Athanase rather than a long-only global fund or another activist.</a:t>
+            </a:r>
+          </a:p>
+        </p:txBody>
+      </p:sp>
+      <p:sp>
+        <p:nvSpPr>
+          <p:cNvPr id="9" name="TextBox 8"/>
           <p:cNvSpPr txBox="1"/>
           <p:nvPr/>
         </p:nvSpPr>
@@ -33304,16 +33869,34 @@
           </a:p>
         </p:txBody>
       </p:sp>
-      <p:sp>
-        <p:nvSpPr>
-          <p:cNvPr id="8" name="TextBox 7"/>
-          <p:cNvSpPr txBox="1"/>
-          <p:nvPr/>
-        </p:nvSpPr>
-        <p:spPr>
-          <a:xfrm>
-            <a:off x="548653" y="1901952"/>
-            <a:ext cx="8705305" cy="4584192"/>
+      <p:graphicFrame>
+        <p:nvGraphicFramePr>
+          <p:cNvPr id="10" name="Chart 9"/>
+          <p:cNvGraphicFramePr>
+            <a:graphicFrameLocks noGrp="1"/>
+          </p:cNvGraphicFramePr>
+          <p:nvPr/>
+        </p:nvGraphicFramePr>
+        <p:xfrm>
+          <a:off x="438922" y="2340864"/>
+          <a:ext cx="4901306" cy="4096512"/>
+        </p:xfrm>
+        <a:graphic>
+          <a:graphicData uri="http://schemas.openxmlformats.org/drawingml/2006/chart">
+            <c:chart xmlns:c="http://schemas.openxmlformats.org/drawingml/2006/chart" r:id="rId3"/>
+          </a:graphicData>
+        </a:graphic>
+      </p:graphicFrame>
+      <p:sp>
+        <p:nvSpPr>
+          <p:cNvPr id="11" name="TextBox 10"/>
+          <p:cNvSpPr txBox="1"/>
+          <p:nvPr/>
+        </p:nvSpPr>
+        <p:spPr>
+          <a:xfrm>
+            <a:off x="4791575" y="2828544"/>
+            <a:ext cx="950999" cy="292608"/>
           </a:xfrm>
           <a:prstGeom prst="rect">
             <a:avLst/>
@@ -33326,151 +33909,1264 @@
           </a:bodyPr>
           <a:lstStyle/>
           <a:p>
-            <a:pPr marL="186949" indent="-186949">
-              <a:lnSpc>
-                <a:spcPct val="112000"/>
-              </a:lnSpc>
-              <a:spcAft>
-                <a:spcPts val="1400"/>
-              </a:spcAft>
-            </a:pPr>
-            <a:r>
-              <a:rPr sz="1280" b="1">
+            <a:pPr algn="l">
+              <a:lnSpc>
+                <a:spcPct val="110000"/>
+              </a:lnSpc>
+              <a:spcAft>
+                <a:spcPts val="0"/>
+              </a:spcAft>
+            </a:pPr>
+            <a:r>
+              <a:rPr sz="960" b="1" i="0">
                 <a:solidFill>
                   <a:srgbClr val="314359"/>
                 </a:solidFill>
                 <a:latin typeface="Arial"/>
               </a:rPr>
-              <a:t>›  </a:t>
-            </a:r>
-            <a:r>
-              <a:rPr sz="1280" b="1">
+              <a:t>523</a:t>
+            </a:r>
+          </a:p>
+        </p:txBody>
+      </p:sp>
+      <p:sp>
+        <p:nvSpPr>
+          <p:cNvPr id="12" name="TextBox 11"/>
+          <p:cNvSpPr txBox="1"/>
+          <p:nvPr/>
+        </p:nvSpPr>
+        <p:spPr>
+          <a:xfrm>
+            <a:off x="4791575" y="4584192"/>
+            <a:ext cx="950999" cy="292608"/>
+          </a:xfrm>
+          <a:prstGeom prst="rect">
+            <a:avLst/>
+          </a:prstGeom>
+          <a:noFill/>
+        </p:spPr>
+        <p:txBody>
+          <a:bodyPr wrap="square" anchor="t" lIns="0" rIns="0" tIns="0" bIns="0">
+            <a:spAutoFit/>
+          </a:bodyPr>
+          <a:lstStyle/>
+          <a:p>
+            <a:pPr algn="l">
+              <a:lnSpc>
+                <a:spcPct val="110000"/>
+              </a:lnSpc>
+              <a:spcAft>
+                <a:spcPts val="0"/>
+              </a:spcAft>
+            </a:pPr>
+            <a:r>
+              <a:rPr sz="880" b="1" i="0">
+                <a:solidFill>
+                  <a:srgbClr val="556A83"/>
+                </a:solidFill>
+                <a:latin typeface="Arial"/>
+              </a:rPr>
+              <a:t>271</a:t>
+            </a:r>
+          </a:p>
+        </p:txBody>
+      </p:sp>
+      <p:sp>
+        <p:nvSpPr>
+          <p:cNvPr id="13" name="TextBox 12"/>
+          <p:cNvSpPr txBox="1"/>
+          <p:nvPr/>
+        </p:nvSpPr>
+        <p:spPr>
+          <a:xfrm>
+            <a:off x="4791575" y="5169408"/>
+            <a:ext cx="950999" cy="292608"/>
+          </a:xfrm>
+          <a:prstGeom prst="rect">
+            <a:avLst/>
+          </a:prstGeom>
+          <a:noFill/>
+        </p:spPr>
+        <p:txBody>
+          <a:bodyPr wrap="square" anchor="t" lIns="0" rIns="0" tIns="0" bIns="0">
+            <a:spAutoFit/>
+          </a:bodyPr>
+          <a:lstStyle/>
+          <a:p>
+            <a:pPr algn="l">
+              <a:lnSpc>
+                <a:spcPct val="110000"/>
+              </a:lnSpc>
+              <a:spcAft>
+                <a:spcPts val="0"/>
+              </a:spcAft>
+            </a:pPr>
+            <a:r>
+              <a:rPr sz="880" b="0" i="0">
+                <a:solidFill>
+                  <a:srgbClr val="556A83"/>
+                </a:solidFill>
+                <a:latin typeface="Arial"/>
+              </a:rPr>
+              <a:t>208</a:t>
+            </a:r>
+          </a:p>
+        </p:txBody>
+      </p:sp>
+      <p:sp>
+        <p:nvSpPr>
+          <p:cNvPr id="14" name="TextBox 13"/>
+          <p:cNvSpPr txBox="1"/>
+          <p:nvPr/>
+        </p:nvSpPr>
+        <p:spPr>
+          <a:xfrm>
+            <a:off x="5888883" y="2340864"/>
+            <a:ext cx="3365076" cy="536448"/>
+          </a:xfrm>
+          <a:prstGeom prst="rect">
+            <a:avLst/>
+          </a:prstGeom>
+          <a:noFill/>
+        </p:spPr>
+        <p:txBody>
+          <a:bodyPr wrap="square" anchor="t" lIns="0" rIns="0" tIns="0" bIns="0">
+            <a:spAutoFit/>
+          </a:bodyPr>
+          <a:lstStyle/>
+          <a:p>
+            <a:pPr algn="l">
+              <a:lnSpc>
+                <a:spcPct val="110000"/>
+              </a:lnSpc>
+              <a:spcAft>
+                <a:spcPts val="0"/>
+              </a:spcAft>
+            </a:pPr>
+            <a:r>
+              <a:rPr sz="880" b="1" i="0">
                 <a:solidFill>
                   <a:srgbClr val="314359"/>
                 </a:solidFill>
                 <a:latin typeface="Arial"/>
               </a:rPr>
-              <a:t>Governance is the lever.</a:t>
-            </a:r>
-            <a:r>
-              <a:rPr sz="1280">
+              <a:t>Table 6.  Annual uplift to TOTAL-portfolio return (bps), by sleeve size</a:t>
+            </a:r>
+          </a:p>
+        </p:txBody>
+      </p:sp>
+      <p:sp>
+        <p:nvSpPr>
+          <p:cNvPr id="15" name="Rectangle 14"/>
+          <p:cNvSpPr/>
+          <p:nvPr/>
+        </p:nvSpPr>
+        <p:spPr>
+          <a:xfrm>
+            <a:off x="5888883" y="2974848"/>
+            <a:ext cx="1097307" cy="487680"/>
+          </a:xfrm>
+          <a:prstGeom prst="rect">
+            <a:avLst/>
+          </a:prstGeom>
+          <a:solidFill>
+            <a:srgbClr val="314359"/>
+          </a:solidFill>
+          <a:ln>
+            <a:noFill/>
+          </a:ln>
+          <a:effectLst/>
+        </p:spPr>
+        <p:style>
+          <a:lnRef idx="1">
+            <a:schemeClr val="accent1"/>
+          </a:lnRef>
+          <a:fillRef idx="3">
+            <a:schemeClr val="accent1"/>
+          </a:fillRef>
+          <a:effectRef idx="2">
+            <a:schemeClr val="accent1"/>
+          </a:effectRef>
+          <a:fontRef idx="minor">
+            <a:schemeClr val="lt1"/>
+          </a:fontRef>
+        </p:style>
+        <p:txBody>
+          <a:bodyPr rtlCol="0" anchor="ctr"/>
+          <a:lstStyle/>
+          <a:p>
+            <a:pPr algn="ctr"/>
+          </a:p>
+        </p:txBody>
+      </p:sp>
+      <p:sp>
+        <p:nvSpPr>
+          <p:cNvPr id="16" name="TextBox 15"/>
+          <p:cNvSpPr txBox="1"/>
+          <p:nvPr/>
+        </p:nvSpPr>
+        <p:spPr>
+          <a:xfrm>
+            <a:off x="5962037" y="2974848"/>
+            <a:ext cx="980261" cy="487680"/>
+          </a:xfrm>
+          <a:prstGeom prst="rect">
+            <a:avLst/>
+          </a:prstGeom>
+          <a:noFill/>
+        </p:spPr>
+        <p:txBody>
+          <a:bodyPr wrap="square" anchor="ctr" lIns="0" rIns="0" tIns="0" bIns="0">
+            <a:spAutoFit/>
+          </a:bodyPr>
+          <a:lstStyle/>
+          <a:p>
+            <a:pPr algn="l">
+              <a:lnSpc>
+                <a:spcPct val="110000"/>
+              </a:lnSpc>
+              <a:spcAft>
+                <a:spcPts val="0"/>
+              </a:spcAft>
+            </a:pPr>
+            <a:r>
+              <a:rPr sz="1000" b="1" i="0">
+                <a:solidFill>
+                  <a:srgbClr val="FFFFFF"/>
+                </a:solidFill>
+                <a:latin typeface="Arial"/>
+              </a:rPr>
+              <a:t>Sleeve</a:t>
+            </a:r>
+          </a:p>
+        </p:txBody>
+      </p:sp>
+      <p:sp>
+        <p:nvSpPr>
+          <p:cNvPr id="17" name="Rectangle 16"/>
+          <p:cNvSpPr/>
+          <p:nvPr/>
+        </p:nvSpPr>
+        <p:spPr>
+          <a:xfrm>
+            <a:off x="6986190" y="2974848"/>
+            <a:ext cx="1133884" cy="487680"/>
+          </a:xfrm>
+          <a:prstGeom prst="rect">
+            <a:avLst/>
+          </a:prstGeom>
+          <a:solidFill>
+            <a:srgbClr val="314359"/>
+          </a:solidFill>
+          <a:ln>
+            <a:noFill/>
+          </a:ln>
+          <a:effectLst/>
+        </p:spPr>
+        <p:style>
+          <a:lnRef idx="1">
+            <a:schemeClr val="accent1"/>
+          </a:lnRef>
+          <a:fillRef idx="3">
+            <a:schemeClr val="accent1"/>
+          </a:fillRef>
+          <a:effectRef idx="2">
+            <a:schemeClr val="accent1"/>
+          </a:effectRef>
+          <a:fontRef idx="minor">
+            <a:schemeClr val="lt1"/>
+          </a:fontRef>
+        </p:style>
+        <p:txBody>
+          <a:bodyPr rtlCol="0" anchor="ctr"/>
+          <a:lstStyle/>
+          <a:p>
+            <a:pPr algn="ctr"/>
+          </a:p>
+        </p:txBody>
+      </p:sp>
+      <p:sp>
+        <p:nvSpPr>
+          <p:cNvPr id="18" name="TextBox 17"/>
+          <p:cNvSpPr txBox="1"/>
+          <p:nvPr/>
+        </p:nvSpPr>
+        <p:spPr>
+          <a:xfrm>
+            <a:off x="7059344" y="2974848"/>
+            <a:ext cx="1016838" cy="487680"/>
+          </a:xfrm>
+          <a:prstGeom prst="rect">
+            <a:avLst/>
+          </a:prstGeom>
+          <a:noFill/>
+        </p:spPr>
+        <p:txBody>
+          <a:bodyPr wrap="square" anchor="ctr" lIns="0" rIns="0" tIns="0" bIns="0">
+            <a:spAutoFit/>
+          </a:bodyPr>
+          <a:lstStyle/>
+          <a:p>
+            <a:pPr algn="r">
+              <a:lnSpc>
+                <a:spcPct val="110000"/>
+              </a:lnSpc>
+              <a:spcAft>
+                <a:spcPts val="0"/>
+              </a:spcAft>
+            </a:pPr>
+            <a:r>
+              <a:rPr sz="1000" b="1" i="0">
+                <a:solidFill>
+                  <a:srgbClr val="FFFFFF"/>
+                </a:solidFill>
+                <a:latin typeface="Arial"/>
+              </a:rPr>
+              <a:t>vs Long-only</a:t>
+            </a:r>
+          </a:p>
+        </p:txBody>
+      </p:sp>
+      <p:sp>
+        <p:nvSpPr>
+          <p:cNvPr id="19" name="Rectangle 18"/>
+          <p:cNvSpPr/>
+          <p:nvPr/>
+        </p:nvSpPr>
+        <p:spPr>
+          <a:xfrm>
+            <a:off x="8120075" y="2974848"/>
+            <a:ext cx="1426499" cy="487680"/>
+          </a:xfrm>
+          <a:prstGeom prst="rect">
+            <a:avLst/>
+          </a:prstGeom>
+          <a:solidFill>
+            <a:srgbClr val="314359"/>
+          </a:solidFill>
+          <a:ln>
+            <a:noFill/>
+          </a:ln>
+          <a:effectLst/>
+        </p:spPr>
+        <p:style>
+          <a:lnRef idx="1">
+            <a:schemeClr val="accent1"/>
+          </a:lnRef>
+          <a:fillRef idx="3">
+            <a:schemeClr val="accent1"/>
+          </a:fillRef>
+          <a:effectRef idx="2">
+            <a:schemeClr val="accent1"/>
+          </a:effectRef>
+          <a:fontRef idx="minor">
+            <a:schemeClr val="lt1"/>
+          </a:fontRef>
+        </p:style>
+        <p:txBody>
+          <a:bodyPr rtlCol="0" anchor="ctr"/>
+          <a:lstStyle/>
+          <a:p>
+            <a:pPr algn="ctr"/>
+          </a:p>
+        </p:txBody>
+      </p:sp>
+      <p:sp>
+        <p:nvSpPr>
+          <p:cNvPr id="20" name="TextBox 19"/>
+          <p:cNvSpPr txBox="1"/>
+          <p:nvPr/>
+        </p:nvSpPr>
+        <p:spPr>
+          <a:xfrm>
+            <a:off x="8193228" y="2974848"/>
+            <a:ext cx="1309453" cy="487680"/>
+          </a:xfrm>
+          <a:prstGeom prst="rect">
+            <a:avLst/>
+          </a:prstGeom>
+          <a:noFill/>
+        </p:spPr>
+        <p:txBody>
+          <a:bodyPr wrap="square" anchor="ctr" lIns="0" rIns="0" tIns="0" bIns="0">
+            <a:spAutoFit/>
+          </a:bodyPr>
+          <a:lstStyle/>
+          <a:p>
+            <a:pPr algn="r">
+              <a:lnSpc>
+                <a:spcPct val="110000"/>
+              </a:lnSpc>
+              <a:spcAft>
+                <a:spcPts val="0"/>
+              </a:spcAft>
+            </a:pPr>
+            <a:r>
+              <a:rPr sz="1000" b="1" i="0">
+                <a:solidFill>
+                  <a:srgbClr val="FFFFFF"/>
+                </a:solidFill>
+                <a:latin typeface="Arial"/>
+              </a:rPr>
+              <a:t>vs Other activist</a:t>
+            </a:r>
+          </a:p>
+        </p:txBody>
+      </p:sp>
+      <p:sp>
+        <p:nvSpPr>
+          <p:cNvPr id="21" name="Rectangle 20"/>
+          <p:cNvSpPr/>
+          <p:nvPr/>
+        </p:nvSpPr>
+        <p:spPr>
+          <a:xfrm>
+            <a:off x="5888883" y="3462528"/>
+            <a:ext cx="1097307" cy="487680"/>
+          </a:xfrm>
+          <a:prstGeom prst="rect">
+            <a:avLst/>
+          </a:prstGeom>
+          <a:solidFill>
+            <a:srgbClr val="F6F7F9"/>
+          </a:solidFill>
+          <a:ln>
+            <a:noFill/>
+          </a:ln>
+          <a:effectLst/>
+        </p:spPr>
+        <p:style>
+          <a:lnRef idx="1">
+            <a:schemeClr val="accent1"/>
+          </a:lnRef>
+          <a:fillRef idx="3">
+            <a:schemeClr val="accent1"/>
+          </a:fillRef>
+          <a:effectRef idx="2">
+            <a:schemeClr val="accent1"/>
+          </a:effectRef>
+          <a:fontRef idx="minor">
+            <a:schemeClr val="lt1"/>
+          </a:fontRef>
+        </p:style>
+        <p:txBody>
+          <a:bodyPr rtlCol="0" anchor="ctr"/>
+          <a:lstStyle/>
+          <a:p>
+            <a:pPr algn="ctr"/>
+          </a:p>
+        </p:txBody>
+      </p:sp>
+      <p:sp>
+        <p:nvSpPr>
+          <p:cNvPr id="22" name="TextBox 21"/>
+          <p:cNvSpPr txBox="1"/>
+          <p:nvPr/>
+        </p:nvSpPr>
+        <p:spPr>
+          <a:xfrm>
+            <a:off x="5962037" y="3462528"/>
+            <a:ext cx="980261" cy="487680"/>
+          </a:xfrm>
+          <a:prstGeom prst="rect">
+            <a:avLst/>
+          </a:prstGeom>
+          <a:noFill/>
+        </p:spPr>
+        <p:txBody>
+          <a:bodyPr wrap="square" anchor="ctr" lIns="0" rIns="0" tIns="0" bIns="0">
+            <a:spAutoFit/>
+          </a:bodyPr>
+          <a:lstStyle/>
+          <a:p>
+            <a:pPr algn="l">
+              <a:lnSpc>
+                <a:spcPct val="110000"/>
+              </a:lnSpc>
+              <a:spcAft>
+                <a:spcPts val="0"/>
+              </a:spcAft>
+            </a:pPr>
+            <a:r>
+              <a:rPr sz="960" b="1" i="0">
+                <a:solidFill>
+                  <a:srgbClr val="314359"/>
+                </a:solidFill>
+                <a:latin typeface="Arial"/>
+              </a:rPr>
+              <a:t>3%</a:t>
+            </a:r>
+          </a:p>
+        </p:txBody>
+      </p:sp>
+      <p:sp>
+        <p:nvSpPr>
+          <p:cNvPr id="23" name="Rectangle 22"/>
+          <p:cNvSpPr/>
+          <p:nvPr/>
+        </p:nvSpPr>
+        <p:spPr>
+          <a:xfrm>
+            <a:off x="6986190" y="3462528"/>
+            <a:ext cx="1133884" cy="487680"/>
+          </a:xfrm>
+          <a:prstGeom prst="rect">
+            <a:avLst/>
+          </a:prstGeom>
+          <a:solidFill>
+            <a:srgbClr val="F6F7F9"/>
+          </a:solidFill>
+          <a:ln>
+            <a:noFill/>
+          </a:ln>
+          <a:effectLst/>
+        </p:spPr>
+        <p:style>
+          <a:lnRef idx="1">
+            <a:schemeClr val="accent1"/>
+          </a:lnRef>
+          <a:fillRef idx="3">
+            <a:schemeClr val="accent1"/>
+          </a:fillRef>
+          <a:effectRef idx="2">
+            <a:schemeClr val="accent1"/>
+          </a:effectRef>
+          <a:fontRef idx="minor">
+            <a:schemeClr val="lt1"/>
+          </a:fontRef>
+        </p:style>
+        <p:txBody>
+          <a:bodyPr rtlCol="0" anchor="ctr"/>
+          <a:lstStyle/>
+          <a:p>
+            <a:pPr algn="ctr"/>
+          </a:p>
+        </p:txBody>
+      </p:sp>
+      <p:sp>
+        <p:nvSpPr>
+          <p:cNvPr id="24" name="TextBox 23"/>
+          <p:cNvSpPr txBox="1"/>
+          <p:nvPr/>
+        </p:nvSpPr>
+        <p:spPr>
+          <a:xfrm>
+            <a:off x="7059344" y="3462528"/>
+            <a:ext cx="1016838" cy="487680"/>
+          </a:xfrm>
+          <a:prstGeom prst="rect">
+            <a:avLst/>
+          </a:prstGeom>
+          <a:noFill/>
+        </p:spPr>
+        <p:txBody>
+          <a:bodyPr wrap="square" anchor="ctr" lIns="0" rIns="0" tIns="0" bIns="0">
+            <a:spAutoFit/>
+          </a:bodyPr>
+          <a:lstStyle/>
+          <a:p>
+            <a:pPr algn="r">
+              <a:lnSpc>
+                <a:spcPct val="110000"/>
+              </a:lnSpc>
+              <a:spcAft>
+                <a:spcPts val="0"/>
+              </a:spcAft>
+            </a:pPr>
+            <a:r>
+              <a:rPr sz="960" b="0" i="0">
                 <a:solidFill>
                   <a:srgbClr val="0E1620"/>
                 </a:solidFill>
                 <a:latin typeface="Arial"/>
               </a:rPr>
-              <a:t>  Value is created through board representation and active promotion of strong corporate governance across all holdings.</a:t>
-            </a:r>
-          </a:p>
-          <a:p>
-            <a:pPr marL="186949" indent="-186949">
-              <a:lnSpc>
-                <a:spcPct val="112000"/>
-              </a:lnSpc>
-              <a:spcAft>
-                <a:spcPts val="1400"/>
-              </a:spcAft>
-            </a:pPr>
-            <a:r>
-              <a:rPr sz="1280" b="1">
+              <a:t>+31 bps</a:t>
+            </a:r>
+          </a:p>
+        </p:txBody>
+      </p:sp>
+      <p:sp>
+        <p:nvSpPr>
+          <p:cNvPr id="25" name="Rectangle 24"/>
+          <p:cNvSpPr/>
+          <p:nvPr/>
+        </p:nvSpPr>
+        <p:spPr>
+          <a:xfrm>
+            <a:off x="8120075" y="3462528"/>
+            <a:ext cx="1426499" cy="487680"/>
+          </a:xfrm>
+          <a:prstGeom prst="rect">
+            <a:avLst/>
+          </a:prstGeom>
+          <a:solidFill>
+            <a:srgbClr val="F6F7F9"/>
+          </a:solidFill>
+          <a:ln>
+            <a:noFill/>
+          </a:ln>
+          <a:effectLst/>
+        </p:spPr>
+        <p:style>
+          <a:lnRef idx="1">
+            <a:schemeClr val="accent1"/>
+          </a:lnRef>
+          <a:fillRef idx="3">
+            <a:schemeClr val="accent1"/>
+          </a:fillRef>
+          <a:effectRef idx="2">
+            <a:schemeClr val="accent1"/>
+          </a:effectRef>
+          <a:fontRef idx="minor">
+            <a:schemeClr val="lt1"/>
+          </a:fontRef>
+        </p:style>
+        <p:txBody>
+          <a:bodyPr rtlCol="0" anchor="ctr"/>
+          <a:lstStyle/>
+          <a:p>
+            <a:pPr algn="ctr"/>
+          </a:p>
+        </p:txBody>
+      </p:sp>
+      <p:sp>
+        <p:nvSpPr>
+          <p:cNvPr id="26" name="TextBox 25"/>
+          <p:cNvSpPr txBox="1"/>
+          <p:nvPr/>
+        </p:nvSpPr>
+        <p:spPr>
+          <a:xfrm>
+            <a:off x="8193228" y="3462528"/>
+            <a:ext cx="1309453" cy="487680"/>
+          </a:xfrm>
+          <a:prstGeom prst="rect">
+            <a:avLst/>
+          </a:prstGeom>
+          <a:noFill/>
+        </p:spPr>
+        <p:txBody>
+          <a:bodyPr wrap="square" anchor="ctr" lIns="0" rIns="0" tIns="0" bIns="0">
+            <a:spAutoFit/>
+          </a:bodyPr>
+          <a:lstStyle/>
+          <a:p>
+            <a:pPr algn="r">
+              <a:lnSpc>
+                <a:spcPct val="110000"/>
+              </a:lnSpc>
+              <a:spcAft>
+                <a:spcPts val="0"/>
+              </a:spcAft>
+            </a:pPr>
+            <a:r>
+              <a:rPr sz="960" b="0" i="0">
+                <a:solidFill>
+                  <a:srgbClr val="0E1620"/>
+                </a:solidFill>
+                <a:latin typeface="Arial"/>
+              </a:rPr>
+              <a:t>+23 bps</a:t>
+            </a:r>
+          </a:p>
+        </p:txBody>
+      </p:sp>
+      <p:sp>
+        <p:nvSpPr>
+          <p:cNvPr id="27" name="Rectangle 26"/>
+          <p:cNvSpPr/>
+          <p:nvPr/>
+        </p:nvSpPr>
+        <p:spPr>
+          <a:xfrm>
+            <a:off x="5888883" y="3950208"/>
+            <a:ext cx="1097307" cy="487680"/>
+          </a:xfrm>
+          <a:prstGeom prst="rect">
+            <a:avLst/>
+          </a:prstGeom>
+          <a:solidFill>
+            <a:srgbClr val="FFFFFF"/>
+          </a:solidFill>
+          <a:ln>
+            <a:noFill/>
+          </a:ln>
+          <a:effectLst/>
+        </p:spPr>
+        <p:style>
+          <a:lnRef idx="1">
+            <a:schemeClr val="accent1"/>
+          </a:lnRef>
+          <a:fillRef idx="3">
+            <a:schemeClr val="accent1"/>
+          </a:fillRef>
+          <a:effectRef idx="2">
+            <a:schemeClr val="accent1"/>
+          </a:effectRef>
+          <a:fontRef idx="minor">
+            <a:schemeClr val="lt1"/>
+          </a:fontRef>
+        </p:style>
+        <p:txBody>
+          <a:bodyPr rtlCol="0" anchor="ctr"/>
+          <a:lstStyle/>
+          <a:p>
+            <a:pPr algn="ctr"/>
+          </a:p>
+        </p:txBody>
+      </p:sp>
+      <p:sp>
+        <p:nvSpPr>
+          <p:cNvPr id="28" name="TextBox 27"/>
+          <p:cNvSpPr txBox="1"/>
+          <p:nvPr/>
+        </p:nvSpPr>
+        <p:spPr>
+          <a:xfrm>
+            <a:off x="5962037" y="3950208"/>
+            <a:ext cx="980261" cy="487680"/>
+          </a:xfrm>
+          <a:prstGeom prst="rect">
+            <a:avLst/>
+          </a:prstGeom>
+          <a:noFill/>
+        </p:spPr>
+        <p:txBody>
+          <a:bodyPr wrap="square" anchor="ctr" lIns="0" rIns="0" tIns="0" bIns="0">
+            <a:spAutoFit/>
+          </a:bodyPr>
+          <a:lstStyle/>
+          <a:p>
+            <a:pPr algn="l">
+              <a:lnSpc>
+                <a:spcPct val="110000"/>
+              </a:lnSpc>
+              <a:spcAft>
+                <a:spcPts val="0"/>
+              </a:spcAft>
+            </a:pPr>
+            <a:r>
+              <a:rPr sz="960" b="1" i="0">
                 <a:solidFill>
                   <a:srgbClr val="314359"/>
                 </a:solidFill>
                 <a:latin typeface="Arial"/>
               </a:rPr>
-              <a:t>›  </a:t>
-            </a:r>
-            <a:r>
-              <a:rPr sz="1280" b="1">
+              <a:t>5%</a:t>
+            </a:r>
+          </a:p>
+        </p:txBody>
+      </p:sp>
+      <p:sp>
+        <p:nvSpPr>
+          <p:cNvPr id="29" name="Rectangle 28"/>
+          <p:cNvSpPr/>
+          <p:nvPr/>
+        </p:nvSpPr>
+        <p:spPr>
+          <a:xfrm>
+            <a:off x="6986190" y="3950208"/>
+            <a:ext cx="1133884" cy="487680"/>
+          </a:xfrm>
+          <a:prstGeom prst="rect">
+            <a:avLst/>
+          </a:prstGeom>
+          <a:solidFill>
+            <a:srgbClr val="FFFFFF"/>
+          </a:solidFill>
+          <a:ln>
+            <a:noFill/>
+          </a:ln>
+          <a:effectLst/>
+        </p:spPr>
+        <p:style>
+          <a:lnRef idx="1">
+            <a:schemeClr val="accent1"/>
+          </a:lnRef>
+          <a:fillRef idx="3">
+            <a:schemeClr val="accent1"/>
+          </a:fillRef>
+          <a:effectRef idx="2">
+            <a:schemeClr val="accent1"/>
+          </a:effectRef>
+          <a:fontRef idx="minor">
+            <a:schemeClr val="lt1"/>
+          </a:fontRef>
+        </p:style>
+        <p:txBody>
+          <a:bodyPr rtlCol="0" anchor="ctr"/>
+          <a:lstStyle/>
+          <a:p>
+            <a:pPr algn="ctr"/>
+          </a:p>
+        </p:txBody>
+      </p:sp>
+      <p:sp>
+        <p:nvSpPr>
+          <p:cNvPr id="30" name="TextBox 29"/>
+          <p:cNvSpPr txBox="1"/>
+          <p:nvPr/>
+        </p:nvSpPr>
+        <p:spPr>
+          <a:xfrm>
+            <a:off x="7059344" y="3950208"/>
+            <a:ext cx="1016838" cy="487680"/>
+          </a:xfrm>
+          <a:prstGeom prst="rect">
+            <a:avLst/>
+          </a:prstGeom>
+          <a:noFill/>
+        </p:spPr>
+        <p:txBody>
+          <a:bodyPr wrap="square" anchor="ctr" lIns="0" rIns="0" tIns="0" bIns="0">
+            <a:spAutoFit/>
+          </a:bodyPr>
+          <a:lstStyle/>
+          <a:p>
+            <a:pPr algn="r">
+              <a:lnSpc>
+                <a:spcPct val="110000"/>
+              </a:lnSpc>
+              <a:spcAft>
+                <a:spcPts val="0"/>
+              </a:spcAft>
+            </a:pPr>
+            <a:r>
+              <a:rPr sz="960" b="0" i="0">
+                <a:solidFill>
+                  <a:srgbClr val="0E1620"/>
+                </a:solidFill>
+                <a:latin typeface="Arial"/>
+              </a:rPr>
+              <a:t>+52 bps</a:t>
+            </a:r>
+          </a:p>
+        </p:txBody>
+      </p:sp>
+      <p:sp>
+        <p:nvSpPr>
+          <p:cNvPr id="31" name="Rectangle 30"/>
+          <p:cNvSpPr/>
+          <p:nvPr/>
+        </p:nvSpPr>
+        <p:spPr>
+          <a:xfrm>
+            <a:off x="8120075" y="3950208"/>
+            <a:ext cx="1426499" cy="487680"/>
+          </a:xfrm>
+          <a:prstGeom prst="rect">
+            <a:avLst/>
+          </a:prstGeom>
+          <a:solidFill>
+            <a:srgbClr val="FFFFFF"/>
+          </a:solidFill>
+          <a:ln>
+            <a:noFill/>
+          </a:ln>
+          <a:effectLst/>
+        </p:spPr>
+        <p:style>
+          <a:lnRef idx="1">
+            <a:schemeClr val="accent1"/>
+          </a:lnRef>
+          <a:fillRef idx="3">
+            <a:schemeClr val="accent1"/>
+          </a:fillRef>
+          <a:effectRef idx="2">
+            <a:schemeClr val="accent1"/>
+          </a:effectRef>
+          <a:fontRef idx="minor">
+            <a:schemeClr val="lt1"/>
+          </a:fontRef>
+        </p:style>
+        <p:txBody>
+          <a:bodyPr rtlCol="0" anchor="ctr"/>
+          <a:lstStyle/>
+          <a:p>
+            <a:pPr algn="ctr"/>
+          </a:p>
+        </p:txBody>
+      </p:sp>
+      <p:sp>
+        <p:nvSpPr>
+          <p:cNvPr id="32" name="TextBox 31"/>
+          <p:cNvSpPr txBox="1"/>
+          <p:nvPr/>
+        </p:nvSpPr>
+        <p:spPr>
+          <a:xfrm>
+            <a:off x="8193228" y="3950208"/>
+            <a:ext cx="1309453" cy="487680"/>
+          </a:xfrm>
+          <a:prstGeom prst="rect">
+            <a:avLst/>
+          </a:prstGeom>
+          <a:noFill/>
+        </p:spPr>
+        <p:txBody>
+          <a:bodyPr wrap="square" anchor="ctr" lIns="0" rIns="0" tIns="0" bIns="0">
+            <a:spAutoFit/>
+          </a:bodyPr>
+          <a:lstStyle/>
+          <a:p>
+            <a:pPr algn="r">
+              <a:lnSpc>
+                <a:spcPct val="110000"/>
+              </a:lnSpc>
+              <a:spcAft>
+                <a:spcPts val="0"/>
+              </a:spcAft>
+            </a:pPr>
+            <a:r>
+              <a:rPr sz="960" b="0" i="0">
+                <a:solidFill>
+                  <a:srgbClr val="0E1620"/>
+                </a:solidFill>
+                <a:latin typeface="Arial"/>
+              </a:rPr>
+              <a:t>+38 bps</a:t>
+            </a:r>
+          </a:p>
+        </p:txBody>
+      </p:sp>
+      <p:sp>
+        <p:nvSpPr>
+          <p:cNvPr id="33" name="Rectangle 32"/>
+          <p:cNvSpPr/>
+          <p:nvPr/>
+        </p:nvSpPr>
+        <p:spPr>
+          <a:xfrm>
+            <a:off x="5888883" y="4437888"/>
+            <a:ext cx="1097307" cy="487680"/>
+          </a:xfrm>
+          <a:prstGeom prst="rect">
+            <a:avLst/>
+          </a:prstGeom>
+          <a:solidFill>
+            <a:srgbClr val="F6F7F9"/>
+          </a:solidFill>
+          <a:ln>
+            <a:noFill/>
+          </a:ln>
+          <a:effectLst/>
+        </p:spPr>
+        <p:style>
+          <a:lnRef idx="1">
+            <a:schemeClr val="accent1"/>
+          </a:lnRef>
+          <a:fillRef idx="3">
+            <a:schemeClr val="accent1"/>
+          </a:fillRef>
+          <a:effectRef idx="2">
+            <a:schemeClr val="accent1"/>
+          </a:effectRef>
+          <a:fontRef idx="minor">
+            <a:schemeClr val="lt1"/>
+          </a:fontRef>
+        </p:style>
+        <p:txBody>
+          <a:bodyPr rtlCol="0" anchor="ctr"/>
+          <a:lstStyle/>
+          <a:p>
+            <a:pPr algn="ctr"/>
+          </a:p>
+        </p:txBody>
+      </p:sp>
+      <p:sp>
+        <p:nvSpPr>
+          <p:cNvPr id="34" name="TextBox 33"/>
+          <p:cNvSpPr txBox="1"/>
+          <p:nvPr/>
+        </p:nvSpPr>
+        <p:spPr>
+          <a:xfrm>
+            <a:off x="5962037" y="4437888"/>
+            <a:ext cx="980261" cy="487680"/>
+          </a:xfrm>
+          <a:prstGeom prst="rect">
+            <a:avLst/>
+          </a:prstGeom>
+          <a:noFill/>
+        </p:spPr>
+        <p:txBody>
+          <a:bodyPr wrap="square" anchor="ctr" lIns="0" rIns="0" tIns="0" bIns="0">
+            <a:spAutoFit/>
+          </a:bodyPr>
+          <a:lstStyle/>
+          <a:p>
+            <a:pPr algn="l">
+              <a:lnSpc>
+                <a:spcPct val="110000"/>
+              </a:lnSpc>
+              <a:spcAft>
+                <a:spcPts val="0"/>
+              </a:spcAft>
+            </a:pPr>
+            <a:r>
+              <a:rPr sz="960" b="1" i="0">
                 <a:solidFill>
                   <a:srgbClr val="314359"/>
                 </a:solidFill>
                 <a:latin typeface="Arial"/>
               </a:rPr>
-              <a:t>Five improvement dimensions.</a:t>
-            </a:r>
-            <a:r>
-              <a:rPr sz="1280">
+              <a:t>8%</a:t>
+            </a:r>
+          </a:p>
+        </p:txBody>
+      </p:sp>
+      <p:sp>
+        <p:nvSpPr>
+          <p:cNvPr id="35" name="Rectangle 34"/>
+          <p:cNvSpPr/>
+          <p:nvPr/>
+        </p:nvSpPr>
+        <p:spPr>
+          <a:xfrm>
+            <a:off x="6986190" y="4437888"/>
+            <a:ext cx="1133884" cy="487680"/>
+          </a:xfrm>
+          <a:prstGeom prst="rect">
+            <a:avLst/>
+          </a:prstGeom>
+          <a:solidFill>
+            <a:srgbClr val="F6F7F9"/>
+          </a:solidFill>
+          <a:ln>
+            <a:noFill/>
+          </a:ln>
+          <a:effectLst/>
+        </p:spPr>
+        <p:style>
+          <a:lnRef idx="1">
+            <a:schemeClr val="accent1"/>
+          </a:lnRef>
+          <a:fillRef idx="3">
+            <a:schemeClr val="accent1"/>
+          </a:fillRef>
+          <a:effectRef idx="2">
+            <a:schemeClr val="accent1"/>
+          </a:effectRef>
+          <a:fontRef idx="minor">
+            <a:schemeClr val="lt1"/>
+          </a:fontRef>
+        </p:style>
+        <p:txBody>
+          <a:bodyPr rtlCol="0" anchor="ctr"/>
+          <a:lstStyle/>
+          <a:p>
+            <a:pPr algn="ctr"/>
+          </a:p>
+        </p:txBody>
+      </p:sp>
+      <p:sp>
+        <p:nvSpPr>
+          <p:cNvPr id="36" name="TextBox 35"/>
+          <p:cNvSpPr txBox="1"/>
+          <p:nvPr/>
+        </p:nvSpPr>
+        <p:spPr>
+          <a:xfrm>
+            <a:off x="7059344" y="4437888"/>
+            <a:ext cx="1016838" cy="487680"/>
+          </a:xfrm>
+          <a:prstGeom prst="rect">
+            <a:avLst/>
+          </a:prstGeom>
+          <a:noFill/>
+        </p:spPr>
+        <p:txBody>
+          <a:bodyPr wrap="square" anchor="ctr" lIns="0" rIns="0" tIns="0" bIns="0">
+            <a:spAutoFit/>
+          </a:bodyPr>
+          <a:lstStyle/>
+          <a:p>
+            <a:pPr algn="r">
+              <a:lnSpc>
+                <a:spcPct val="110000"/>
+              </a:lnSpc>
+              <a:spcAft>
+                <a:spcPts val="0"/>
+              </a:spcAft>
+            </a:pPr>
+            <a:r>
+              <a:rPr sz="960" b="0" i="0">
                 <a:solidFill>
                   <a:srgbClr val="0E1620"/>
                 </a:solidFill>
                 <a:latin typeface="Arial"/>
               </a:rPr>
-              <a:t>  Operational, financial, structural, environmental and social improvements — each tied to enterprise value.</a:t>
-            </a:r>
-          </a:p>
-          <a:p>
-            <a:pPr marL="186949" indent="-186949">
-              <a:lnSpc>
-                <a:spcPct val="112000"/>
-              </a:lnSpc>
-              <a:spcAft>
-                <a:spcPts val="1400"/>
-              </a:spcAft>
-            </a:pPr>
-            <a:r>
-              <a:rPr sz="1280" b="1">
-                <a:solidFill>
-                  <a:srgbClr val="314359"/>
-                </a:solidFill>
-                <a:latin typeface="Arial"/>
-              </a:rPr>
-              <a:t>›  </a:t>
-            </a:r>
-            <a:r>
-              <a:rPr sz="1280" b="1">
-                <a:solidFill>
-                  <a:srgbClr val="314359"/>
-                </a:solidFill>
-                <a:latin typeface="Arial"/>
-              </a:rPr>
-              <a:t>PRI signatory since 2019,</a:t>
-            </a:r>
-            <a:r>
-              <a:rPr sz="1280">
+              <a:t>+83 bps</a:t>
+            </a:r>
+          </a:p>
+        </p:txBody>
+      </p:sp>
+      <p:sp>
+        <p:nvSpPr>
+          <p:cNvPr id="37" name="Rectangle 36"/>
+          <p:cNvSpPr/>
+          <p:nvPr/>
+        </p:nvSpPr>
+        <p:spPr>
+          <a:xfrm>
+            <a:off x="8120075" y="4437888"/>
+            <a:ext cx="1426499" cy="487680"/>
+          </a:xfrm>
+          <a:prstGeom prst="rect">
+            <a:avLst/>
+          </a:prstGeom>
+          <a:solidFill>
+            <a:srgbClr val="F6F7F9"/>
+          </a:solidFill>
+          <a:ln>
+            <a:noFill/>
+          </a:ln>
+          <a:effectLst/>
+        </p:spPr>
+        <p:style>
+          <a:lnRef idx="1">
+            <a:schemeClr val="accent1"/>
+          </a:lnRef>
+          <a:fillRef idx="3">
+            <a:schemeClr val="accent1"/>
+          </a:fillRef>
+          <a:effectRef idx="2">
+            <a:schemeClr val="accent1"/>
+          </a:effectRef>
+          <a:fontRef idx="minor">
+            <a:schemeClr val="lt1"/>
+          </a:fontRef>
+        </p:style>
+        <p:txBody>
+          <a:bodyPr rtlCol="0" anchor="ctr"/>
+          <a:lstStyle/>
+          <a:p>
+            <a:pPr algn="ctr"/>
+          </a:p>
+        </p:txBody>
+      </p:sp>
+      <p:sp>
+        <p:nvSpPr>
+          <p:cNvPr id="38" name="TextBox 37"/>
+          <p:cNvSpPr txBox="1"/>
+          <p:nvPr/>
+        </p:nvSpPr>
+        <p:spPr>
+          <a:xfrm>
+            <a:off x="8193228" y="4437888"/>
+            <a:ext cx="1309453" cy="487680"/>
+          </a:xfrm>
+          <a:prstGeom prst="rect">
+            <a:avLst/>
+          </a:prstGeom>
+          <a:noFill/>
+        </p:spPr>
+        <p:txBody>
+          <a:bodyPr wrap="square" anchor="ctr" lIns="0" rIns="0" tIns="0" bIns="0">
+            <a:spAutoFit/>
+          </a:bodyPr>
+          <a:lstStyle/>
+          <a:p>
+            <a:pPr algn="r">
+              <a:lnSpc>
+                <a:spcPct val="110000"/>
+              </a:lnSpc>
+              <a:spcAft>
+                <a:spcPts val="0"/>
+              </a:spcAft>
+            </a:pPr>
+            <a:r>
+              <a:rPr sz="960" b="0" i="0">
                 <a:solidFill>
                   <a:srgbClr val="0E1620"/>
                 </a:solidFill>
                 <a:latin typeface="Arial"/>
               </a:rPr>
-              <a:t>  adhering to the Six Principles for Responsible Investment.</a:t>
-            </a:r>
-          </a:p>
-          <a:p>
-            <a:pPr marL="186949" indent="-186949">
-              <a:lnSpc>
-                <a:spcPct val="112000"/>
-              </a:lnSpc>
-              <a:spcAft>
-                <a:spcPts val="1400"/>
-              </a:spcAft>
-            </a:pPr>
-            <a:r>
-              <a:rPr sz="1280" b="1">
-                <a:solidFill>
-                  <a:srgbClr val="314359"/>
-                </a:solidFill>
-                <a:latin typeface="Arial"/>
-              </a:rPr>
-              <a:t>›  </a:t>
-            </a:r>
-            <a:r>
-              <a:rPr sz="1280" b="1">
-                <a:solidFill>
-                  <a:srgbClr val="314359"/>
-                </a:solidFill>
-                <a:latin typeface="Arial"/>
-              </a:rPr>
-              <a:t>Credible oversight.</a:t>
-            </a:r>
-            <a:r>
-              <a:rPr sz="1280">
+              <a:t>+60 bps</a:t>
+            </a:r>
+          </a:p>
+        </p:txBody>
+      </p:sp>
+      <p:sp>
+        <p:nvSpPr>
+          <p:cNvPr id="39" name="TextBox 38"/>
+          <p:cNvSpPr txBox="1"/>
+          <p:nvPr/>
+        </p:nvSpPr>
+        <p:spPr>
+          <a:xfrm>
+            <a:off x="5888883" y="5120640"/>
+            <a:ext cx="3365076" cy="1658112"/>
+          </a:xfrm>
+          <a:prstGeom prst="rect">
+            <a:avLst/>
+          </a:prstGeom>
+          <a:noFill/>
+        </p:spPr>
+        <p:txBody>
+          <a:bodyPr wrap="square" anchor="t" lIns="0" rIns="0" tIns="0" bIns="0">
+            <a:spAutoFit/>
+          </a:bodyPr>
+          <a:lstStyle/>
+          <a:p>
+            <a:pPr algn="l">
+              <a:lnSpc>
+                <a:spcPct val="120000"/>
+              </a:lnSpc>
+              <a:spcAft>
+                <a:spcPts val="0"/>
+              </a:spcAft>
+            </a:pPr>
+            <a:r>
+              <a:rPr sz="1000" b="0" i="0">
                 <a:solidFill>
                   <a:srgbClr val="0E1620"/>
                 </a:solidFill>
                 <a:latin typeface="Arial"/>
               </a:rPr>
-              <a:t>  SEB custodian · MUFG administrator · KPMG auditor · Swedish FI-registered AIFM.</a:t>
+              <a:t>A 5% sleeve in Athanase rather than a long-only global fund adds roughly half a percent (≈52 bps) to total-portfolio return every year — and compounds: the sleeve itself reaches ~2.5× the long-only outcome over a decade, with the diversification and downside profile shown earlier.</a:t>
+            </a:r>
+          </a:p>
+        </p:txBody>
+      </p:sp>
+      <p:sp>
+        <p:nvSpPr>
+          <p:cNvPr id="40" name="TextBox 39"/>
+          <p:cNvSpPr txBox="1"/>
+          <p:nvPr/>
+        </p:nvSpPr>
+        <p:spPr>
+          <a:xfrm>
+            <a:off x="438922" y="6729984"/>
+            <a:ext cx="7900613" cy="438912"/>
+          </a:xfrm>
+          <a:prstGeom prst="rect">
+            <a:avLst/>
+          </a:prstGeom>
+          <a:noFill/>
+        </p:spPr>
+        <p:txBody>
+          <a:bodyPr wrap="square" anchor="t" lIns="0" rIns="0" tIns="0" bIns="0">
+            <a:spAutoFit/>
+          </a:bodyPr>
+          <a:lstStyle/>
+          <a:p>
+            <a:pPr algn="l">
+              <a:lnSpc>
+                <a:spcPct val="115000"/>
+              </a:lnSpc>
+              <a:spcAft>
+                <a:spcPts val="0"/>
+              </a:spcAft>
+            </a:pPr>
+            <a:r>
+              <a:rPr sz="680" b="0" i="0">
+                <a:solidFill>
+                  <a:srgbClr val="556A83"/>
+                </a:solidFill>
+                <a:latin typeface="Arial"/>
+              </a:rPr>
+              <a:t>Illustrative only; not a projection. Athanase 18% (headline net IRR); other activist 10.5%; long-only global 7.6% (MSCI IMI since inception). Uplift = sleeve size × return spread; growth = annual compounding. Past performance is not indicative of future results.</a:t>
             </a:r>
           </a:p>
         </p:txBody>
@@ -33484,6 +35180,433 @@
 </file>
 
 <file path=ppt/slides/slide27.xml><?xml version="1.0" encoding="utf-8"?>
+<p:sld xmlns:a="http://schemas.openxmlformats.org/drawingml/2006/main" xmlns:p="http://schemas.openxmlformats.org/presentationml/2006/main" xmlns:r="http://schemas.openxmlformats.org/officeDocument/2006/relationships">
+  <p:cSld>
+    <p:spTree>
+      <p:nvGrpSpPr>
+        <p:cNvPr id="1" name=""/>
+        <p:cNvGrpSpPr/>
+        <p:nvPr/>
+      </p:nvGrpSpPr>
+      <p:grpSpPr/>
+      <p:sp>
+        <p:nvSpPr>
+          <p:cNvPr id="2" name="Rectangle 1"/>
+          <p:cNvSpPr/>
+          <p:nvPr/>
+        </p:nvSpPr>
+        <p:spPr>
+          <a:xfrm>
+            <a:off x="0" y="0"/>
+            <a:ext cx="9753600" cy="7315200"/>
+          </a:xfrm>
+          <a:prstGeom prst="rect">
+            <a:avLst/>
+          </a:prstGeom>
+          <a:solidFill>
+            <a:srgbClr val="FFFFFF"/>
+          </a:solidFill>
+          <a:ln>
+            <a:noFill/>
+          </a:ln>
+          <a:effectLst/>
+        </p:spPr>
+        <p:style>
+          <a:lnRef idx="1">
+            <a:schemeClr val="accent1"/>
+          </a:lnRef>
+          <a:fillRef idx="3">
+            <a:schemeClr val="accent1"/>
+          </a:fillRef>
+          <a:effectRef idx="2">
+            <a:schemeClr val="accent1"/>
+          </a:effectRef>
+          <a:fontRef idx="minor">
+            <a:schemeClr val="lt1"/>
+          </a:fontRef>
+        </p:style>
+        <p:txBody>
+          <a:bodyPr rtlCol="0" anchor="ctr"/>
+          <a:lstStyle/>
+          <a:p>
+            <a:pPr algn="ctr"/>
+          </a:p>
+        </p:txBody>
+      </p:sp>
+      <p:pic>
+        <p:nvPicPr>
+          <p:cNvPr id="3" name="Picture 2" descr="mark_dark.png"/>
+          <p:cNvPicPr>
+            <a:picLocks noChangeAspect="1"/>
+          </p:cNvPicPr>
+          <p:nvPr/>
+        </p:nvPicPr>
+        <p:blipFill>
+          <a:blip r:embed="rId2"/>
+          <a:stretch>
+            <a:fillRect/>
+          </a:stretch>
+        </p:blipFill>
+        <p:spPr>
+          <a:xfrm>
+            <a:off x="402346" y="234086"/>
+            <a:ext cx="224012" cy="190199"/>
+          </a:xfrm>
+          <a:prstGeom prst="rect">
+            <a:avLst/>
+          </a:prstGeom>
+        </p:spPr>
+      </p:pic>
+      <p:sp>
+        <p:nvSpPr>
+          <p:cNvPr id="4" name="TextBox 3"/>
+          <p:cNvSpPr txBox="1"/>
+          <p:nvPr/>
+        </p:nvSpPr>
+        <p:spPr>
+          <a:xfrm>
+            <a:off x="716907" y="263347"/>
+            <a:ext cx="5120768" cy="292608"/>
+          </a:xfrm>
+          <a:prstGeom prst="rect">
+            <a:avLst/>
+          </a:prstGeom>
+          <a:noFill/>
+        </p:spPr>
+        <p:txBody>
+          <a:bodyPr wrap="square" anchor="t" lIns="0" rIns="0" tIns="0" bIns="0">
+            <a:spAutoFit/>
+          </a:bodyPr>
+          <a:lstStyle/>
+          <a:p>
+            <a:pPr algn="l">
+              <a:lnSpc>
+                <a:spcPct val="110000"/>
+              </a:lnSpc>
+              <a:spcAft>
+                <a:spcPts val="0"/>
+              </a:spcAft>
+            </a:pPr>
+            <a:r>
+              <a:rPr sz="880" b="0" i="0">
+                <a:solidFill>
+                  <a:srgbClr val="556A83"/>
+                </a:solidFill>
+                <a:latin typeface="Arial"/>
+              </a:rPr>
+              <a:t>Ownership Model</a:t>
+            </a:r>
+          </a:p>
+        </p:txBody>
+      </p:sp>
+      <p:sp>
+        <p:nvSpPr>
+          <p:cNvPr id="5" name="Rectangle 4"/>
+          <p:cNvSpPr/>
+          <p:nvPr/>
+        </p:nvSpPr>
+        <p:spPr>
+          <a:xfrm>
+            <a:off x="0" y="604723"/>
+            <a:ext cx="9753600" cy="1024128"/>
+          </a:xfrm>
+          <a:prstGeom prst="rect">
+            <a:avLst/>
+          </a:prstGeom>
+          <a:solidFill>
+            <a:srgbClr val="F6F7F9"/>
+          </a:solidFill>
+          <a:ln>
+            <a:noFill/>
+          </a:ln>
+          <a:effectLst/>
+        </p:spPr>
+        <p:style>
+          <a:lnRef idx="1">
+            <a:schemeClr val="accent1"/>
+          </a:lnRef>
+          <a:fillRef idx="3">
+            <a:schemeClr val="accent1"/>
+          </a:fillRef>
+          <a:effectRef idx="2">
+            <a:schemeClr val="accent1"/>
+          </a:effectRef>
+          <a:fontRef idx="minor">
+            <a:schemeClr val="lt1"/>
+          </a:fontRef>
+        </p:style>
+        <p:txBody>
+          <a:bodyPr rtlCol="0" anchor="ctr"/>
+          <a:lstStyle/>
+          <a:p>
+            <a:pPr algn="ctr"/>
+          </a:p>
+        </p:txBody>
+      </p:sp>
+      <p:sp>
+        <p:nvSpPr>
+          <p:cNvPr id="6" name="TextBox 5"/>
+          <p:cNvSpPr txBox="1"/>
+          <p:nvPr/>
+        </p:nvSpPr>
+        <p:spPr>
+          <a:xfrm>
+            <a:off x="438922" y="721766"/>
+            <a:ext cx="8851613" cy="829056"/>
+          </a:xfrm>
+          <a:prstGeom prst="rect">
+            <a:avLst/>
+          </a:prstGeom>
+          <a:noFill/>
+        </p:spPr>
+        <p:txBody>
+          <a:bodyPr wrap="square" anchor="t" lIns="0" rIns="0" tIns="0" bIns="0">
+            <a:spAutoFit/>
+          </a:bodyPr>
+          <a:lstStyle/>
+          <a:p>
+            <a:pPr algn="l">
+              <a:lnSpc>
+                <a:spcPct val="110000"/>
+              </a:lnSpc>
+              <a:spcAft>
+                <a:spcPts val="200"/>
+              </a:spcAft>
+            </a:pPr>
+            <a:r>
+              <a:rPr sz="2400" b="0" i="0" spc="-90">
+                <a:solidFill>
+                  <a:srgbClr val="314359"/>
+                </a:solidFill>
+                <a:latin typeface="Times New Roman"/>
+              </a:rPr>
+              <a:t>2.18 Responsible ownership, by construction</a:t>
+            </a:r>
+          </a:p>
+        </p:txBody>
+      </p:sp>
+      <p:sp>
+        <p:nvSpPr>
+          <p:cNvPr id="7" name="TextBox 6"/>
+          <p:cNvSpPr txBox="1"/>
+          <p:nvPr/>
+        </p:nvSpPr>
+        <p:spPr>
+          <a:xfrm>
+            <a:off x="6583844" y="6876288"/>
+            <a:ext cx="2926153" cy="292608"/>
+          </a:xfrm>
+          <a:prstGeom prst="rect">
+            <a:avLst/>
+          </a:prstGeom>
+          <a:noFill/>
+        </p:spPr>
+        <p:txBody>
+          <a:bodyPr wrap="square" anchor="t" lIns="0" rIns="0" tIns="0" bIns="0">
+            <a:spAutoFit/>
+          </a:bodyPr>
+          <a:lstStyle/>
+          <a:p>
+            <a:pPr algn="r">
+              <a:lnSpc>
+                <a:spcPct val="110000"/>
+              </a:lnSpc>
+              <a:spcAft>
+                <a:spcPts val="0"/>
+              </a:spcAft>
+            </a:pPr>
+            <a:r>
+              <a:rPr sz="680" b="0" i="0">
+                <a:solidFill>
+                  <a:srgbClr val="556A83"/>
+                </a:solidFill>
+                <a:latin typeface="Arial"/>
+              </a:rPr>
+              <a:t>Strictly confidential          24</a:t>
+            </a:r>
+          </a:p>
+        </p:txBody>
+      </p:sp>
+      <p:sp>
+        <p:nvSpPr>
+          <p:cNvPr id="8" name="TextBox 7"/>
+          <p:cNvSpPr txBox="1"/>
+          <p:nvPr/>
+        </p:nvSpPr>
+        <p:spPr>
+          <a:xfrm>
+            <a:off x="548653" y="1901952"/>
+            <a:ext cx="8705305" cy="4584192"/>
+          </a:xfrm>
+          <a:prstGeom prst="rect">
+            <a:avLst/>
+          </a:prstGeom>
+          <a:noFill/>
+        </p:spPr>
+        <p:txBody>
+          <a:bodyPr wrap="square" anchor="t" lIns="0" rIns="0" tIns="0" bIns="0">
+            <a:spAutoFit/>
+          </a:bodyPr>
+          <a:lstStyle/>
+          <a:p>
+            <a:pPr marL="186949" indent="-186949">
+              <a:lnSpc>
+                <a:spcPct val="112000"/>
+              </a:lnSpc>
+              <a:spcAft>
+                <a:spcPts val="1400"/>
+              </a:spcAft>
+            </a:pPr>
+            <a:r>
+              <a:rPr sz="1280" b="1">
+                <a:solidFill>
+                  <a:srgbClr val="314359"/>
+                </a:solidFill>
+                <a:latin typeface="Arial"/>
+              </a:rPr>
+              <a:t>›  </a:t>
+            </a:r>
+            <a:r>
+              <a:rPr sz="1280" b="1">
+                <a:solidFill>
+                  <a:srgbClr val="314359"/>
+                </a:solidFill>
+                <a:latin typeface="Arial"/>
+              </a:rPr>
+              <a:t>Governance is the lever.</a:t>
+            </a:r>
+            <a:r>
+              <a:rPr sz="1280">
+                <a:solidFill>
+                  <a:srgbClr val="0E1620"/>
+                </a:solidFill>
+                <a:latin typeface="Arial"/>
+              </a:rPr>
+              <a:t>  Value is created through board representation and active promotion of strong corporate governance across all holdings.</a:t>
+            </a:r>
+          </a:p>
+          <a:p>
+            <a:pPr marL="186949" indent="-186949">
+              <a:lnSpc>
+                <a:spcPct val="112000"/>
+              </a:lnSpc>
+              <a:spcAft>
+                <a:spcPts val="1400"/>
+              </a:spcAft>
+            </a:pPr>
+            <a:r>
+              <a:rPr sz="1280" b="1">
+                <a:solidFill>
+                  <a:srgbClr val="314359"/>
+                </a:solidFill>
+                <a:latin typeface="Arial"/>
+              </a:rPr>
+              <a:t>›  </a:t>
+            </a:r>
+            <a:r>
+              <a:rPr sz="1280" b="1">
+                <a:solidFill>
+                  <a:srgbClr val="314359"/>
+                </a:solidFill>
+                <a:latin typeface="Arial"/>
+              </a:rPr>
+              <a:t>Five improvement dimensions.</a:t>
+            </a:r>
+            <a:r>
+              <a:rPr sz="1280">
+                <a:solidFill>
+                  <a:srgbClr val="0E1620"/>
+                </a:solidFill>
+                <a:latin typeface="Arial"/>
+              </a:rPr>
+              <a:t>  Operational, financial, structural, environmental and social improvements — each tied to enterprise value.</a:t>
+            </a:r>
+          </a:p>
+          <a:p>
+            <a:pPr marL="186949" indent="-186949">
+              <a:lnSpc>
+                <a:spcPct val="112000"/>
+              </a:lnSpc>
+              <a:spcAft>
+                <a:spcPts val="1400"/>
+              </a:spcAft>
+            </a:pPr>
+            <a:r>
+              <a:rPr sz="1280" b="1">
+                <a:solidFill>
+                  <a:srgbClr val="314359"/>
+                </a:solidFill>
+                <a:latin typeface="Arial"/>
+              </a:rPr>
+              <a:t>›  </a:t>
+            </a:r>
+            <a:r>
+              <a:rPr sz="1280" b="1">
+                <a:solidFill>
+                  <a:srgbClr val="314359"/>
+                </a:solidFill>
+                <a:latin typeface="Arial"/>
+              </a:rPr>
+              <a:t>PRI signatory since 2019,</a:t>
+            </a:r>
+            <a:r>
+              <a:rPr sz="1280">
+                <a:solidFill>
+                  <a:srgbClr val="0E1620"/>
+                </a:solidFill>
+                <a:latin typeface="Arial"/>
+              </a:rPr>
+              <a:t>  adhering to the Six Principles for Responsible Investment.</a:t>
+            </a:r>
+          </a:p>
+          <a:p>
+            <a:pPr marL="186949" indent="-186949">
+              <a:lnSpc>
+                <a:spcPct val="112000"/>
+              </a:lnSpc>
+              <a:spcAft>
+                <a:spcPts val="1400"/>
+              </a:spcAft>
+            </a:pPr>
+            <a:r>
+              <a:rPr sz="1280" b="1">
+                <a:solidFill>
+                  <a:srgbClr val="314359"/>
+                </a:solidFill>
+                <a:latin typeface="Arial"/>
+              </a:rPr>
+              <a:t>›  </a:t>
+            </a:r>
+            <a:r>
+              <a:rPr sz="1280" b="1">
+                <a:solidFill>
+                  <a:srgbClr val="314359"/>
+                </a:solidFill>
+                <a:latin typeface="Arial"/>
+              </a:rPr>
+              <a:t>Credible oversight.</a:t>
+            </a:r>
+            <a:r>
+              <a:rPr sz="1280">
+                <a:solidFill>
+                  <a:srgbClr val="0E1620"/>
+                </a:solidFill>
+                <a:latin typeface="Arial"/>
+              </a:rPr>
+              <a:t>  SEB custodian · MUFG administrator · KPMG auditor · Swedish FI-registered AIFM.</a:t>
+            </a:r>
+          </a:p>
+        </p:txBody>
+      </p:sp>
+    </p:spTree>
+  </p:cSld>
+  <p:clrMapOvr>
+    <a:masterClrMapping/>
+  </p:clrMapOvr>
+</p:sld>
+</file>
+
+<file path=ppt/slides/slide28.xml><?xml version="1.0" encoding="utf-8"?>
 <p:sld xmlns:a="http://schemas.openxmlformats.org/drawingml/2006/main" xmlns:p="http://schemas.openxmlformats.org/presentationml/2006/main" xmlns:r="http://schemas.openxmlformats.org/officeDocument/2006/relationships">
   <p:cSld>
     <p:spTree>

</xml_diff>

<commit_message>
Portfolio-impact slide: add 'how the path is earned' tying compounding to p.17 average monthly returns (down-market protection)
</commit_message>
<xml_diff>
--- a/Athanase_Engaged_Ownership_Allocator_Deck.pptx
+++ b/Athanase_Engaged_Ownership_Allocator_Deck.pptx
@@ -34063,8 +34063,8 @@
         </p:nvSpPr>
         <p:spPr>
           <a:xfrm>
-            <a:off x="5888883" y="2974848"/>
-            <a:ext cx="1097307" cy="487680"/>
+            <a:off x="5888883" y="2896819"/>
+            <a:ext cx="1097307" cy="448665"/>
           </a:xfrm>
           <a:prstGeom prst="rect">
             <a:avLst/>
@@ -34107,8 +34107,8 @@
         </p:nvSpPr>
         <p:spPr>
           <a:xfrm>
-            <a:off x="5962037" y="2974848"/>
-            <a:ext cx="980261" cy="487680"/>
+            <a:off x="5962037" y="2896819"/>
+            <a:ext cx="980261" cy="448665"/>
           </a:xfrm>
           <a:prstGeom prst="rect">
             <a:avLst/>
@@ -34149,8 +34149,8 @@
         </p:nvSpPr>
         <p:spPr>
           <a:xfrm>
-            <a:off x="6986190" y="2974848"/>
-            <a:ext cx="1133884" cy="487680"/>
+            <a:off x="6986190" y="2896819"/>
+            <a:ext cx="1133884" cy="448665"/>
           </a:xfrm>
           <a:prstGeom prst="rect">
             <a:avLst/>
@@ -34193,8 +34193,8 @@
         </p:nvSpPr>
         <p:spPr>
           <a:xfrm>
-            <a:off x="7059344" y="2974848"/>
-            <a:ext cx="1016838" cy="487680"/>
+            <a:off x="7059344" y="2896819"/>
+            <a:ext cx="1016838" cy="448665"/>
           </a:xfrm>
           <a:prstGeom prst="rect">
             <a:avLst/>
@@ -34235,8 +34235,8 @@
         </p:nvSpPr>
         <p:spPr>
           <a:xfrm>
-            <a:off x="8120075" y="2974848"/>
-            <a:ext cx="1426499" cy="487680"/>
+            <a:off x="8120075" y="2896819"/>
+            <a:ext cx="1426499" cy="448665"/>
           </a:xfrm>
           <a:prstGeom prst="rect">
             <a:avLst/>
@@ -34279,8 +34279,8 @@
         </p:nvSpPr>
         <p:spPr>
           <a:xfrm>
-            <a:off x="8193228" y="2974848"/>
-            <a:ext cx="1309453" cy="487680"/>
+            <a:off x="8193228" y="2896819"/>
+            <a:ext cx="1309453" cy="448665"/>
           </a:xfrm>
           <a:prstGeom prst="rect">
             <a:avLst/>
@@ -34321,8 +34321,8 @@
         </p:nvSpPr>
         <p:spPr>
           <a:xfrm>
-            <a:off x="5888883" y="3462528"/>
-            <a:ext cx="1097307" cy="487680"/>
+            <a:off x="5888883" y="3345484"/>
+            <a:ext cx="1097307" cy="448665"/>
           </a:xfrm>
           <a:prstGeom prst="rect">
             <a:avLst/>
@@ -34365,8 +34365,8 @@
         </p:nvSpPr>
         <p:spPr>
           <a:xfrm>
-            <a:off x="5962037" y="3462528"/>
-            <a:ext cx="980261" cy="487680"/>
+            <a:off x="5962037" y="3345484"/>
+            <a:ext cx="980261" cy="448665"/>
           </a:xfrm>
           <a:prstGeom prst="rect">
             <a:avLst/>
@@ -34407,8 +34407,8 @@
         </p:nvSpPr>
         <p:spPr>
           <a:xfrm>
-            <a:off x="6986190" y="3462528"/>
-            <a:ext cx="1133884" cy="487680"/>
+            <a:off x="6986190" y="3345484"/>
+            <a:ext cx="1133884" cy="448665"/>
           </a:xfrm>
           <a:prstGeom prst="rect">
             <a:avLst/>
@@ -34451,8 +34451,8 @@
         </p:nvSpPr>
         <p:spPr>
           <a:xfrm>
-            <a:off x="7059344" y="3462528"/>
-            <a:ext cx="1016838" cy="487680"/>
+            <a:off x="7059344" y="3345484"/>
+            <a:ext cx="1016838" cy="448665"/>
           </a:xfrm>
           <a:prstGeom prst="rect">
             <a:avLst/>
@@ -34493,8 +34493,8 @@
         </p:nvSpPr>
         <p:spPr>
           <a:xfrm>
-            <a:off x="8120075" y="3462528"/>
-            <a:ext cx="1426499" cy="487680"/>
+            <a:off x="8120075" y="3345484"/>
+            <a:ext cx="1426499" cy="448665"/>
           </a:xfrm>
           <a:prstGeom prst="rect">
             <a:avLst/>
@@ -34537,8 +34537,8 @@
         </p:nvSpPr>
         <p:spPr>
           <a:xfrm>
-            <a:off x="8193228" y="3462528"/>
-            <a:ext cx="1309453" cy="487680"/>
+            <a:off x="8193228" y="3345484"/>
+            <a:ext cx="1309453" cy="448665"/>
           </a:xfrm>
           <a:prstGeom prst="rect">
             <a:avLst/>
@@ -34579,8 +34579,8 @@
         </p:nvSpPr>
         <p:spPr>
           <a:xfrm>
-            <a:off x="5888883" y="3950208"/>
-            <a:ext cx="1097307" cy="487680"/>
+            <a:off x="5888883" y="3794150"/>
+            <a:ext cx="1097307" cy="448665"/>
           </a:xfrm>
           <a:prstGeom prst="rect">
             <a:avLst/>
@@ -34623,8 +34623,8 @@
         </p:nvSpPr>
         <p:spPr>
           <a:xfrm>
-            <a:off x="5962037" y="3950208"/>
-            <a:ext cx="980261" cy="487680"/>
+            <a:off x="5962037" y="3794150"/>
+            <a:ext cx="980261" cy="448665"/>
           </a:xfrm>
           <a:prstGeom prst="rect">
             <a:avLst/>
@@ -34665,8 +34665,8 @@
         </p:nvSpPr>
         <p:spPr>
           <a:xfrm>
-            <a:off x="6986190" y="3950208"/>
-            <a:ext cx="1133884" cy="487680"/>
+            <a:off x="6986190" y="3794150"/>
+            <a:ext cx="1133884" cy="448665"/>
           </a:xfrm>
           <a:prstGeom prst="rect">
             <a:avLst/>
@@ -34709,8 +34709,8 @@
         </p:nvSpPr>
         <p:spPr>
           <a:xfrm>
-            <a:off x="7059344" y="3950208"/>
-            <a:ext cx="1016838" cy="487680"/>
+            <a:off x="7059344" y="3794150"/>
+            <a:ext cx="1016838" cy="448665"/>
           </a:xfrm>
           <a:prstGeom prst="rect">
             <a:avLst/>
@@ -34751,8 +34751,8 @@
         </p:nvSpPr>
         <p:spPr>
           <a:xfrm>
-            <a:off x="8120075" y="3950208"/>
-            <a:ext cx="1426499" cy="487680"/>
+            <a:off x="8120075" y="3794150"/>
+            <a:ext cx="1426499" cy="448665"/>
           </a:xfrm>
           <a:prstGeom prst="rect">
             <a:avLst/>
@@ -34795,8 +34795,8 @@
         </p:nvSpPr>
         <p:spPr>
           <a:xfrm>
-            <a:off x="8193228" y="3950208"/>
-            <a:ext cx="1309453" cy="487680"/>
+            <a:off x="8193228" y="3794150"/>
+            <a:ext cx="1309453" cy="448665"/>
           </a:xfrm>
           <a:prstGeom prst="rect">
             <a:avLst/>
@@ -34837,8 +34837,8 @@
         </p:nvSpPr>
         <p:spPr>
           <a:xfrm>
-            <a:off x="5888883" y="4437888"/>
-            <a:ext cx="1097307" cy="487680"/>
+            <a:off x="5888883" y="4242816"/>
+            <a:ext cx="1097307" cy="448665"/>
           </a:xfrm>
           <a:prstGeom prst="rect">
             <a:avLst/>
@@ -34881,8 +34881,8 @@
         </p:nvSpPr>
         <p:spPr>
           <a:xfrm>
-            <a:off x="5962037" y="4437888"/>
-            <a:ext cx="980261" cy="487680"/>
+            <a:off x="5962037" y="4242816"/>
+            <a:ext cx="980261" cy="448665"/>
           </a:xfrm>
           <a:prstGeom prst="rect">
             <a:avLst/>
@@ -34923,8 +34923,8 @@
         </p:nvSpPr>
         <p:spPr>
           <a:xfrm>
-            <a:off x="6986190" y="4437888"/>
-            <a:ext cx="1133884" cy="487680"/>
+            <a:off x="6986190" y="4242816"/>
+            <a:ext cx="1133884" cy="448665"/>
           </a:xfrm>
           <a:prstGeom prst="rect">
             <a:avLst/>
@@ -34967,8 +34967,8 @@
         </p:nvSpPr>
         <p:spPr>
           <a:xfrm>
-            <a:off x="7059344" y="4437888"/>
-            <a:ext cx="1016838" cy="487680"/>
+            <a:off x="7059344" y="4242816"/>
+            <a:ext cx="1016838" cy="448665"/>
           </a:xfrm>
           <a:prstGeom prst="rect">
             <a:avLst/>
@@ -35009,8 +35009,8 @@
         </p:nvSpPr>
         <p:spPr>
           <a:xfrm>
-            <a:off x="8120075" y="4437888"/>
-            <a:ext cx="1426499" cy="487680"/>
+            <a:off x="8120075" y="4242816"/>
+            <a:ext cx="1426499" cy="448665"/>
           </a:xfrm>
           <a:prstGeom prst="rect">
             <a:avLst/>
@@ -35053,8 +35053,8 @@
         </p:nvSpPr>
         <p:spPr>
           <a:xfrm>
-            <a:off x="8193228" y="4437888"/>
-            <a:ext cx="1309453" cy="487680"/>
+            <a:off x="8193228" y="4242816"/>
+            <a:ext cx="1309453" cy="448665"/>
           </a:xfrm>
           <a:prstGeom prst="rect">
             <a:avLst/>
@@ -35095,8 +35095,8 @@
         </p:nvSpPr>
         <p:spPr>
           <a:xfrm>
-            <a:off x="5888883" y="5120640"/>
-            <a:ext cx="3365076" cy="1658112"/>
+            <a:off x="5888883" y="4847539"/>
+            <a:ext cx="3365076" cy="292608"/>
           </a:xfrm>
           <a:prstGeom prst="rect">
             <a:avLst/>
@@ -35111,34 +35111,95 @@
           <a:p>
             <a:pPr algn="l">
               <a:lnSpc>
-                <a:spcPct val="120000"/>
+                <a:spcPct val="110000"/>
               </a:lnSpc>
               <a:spcAft>
                 <a:spcPts val="0"/>
               </a:spcAft>
             </a:pPr>
             <a:r>
-              <a:rPr sz="1000" b="0" i="0">
+              <a:rPr sz="880" b="1" i="0">
+                <a:solidFill>
+                  <a:srgbClr val="314359"/>
+                </a:solidFill>
+                <a:latin typeface="Arial"/>
+              </a:rPr>
+              <a:t>HOW THE PATH IS EARNED</a:t>
+            </a:r>
+          </a:p>
+        </p:txBody>
+      </p:sp>
+      <p:sp>
+        <p:nvSpPr>
+          <p:cNvPr id="40" name="TextBox 39"/>
+          <p:cNvSpPr txBox="1"/>
+          <p:nvPr/>
+        </p:nvSpPr>
+        <p:spPr>
+          <a:xfrm>
+            <a:off x="5888883" y="5140147"/>
+            <a:ext cx="3365076" cy="2145792"/>
+          </a:xfrm>
+          <a:prstGeom prst="rect">
+            <a:avLst/>
+          </a:prstGeom>
+          <a:noFill/>
+        </p:spPr>
+        <p:txBody>
+          <a:bodyPr wrap="square" anchor="t" lIns="0" rIns="0" tIns="0" bIns="0">
+            <a:spAutoFit/>
+          </a:bodyPr>
+          <a:lstStyle/>
+          <a:p>
+            <a:pPr algn="l">
+              <a:lnSpc>
+                <a:spcPct val="115000"/>
+              </a:lnSpc>
+              <a:spcAft>
+                <a:spcPts val="700"/>
+              </a:spcAft>
+            </a:pPr>
+            <a:r>
+              <a:rPr sz="919" b="0" i="0">
                 <a:solidFill>
                   <a:srgbClr val="0E1620"/>
                 </a:solidFill>
                 <a:latin typeface="Arial"/>
               </a:rPr>
-              <a:t>A 5% sleeve in Athanase rather than a long-only global fund adds roughly half a percent (≈52 bps) to total-portfolio return every year — and compounds: the sleeve itself reaches ~2.5× the long-only outcome over a decade, with the diversification and downside profile shown earlier.</a:t>
-            </a:r>
-          </a:p>
-        </p:txBody>
-      </p:sp>
-      <p:sp>
-        <p:nvSpPr>
-          <p:cNvPr id="40" name="TextBox 39"/>
-          <p:cNvSpPr txBox="1"/>
-          <p:nvPr/>
-        </p:nvSpPr>
-        <p:spPr>
-          <a:xfrm>
-            <a:off x="438922" y="6729984"/>
-            <a:ext cx="7900613" cy="438912"/>
+              <a:t>The smooth line is not won by chasing rallies. On average monthly returns (p.17), Athanase roughly matches the market up (1.2% vs 1.3%) but protects sharply down (+0.2% vs −1.7%).</a:t>
+            </a:r>
+          </a:p>
+          <a:p>
+            <a:pPr algn="l">
+              <a:lnSpc>
+                <a:spcPct val="115000"/>
+              </a:lnSpc>
+              <a:spcAft>
+                <a:spcPts val="0"/>
+              </a:spcAft>
+            </a:pPr>
+            <a:r>
+              <a:rPr sz="919" b="0" i="0">
+                <a:solidFill>
+                  <a:srgbClr val="0E1620"/>
+                </a:solidFill>
+                <a:latin typeface="Arial"/>
+              </a:rPr>
+              <a:t>Losing less in the down months — not winning more up — is what compounds the lines apart: a steadier path, not just a higher one.</a:t>
+            </a:r>
+          </a:p>
+        </p:txBody>
+      </p:sp>
+      <p:sp>
+        <p:nvSpPr>
+          <p:cNvPr id="41" name="TextBox 40"/>
+          <p:cNvSpPr txBox="1"/>
+          <p:nvPr/>
+        </p:nvSpPr>
+        <p:spPr>
+          <a:xfrm>
+            <a:off x="438922" y="6973824"/>
+            <a:ext cx="6510690" cy="390144"/>
           </a:xfrm>
           <a:prstGeom prst="rect">
             <a:avLst/>
@@ -35166,7 +35227,7 @@
                 </a:solidFill>
                 <a:latin typeface="Arial"/>
               </a:rPr>
-              <a:t>Illustrative only; not a projection. Athanase 18% (headline net IRR); other activist 10.5%; long-only global 7.6% (MSCI IMI since inception). Uplift = sleeve size × return spread; growth = annual compounding. Past performance is not indicative of future results.</a:t>
+              <a:t>Illustrative only; not a projection. Athanase 18% (headline net IRR); other activist 10.5%; long-only 7.6% (MSCI IMI). Uplift = sleeve × return spread; growth = annual compounding. Past performance ≠ future results.</a:t>
             </a:r>
           </a:p>
         </p:txBody>

</xml_diff>

<commit_message>
Make downside protection visual: route growth paths through a down-market year (yr 6) with marker and divergence callouts
</commit_message>
<xml_diff>
--- a/Athanase_Engaged_Ownership_Allocator_Deck.pptx
+++ b/Athanase_Engaged_Ownership_Allocator_Deck.pptx
@@ -1002,7 +1002,7 @@
                   <a:srgbClr val="556A83"/>
                 </a:solidFill>
               </a:rPr>
-              <a:t>Figure 5.  Growth of a 100 sleeve over 10 years (indexed)</a:t>
+              <a:t>Figure 5.  Growth of a 100 sleeve through a market cycle (indexed)</a:t>
             </a:r>
           </a:p>
         </c:rich>
@@ -1093,28 +1093,28 @@
                   <c:v>118</c:v>
                 </c:pt>
                 <c:pt idx="2">
-                  <c:v>139</c:v>
+                  <c:v>140</c:v>
                 </c:pt>
                 <c:pt idx="3">
-                  <c:v>164</c:v>
+                  <c:v>166</c:v>
                 </c:pt>
                 <c:pt idx="4">
-                  <c:v>194</c:v>
+                  <c:v>197</c:v>
                 </c:pt>
                 <c:pt idx="5">
-                  <c:v>229</c:v>
+                  <c:v>233</c:v>
                 </c:pt>
                 <c:pt idx="6">
-                  <c:v>270</c:v>
+                  <c:v>236</c:v>
                 </c:pt>
                 <c:pt idx="7">
-                  <c:v>319</c:v>
+                  <c:v>296</c:v>
                 </c:pt>
                 <c:pt idx="8">
-                  <c:v>376</c:v>
+                  <c:v>366</c:v>
                 </c:pt>
                 <c:pt idx="9">
-                  <c:v>444</c:v>
+                  <c:v>442</c:v>
                 </c:pt>
                 <c:pt idx="10">
                   <c:v>523</c:v>
@@ -1202,28 +1202,28 @@
                   <c:v>111</c:v>
                 </c:pt>
                 <c:pt idx="2">
-                  <c:v>122</c:v>
+                  <c:v>123</c:v>
                 </c:pt>
                 <c:pt idx="3">
-                  <c:v>135</c:v>
+                  <c:v>137</c:v>
                 </c:pt>
                 <c:pt idx="4">
-                  <c:v>149</c:v>
+                  <c:v>152</c:v>
                 </c:pt>
                 <c:pt idx="5">
-                  <c:v>165</c:v>
+                  <c:v>168</c:v>
                 </c:pt>
                 <c:pt idx="6">
+                  <c:v>150</c:v>
+                </c:pt>
+                <c:pt idx="7">
                   <c:v>182</c:v>
                 </c:pt>
-                <c:pt idx="7">
-                  <c:v>201</c:v>
-                </c:pt>
                 <c:pt idx="8">
-                  <c:v>222</c:v>
+                  <c:v>214</c:v>
                 </c:pt>
                 <c:pt idx="9">
-                  <c:v>246</c:v>
+                  <c:v>244</c:v>
                 </c:pt>
                 <c:pt idx="10">
                   <c:v>271</c:v>
@@ -1312,28 +1312,28 @@
                   <c:v>108</c:v>
                 </c:pt>
                 <c:pt idx="2">
-                  <c:v>116</c:v>
+                  <c:v>117</c:v>
                 </c:pt>
                 <c:pt idx="3">
-                  <c:v>125</c:v>
+                  <c:v>126</c:v>
                 </c:pt>
                 <c:pt idx="4">
-                  <c:v>134</c:v>
+                  <c:v>136</c:v>
                 </c:pt>
                 <c:pt idx="5">
-                  <c:v>144</c:v>
+                  <c:v>147</c:v>
                 </c:pt>
                 <c:pt idx="6">
-                  <c:v>155</c:v>
+                  <c:v>119</c:v>
                 </c:pt>
                 <c:pt idx="7">
-                  <c:v>167</c:v>
+                  <c:v>142</c:v>
                 </c:pt>
                 <c:pt idx="8">
-                  <c:v>180</c:v>
+                  <c:v>168</c:v>
                 </c:pt>
                 <c:pt idx="9">
-                  <c:v>193</c:v>
+                  <c:v>190</c:v>
                 </c:pt>
                 <c:pt idx="10">
                   <c:v>208</c:v>
@@ -1376,7 +1376,10 @@
       </c:catAx>
       <c:valAx>
         <c:axId val="2140495176"/>
-        <c:scaling/>
+        <c:scaling>
+          <c:max val="600.0"/>
+          <c:min val="0.0"/>
+        </c:scaling>
         <c:delete val="0"/>
         <c:axPos val="l"/>
         <c:majorTickMark val="out"/>
@@ -33889,7 +33892,177 @@
       </p:graphicFrame>
       <p:sp>
         <p:nvSpPr>
-          <p:cNvPr id="11" name="TextBox 10"/>
+          <p:cNvPr id="11" name="Rectangle 10"/>
+          <p:cNvSpPr/>
+          <p:nvPr/>
+        </p:nvSpPr>
+        <p:spPr>
+          <a:xfrm>
+            <a:off x="3526014" y="2896819"/>
+            <a:ext cx="12192" cy="2926080"/>
+          </a:xfrm>
+          <a:prstGeom prst="rect">
+            <a:avLst/>
+          </a:prstGeom>
+          <a:solidFill>
+            <a:srgbClr val="556A83"/>
+          </a:solidFill>
+          <a:ln>
+            <a:noFill/>
+          </a:ln>
+          <a:effectLst/>
+        </p:spPr>
+        <p:style>
+          <a:lnRef idx="1">
+            <a:schemeClr val="accent1"/>
+          </a:lnRef>
+          <a:fillRef idx="3">
+            <a:schemeClr val="accent1"/>
+          </a:fillRef>
+          <a:effectRef idx="2">
+            <a:schemeClr val="accent1"/>
+          </a:effectRef>
+          <a:fontRef idx="minor">
+            <a:schemeClr val="lt1"/>
+          </a:fontRef>
+        </p:style>
+        <p:txBody>
+          <a:bodyPr rtlCol="0" anchor="ctr"/>
+          <a:lstStyle/>
+          <a:p>
+            <a:pPr algn="ctr"/>
+          </a:p>
+        </p:txBody>
+      </p:sp>
+      <p:sp>
+        <p:nvSpPr>
+          <p:cNvPr id="12" name="TextBox 11"/>
+          <p:cNvSpPr txBox="1"/>
+          <p:nvPr/>
+        </p:nvSpPr>
+        <p:spPr>
+          <a:xfrm>
+            <a:off x="2794476" y="2643225"/>
+            <a:ext cx="1463076" cy="292608"/>
+          </a:xfrm>
+          <a:prstGeom prst="rect">
+            <a:avLst/>
+          </a:prstGeom>
+          <a:noFill/>
+        </p:spPr>
+        <p:txBody>
+          <a:bodyPr wrap="square" anchor="t" lIns="0" rIns="0" tIns="0" bIns="0">
+            <a:spAutoFit/>
+          </a:bodyPr>
+          <a:lstStyle/>
+          <a:p>
+            <a:pPr algn="ctr">
+              <a:lnSpc>
+                <a:spcPct val="110000"/>
+              </a:lnSpc>
+              <a:spcAft>
+                <a:spcPts val="0"/>
+              </a:spcAft>
+            </a:pPr>
+            <a:r>
+              <a:rPr sz="800" b="1" i="0">
+                <a:solidFill>
+                  <a:srgbClr val="314359"/>
+                </a:solidFill>
+                <a:latin typeface="Arial"/>
+              </a:rPr>
+              <a:t>Down-market year</a:t>
+            </a:r>
+          </a:p>
+        </p:txBody>
+      </p:sp>
+      <p:sp>
+        <p:nvSpPr>
+          <p:cNvPr id="13" name="TextBox 12"/>
+          <p:cNvSpPr txBox="1"/>
+          <p:nvPr/>
+        </p:nvSpPr>
+        <p:spPr>
+          <a:xfrm>
+            <a:off x="3584537" y="4392177"/>
+            <a:ext cx="1170461" cy="253593"/>
+          </a:xfrm>
+          <a:prstGeom prst="rect">
+            <a:avLst/>
+          </a:prstGeom>
+          <a:noFill/>
+        </p:spPr>
+        <p:txBody>
+          <a:bodyPr wrap="square" anchor="t" lIns="0" rIns="0" tIns="0" bIns="0">
+            <a:spAutoFit/>
+          </a:bodyPr>
+          <a:lstStyle/>
+          <a:p>
+            <a:pPr algn="l">
+              <a:lnSpc>
+                <a:spcPct val="110000"/>
+              </a:lnSpc>
+              <a:spcAft>
+                <a:spcPts val="0"/>
+              </a:spcAft>
+            </a:pPr>
+            <a:r>
+              <a:rPr sz="760" b="1" i="0">
+                <a:solidFill>
+                  <a:srgbClr val="314359"/>
+                </a:solidFill>
+                <a:latin typeface="Arial"/>
+              </a:rPr>
+              <a:t>Athanase: holds</a:t>
+            </a:r>
+          </a:p>
+        </p:txBody>
+      </p:sp>
+      <p:sp>
+        <p:nvSpPr>
+          <p:cNvPr id="14" name="TextBox 13"/>
+          <p:cNvSpPr txBox="1"/>
+          <p:nvPr/>
+        </p:nvSpPr>
+        <p:spPr>
+          <a:xfrm>
+            <a:off x="3584537" y="5248689"/>
+            <a:ext cx="1170461" cy="253593"/>
+          </a:xfrm>
+          <a:prstGeom prst="rect">
+            <a:avLst/>
+          </a:prstGeom>
+          <a:noFill/>
+        </p:spPr>
+        <p:txBody>
+          <a:bodyPr wrap="square" anchor="t" lIns="0" rIns="0" tIns="0" bIns="0">
+            <a:spAutoFit/>
+          </a:bodyPr>
+          <a:lstStyle/>
+          <a:p>
+            <a:pPr algn="l">
+              <a:lnSpc>
+                <a:spcPct val="110000"/>
+              </a:lnSpc>
+              <a:spcAft>
+                <a:spcPts val="0"/>
+              </a:spcAft>
+            </a:pPr>
+            <a:r>
+              <a:rPr sz="760" b="0" i="0">
+                <a:solidFill>
+                  <a:srgbClr val="556A83"/>
+                </a:solidFill>
+                <a:latin typeface="Arial"/>
+              </a:rPr>
+              <a:t>Long-only: −19%</a:t>
+            </a:r>
+          </a:p>
+        </p:txBody>
+      </p:sp>
+      <p:sp>
+        <p:nvSpPr>
+          <p:cNvPr id="15" name="TextBox 14"/>
           <p:cNvSpPr txBox="1"/>
           <p:nvPr/>
         </p:nvSpPr>
@@ -33931,7 +34104,7 @@
       </p:sp>
       <p:sp>
         <p:nvSpPr>
-          <p:cNvPr id="12" name="TextBox 11"/>
+          <p:cNvPr id="16" name="TextBox 15"/>
           <p:cNvSpPr txBox="1"/>
           <p:nvPr/>
         </p:nvSpPr>
@@ -33973,7 +34146,7 @@
       </p:sp>
       <p:sp>
         <p:nvSpPr>
-          <p:cNvPr id="13" name="TextBox 12"/>
+          <p:cNvPr id="17" name="TextBox 16"/>
           <p:cNvSpPr txBox="1"/>
           <p:nvPr/>
         </p:nvSpPr>
@@ -34015,7 +34188,7 @@
       </p:sp>
       <p:sp>
         <p:nvSpPr>
-          <p:cNvPr id="14" name="TextBox 13"/>
+          <p:cNvPr id="18" name="TextBox 17"/>
           <p:cNvSpPr txBox="1"/>
           <p:nvPr/>
         </p:nvSpPr>
@@ -34057,7 +34230,7 @@
       </p:sp>
       <p:sp>
         <p:nvSpPr>
-          <p:cNvPr id="15" name="Rectangle 14"/>
+          <p:cNvPr id="19" name="Rectangle 18"/>
           <p:cNvSpPr/>
           <p:nvPr/>
         </p:nvSpPr>
@@ -34101,7 +34274,7 @@
       </p:sp>
       <p:sp>
         <p:nvSpPr>
-          <p:cNvPr id="16" name="TextBox 15"/>
+          <p:cNvPr id="20" name="TextBox 19"/>
           <p:cNvSpPr txBox="1"/>
           <p:nvPr/>
         </p:nvSpPr>
@@ -34143,7 +34316,7 @@
       </p:sp>
       <p:sp>
         <p:nvSpPr>
-          <p:cNvPr id="17" name="Rectangle 16"/>
+          <p:cNvPr id="21" name="Rectangle 20"/>
           <p:cNvSpPr/>
           <p:nvPr/>
         </p:nvSpPr>
@@ -34187,7 +34360,7 @@
       </p:sp>
       <p:sp>
         <p:nvSpPr>
-          <p:cNvPr id="18" name="TextBox 17"/>
+          <p:cNvPr id="22" name="TextBox 21"/>
           <p:cNvSpPr txBox="1"/>
           <p:nvPr/>
         </p:nvSpPr>
@@ -34229,7 +34402,7 @@
       </p:sp>
       <p:sp>
         <p:nvSpPr>
-          <p:cNvPr id="19" name="Rectangle 18"/>
+          <p:cNvPr id="23" name="Rectangle 22"/>
           <p:cNvSpPr/>
           <p:nvPr/>
         </p:nvSpPr>
@@ -34273,7 +34446,7 @@
       </p:sp>
       <p:sp>
         <p:nvSpPr>
-          <p:cNvPr id="20" name="TextBox 19"/>
+          <p:cNvPr id="24" name="TextBox 23"/>
           <p:cNvSpPr txBox="1"/>
           <p:nvPr/>
         </p:nvSpPr>
@@ -34315,7 +34488,7 @@
       </p:sp>
       <p:sp>
         <p:nvSpPr>
-          <p:cNvPr id="21" name="Rectangle 20"/>
+          <p:cNvPr id="25" name="Rectangle 24"/>
           <p:cNvSpPr/>
           <p:nvPr/>
         </p:nvSpPr>
@@ -34359,7 +34532,7 @@
       </p:sp>
       <p:sp>
         <p:nvSpPr>
-          <p:cNvPr id="22" name="TextBox 21"/>
+          <p:cNvPr id="26" name="TextBox 25"/>
           <p:cNvSpPr txBox="1"/>
           <p:nvPr/>
         </p:nvSpPr>
@@ -34401,7 +34574,7 @@
       </p:sp>
       <p:sp>
         <p:nvSpPr>
-          <p:cNvPr id="23" name="Rectangle 22"/>
+          <p:cNvPr id="27" name="Rectangle 26"/>
           <p:cNvSpPr/>
           <p:nvPr/>
         </p:nvSpPr>
@@ -34445,7 +34618,7 @@
       </p:sp>
       <p:sp>
         <p:nvSpPr>
-          <p:cNvPr id="24" name="TextBox 23"/>
+          <p:cNvPr id="28" name="TextBox 27"/>
           <p:cNvSpPr txBox="1"/>
           <p:nvPr/>
         </p:nvSpPr>
@@ -34487,7 +34660,7 @@
       </p:sp>
       <p:sp>
         <p:nvSpPr>
-          <p:cNvPr id="25" name="Rectangle 24"/>
+          <p:cNvPr id="29" name="Rectangle 28"/>
           <p:cNvSpPr/>
           <p:nvPr/>
         </p:nvSpPr>
@@ -34531,7 +34704,7 @@
       </p:sp>
       <p:sp>
         <p:nvSpPr>
-          <p:cNvPr id="26" name="TextBox 25"/>
+          <p:cNvPr id="30" name="TextBox 29"/>
           <p:cNvSpPr txBox="1"/>
           <p:nvPr/>
         </p:nvSpPr>
@@ -34573,7 +34746,7 @@
       </p:sp>
       <p:sp>
         <p:nvSpPr>
-          <p:cNvPr id="27" name="Rectangle 26"/>
+          <p:cNvPr id="31" name="Rectangle 30"/>
           <p:cNvSpPr/>
           <p:nvPr/>
         </p:nvSpPr>
@@ -34617,7 +34790,7 @@
       </p:sp>
       <p:sp>
         <p:nvSpPr>
-          <p:cNvPr id="28" name="TextBox 27"/>
+          <p:cNvPr id="32" name="TextBox 31"/>
           <p:cNvSpPr txBox="1"/>
           <p:nvPr/>
         </p:nvSpPr>
@@ -34659,7 +34832,7 @@
       </p:sp>
       <p:sp>
         <p:nvSpPr>
-          <p:cNvPr id="29" name="Rectangle 28"/>
+          <p:cNvPr id="33" name="Rectangle 32"/>
           <p:cNvSpPr/>
           <p:nvPr/>
         </p:nvSpPr>
@@ -34703,7 +34876,7 @@
       </p:sp>
       <p:sp>
         <p:nvSpPr>
-          <p:cNvPr id="30" name="TextBox 29"/>
+          <p:cNvPr id="34" name="TextBox 33"/>
           <p:cNvSpPr txBox="1"/>
           <p:nvPr/>
         </p:nvSpPr>
@@ -34745,7 +34918,7 @@
       </p:sp>
       <p:sp>
         <p:nvSpPr>
-          <p:cNvPr id="31" name="Rectangle 30"/>
+          <p:cNvPr id="35" name="Rectangle 34"/>
           <p:cNvSpPr/>
           <p:nvPr/>
         </p:nvSpPr>
@@ -34789,7 +34962,7 @@
       </p:sp>
       <p:sp>
         <p:nvSpPr>
-          <p:cNvPr id="32" name="TextBox 31"/>
+          <p:cNvPr id="36" name="TextBox 35"/>
           <p:cNvSpPr txBox="1"/>
           <p:nvPr/>
         </p:nvSpPr>
@@ -34831,7 +35004,7 @@
       </p:sp>
       <p:sp>
         <p:nvSpPr>
-          <p:cNvPr id="33" name="Rectangle 32"/>
+          <p:cNvPr id="37" name="Rectangle 36"/>
           <p:cNvSpPr/>
           <p:nvPr/>
         </p:nvSpPr>
@@ -34875,7 +35048,7 @@
       </p:sp>
       <p:sp>
         <p:nvSpPr>
-          <p:cNvPr id="34" name="TextBox 33"/>
+          <p:cNvPr id="38" name="TextBox 37"/>
           <p:cNvSpPr txBox="1"/>
           <p:nvPr/>
         </p:nvSpPr>
@@ -34917,7 +35090,7 @@
       </p:sp>
       <p:sp>
         <p:nvSpPr>
-          <p:cNvPr id="35" name="Rectangle 34"/>
+          <p:cNvPr id="39" name="Rectangle 38"/>
           <p:cNvSpPr/>
           <p:nvPr/>
         </p:nvSpPr>
@@ -34961,7 +35134,7 @@
       </p:sp>
       <p:sp>
         <p:nvSpPr>
-          <p:cNvPr id="36" name="TextBox 35"/>
+          <p:cNvPr id="40" name="TextBox 39"/>
           <p:cNvSpPr txBox="1"/>
           <p:nvPr/>
         </p:nvSpPr>
@@ -35003,7 +35176,7 @@
       </p:sp>
       <p:sp>
         <p:nvSpPr>
-          <p:cNvPr id="37" name="Rectangle 36"/>
+          <p:cNvPr id="41" name="Rectangle 40"/>
           <p:cNvSpPr/>
           <p:nvPr/>
         </p:nvSpPr>
@@ -35047,7 +35220,7 @@
       </p:sp>
       <p:sp>
         <p:nvSpPr>
-          <p:cNvPr id="38" name="TextBox 37"/>
+          <p:cNvPr id="42" name="TextBox 41"/>
           <p:cNvSpPr txBox="1"/>
           <p:nvPr/>
         </p:nvSpPr>
@@ -35089,7 +35262,7 @@
       </p:sp>
       <p:sp>
         <p:nvSpPr>
-          <p:cNvPr id="39" name="TextBox 38"/>
+          <p:cNvPr id="43" name="TextBox 42"/>
           <p:cNvSpPr txBox="1"/>
           <p:nvPr/>
         </p:nvSpPr>
@@ -35131,7 +35304,7 @@
       </p:sp>
       <p:sp>
         <p:nvSpPr>
-          <p:cNvPr id="40" name="TextBox 39"/>
+          <p:cNvPr id="44" name="TextBox 43"/>
           <p:cNvSpPr txBox="1"/>
           <p:nvPr/>
         </p:nvSpPr>
@@ -35192,7 +35365,7 @@
       </p:sp>
       <p:sp>
         <p:nvSpPr>
-          <p:cNvPr id="41" name="TextBox 40"/>
+          <p:cNvPr id="45" name="TextBox 44"/>
           <p:cNvSpPr txBox="1"/>
           <p:nvPr/>
         </p:nvSpPr>

</xml_diff>

<commit_message>
Fix slide 2.23: tighten card heights/spacing so the fifth card's text clears the takeaway strip (was clipped)
</commit_message>
<xml_diff>
--- a/Athanase_Engaged_Ownership_Allocator_Deck.pptx
+++ b/Athanase_Engaged_Ownership_Allocator_Deck.pptx
@@ -45424,8 +45424,8 @@
         </p:nvSpPr>
         <p:spPr>
           <a:xfrm>
-            <a:off x="5157345" y="2262835"/>
-            <a:ext cx="4169768" cy="819302"/>
+            <a:off x="5157345" y="2223819"/>
+            <a:ext cx="4169768" cy="760780"/>
           </a:xfrm>
           <a:prstGeom prst="rect">
             <a:avLst/>
@@ -45468,7 +45468,7 @@
         </p:nvSpPr>
         <p:spPr>
           <a:xfrm>
-            <a:off x="5303652" y="2360371"/>
+            <a:off x="5303652" y="2311602"/>
             <a:ext cx="1463076" cy="243840"/>
           </a:xfrm>
           <a:prstGeom prst="rect">
@@ -45510,7 +45510,7 @@
         </p:nvSpPr>
         <p:spPr>
           <a:xfrm>
-            <a:off x="6656997" y="2350617"/>
+            <a:off x="6656997" y="2301848"/>
             <a:ext cx="2487230" cy="292608"/>
           </a:xfrm>
           <a:prstGeom prst="rect">
@@ -45552,8 +45552,8 @@
         </p:nvSpPr>
         <p:spPr>
           <a:xfrm>
-            <a:off x="5303652" y="2652979"/>
-            <a:ext cx="3877152" cy="409651"/>
+            <a:off x="5303652" y="2574949"/>
+            <a:ext cx="3877152" cy="390144"/>
           </a:xfrm>
           <a:prstGeom prst="rect">
             <a:avLst/>
@@ -45568,14 +45568,14 @@
           <a:p>
             <a:pPr algn="l">
               <a:lnSpc>
-                <a:spcPct val="108000"/>
-              </a:lnSpc>
-              <a:spcAft>
-                <a:spcPts val="0"/>
-              </a:spcAft>
-            </a:pPr>
-            <a:r>
-              <a:rPr sz="800" b="0" i="0">
+                <a:spcPct val="105000"/>
+              </a:lnSpc>
+              <a:spcAft>
+                <a:spcPts val="0"/>
+              </a:spcAft>
+            </a:pPr>
+            <a:r>
+              <a:rPr sz="760" b="0" i="0">
                 <a:solidFill>
                   <a:srgbClr val="0E1620"/>
                 </a:solidFill>
@@ -45594,8 +45594,8 @@
         </p:nvSpPr>
         <p:spPr>
           <a:xfrm>
-            <a:off x="5157345" y="3179673"/>
-            <a:ext cx="4169768" cy="819302"/>
+            <a:off x="5157345" y="3043122"/>
+            <a:ext cx="4169768" cy="760780"/>
           </a:xfrm>
           <a:prstGeom prst="rect">
             <a:avLst/>
@@ -45638,7 +45638,7 @@
         </p:nvSpPr>
         <p:spPr>
           <a:xfrm>
-            <a:off x="5303652" y="3277209"/>
+            <a:off x="5303652" y="3130904"/>
             <a:ext cx="1463076" cy="243840"/>
           </a:xfrm>
           <a:prstGeom prst="rect">
@@ -45680,7 +45680,7 @@
         </p:nvSpPr>
         <p:spPr>
           <a:xfrm>
-            <a:off x="6656997" y="3267456"/>
+            <a:off x="6656997" y="3121150"/>
             <a:ext cx="2487230" cy="292608"/>
           </a:xfrm>
           <a:prstGeom prst="rect">
@@ -45722,8 +45722,8 @@
         </p:nvSpPr>
         <p:spPr>
           <a:xfrm>
-            <a:off x="5303652" y="3569817"/>
-            <a:ext cx="3877152" cy="409651"/>
+            <a:off x="5303652" y="3394251"/>
+            <a:ext cx="3877152" cy="390144"/>
           </a:xfrm>
           <a:prstGeom prst="rect">
             <a:avLst/>
@@ -45738,14 +45738,14 @@
           <a:p>
             <a:pPr algn="l">
               <a:lnSpc>
-                <a:spcPct val="108000"/>
-              </a:lnSpc>
-              <a:spcAft>
-                <a:spcPts val="0"/>
-              </a:spcAft>
-            </a:pPr>
-            <a:r>
-              <a:rPr sz="800" b="0" i="0">
+                <a:spcPct val="105000"/>
+              </a:lnSpc>
+              <a:spcAft>
+                <a:spcPts val="0"/>
+              </a:spcAft>
+            </a:pPr>
+            <a:r>
+              <a:rPr sz="760" b="0" i="0">
                 <a:solidFill>
                   <a:srgbClr val="0E1620"/>
                 </a:solidFill>
@@ -45764,8 +45764,8 @@
         </p:nvSpPr>
         <p:spPr>
           <a:xfrm>
-            <a:off x="5157345" y="4096512"/>
-            <a:ext cx="4169768" cy="819302"/>
+            <a:off x="5157345" y="3862424"/>
+            <a:ext cx="4169768" cy="760780"/>
           </a:xfrm>
           <a:prstGeom prst="rect">
             <a:avLst/>
@@ -45808,7 +45808,7 @@
         </p:nvSpPr>
         <p:spPr>
           <a:xfrm>
-            <a:off x="5303652" y="4194048"/>
+            <a:off x="5303652" y="3950206"/>
             <a:ext cx="1463076" cy="243840"/>
           </a:xfrm>
           <a:prstGeom prst="rect">
@@ -45850,7 +45850,7 @@
         </p:nvSpPr>
         <p:spPr>
           <a:xfrm>
-            <a:off x="6656997" y="4184294"/>
+            <a:off x="6656997" y="3940453"/>
             <a:ext cx="2487230" cy="292608"/>
           </a:xfrm>
           <a:prstGeom prst="rect">
@@ -45892,8 +45892,8 @@
         </p:nvSpPr>
         <p:spPr>
           <a:xfrm>
-            <a:off x="5303652" y="4486656"/>
-            <a:ext cx="3877152" cy="409651"/>
+            <a:off x="5303652" y="4213554"/>
+            <a:ext cx="3877152" cy="390144"/>
           </a:xfrm>
           <a:prstGeom prst="rect">
             <a:avLst/>
@@ -45908,14 +45908,14 @@
           <a:p>
             <a:pPr algn="l">
               <a:lnSpc>
-                <a:spcPct val="108000"/>
-              </a:lnSpc>
-              <a:spcAft>
-                <a:spcPts val="0"/>
-              </a:spcAft>
-            </a:pPr>
-            <a:r>
-              <a:rPr sz="800" b="0" i="0">
+                <a:spcPct val="105000"/>
+              </a:lnSpc>
+              <a:spcAft>
+                <a:spcPts val="0"/>
+              </a:spcAft>
+            </a:pPr>
+            <a:r>
+              <a:rPr sz="760" b="0" i="0">
                 <a:solidFill>
                   <a:srgbClr val="0E1620"/>
                 </a:solidFill>
@@ -45934,8 +45934,8 @@
         </p:nvSpPr>
         <p:spPr>
           <a:xfrm>
-            <a:off x="5157345" y="5013350"/>
-            <a:ext cx="4169768" cy="819302"/>
+            <a:off x="5157345" y="4681726"/>
+            <a:ext cx="4169768" cy="760780"/>
           </a:xfrm>
           <a:prstGeom prst="rect">
             <a:avLst/>
@@ -45978,7 +45978,7 @@
         </p:nvSpPr>
         <p:spPr>
           <a:xfrm>
-            <a:off x="5303652" y="5110886"/>
+            <a:off x="5303652" y="4769509"/>
             <a:ext cx="1463076" cy="243840"/>
           </a:xfrm>
           <a:prstGeom prst="rect">
@@ -46020,7 +46020,7 @@
         </p:nvSpPr>
         <p:spPr>
           <a:xfrm>
-            <a:off x="6656997" y="5101132"/>
+            <a:off x="6656997" y="4759755"/>
             <a:ext cx="2487230" cy="292608"/>
           </a:xfrm>
           <a:prstGeom prst="rect">
@@ -46062,8 +46062,8 @@
         </p:nvSpPr>
         <p:spPr>
           <a:xfrm>
-            <a:off x="5303652" y="5403494"/>
-            <a:ext cx="3877152" cy="409651"/>
+            <a:off x="5303652" y="5032856"/>
+            <a:ext cx="3877152" cy="390144"/>
           </a:xfrm>
           <a:prstGeom prst="rect">
             <a:avLst/>
@@ -46078,14 +46078,14 @@
           <a:p>
             <a:pPr algn="l">
               <a:lnSpc>
-                <a:spcPct val="108000"/>
-              </a:lnSpc>
-              <a:spcAft>
-                <a:spcPts val="0"/>
-              </a:spcAft>
-            </a:pPr>
-            <a:r>
-              <a:rPr sz="800" b="0" i="0">
+                <a:spcPct val="105000"/>
+              </a:lnSpc>
+              <a:spcAft>
+                <a:spcPts val="0"/>
+              </a:spcAft>
+            </a:pPr>
+            <a:r>
+              <a:rPr sz="760" b="0" i="0">
                 <a:solidFill>
                   <a:srgbClr val="0E1620"/>
                 </a:solidFill>
@@ -46104,8 +46104,8 @@
         </p:nvSpPr>
         <p:spPr>
           <a:xfrm>
-            <a:off x="5157345" y="5930188"/>
-            <a:ext cx="4169768" cy="819302"/>
+            <a:off x="5157345" y="5501029"/>
+            <a:ext cx="4169768" cy="760780"/>
           </a:xfrm>
           <a:prstGeom prst="rect">
             <a:avLst/>
@@ -46148,7 +46148,7 @@
         </p:nvSpPr>
         <p:spPr>
           <a:xfrm>
-            <a:off x="5303652" y="6027724"/>
+            <a:off x="5303652" y="5588811"/>
             <a:ext cx="1463076" cy="243840"/>
           </a:xfrm>
           <a:prstGeom prst="rect">
@@ -46190,7 +46190,7 @@
         </p:nvSpPr>
         <p:spPr>
           <a:xfrm>
-            <a:off x="6656997" y="6017971"/>
+            <a:off x="6656997" y="5579058"/>
             <a:ext cx="2487230" cy="292608"/>
           </a:xfrm>
           <a:prstGeom prst="rect">
@@ -46232,8 +46232,8 @@
         </p:nvSpPr>
         <p:spPr>
           <a:xfrm>
-            <a:off x="5303652" y="6320332"/>
-            <a:ext cx="3877152" cy="409651"/>
+            <a:off x="5303652" y="5852158"/>
+            <a:ext cx="3877152" cy="390144"/>
           </a:xfrm>
           <a:prstGeom prst="rect">
             <a:avLst/>
@@ -46248,14 +46248,14 @@
           <a:p>
             <a:pPr algn="l">
               <a:lnSpc>
-                <a:spcPct val="108000"/>
-              </a:lnSpc>
-              <a:spcAft>
-                <a:spcPts val="0"/>
-              </a:spcAft>
-            </a:pPr>
-            <a:r>
-              <a:rPr sz="800" b="0" i="0">
+                <a:spcPct val="105000"/>
+              </a:lnSpc>
+              <a:spcAft>
+                <a:spcPts val="0"/>
+              </a:spcAft>
+            </a:pPr>
+            <a:r>
+              <a:rPr sz="760" b="0" i="0">
                 <a:solidFill>
                   <a:srgbClr val="0E1620"/>
                 </a:solidFill>

</xml_diff>

<commit_message>
Proof slide: replace Haldex deal with clear data-driven downside-protection points; remove 'ex Athanase Tech' robustness caveat from 2.16
</commit_message>
<xml_diff>
--- a/Athanase_Engaged_Ownership_Allocator_Deck.pptx
+++ b/Athanase_Engaged_Ownership_Allocator_Deck.pptx
@@ -19016,7 +19016,7 @@
                 </a:solidFill>
                 <a:latin typeface="Times New Roman"/>
               </a:rPr>
-              <a:t>Haldex AB</a:t>
+              <a:t>What downside protection means</a:t>
             </a:r>
           </a:p>
           <a:p>
@@ -19035,7 +19035,7 @@
                 </a:solidFill>
                 <a:latin typeface="Arial"/>
               </a:rPr>
-              <a:t>81% IRR · 3.9x money multiple. Spun off Concentric, refocused the core, re-invested in 2020 for a further 2.0x in under two years.</a:t>
+              <a:t>In the market’s down months Athanase fell ~1.5% on average versus the market’s ~3.8% — losing less than half as much when it matters.</a:t>
             </a:r>
           </a:p>
           <a:p>
@@ -19054,7 +19054,7 @@
                 </a:solidFill>
                 <a:latin typeface="Times New Roman"/>
               </a:rPr>
-              <a:t>Compounding</a:t>
+              <a:t>Positive when the market wasn’t</a:t>
             </a:r>
           </a:p>
           <a:p>
@@ -19073,7 +19073,7 @@
                 </a:solidFill>
                 <a:latin typeface="Arial"/>
               </a:rPr>
-              <a:t>~18x gross vs ~14x for MSCI IMI since 2006, with EBITA growth of +14.5% across portfolio companies.</a:t>
+              <a:t>Across the six worst years for global equities, Athanase outperformed in five — and stayed positive in two: +9% in 2015 and +0.3% in 2022, while the market fell −6% and −20%.</a:t>
             </a:r>
           </a:p>
           <a:p>
@@ -19092,7 +19092,7 @@
                 </a:solidFill>
                 <a:latin typeface="Times New Roman"/>
               </a:rPr>
-              <a:t>Hit rate</a:t>
+              <a:t>Why it compounds</a:t>
             </a:r>
           </a:p>
           <a:p>
@@ -19111,7 +19111,7 @@
                 </a:solidFill>
                 <a:latin typeface="Arial"/>
               </a:rPr>
-              <a:t>39 larger investments since 2006 — profitable in 36, lost money in only 3.</a:t>
+              <a:t>Losing less in drawdowns leaves more capital working in the recovery — the engine behind ~18x growth vs ~14x for MSCI IMI since 2006.</a:t>
             </a:r>
           </a:p>
         </p:txBody>
@@ -35298,7 +35298,7 @@
                 <a:spcPct val="113000"/>
               </a:lnSpc>
               <a:spcAft>
-                <a:spcPts val="900"/>
+                <a:spcPts val="1100"/>
               </a:spcAft>
             </a:pPr>
             <a:r>
@@ -35317,7 +35317,7 @@
                 <a:spcPct val="113000"/>
               </a:lnSpc>
               <a:spcAft>
-                <a:spcPts val="900"/>
+                <a:spcPts val="1100"/>
               </a:spcAft>
             </a:pPr>
             <a:r>
@@ -35336,7 +35336,7 @@
                 <a:spcPct val="113000"/>
               </a:lnSpc>
               <a:spcAft>
-                <a:spcPts val="900"/>
+                <a:spcPts val="1100"/>
               </a:spcAft>
             </a:pPr>
             <a:r>
@@ -35347,25 +35347,6 @@
                 <a:latin typeface="Arial"/>
               </a:rPr>
               <a:t>Two decade-definers, not one: Klarna 28× (2007) and Athanase Tech 5.4× (2021)</a:t>
-            </a:r>
-          </a:p>
-          <a:p>
-            <a:pPr algn="l">
-              <a:lnSpc>
-                <a:spcPct val="113000"/>
-              </a:lnSpc>
-              <a:spcAft>
-                <a:spcPts val="900"/>
-              </a:spcAft>
-            </a:pPr>
-            <a:r>
-              <a:rPr sz="1120" b="0" i="0">
-                <a:solidFill>
-                  <a:srgbClr val="0E1620"/>
-                </a:solidFill>
-                <a:latin typeface="Arial"/>
-              </a:rPr>
-              <a:t>Robust: even excluding Athanase Tech entirely, AIPFII still ~10% net annualised</a:t>
             </a:r>
           </a:p>
         </p:txBody>

</xml_diff>

<commit_message>
Team slide: add operations/finance/control team as independent investor-safety layer; segregation-of-duties strip with SEB/MUFG/KPMG oversight
</commit_message>
<xml_diff>
--- a/Athanase_Engaged_Ownership_Allocator_Deck.pptx
+++ b/Athanase_Engaged_Ownership_Allocator_Deck.pptx
@@ -7657,7 +7657,7 @@
                 </a:solidFill>
                 <a:latin typeface="Arial"/>
               </a:rPr>
-              <a:t>One investment team, working together across four vehicles since 1992 — operators, allocators and board directors.</a:t>
+              <a:t>An integrated investment team — and an independent operations, finance and control function that safeguards investor capital.</a:t>
             </a:r>
           </a:p>
         </p:txBody>
@@ -7706,14 +7706,56 @@
       </p:sp>
       <p:sp>
         <p:nvSpPr>
-          <p:cNvPr id="9" name="Rectangle 8"/>
+          <p:cNvPr id="9" name="TextBox 8"/>
+          <p:cNvSpPr txBox="1"/>
+          <p:nvPr/>
+        </p:nvSpPr>
+        <p:spPr>
+          <a:xfrm>
+            <a:off x="438922" y="2126284"/>
+            <a:ext cx="5852306" cy="292608"/>
+          </a:xfrm>
+          <a:prstGeom prst="rect">
+            <a:avLst/>
+          </a:prstGeom>
+          <a:noFill/>
+        </p:spPr>
+        <p:txBody>
+          <a:bodyPr wrap="square" anchor="t" lIns="0" rIns="0" tIns="0" bIns="0">
+            <a:spAutoFit/>
+          </a:bodyPr>
+          <a:lstStyle/>
+          <a:p>
+            <a:pPr algn="l">
+              <a:lnSpc>
+                <a:spcPct val="110000"/>
+              </a:lnSpc>
+              <a:spcAft>
+                <a:spcPts val="0"/>
+              </a:spcAft>
+            </a:pPr>
+            <a:r>
+              <a:rPr sz="880" b="1" i="0">
+                <a:solidFill>
+                  <a:srgbClr val="314359"/>
+                </a:solidFill>
+                <a:latin typeface="Arial"/>
+              </a:rPr>
+              <a:t>INVESTMENT TEAM</a:t>
+            </a:r>
+          </a:p>
+        </p:txBody>
+      </p:sp>
+      <p:sp>
+        <p:nvSpPr>
+          <p:cNvPr id="10" name="Rectangle 9"/>
           <p:cNvSpPr/>
           <p:nvPr/>
         </p:nvSpPr>
         <p:spPr>
           <a:xfrm>
-            <a:off x="438922" y="2292096"/>
-            <a:ext cx="2904207" cy="1872691"/>
+            <a:off x="438922" y="2438400"/>
+            <a:ext cx="1704484" cy="1463040"/>
           </a:xfrm>
           <a:prstGeom prst="rect">
             <a:avLst/>
@@ -7750,14 +7792,14 @@
       </p:sp>
       <p:sp>
         <p:nvSpPr>
-          <p:cNvPr id="10" name="Rectangle 9"/>
+          <p:cNvPr id="11" name="Rectangle 10"/>
           <p:cNvSpPr/>
           <p:nvPr/>
         </p:nvSpPr>
         <p:spPr>
           <a:xfrm>
-            <a:off x="438922" y="2292096"/>
-            <a:ext cx="51207" cy="1872691"/>
+            <a:off x="438922" y="2438400"/>
+            <a:ext cx="43892" cy="1463040"/>
           </a:xfrm>
           <a:prstGeom prst="rect">
             <a:avLst/>
@@ -7794,14 +7836,14 @@
       </p:sp>
       <p:sp>
         <p:nvSpPr>
-          <p:cNvPr id="11" name="TextBox 10"/>
-          <p:cNvSpPr txBox="1"/>
-          <p:nvPr/>
-        </p:nvSpPr>
-        <p:spPr>
-          <a:xfrm>
-            <a:off x="621807" y="2448153"/>
-            <a:ext cx="2611591" cy="292608"/>
+          <p:cNvPr id="12" name="TextBox 11"/>
+          <p:cNvSpPr txBox="1"/>
+          <p:nvPr/>
+        </p:nvSpPr>
+        <p:spPr>
+          <a:xfrm>
+            <a:off x="585230" y="2565196"/>
+            <a:ext cx="1470391" cy="292608"/>
           </a:xfrm>
           <a:prstGeom prst="rect">
             <a:avLst/>
@@ -7823,7 +7865,7 @@
               </a:spcAft>
             </a:pPr>
             <a:r>
-              <a:rPr sz="1120" b="1" i="0">
+              <a:rPr sz="1000" b="1" i="0">
                 <a:solidFill>
                   <a:srgbClr val="314359"/>
                 </a:solidFill>
@@ -7836,14 +7878,14 @@
       </p:sp>
       <p:sp>
         <p:nvSpPr>
-          <p:cNvPr id="12" name="TextBox 11"/>
-          <p:cNvSpPr txBox="1"/>
-          <p:nvPr/>
-        </p:nvSpPr>
-        <p:spPr>
-          <a:xfrm>
-            <a:off x="621807" y="2740761"/>
-            <a:ext cx="2611591" cy="243840"/>
+          <p:cNvPr id="13" name="TextBox 12"/>
+          <p:cNvSpPr txBox="1"/>
+          <p:nvPr/>
+        </p:nvSpPr>
+        <p:spPr>
+          <a:xfrm>
+            <a:off x="585230" y="2848051"/>
+            <a:ext cx="1470391" cy="234086"/>
           </a:xfrm>
           <a:prstGeom prst="rect">
             <a:avLst/>
@@ -7865,7 +7907,7 @@
               </a:spcAft>
             </a:pPr>
             <a:r>
-              <a:rPr sz="760" b="1" i="0">
+              <a:rPr sz="680" b="1" i="0">
                 <a:solidFill>
                   <a:srgbClr val="314359"/>
                 </a:solidFill>
@@ -7878,14 +7920,14 @@
       </p:sp>
       <p:sp>
         <p:nvSpPr>
-          <p:cNvPr id="13" name="TextBox 12"/>
-          <p:cNvSpPr txBox="1"/>
-          <p:nvPr/>
-        </p:nvSpPr>
-        <p:spPr>
-          <a:xfrm>
-            <a:off x="621807" y="3023616"/>
-            <a:ext cx="2575014" cy="1072896"/>
+          <p:cNvPr id="14" name="TextBox 13"/>
+          <p:cNvSpPr txBox="1"/>
+          <p:nvPr/>
+        </p:nvSpPr>
+        <p:spPr>
+          <a:xfrm>
+            <a:off x="585230" y="3101644"/>
+            <a:ext cx="1455761" cy="682752"/>
           </a:xfrm>
           <a:prstGeom prst="rect">
             <a:avLst/>
@@ -7900,34 +7942,34 @@
           <a:p>
             <a:pPr algn="l">
               <a:lnSpc>
-                <a:spcPct val="113000"/>
-              </a:lnSpc>
-              <a:spcAft>
-                <a:spcPts val="0"/>
-              </a:spcAft>
-            </a:pPr>
-            <a:r>
-              <a:rPr sz="800" b="0" i="0">
+                <a:spcPct val="110000"/>
+              </a:lnSpc>
+              <a:spcAft>
+                <a:spcPts val="0"/>
+              </a:spcAft>
+            </a:pPr>
+            <a:r>
+              <a:rPr sz="720" b="0" i="0">
                 <a:solidFill>
                   <a:srgbClr val="0E1620"/>
                 </a:solidFill>
                 <a:latin typeface="Arial"/>
               </a:rPr>
-              <a:t>Leads the same team since 2006. Former CEO/CIO of industrial conglomerate Brokk; earlier Lehman Brothers and Salomon Smith Barney.</a:t>
-            </a:r>
-          </a:p>
-        </p:txBody>
-      </p:sp>
-      <p:sp>
-        <p:nvSpPr>
-          <p:cNvPr id="14" name="Rectangle 13"/>
+              <a:t>Ex-CEO/CIO of Brokk; Lehman Brothers, Salomon Smith Barney.</a:t>
+            </a:r>
+          </a:p>
+        </p:txBody>
+      </p:sp>
+      <p:sp>
+        <p:nvSpPr>
+          <p:cNvPr id="15" name="Rectangle 14"/>
           <p:cNvSpPr/>
           <p:nvPr/>
         </p:nvSpPr>
         <p:spPr>
           <a:xfrm>
-            <a:off x="3416283" y="2292096"/>
-            <a:ext cx="2904207" cy="1872691"/>
+            <a:off x="2231191" y="2438400"/>
+            <a:ext cx="1704484" cy="1463040"/>
           </a:xfrm>
           <a:prstGeom prst="rect">
             <a:avLst/>
@@ -7964,14 +8006,14 @@
       </p:sp>
       <p:sp>
         <p:nvSpPr>
-          <p:cNvPr id="15" name="Rectangle 14"/>
+          <p:cNvPr id="16" name="Rectangle 15"/>
           <p:cNvSpPr/>
           <p:nvPr/>
         </p:nvSpPr>
         <p:spPr>
           <a:xfrm>
-            <a:off x="3416283" y="2292096"/>
-            <a:ext cx="51207" cy="1872691"/>
+            <a:off x="2231191" y="2438400"/>
+            <a:ext cx="43892" cy="1463040"/>
           </a:xfrm>
           <a:prstGeom prst="rect">
             <a:avLst/>
@@ -8008,14 +8050,14 @@
       </p:sp>
       <p:sp>
         <p:nvSpPr>
-          <p:cNvPr id="16" name="TextBox 15"/>
-          <p:cNvSpPr txBox="1"/>
-          <p:nvPr/>
-        </p:nvSpPr>
-        <p:spPr>
-          <a:xfrm>
-            <a:off x="3599168" y="2448153"/>
-            <a:ext cx="2611591" cy="292608"/>
+          <p:cNvPr id="17" name="TextBox 16"/>
+          <p:cNvSpPr txBox="1"/>
+          <p:nvPr/>
+        </p:nvSpPr>
+        <p:spPr>
+          <a:xfrm>
+            <a:off x="2377499" y="2565196"/>
+            <a:ext cx="1470391" cy="292608"/>
           </a:xfrm>
           <a:prstGeom prst="rect">
             <a:avLst/>
@@ -8037,7 +8079,7 @@
               </a:spcAft>
             </a:pPr>
             <a:r>
-              <a:rPr sz="1120" b="1" i="0">
+              <a:rPr sz="1000" b="1" i="0">
                 <a:solidFill>
                   <a:srgbClr val="314359"/>
                 </a:solidFill>
@@ -8050,14 +8092,14 @@
       </p:sp>
       <p:sp>
         <p:nvSpPr>
-          <p:cNvPr id="17" name="TextBox 16"/>
-          <p:cNvSpPr txBox="1"/>
-          <p:nvPr/>
-        </p:nvSpPr>
-        <p:spPr>
-          <a:xfrm>
-            <a:off x="3599168" y="2740761"/>
-            <a:ext cx="2611591" cy="243840"/>
+          <p:cNvPr id="18" name="TextBox 17"/>
+          <p:cNvSpPr txBox="1"/>
+          <p:nvPr/>
+        </p:nvSpPr>
+        <p:spPr>
+          <a:xfrm>
+            <a:off x="2377499" y="2848051"/>
+            <a:ext cx="1470391" cy="234086"/>
           </a:xfrm>
           <a:prstGeom prst="rect">
             <a:avLst/>
@@ -8079,7 +8121,7 @@
               </a:spcAft>
             </a:pPr>
             <a:r>
-              <a:rPr sz="760" b="1" i="0">
+              <a:rPr sz="680" b="1" i="0">
                 <a:solidFill>
                   <a:srgbClr val="314359"/>
                 </a:solidFill>
@@ -8092,14 +8134,14 @@
       </p:sp>
       <p:sp>
         <p:nvSpPr>
-          <p:cNvPr id="18" name="TextBox 17"/>
-          <p:cNvSpPr txBox="1"/>
-          <p:nvPr/>
-        </p:nvSpPr>
-        <p:spPr>
-          <a:xfrm>
-            <a:off x="3599168" y="3023616"/>
-            <a:ext cx="2575014" cy="1072896"/>
+          <p:cNvPr id="19" name="TextBox 18"/>
+          <p:cNvSpPr txBox="1"/>
+          <p:nvPr/>
+        </p:nvSpPr>
+        <p:spPr>
+          <a:xfrm>
+            <a:off x="2377499" y="3101644"/>
+            <a:ext cx="1455761" cy="682752"/>
           </a:xfrm>
           <a:prstGeom prst="rect">
             <a:avLst/>
@@ -8114,34 +8156,34 @@
           <a:p>
             <a:pPr algn="l">
               <a:lnSpc>
-                <a:spcPct val="113000"/>
-              </a:lnSpc>
-              <a:spcAft>
-                <a:spcPts val="0"/>
-              </a:spcAft>
-            </a:pPr>
-            <a:r>
-              <a:rPr sz="800" b="0" i="0">
+                <a:spcPct val="110000"/>
+              </a:lnSpc>
+              <a:spcAft>
+                <a:spcPts val="0"/>
+              </a:spcAft>
+            </a:pPr>
+            <a:r>
+              <a:rPr sz="720" b="0" i="0">
                 <a:solidFill>
                   <a:srgbClr val="0E1620"/>
                 </a:solidFill>
                 <a:latin typeface="Arial"/>
               </a:rPr>
-              <a:t>Co-founder &amp; CEO of Tradimus; Senior VP at Electrolux; owner-operator of a group of private tech companies — deep industrial operating experience.</a:t>
-            </a:r>
-          </a:p>
-        </p:txBody>
-      </p:sp>
-      <p:sp>
-        <p:nvSpPr>
-          <p:cNvPr id="19" name="Rectangle 18"/>
+              <a:t>Ex-CEO of Tradimus; Senior VP, Electrolux; tech owner-operator.</a:t>
+            </a:r>
+          </a:p>
+        </p:txBody>
+      </p:sp>
+      <p:sp>
+        <p:nvSpPr>
+          <p:cNvPr id="20" name="Rectangle 19"/>
           <p:cNvSpPr/>
           <p:nvPr/>
         </p:nvSpPr>
         <p:spPr>
           <a:xfrm>
-            <a:off x="6393644" y="2292096"/>
-            <a:ext cx="2904207" cy="1872691"/>
+            <a:off x="4023460" y="2438400"/>
+            <a:ext cx="1704484" cy="1463040"/>
           </a:xfrm>
           <a:prstGeom prst="rect">
             <a:avLst/>
@@ -8178,14 +8220,14 @@
       </p:sp>
       <p:sp>
         <p:nvSpPr>
-          <p:cNvPr id="20" name="Rectangle 19"/>
+          <p:cNvPr id="21" name="Rectangle 20"/>
           <p:cNvSpPr/>
           <p:nvPr/>
         </p:nvSpPr>
         <p:spPr>
           <a:xfrm>
-            <a:off x="6393644" y="2292096"/>
-            <a:ext cx="51207" cy="1872691"/>
+            <a:off x="4023460" y="2438400"/>
+            <a:ext cx="43892" cy="1463040"/>
           </a:xfrm>
           <a:prstGeom prst="rect">
             <a:avLst/>
@@ -8222,14 +8264,14 @@
       </p:sp>
       <p:sp>
         <p:nvSpPr>
-          <p:cNvPr id="21" name="TextBox 20"/>
-          <p:cNvSpPr txBox="1"/>
-          <p:nvPr/>
-        </p:nvSpPr>
-        <p:spPr>
-          <a:xfrm>
-            <a:off x="6576529" y="2448153"/>
-            <a:ext cx="2611591" cy="292608"/>
+          <p:cNvPr id="22" name="TextBox 21"/>
+          <p:cNvSpPr txBox="1"/>
+          <p:nvPr/>
+        </p:nvSpPr>
+        <p:spPr>
+          <a:xfrm>
+            <a:off x="4169768" y="2565196"/>
+            <a:ext cx="1470391" cy="292608"/>
           </a:xfrm>
           <a:prstGeom prst="rect">
             <a:avLst/>
@@ -8251,7 +8293,7 @@
               </a:spcAft>
             </a:pPr>
             <a:r>
-              <a:rPr sz="1120" b="1" i="0">
+              <a:rPr sz="1000" b="1" i="0">
                 <a:solidFill>
                   <a:srgbClr val="314359"/>
                 </a:solidFill>
@@ -8264,14 +8306,14 @@
       </p:sp>
       <p:sp>
         <p:nvSpPr>
-          <p:cNvPr id="22" name="TextBox 21"/>
-          <p:cNvSpPr txBox="1"/>
-          <p:nvPr/>
-        </p:nvSpPr>
-        <p:spPr>
-          <a:xfrm>
-            <a:off x="6576529" y="2740761"/>
-            <a:ext cx="2611591" cy="243840"/>
+          <p:cNvPr id="23" name="TextBox 22"/>
+          <p:cNvSpPr txBox="1"/>
+          <p:nvPr/>
+        </p:nvSpPr>
+        <p:spPr>
+          <a:xfrm>
+            <a:off x="4169768" y="2848051"/>
+            <a:ext cx="1470391" cy="234086"/>
           </a:xfrm>
           <a:prstGeom prst="rect">
             <a:avLst/>
@@ -8293,7 +8335,7 @@
               </a:spcAft>
             </a:pPr>
             <a:r>
-              <a:rPr sz="760" b="1" i="0">
+              <a:rPr sz="680" b="1" i="0">
                 <a:solidFill>
                   <a:srgbClr val="314359"/>
                 </a:solidFill>
@@ -8306,14 +8348,14 @@
       </p:sp>
       <p:sp>
         <p:nvSpPr>
-          <p:cNvPr id="23" name="TextBox 22"/>
-          <p:cNvSpPr txBox="1"/>
-          <p:nvPr/>
-        </p:nvSpPr>
-        <p:spPr>
-          <a:xfrm>
-            <a:off x="6576529" y="3023616"/>
-            <a:ext cx="2575014" cy="1072896"/>
+          <p:cNvPr id="24" name="TextBox 23"/>
+          <p:cNvSpPr txBox="1"/>
+          <p:nvPr/>
+        </p:nvSpPr>
+        <p:spPr>
+          <a:xfrm>
+            <a:off x="4169768" y="3101644"/>
+            <a:ext cx="1455761" cy="682752"/>
           </a:xfrm>
           <a:prstGeom prst="rect">
             <a:avLst/>
@@ -8328,34 +8370,34 @@
           <a:p>
             <a:pPr algn="l">
               <a:lnSpc>
-                <a:spcPct val="113000"/>
-              </a:lnSpc>
-              <a:spcAft>
-                <a:spcPts val="0"/>
-              </a:spcAft>
-            </a:pPr>
-            <a:r>
-              <a:rPr sz="800" b="0" i="0">
+                <a:spcPct val="110000"/>
+              </a:lnSpc>
+              <a:spcAft>
+                <a:spcPts val="0"/>
+              </a:spcAft>
+            </a:pPr>
+            <a:r>
+              <a:rPr sz="720" b="0" i="0">
                 <a:solidFill>
                   <a:srgbClr val="0E1620"/>
                 </a:solidFill>
                 <a:latin typeface="Arial"/>
               </a:rPr>
-              <a:t>Responsible PM at Adrigo, Catella, Pan Capital and Nordea; equity research at Brummer &amp; Partners and Cazenove.</a:t>
-            </a:r>
-          </a:p>
-        </p:txBody>
-      </p:sp>
-      <p:sp>
-        <p:nvSpPr>
-          <p:cNvPr id="24" name="Rectangle 23"/>
+              <a:t>Ex-PM at Adrigo, Catella, Pan Capital and Nordea.</a:t>
+            </a:r>
+          </a:p>
+        </p:txBody>
+      </p:sp>
+      <p:sp>
+        <p:nvSpPr>
+          <p:cNvPr id="25" name="Rectangle 24"/>
           <p:cNvSpPr/>
           <p:nvPr/>
         </p:nvSpPr>
         <p:spPr>
           <a:xfrm>
-            <a:off x="438922" y="4320844"/>
-            <a:ext cx="2904207" cy="1872691"/>
+            <a:off x="5815729" y="2438400"/>
+            <a:ext cx="1704484" cy="1463040"/>
           </a:xfrm>
           <a:prstGeom prst="rect">
             <a:avLst/>
@@ -8392,14 +8434,14 @@
       </p:sp>
       <p:sp>
         <p:nvSpPr>
-          <p:cNvPr id="25" name="Rectangle 24"/>
+          <p:cNvPr id="26" name="Rectangle 25"/>
           <p:cNvSpPr/>
           <p:nvPr/>
         </p:nvSpPr>
         <p:spPr>
           <a:xfrm>
-            <a:off x="438922" y="4320844"/>
-            <a:ext cx="51207" cy="1872691"/>
+            <a:off x="5815729" y="2438400"/>
+            <a:ext cx="43892" cy="1463040"/>
           </a:xfrm>
           <a:prstGeom prst="rect">
             <a:avLst/>
@@ -8436,14 +8478,14 @@
       </p:sp>
       <p:sp>
         <p:nvSpPr>
-          <p:cNvPr id="26" name="TextBox 25"/>
-          <p:cNvSpPr txBox="1"/>
-          <p:nvPr/>
-        </p:nvSpPr>
-        <p:spPr>
-          <a:xfrm>
-            <a:off x="621807" y="4476902"/>
-            <a:ext cx="2611591" cy="292608"/>
+          <p:cNvPr id="27" name="TextBox 26"/>
+          <p:cNvSpPr txBox="1"/>
+          <p:nvPr/>
+        </p:nvSpPr>
+        <p:spPr>
+          <a:xfrm>
+            <a:off x="5962037" y="2565196"/>
+            <a:ext cx="1470391" cy="292608"/>
           </a:xfrm>
           <a:prstGeom prst="rect">
             <a:avLst/>
@@ -8465,7 +8507,7 @@
               </a:spcAft>
             </a:pPr>
             <a:r>
-              <a:rPr sz="1120" b="1" i="0">
+              <a:rPr sz="1000" b="1" i="0">
                 <a:solidFill>
                   <a:srgbClr val="314359"/>
                 </a:solidFill>
@@ -8478,14 +8520,14 @@
       </p:sp>
       <p:sp>
         <p:nvSpPr>
-          <p:cNvPr id="27" name="TextBox 26"/>
-          <p:cNvSpPr txBox="1"/>
-          <p:nvPr/>
-        </p:nvSpPr>
-        <p:spPr>
-          <a:xfrm>
-            <a:off x="621807" y="4769510"/>
-            <a:ext cx="2611591" cy="243840"/>
+          <p:cNvPr id="28" name="TextBox 27"/>
+          <p:cNvSpPr txBox="1"/>
+          <p:nvPr/>
+        </p:nvSpPr>
+        <p:spPr>
+          <a:xfrm>
+            <a:off x="5962037" y="2848051"/>
+            <a:ext cx="1470391" cy="234086"/>
           </a:xfrm>
           <a:prstGeom prst="rect">
             <a:avLst/>
@@ -8507,7 +8549,7 @@
               </a:spcAft>
             </a:pPr>
             <a:r>
-              <a:rPr sz="760" b="1" i="0">
+              <a:rPr sz="680" b="1" i="0">
                 <a:solidFill>
                   <a:srgbClr val="314359"/>
                 </a:solidFill>
@@ -8520,14 +8562,14 @@
       </p:sp>
       <p:sp>
         <p:nvSpPr>
-          <p:cNvPr id="28" name="TextBox 27"/>
-          <p:cNvSpPr txBox="1"/>
-          <p:nvPr/>
-        </p:nvSpPr>
-        <p:spPr>
-          <a:xfrm>
-            <a:off x="621807" y="5052364"/>
-            <a:ext cx="2575014" cy="1072896"/>
+          <p:cNvPr id="29" name="TextBox 28"/>
+          <p:cNvSpPr txBox="1"/>
+          <p:nvPr/>
+        </p:nvSpPr>
+        <p:spPr>
+          <a:xfrm>
+            <a:off x="5962037" y="3101644"/>
+            <a:ext cx="1455761" cy="682752"/>
           </a:xfrm>
           <a:prstGeom prst="rect">
             <a:avLst/>
@@ -8542,34 +8584,34 @@
           <a:p>
             <a:pPr algn="l">
               <a:lnSpc>
-                <a:spcPct val="113000"/>
-              </a:lnSpc>
-              <a:spcAft>
-                <a:spcPts val="0"/>
-              </a:spcAft>
-            </a:pPr>
-            <a:r>
-              <a:rPr sz="800" b="0" i="0">
+                <a:spcPct val="110000"/>
+              </a:lnSpc>
+              <a:spcAft>
+                <a:spcPts val="0"/>
+              </a:spcAft>
+            </a:pPr>
+            <a:r>
+              <a:rPr sz="720" b="0" i="0">
                 <a:solidFill>
                   <a:srgbClr val="0E1620"/>
                 </a:solidFill>
                 <a:latin typeface="Arial"/>
               </a:rPr>
-              <a:t>PM and Head of Research of the same team since 1996; former CEO &amp; CIO of HQ Fonder; multiple senior roles at Carnegie.</a:t>
-            </a:r>
-          </a:p>
-        </p:txBody>
-      </p:sp>
-      <p:sp>
-        <p:nvSpPr>
-          <p:cNvPr id="29" name="Rectangle 28"/>
+              <a:t>On the team since 1996; ex-CEO/CIO of HQ Fonder; Carnegie.</a:t>
+            </a:r>
+          </a:p>
+        </p:txBody>
+      </p:sp>
+      <p:sp>
+        <p:nvSpPr>
+          <p:cNvPr id="30" name="Rectangle 29"/>
           <p:cNvSpPr/>
           <p:nvPr/>
         </p:nvSpPr>
         <p:spPr>
           <a:xfrm>
-            <a:off x="3416283" y="4320844"/>
-            <a:ext cx="2904207" cy="1872691"/>
+            <a:off x="7607998" y="2438400"/>
+            <a:ext cx="1704484" cy="1463040"/>
           </a:xfrm>
           <a:prstGeom prst="rect">
             <a:avLst/>
@@ -8606,14 +8648,14 @@
       </p:sp>
       <p:sp>
         <p:nvSpPr>
-          <p:cNvPr id="30" name="Rectangle 29"/>
+          <p:cNvPr id="31" name="Rectangle 30"/>
           <p:cNvSpPr/>
           <p:nvPr/>
         </p:nvSpPr>
         <p:spPr>
           <a:xfrm>
-            <a:off x="3416283" y="4320844"/>
-            <a:ext cx="51207" cy="1872691"/>
+            <a:off x="7607998" y="2438400"/>
+            <a:ext cx="43892" cy="1463040"/>
           </a:xfrm>
           <a:prstGeom prst="rect">
             <a:avLst/>
@@ -8650,14 +8692,14 @@
       </p:sp>
       <p:sp>
         <p:nvSpPr>
-          <p:cNvPr id="31" name="TextBox 30"/>
-          <p:cNvSpPr txBox="1"/>
-          <p:nvPr/>
-        </p:nvSpPr>
-        <p:spPr>
-          <a:xfrm>
-            <a:off x="3599168" y="4476902"/>
-            <a:ext cx="2611591" cy="292608"/>
+          <p:cNvPr id="32" name="TextBox 31"/>
+          <p:cNvSpPr txBox="1"/>
+          <p:nvPr/>
+        </p:nvSpPr>
+        <p:spPr>
+          <a:xfrm>
+            <a:off x="7754305" y="2565196"/>
+            <a:ext cx="1470391" cy="292608"/>
           </a:xfrm>
           <a:prstGeom prst="rect">
             <a:avLst/>
@@ -8679,7 +8721,7 @@
               </a:spcAft>
             </a:pPr>
             <a:r>
-              <a:rPr sz="1120" b="1" i="0">
+              <a:rPr sz="1000" b="1" i="0">
                 <a:solidFill>
                   <a:srgbClr val="314359"/>
                 </a:solidFill>
@@ -8692,14 +8734,14 @@
       </p:sp>
       <p:sp>
         <p:nvSpPr>
-          <p:cNvPr id="32" name="TextBox 31"/>
-          <p:cNvSpPr txBox="1"/>
-          <p:nvPr/>
-        </p:nvSpPr>
-        <p:spPr>
-          <a:xfrm>
-            <a:off x="3599168" y="4769510"/>
-            <a:ext cx="2611591" cy="243840"/>
+          <p:cNvPr id="33" name="TextBox 32"/>
+          <p:cNvSpPr txBox="1"/>
+          <p:nvPr/>
+        </p:nvSpPr>
+        <p:spPr>
+          <a:xfrm>
+            <a:off x="7754305" y="2848051"/>
+            <a:ext cx="1470391" cy="234086"/>
           </a:xfrm>
           <a:prstGeom prst="rect">
             <a:avLst/>
@@ -8721,7 +8763,7 @@
               </a:spcAft>
             </a:pPr>
             <a:r>
-              <a:rPr sz="760" b="1" i="0">
+              <a:rPr sz="680" b="1" i="0">
                 <a:solidFill>
                   <a:srgbClr val="314359"/>
                 </a:solidFill>
@@ -8734,14 +8776,14 @@
       </p:sp>
       <p:sp>
         <p:nvSpPr>
-          <p:cNvPr id="33" name="TextBox 32"/>
-          <p:cNvSpPr txBox="1"/>
-          <p:nvPr/>
-        </p:nvSpPr>
-        <p:spPr>
-          <a:xfrm>
-            <a:off x="3599168" y="5052364"/>
-            <a:ext cx="2575014" cy="1072896"/>
+          <p:cNvPr id="34" name="TextBox 33"/>
+          <p:cNvSpPr txBox="1"/>
+          <p:nvPr/>
+        </p:nvSpPr>
+        <p:spPr>
+          <a:xfrm>
+            <a:off x="7754305" y="3101644"/>
+            <a:ext cx="1455761" cy="682752"/>
           </a:xfrm>
           <a:prstGeom prst="rect">
             <a:avLst/>
@@ -8756,34 +8798,76 @@
           <a:p>
             <a:pPr algn="l">
               <a:lnSpc>
-                <a:spcPct val="113000"/>
-              </a:lnSpc>
-              <a:spcAft>
-                <a:spcPts val="0"/>
-              </a:spcAft>
-            </a:pPr>
-            <a:r>
-              <a:rPr sz="800" b="0" i="0">
+                <a:spcPct val="110000"/>
+              </a:lnSpc>
+              <a:spcAft>
+                <a:spcPts val="0"/>
+              </a:spcAft>
+            </a:pPr>
+            <a:r>
+              <a:rPr sz="720" b="0" i="0">
                 <a:solidFill>
                   <a:srgbClr val="0E1620"/>
                 </a:solidFill>
                 <a:latin typeface="Arial"/>
               </a:rPr>
-              <a:t>On the same investment team since 2006; former CFO of portfolio company Global Batterier — operator and financier.</a:t>
-            </a:r>
-          </a:p>
-        </p:txBody>
-      </p:sp>
-      <p:sp>
-        <p:nvSpPr>
-          <p:cNvPr id="34" name="Rectangle 33"/>
+              <a:t>On the team since 2006; ex-CFO of Global Batterier.</a:t>
+            </a:r>
+          </a:p>
+        </p:txBody>
+      </p:sp>
+      <p:sp>
+        <p:nvSpPr>
+          <p:cNvPr id="35" name="TextBox 34"/>
+          <p:cNvSpPr txBox="1"/>
+          <p:nvPr/>
+        </p:nvSpPr>
+        <p:spPr>
+          <a:xfrm>
+            <a:off x="438922" y="4096512"/>
+            <a:ext cx="6583844" cy="292608"/>
+          </a:xfrm>
+          <a:prstGeom prst="rect">
+            <a:avLst/>
+          </a:prstGeom>
+          <a:noFill/>
+        </p:spPr>
+        <p:txBody>
+          <a:bodyPr wrap="square" anchor="t" lIns="0" rIns="0" tIns="0" bIns="0">
+            <a:spAutoFit/>
+          </a:bodyPr>
+          <a:lstStyle/>
+          <a:p>
+            <a:pPr algn="l">
+              <a:lnSpc>
+                <a:spcPct val="110000"/>
+              </a:lnSpc>
+              <a:spcAft>
+                <a:spcPts val="0"/>
+              </a:spcAft>
+            </a:pPr>
+            <a:r>
+              <a:rPr sz="880" b="1" i="0">
+                <a:solidFill>
+                  <a:srgbClr val="314359"/>
+                </a:solidFill>
+                <a:latin typeface="Arial"/>
+              </a:rPr>
+              <a:t>OPERATIONS, FINANCE &amp; CONTROL — INDEPENDENT OF THE INVESTMENT TEAM</a:t>
+            </a:r>
+          </a:p>
+        </p:txBody>
+      </p:sp>
+      <p:sp>
+        <p:nvSpPr>
+          <p:cNvPr id="36" name="Rectangle 35"/>
           <p:cNvSpPr/>
           <p:nvPr/>
         </p:nvSpPr>
         <p:spPr>
           <a:xfrm>
-            <a:off x="6393644" y="4320844"/>
-            <a:ext cx="2904207" cy="1872691"/>
+            <a:off x="438922" y="4408626"/>
+            <a:ext cx="2165353" cy="1414272"/>
           </a:xfrm>
           <a:prstGeom prst="rect">
             <a:avLst/>
@@ -8820,14 +8904,14 @@
       </p:sp>
       <p:sp>
         <p:nvSpPr>
-          <p:cNvPr id="35" name="Rectangle 34"/>
+          <p:cNvPr id="37" name="Rectangle 36"/>
           <p:cNvSpPr/>
           <p:nvPr/>
         </p:nvSpPr>
         <p:spPr>
           <a:xfrm>
-            <a:off x="6393644" y="4320844"/>
-            <a:ext cx="51207" cy="1872691"/>
+            <a:off x="438922" y="4408626"/>
+            <a:ext cx="43892" cy="1414272"/>
           </a:xfrm>
           <a:prstGeom prst="rect">
             <a:avLst/>
@@ -8864,14 +8948,14 @@
       </p:sp>
       <p:sp>
         <p:nvSpPr>
-          <p:cNvPr id="36" name="TextBox 35"/>
-          <p:cNvSpPr txBox="1"/>
-          <p:nvPr/>
-        </p:nvSpPr>
-        <p:spPr>
-          <a:xfrm>
-            <a:off x="6576529" y="4476902"/>
-            <a:ext cx="2611591" cy="292608"/>
+          <p:cNvPr id="38" name="TextBox 37"/>
+          <p:cNvSpPr txBox="1"/>
+          <p:nvPr/>
+        </p:nvSpPr>
+        <p:spPr>
+          <a:xfrm>
+            <a:off x="585230" y="4535422"/>
+            <a:ext cx="1931261" cy="292608"/>
           </a:xfrm>
           <a:prstGeom prst="rect">
             <a:avLst/>
@@ -8893,7 +8977,7 @@
               </a:spcAft>
             </a:pPr>
             <a:r>
-              <a:rPr sz="1120" b="1" i="0">
+              <a:rPr sz="1000" b="1" i="0">
                 <a:solidFill>
                   <a:srgbClr val="314359"/>
                 </a:solidFill>
@@ -8906,14 +8990,14 @@
       </p:sp>
       <p:sp>
         <p:nvSpPr>
-          <p:cNvPr id="37" name="TextBox 36"/>
-          <p:cNvSpPr txBox="1"/>
-          <p:nvPr/>
-        </p:nvSpPr>
-        <p:spPr>
-          <a:xfrm>
-            <a:off x="6576529" y="4769510"/>
-            <a:ext cx="2611591" cy="243840"/>
+          <p:cNvPr id="39" name="TextBox 38"/>
+          <p:cNvSpPr txBox="1"/>
+          <p:nvPr/>
+        </p:nvSpPr>
+        <p:spPr>
+          <a:xfrm>
+            <a:off x="585230" y="4818277"/>
+            <a:ext cx="1931261" cy="234086"/>
           </a:xfrm>
           <a:prstGeom prst="rect">
             <a:avLst/>
@@ -8935,7 +9019,7 @@
               </a:spcAft>
             </a:pPr>
             <a:r>
-              <a:rPr sz="760" b="1" i="0">
+              <a:rPr sz="680" b="1" i="0">
                 <a:solidFill>
                   <a:srgbClr val="314359"/>
                 </a:solidFill>
@@ -8948,14 +9032,14 @@
       </p:sp>
       <p:sp>
         <p:nvSpPr>
-          <p:cNvPr id="38" name="TextBox 37"/>
-          <p:cNvSpPr txBox="1"/>
-          <p:nvPr/>
-        </p:nvSpPr>
-        <p:spPr>
-          <a:xfrm>
-            <a:off x="6576529" y="5052364"/>
-            <a:ext cx="2575014" cy="1072896"/>
+          <p:cNvPr id="40" name="TextBox 39"/>
+          <p:cNvSpPr txBox="1"/>
+          <p:nvPr/>
+        </p:nvSpPr>
+        <p:spPr>
+          <a:xfrm>
+            <a:off x="585230" y="5071870"/>
+            <a:ext cx="1916630" cy="682752"/>
           </a:xfrm>
           <a:prstGeom prst="rect">
             <a:avLst/>
@@ -8970,34 +9054,122 @@
           <a:p>
             <a:pPr algn="l">
               <a:lnSpc>
-                <a:spcPct val="113000"/>
-              </a:lnSpc>
-              <a:spcAft>
-                <a:spcPts val="0"/>
-              </a:spcAft>
-            </a:pPr>
-            <a:r>
-              <a:rPr sz="800" b="0" i="0">
+                <a:spcPct val="110000"/>
+              </a:lnSpc>
+              <a:spcAft>
+                <a:spcPts val="0"/>
+              </a:spcAft>
+            </a:pPr>
+            <a:r>
+              <a:rPr sz="720" b="0" i="0">
                 <a:solidFill>
                   <a:srgbClr val="0E1620"/>
                 </a:solidFill>
                 <a:latin typeface="Arial"/>
               </a:rPr>
-              <a:t>Previously COO/CFO at Captor Fund Management; risk manager at Carnegie Investment Bank and AB Industrivärden.</a:t>
-            </a:r>
-          </a:p>
-        </p:txBody>
-      </p:sp>
-      <p:sp>
-        <p:nvSpPr>
-          <p:cNvPr id="39" name="TextBox 38"/>
-          <p:cNvSpPr txBox="1"/>
-          <p:nvPr/>
-        </p:nvSpPr>
-        <p:spPr>
-          <a:xfrm>
-            <a:off x="438922" y="6339840"/>
-            <a:ext cx="8924767" cy="487680"/>
+              <a:t>Ex-COO/CFO of Captor Fund Mgmt; risk manager at Carnegie and AB Industrivärden.</a:t>
+            </a:r>
+          </a:p>
+        </p:txBody>
+      </p:sp>
+      <p:sp>
+        <p:nvSpPr>
+          <p:cNvPr id="41" name="Rectangle 40"/>
+          <p:cNvSpPr/>
+          <p:nvPr/>
+        </p:nvSpPr>
+        <p:spPr>
+          <a:xfrm>
+            <a:off x="2699376" y="4408626"/>
+            <a:ext cx="2165353" cy="1414272"/>
+          </a:xfrm>
+          <a:prstGeom prst="rect">
+            <a:avLst/>
+          </a:prstGeom>
+          <a:solidFill>
+            <a:srgbClr val="F6F7F9"/>
+          </a:solidFill>
+          <a:ln>
+            <a:noFill/>
+          </a:ln>
+          <a:effectLst/>
+        </p:spPr>
+        <p:style>
+          <a:lnRef idx="1">
+            <a:schemeClr val="accent1"/>
+          </a:lnRef>
+          <a:fillRef idx="3">
+            <a:schemeClr val="accent1"/>
+          </a:fillRef>
+          <a:effectRef idx="2">
+            <a:schemeClr val="accent1"/>
+          </a:effectRef>
+          <a:fontRef idx="minor">
+            <a:schemeClr val="lt1"/>
+          </a:fontRef>
+        </p:style>
+        <p:txBody>
+          <a:bodyPr rtlCol="0" anchor="ctr"/>
+          <a:lstStyle/>
+          <a:p>
+            <a:pPr algn="ctr"/>
+          </a:p>
+        </p:txBody>
+      </p:sp>
+      <p:sp>
+        <p:nvSpPr>
+          <p:cNvPr id="42" name="Rectangle 41"/>
+          <p:cNvSpPr/>
+          <p:nvPr/>
+        </p:nvSpPr>
+        <p:spPr>
+          <a:xfrm>
+            <a:off x="2699376" y="4408626"/>
+            <a:ext cx="43892" cy="1414272"/>
+          </a:xfrm>
+          <a:prstGeom prst="rect">
+            <a:avLst/>
+          </a:prstGeom>
+          <a:solidFill>
+            <a:srgbClr val="152130"/>
+          </a:solidFill>
+          <a:ln>
+            <a:noFill/>
+          </a:ln>
+          <a:effectLst/>
+        </p:spPr>
+        <p:style>
+          <a:lnRef idx="1">
+            <a:schemeClr val="accent1"/>
+          </a:lnRef>
+          <a:fillRef idx="3">
+            <a:schemeClr val="accent1"/>
+          </a:fillRef>
+          <a:effectRef idx="2">
+            <a:schemeClr val="accent1"/>
+          </a:effectRef>
+          <a:fontRef idx="minor">
+            <a:schemeClr val="lt1"/>
+          </a:fontRef>
+        </p:style>
+        <p:txBody>
+          <a:bodyPr rtlCol="0" anchor="ctr"/>
+          <a:lstStyle/>
+          <a:p>
+            <a:pPr algn="ctr"/>
+          </a:p>
+        </p:txBody>
+      </p:sp>
+      <p:sp>
+        <p:nvSpPr>
+          <p:cNvPr id="43" name="TextBox 42"/>
+          <p:cNvSpPr txBox="1"/>
+          <p:nvPr/>
+        </p:nvSpPr>
+        <p:spPr>
+          <a:xfrm>
+            <a:off x="2845683" y="4535422"/>
+            <a:ext cx="1931261" cy="292608"/>
           </a:xfrm>
           <a:prstGeom prst="rect">
             <a:avLst/>
@@ -9019,13 +9191,611 @@
               </a:spcAft>
             </a:pPr>
             <a:r>
-              <a:rPr sz="1000" b="0" i="1">
+              <a:rPr sz="1000" b="1" i="0">
                 <a:solidFill>
                   <a:srgbClr val="314359"/>
                 </a:solidFill>
-                <a:latin typeface="Arial"/>
-              </a:rPr>
-              <a:t>Supported by a dedicated fund-operations, risk and technology team — the same unit has compounded capital through every cycle since 1992.</a:t>
+                <a:latin typeface="Times New Roman"/>
+              </a:rPr>
+              <a:t>Grant Loon</a:t>
+            </a:r>
+          </a:p>
+        </p:txBody>
+      </p:sp>
+      <p:sp>
+        <p:nvSpPr>
+          <p:cNvPr id="44" name="TextBox 43"/>
+          <p:cNvSpPr txBox="1"/>
+          <p:nvPr/>
+        </p:nvSpPr>
+        <p:spPr>
+          <a:xfrm>
+            <a:off x="2845683" y="4818277"/>
+            <a:ext cx="1931261" cy="234086"/>
+          </a:xfrm>
+          <a:prstGeom prst="rect">
+            <a:avLst/>
+          </a:prstGeom>
+          <a:noFill/>
+        </p:spPr>
+        <p:txBody>
+          <a:bodyPr wrap="square" anchor="t" lIns="0" rIns="0" tIns="0" bIns="0">
+            <a:spAutoFit/>
+          </a:bodyPr>
+          <a:lstStyle/>
+          <a:p>
+            <a:pPr algn="l">
+              <a:lnSpc>
+                <a:spcPct val="110000"/>
+              </a:lnSpc>
+              <a:spcAft>
+                <a:spcPts val="0"/>
+              </a:spcAft>
+            </a:pPr>
+            <a:r>
+              <a:rPr sz="680" b="1" i="0">
+                <a:solidFill>
+                  <a:srgbClr val="314359"/>
+                </a:solidFill>
+                <a:latin typeface="Arial"/>
+              </a:rPr>
+              <a:t>HEAD OF FUND OPERATIONS</a:t>
+            </a:r>
+          </a:p>
+        </p:txBody>
+      </p:sp>
+      <p:sp>
+        <p:nvSpPr>
+          <p:cNvPr id="45" name="TextBox 44"/>
+          <p:cNvSpPr txBox="1"/>
+          <p:nvPr/>
+        </p:nvSpPr>
+        <p:spPr>
+          <a:xfrm>
+            <a:off x="2845683" y="5071870"/>
+            <a:ext cx="1916630" cy="682752"/>
+          </a:xfrm>
+          <a:prstGeom prst="rect">
+            <a:avLst/>
+          </a:prstGeom>
+          <a:noFill/>
+        </p:spPr>
+        <p:txBody>
+          <a:bodyPr wrap="square" anchor="t" lIns="0" rIns="0" tIns="0" bIns="0">
+            <a:spAutoFit/>
+          </a:bodyPr>
+          <a:lstStyle/>
+          <a:p>
+            <a:pPr algn="l">
+              <a:lnSpc>
+                <a:spcPct val="110000"/>
+              </a:lnSpc>
+              <a:spcAft>
+                <a:spcPts val="0"/>
+              </a:spcAft>
+            </a:pPr>
+            <a:r>
+              <a:rPr sz="720" b="0" i="0">
+                <a:solidFill>
+                  <a:srgbClr val="0E1620"/>
+                </a:solidFill>
+                <a:latin typeface="Arial"/>
+              </a:rPr>
+              <a:t>Ex-COO of Madrague Capital and Port Capital; Soros, Commerzbank, Morgan Stanley.</a:t>
+            </a:r>
+          </a:p>
+        </p:txBody>
+      </p:sp>
+      <p:sp>
+        <p:nvSpPr>
+          <p:cNvPr id="46" name="Rectangle 45"/>
+          <p:cNvSpPr/>
+          <p:nvPr/>
+        </p:nvSpPr>
+        <p:spPr>
+          <a:xfrm>
+            <a:off x="4959829" y="4408626"/>
+            <a:ext cx="2165353" cy="1414272"/>
+          </a:xfrm>
+          <a:prstGeom prst="rect">
+            <a:avLst/>
+          </a:prstGeom>
+          <a:solidFill>
+            <a:srgbClr val="F6F7F9"/>
+          </a:solidFill>
+          <a:ln>
+            <a:noFill/>
+          </a:ln>
+          <a:effectLst/>
+        </p:spPr>
+        <p:style>
+          <a:lnRef idx="1">
+            <a:schemeClr val="accent1"/>
+          </a:lnRef>
+          <a:fillRef idx="3">
+            <a:schemeClr val="accent1"/>
+          </a:fillRef>
+          <a:effectRef idx="2">
+            <a:schemeClr val="accent1"/>
+          </a:effectRef>
+          <a:fontRef idx="minor">
+            <a:schemeClr val="lt1"/>
+          </a:fontRef>
+        </p:style>
+        <p:txBody>
+          <a:bodyPr rtlCol="0" anchor="ctr"/>
+          <a:lstStyle/>
+          <a:p>
+            <a:pPr algn="ctr"/>
+          </a:p>
+        </p:txBody>
+      </p:sp>
+      <p:sp>
+        <p:nvSpPr>
+          <p:cNvPr id="47" name="Rectangle 46"/>
+          <p:cNvSpPr/>
+          <p:nvPr/>
+        </p:nvSpPr>
+        <p:spPr>
+          <a:xfrm>
+            <a:off x="4959829" y="4408626"/>
+            <a:ext cx="43892" cy="1414272"/>
+          </a:xfrm>
+          <a:prstGeom prst="rect">
+            <a:avLst/>
+          </a:prstGeom>
+          <a:solidFill>
+            <a:srgbClr val="152130"/>
+          </a:solidFill>
+          <a:ln>
+            <a:noFill/>
+          </a:ln>
+          <a:effectLst/>
+        </p:spPr>
+        <p:style>
+          <a:lnRef idx="1">
+            <a:schemeClr val="accent1"/>
+          </a:lnRef>
+          <a:fillRef idx="3">
+            <a:schemeClr val="accent1"/>
+          </a:fillRef>
+          <a:effectRef idx="2">
+            <a:schemeClr val="accent1"/>
+          </a:effectRef>
+          <a:fontRef idx="minor">
+            <a:schemeClr val="lt1"/>
+          </a:fontRef>
+        </p:style>
+        <p:txBody>
+          <a:bodyPr rtlCol="0" anchor="ctr"/>
+          <a:lstStyle/>
+          <a:p>
+            <a:pPr algn="ctr"/>
+          </a:p>
+        </p:txBody>
+      </p:sp>
+      <p:sp>
+        <p:nvSpPr>
+          <p:cNvPr id="48" name="TextBox 47"/>
+          <p:cNvSpPr txBox="1"/>
+          <p:nvPr/>
+        </p:nvSpPr>
+        <p:spPr>
+          <a:xfrm>
+            <a:off x="5106137" y="4535422"/>
+            <a:ext cx="1931261" cy="292608"/>
+          </a:xfrm>
+          <a:prstGeom prst="rect">
+            <a:avLst/>
+          </a:prstGeom>
+          <a:noFill/>
+        </p:spPr>
+        <p:txBody>
+          <a:bodyPr wrap="square" anchor="t" lIns="0" rIns="0" tIns="0" bIns="0">
+            <a:spAutoFit/>
+          </a:bodyPr>
+          <a:lstStyle/>
+          <a:p>
+            <a:pPr algn="l">
+              <a:lnSpc>
+                <a:spcPct val="110000"/>
+              </a:lnSpc>
+              <a:spcAft>
+                <a:spcPts val="0"/>
+              </a:spcAft>
+            </a:pPr>
+            <a:r>
+              <a:rPr sz="1000" b="1" i="0">
+                <a:solidFill>
+                  <a:srgbClr val="314359"/>
+                </a:solidFill>
+                <a:latin typeface="Times New Roman"/>
+              </a:rPr>
+              <a:t>Eva Andersson</a:t>
+            </a:r>
+          </a:p>
+        </p:txBody>
+      </p:sp>
+      <p:sp>
+        <p:nvSpPr>
+          <p:cNvPr id="49" name="TextBox 48"/>
+          <p:cNvSpPr txBox="1"/>
+          <p:nvPr/>
+        </p:nvSpPr>
+        <p:spPr>
+          <a:xfrm>
+            <a:off x="5106137" y="4818277"/>
+            <a:ext cx="1931261" cy="234086"/>
+          </a:xfrm>
+          <a:prstGeom prst="rect">
+            <a:avLst/>
+          </a:prstGeom>
+          <a:noFill/>
+        </p:spPr>
+        <p:txBody>
+          <a:bodyPr wrap="square" anchor="t" lIns="0" rIns="0" tIns="0" bIns="0">
+            <a:spAutoFit/>
+          </a:bodyPr>
+          <a:lstStyle/>
+          <a:p>
+            <a:pPr algn="l">
+              <a:lnSpc>
+                <a:spcPct val="110000"/>
+              </a:lnSpc>
+              <a:spcAft>
+                <a:spcPts val="0"/>
+              </a:spcAft>
+            </a:pPr>
+            <a:r>
+              <a:rPr sz="680" b="1" i="0">
+                <a:solidFill>
+                  <a:srgbClr val="314359"/>
+                </a:solidFill>
+                <a:latin typeface="Arial"/>
+              </a:rPr>
+              <a:t>FUND OPERATIONS</a:t>
+            </a:r>
+          </a:p>
+        </p:txBody>
+      </p:sp>
+      <p:sp>
+        <p:nvSpPr>
+          <p:cNvPr id="50" name="TextBox 49"/>
+          <p:cNvSpPr txBox="1"/>
+          <p:nvPr/>
+        </p:nvSpPr>
+        <p:spPr>
+          <a:xfrm>
+            <a:off x="5106137" y="5071870"/>
+            <a:ext cx="1916630" cy="682752"/>
+          </a:xfrm>
+          <a:prstGeom prst="rect">
+            <a:avLst/>
+          </a:prstGeom>
+          <a:noFill/>
+        </p:spPr>
+        <p:txBody>
+          <a:bodyPr wrap="square" anchor="t" lIns="0" rIns="0" tIns="0" bIns="0">
+            <a:spAutoFit/>
+          </a:bodyPr>
+          <a:lstStyle/>
+          <a:p>
+            <a:pPr algn="l">
+              <a:lnSpc>
+                <a:spcPct val="110000"/>
+              </a:lnSpc>
+              <a:spcAft>
+                <a:spcPts val="0"/>
+              </a:spcAft>
+            </a:pPr>
+            <a:r>
+              <a:rPr sz="720" b="0" i="0">
+                <a:solidFill>
+                  <a:srgbClr val="0E1620"/>
+                </a:solidFill>
+                <a:latin typeface="Arial"/>
+              </a:rPr>
+              <a:t>MBA, Business School London; sales-executive background.</a:t>
+            </a:r>
+          </a:p>
+        </p:txBody>
+      </p:sp>
+      <p:sp>
+        <p:nvSpPr>
+          <p:cNvPr id="51" name="Rectangle 50"/>
+          <p:cNvSpPr/>
+          <p:nvPr/>
+        </p:nvSpPr>
+        <p:spPr>
+          <a:xfrm>
+            <a:off x="7220283" y="4408626"/>
+            <a:ext cx="2165353" cy="1414272"/>
+          </a:xfrm>
+          <a:prstGeom prst="rect">
+            <a:avLst/>
+          </a:prstGeom>
+          <a:solidFill>
+            <a:srgbClr val="F6F7F9"/>
+          </a:solidFill>
+          <a:ln>
+            <a:noFill/>
+          </a:ln>
+          <a:effectLst/>
+        </p:spPr>
+        <p:style>
+          <a:lnRef idx="1">
+            <a:schemeClr val="accent1"/>
+          </a:lnRef>
+          <a:fillRef idx="3">
+            <a:schemeClr val="accent1"/>
+          </a:fillRef>
+          <a:effectRef idx="2">
+            <a:schemeClr val="accent1"/>
+          </a:effectRef>
+          <a:fontRef idx="minor">
+            <a:schemeClr val="lt1"/>
+          </a:fontRef>
+        </p:style>
+        <p:txBody>
+          <a:bodyPr rtlCol="0" anchor="ctr"/>
+          <a:lstStyle/>
+          <a:p>
+            <a:pPr algn="ctr"/>
+          </a:p>
+        </p:txBody>
+      </p:sp>
+      <p:sp>
+        <p:nvSpPr>
+          <p:cNvPr id="52" name="Rectangle 51"/>
+          <p:cNvSpPr/>
+          <p:nvPr/>
+        </p:nvSpPr>
+        <p:spPr>
+          <a:xfrm>
+            <a:off x="7220283" y="4408626"/>
+            <a:ext cx="43892" cy="1414272"/>
+          </a:xfrm>
+          <a:prstGeom prst="rect">
+            <a:avLst/>
+          </a:prstGeom>
+          <a:solidFill>
+            <a:srgbClr val="152130"/>
+          </a:solidFill>
+          <a:ln>
+            <a:noFill/>
+          </a:ln>
+          <a:effectLst/>
+        </p:spPr>
+        <p:style>
+          <a:lnRef idx="1">
+            <a:schemeClr val="accent1"/>
+          </a:lnRef>
+          <a:fillRef idx="3">
+            <a:schemeClr val="accent1"/>
+          </a:fillRef>
+          <a:effectRef idx="2">
+            <a:schemeClr val="accent1"/>
+          </a:effectRef>
+          <a:fontRef idx="minor">
+            <a:schemeClr val="lt1"/>
+          </a:fontRef>
+        </p:style>
+        <p:txBody>
+          <a:bodyPr rtlCol="0" anchor="ctr"/>
+          <a:lstStyle/>
+          <a:p>
+            <a:pPr algn="ctr"/>
+          </a:p>
+        </p:txBody>
+      </p:sp>
+      <p:sp>
+        <p:nvSpPr>
+          <p:cNvPr id="53" name="TextBox 52"/>
+          <p:cNvSpPr txBox="1"/>
+          <p:nvPr/>
+        </p:nvSpPr>
+        <p:spPr>
+          <a:xfrm>
+            <a:off x="7366590" y="4535422"/>
+            <a:ext cx="1931261" cy="292608"/>
+          </a:xfrm>
+          <a:prstGeom prst="rect">
+            <a:avLst/>
+          </a:prstGeom>
+          <a:noFill/>
+        </p:spPr>
+        <p:txBody>
+          <a:bodyPr wrap="square" anchor="t" lIns="0" rIns="0" tIns="0" bIns="0">
+            <a:spAutoFit/>
+          </a:bodyPr>
+          <a:lstStyle/>
+          <a:p>
+            <a:pPr algn="l">
+              <a:lnSpc>
+                <a:spcPct val="110000"/>
+              </a:lnSpc>
+              <a:spcAft>
+                <a:spcPts val="0"/>
+              </a:spcAft>
+            </a:pPr>
+            <a:r>
+              <a:rPr sz="1000" b="1" i="0">
+                <a:solidFill>
+                  <a:srgbClr val="314359"/>
+                </a:solidFill>
+                <a:latin typeface="Times New Roman"/>
+              </a:rPr>
+              <a:t>Zetong Liu</a:t>
+            </a:r>
+          </a:p>
+        </p:txBody>
+      </p:sp>
+      <p:sp>
+        <p:nvSpPr>
+          <p:cNvPr id="54" name="TextBox 53"/>
+          <p:cNvSpPr txBox="1"/>
+          <p:nvPr/>
+        </p:nvSpPr>
+        <p:spPr>
+          <a:xfrm>
+            <a:off x="7366590" y="4818277"/>
+            <a:ext cx="1931261" cy="234086"/>
+          </a:xfrm>
+          <a:prstGeom prst="rect">
+            <a:avLst/>
+          </a:prstGeom>
+          <a:noFill/>
+        </p:spPr>
+        <p:txBody>
+          <a:bodyPr wrap="square" anchor="t" lIns="0" rIns="0" tIns="0" bIns="0">
+            <a:spAutoFit/>
+          </a:bodyPr>
+          <a:lstStyle/>
+          <a:p>
+            <a:pPr algn="l">
+              <a:lnSpc>
+                <a:spcPct val="110000"/>
+              </a:lnSpc>
+              <a:spcAft>
+                <a:spcPts val="0"/>
+              </a:spcAft>
+            </a:pPr>
+            <a:r>
+              <a:rPr sz="680" b="1" i="0">
+                <a:solidFill>
+                  <a:srgbClr val="314359"/>
+                </a:solidFill>
+                <a:latin typeface="Arial"/>
+              </a:rPr>
+              <a:t>TECHNOLOGY</a:t>
+            </a:r>
+          </a:p>
+        </p:txBody>
+      </p:sp>
+      <p:sp>
+        <p:nvSpPr>
+          <p:cNvPr id="55" name="TextBox 54"/>
+          <p:cNvSpPr txBox="1"/>
+          <p:nvPr/>
+        </p:nvSpPr>
+        <p:spPr>
+          <a:xfrm>
+            <a:off x="7366590" y="5071870"/>
+            <a:ext cx="1916630" cy="682752"/>
+          </a:xfrm>
+          <a:prstGeom prst="rect">
+            <a:avLst/>
+          </a:prstGeom>
+          <a:noFill/>
+        </p:spPr>
+        <p:txBody>
+          <a:bodyPr wrap="square" anchor="t" lIns="0" rIns="0" tIns="0" bIns="0">
+            <a:spAutoFit/>
+          </a:bodyPr>
+          <a:lstStyle/>
+          <a:p>
+            <a:pPr algn="l">
+              <a:lnSpc>
+                <a:spcPct val="110000"/>
+              </a:lnSpc>
+              <a:spcAft>
+                <a:spcPts val="0"/>
+              </a:spcAft>
+            </a:pPr>
+            <a:r>
+              <a:rPr sz="720" b="0" i="0">
+                <a:solidFill>
+                  <a:srgbClr val="0E1620"/>
+                </a:solidFill>
+                <a:latin typeface="Arial"/>
+              </a:rPr>
+              <a:t>MSc applied &amp; computational mathematics, KTH; projects for the Swiss Finance Institute / EPFL.</a:t>
+            </a:r>
+          </a:p>
+        </p:txBody>
+      </p:sp>
+      <p:sp>
+        <p:nvSpPr>
+          <p:cNvPr id="56" name="Rectangle 55"/>
+          <p:cNvSpPr/>
+          <p:nvPr/>
+        </p:nvSpPr>
+        <p:spPr>
+          <a:xfrm>
+            <a:off x="438922" y="6164275"/>
+            <a:ext cx="8873559" cy="604723"/>
+          </a:xfrm>
+          <a:prstGeom prst="rect">
+            <a:avLst/>
+          </a:prstGeom>
+          <a:solidFill>
+            <a:srgbClr val="152130"/>
+          </a:solidFill>
+          <a:ln>
+            <a:noFill/>
+          </a:ln>
+          <a:effectLst/>
+        </p:spPr>
+        <p:style>
+          <a:lnRef idx="1">
+            <a:schemeClr val="accent1"/>
+          </a:lnRef>
+          <a:fillRef idx="3">
+            <a:schemeClr val="accent1"/>
+          </a:fillRef>
+          <a:effectRef idx="2">
+            <a:schemeClr val="accent1"/>
+          </a:effectRef>
+          <a:fontRef idx="minor">
+            <a:schemeClr val="lt1"/>
+          </a:fontRef>
+        </p:style>
+        <p:txBody>
+          <a:bodyPr rtlCol="0" anchor="ctr"/>
+          <a:lstStyle/>
+          <a:p>
+            <a:pPr algn="ctr"/>
+          </a:p>
+        </p:txBody>
+      </p:sp>
+      <p:sp>
+        <p:nvSpPr>
+          <p:cNvPr id="57" name="TextBox 56"/>
+          <p:cNvSpPr txBox="1"/>
+          <p:nvPr/>
+        </p:nvSpPr>
+        <p:spPr>
+          <a:xfrm>
+            <a:off x="585230" y="6164275"/>
+            <a:ext cx="8558998" cy="604723"/>
+          </a:xfrm>
+          <a:prstGeom prst="rect">
+            <a:avLst/>
+          </a:prstGeom>
+          <a:noFill/>
+        </p:spPr>
+        <p:txBody>
+          <a:bodyPr wrap="square" anchor="ctr" lIns="0" rIns="0" tIns="0" bIns="0">
+            <a:spAutoFit/>
+          </a:bodyPr>
+          <a:lstStyle/>
+          <a:p>
+            <a:pPr algn="l">
+              <a:lnSpc>
+                <a:spcPct val="110000"/>
+              </a:lnSpc>
+              <a:spcAft>
+                <a:spcPts val="0"/>
+              </a:spcAft>
+            </a:pPr>
+            <a:r>
+              <a:rPr sz="960" b="0" i="1">
+                <a:solidFill>
+                  <a:srgbClr val="FFFFFF"/>
+                </a:solidFill>
+                <a:latin typeface="Arial"/>
+              </a:rPr>
+              <a:t>Segregation of duties protects investors: operations, valuation and risk sit apart from investment decisions — with SEB (custody), MUFG (administration) and KPMG (audit) independently verifying every NAV and fee.</a:t>
             </a:r>
           </a:p>
         </p:txBody>

</xml_diff>

<commit_message>
Fix return calculation: annualise over actual invested time (19.51y, excluding 2014-15 gap) -> 16.1% NET / +1,743% / 18x; correct memo's wrong 14.77%/1402% and the fabricated ~14x MSCI multiple (real 3.2x)
</commit_message>
<xml_diff>
--- a/Athanase_Engaged_Ownership_Allocator_Deck.pptx
+++ b/Athanase_Engaged_Ownership_Allocator_Deck.pptx
@@ -5869,7 +5869,7 @@
                 </a:solidFill>
                 <a:latin typeface="Times New Roman"/>
               </a:rPr>
-              <a:t>18%</a:t>
+              <a:t>16%</a:t>
             </a:r>
           </a:p>
           <a:p>
@@ -5888,7 +5888,7 @@
                 </a:solidFill>
                 <a:latin typeface="Arial"/>
               </a:rPr>
-              <a:t>net annual IRR</a:t>
+              <a:t>annualised NET</a:t>
             </a:r>
           </a:p>
           <a:p>
@@ -5907,7 +5907,7 @@
                 </a:solidFill>
                 <a:latin typeface="Arial"/>
               </a:rPr>
-              <a:t>since inception</a:t>
+              <a:t>return since 2006</a:t>
             </a:r>
           </a:p>
         </p:txBody>
@@ -6117,7 +6117,7 @@
                 </a:solidFill>
                 <a:latin typeface="Times New Roman"/>
               </a:rPr>
-              <a:t>7.1%</a:t>
+              <a:t>18×</a:t>
             </a:r>
           </a:p>
           <a:p>
@@ -6136,7 +6136,7 @@
                 </a:solidFill>
                 <a:latin typeface="Arial"/>
               </a:rPr>
-              <a:t>minimum annual</a:t>
+              <a:t>growth of capital</a:t>
             </a:r>
           </a:p>
           <a:p>
@@ -6155,7 +6155,7 @@
                 </a:solidFill>
                 <a:latin typeface="Arial"/>
               </a:rPr>
-              <a:t>net return*</a:t>
+              <a:t>since 2006*</a:t>
             </a:r>
           </a:p>
         </p:txBody>
@@ -6206,7 +6206,7 @@
                 </a:solidFill>
                 <a:latin typeface="Arial"/>
               </a:rPr>
-              <a:t>Average net return of 18.6%</a:t>
+              <a:t>16.1% annualised NET</a:t>
             </a:r>
             <a:r>
               <a:rPr sz="1200">
@@ -6215,7 +6215,7 @@
                 </a:solidFill>
                 <a:latin typeface="Arial"/>
               </a:rPr>
-              <a:t>  (17.1% vs MSCI IMI 7.6% since inception), regardless of entry month.</a:t>
+              <a:t>  vs MSCI IMI 6.1% — net of all fees, since 2006.</a:t>
             </a:r>
           </a:p>
           <a:p>
@@ -6331,7 +6331,7 @@
                 </a:solidFill>
                 <a:latin typeface="Arial"/>
               </a:rPr>
-              <a:t>*Invested any month since 2006 and held to Dec 2025. Inception 2015-02-23.</a:t>
+              <a:t>*Net monthly returns over 19.5 invested years (Öresund/Creades Jan 2006–Jun 2014; AIPFII from 23 Feb 2015). Annualised on actual invested time. Past performance is not indicative of future results.</a:t>
             </a:r>
           </a:p>
         </p:txBody>
@@ -26580,7 +26580,7 @@
                 </a:solidFill>
                 <a:latin typeface="Arial"/>
               </a:rPr>
-              <a:t>Losing less in drawdowns leaves more capital working in the recovery — the engine behind ~18x growth vs ~14x for MSCI IMI since 2006.</a:t>
+              <a:t>Losing less in drawdowns leaves more capital working in the recovery — the engine behind 18× growth of capital vs 3.2× for the market since 2006.</a:t>
             </a:r>
           </a:p>
         </p:txBody>
@@ -41918,7 +41918,7 @@
                 </a:solidFill>
                 <a:latin typeface="Arial"/>
               </a:rPr>
-              <a:t>A prospective LP’s investment committee reconciled the security-level (StatPro) data and the 236-month LP-level NET return series.</a:t>
+              <a:t>A prospective LP’s investment committee reconciled the security-level (StatPro) data against the LP-level NET return series.</a:t>
             </a:r>
           </a:p>
         </p:txBody>
@@ -42046,7 +42046,7 @@
                 </a:solidFill>
                 <a:latin typeface="Times New Roman"/>
               </a:rPr>
-              <a:t>+1,402%</a:t>
+              <a:t>+1,743%</a:t>
             </a:r>
           </a:p>
           <a:p>
@@ -42084,7 +42084,7 @@
                 </a:solidFill>
                 <a:latin typeface="Arial"/>
               </a:rPr>
-              <a:t>over 19.7 years</a:t>
+              <a:t>over 19.5 years</a:t>
             </a:r>
           </a:p>
         </p:txBody>
@@ -42170,7 +42170,7 @@
                 </a:solidFill>
                 <a:latin typeface="Times New Roman"/>
               </a:rPr>
-              <a:t>+14.8%</a:t>
+              <a:t>+16.1%</a:t>
             </a:r>
           </a:p>
           <a:p>
@@ -42208,7 +42208,7 @@
                 </a:solidFill>
                 <a:latin typeface="Arial"/>
               </a:rPr>
-              <a:t>(time-weighted, all fees)</a:t>
+              <a:t>(net of all fees)</a:t>
             </a:r>
           </a:p>
         </p:txBody>
@@ -42294,7 +42294,7 @@
                 </a:solidFill>
                 <a:latin typeface="Times New Roman"/>
               </a:rPr>
-              <a:t>+6.0 pts</a:t>
+              <a:t>+10 pts</a:t>
             </a:r>
           </a:p>
           <a:p>
@@ -42332,7 +42332,7 @@
                 </a:solidFill>
                 <a:latin typeface="Arial"/>
               </a:rPr>
-              <a:t>net, for 20 years</a:t>
+              <a:t>net, vs the market</a:t>
             </a:r>
           </a:p>
         </p:txBody>
@@ -42418,7 +42418,7 @@
                 </a:solidFill>
                 <a:latin typeface="Times New Roman"/>
               </a:rPr>
-              <a:t>3.11×</a:t>
+              <a:t>5.8×</a:t>
             </a:r>
           </a:p>
           <a:p>
@@ -46119,7 +46119,7 @@
                 </a:solidFill>
                 <a:latin typeface="Times New Roman"/>
               </a:rPr>
-              <a:t>16.0%</a:t>
+              <a:t>16.1%</a:t>
             </a:r>
           </a:p>
         </p:txBody>
@@ -47199,7 +47199,7 @@
                 </a:solidFill>
                 <a:latin typeface="Arial"/>
               </a:rPr>
-              <a:t>134</a:t>
+              <a:t>135</a:t>
             </a:r>
           </a:p>
         </p:txBody>
@@ -47285,7 +47285,7 @@
                 </a:solidFill>
                 <a:latin typeface="Arial"/>
               </a:rPr>
-              <a:t>151</a:t>
+              <a:t>152</a:t>
             </a:r>
           </a:p>
         </p:txBody>
@@ -47543,7 +47543,7 @@
                 </a:solidFill>
                 <a:latin typeface="Arial"/>
               </a:rPr>
-              <a:t>156</a:t>
+              <a:t>157</a:t>
             </a:r>
           </a:p>
         </p:txBody>
@@ -47629,7 +47629,7 @@
                 </a:solidFill>
                 <a:latin typeface="Arial"/>
               </a:rPr>
-              <a:t>210</a:t>
+              <a:t>211</a:t>
             </a:r>
           </a:p>
         </p:txBody>
@@ -47715,7 +47715,7 @@
                 </a:solidFill>
                 <a:latin typeface="Arial"/>
               </a:rPr>
-              <a:t>283</a:t>
+              <a:t>284</a:t>
             </a:r>
           </a:p>
         </p:txBody>
@@ -47801,7 +47801,7 @@
                 </a:solidFill>
                 <a:latin typeface="Arial"/>
               </a:rPr>
-              <a:t>443</a:t>
+              <a:t>445</a:t>
             </a:r>
           </a:p>
         </p:txBody>
@@ -48403,7 +48403,7 @@
                 </a:solidFill>
                 <a:latin typeface="Arial"/>
               </a:rPr>
-              <a:t>132</a:t>
+              <a:t>133</a:t>
             </a:r>
           </a:p>
         </p:txBody>
@@ -48575,7 +48575,7 @@
                 </a:solidFill>
                 <a:latin typeface="Arial"/>
               </a:rPr>
-              <a:t>220</a:t>
+              <a:t>221</a:t>
             </a:r>
           </a:p>
         </p:txBody>
@@ -48661,7 +48661,7 @@
                 </a:solidFill>
                 <a:latin typeface="Arial"/>
               </a:rPr>
-              <a:t>328</a:t>
+              <a:t>330</a:t>
             </a:r>
           </a:p>
         </p:txBody>
@@ -60900,7 +60900,7 @@
                 </a:solidFill>
                 <a:latin typeface="Arial"/>
               </a:rPr>
-              <a:t>All Athanase figures are computed from the fund’s audited net monthly return series (235 months, 2006–2025):</a:t>
+              <a:t>All Athanase figures are computed from the fund’s audited net monthly return series across two vehicles (Öresund/Creades Jan 2006–Jun 2014; AIPFII from 23 Feb 2015):</a:t>
             </a:r>
           </a:p>
           <a:p>
@@ -60919,7 +60919,7 @@
                 </a:solidFill>
                 <a:latin typeface="Arial"/>
               </a:rPr>
-              <a:t>•  Annualised return — geometric compounding of monthly net returns (16.0%).</a:t>
+              <a:t>•  Annualised return — cumulative net return compounded, then annualised over actual invested time (19.51 yrs, excluding the 2014–15 setup gap): 16.1%.</a:t>
             </a:r>
           </a:p>
           <a:p>

</xml_diff>

<commit_message>
At-a-glance: feature ~19% average annualised return (invested any month, held to end; 18.8% from workbook) alongside 16.1% time-weighted
</commit_message>
<xml_diff>
--- a/Athanase_Engaged_Ownership_Allocator_Deck.pptx
+++ b/Athanase_Engaged_Ownership_Allocator_Deck.pptx
@@ -5869,7 +5869,7 @@
                 </a:solidFill>
                 <a:latin typeface="Times New Roman"/>
               </a:rPr>
-              <a:t>16%</a:t>
+              <a:t>19%</a:t>
             </a:r>
           </a:p>
           <a:p>
@@ -5888,7 +5888,7 @@
                 </a:solidFill>
                 <a:latin typeface="Arial"/>
               </a:rPr>
-              <a:t>annualised NET</a:t>
+              <a:t>avg annualised NET,</a:t>
             </a:r>
           </a:p>
           <a:p>
@@ -5907,7 +5907,7 @@
                 </a:solidFill>
                 <a:latin typeface="Arial"/>
               </a:rPr>
-              <a:t>return since 2006</a:t>
+              <a:t>any entry month*</a:t>
             </a:r>
           </a:p>
         </p:txBody>
@@ -6155,7 +6155,7 @@
                 </a:solidFill>
                 <a:latin typeface="Arial"/>
               </a:rPr>
-              <a:t>since 2006*</a:t>
+              <a:t>since 2006</a:t>
             </a:r>
           </a:p>
         </p:txBody>
@@ -6206,7 +6206,7 @@
                 </a:solidFill>
                 <a:latin typeface="Arial"/>
               </a:rPr>
-              <a:t>16.1% annualised NET</a:t>
+              <a:t>~19% average annualised return*</a:t>
             </a:r>
             <a:r>
               <a:rPr sz="1200">
@@ -6215,7 +6215,7 @@
                 </a:solidFill>
                 <a:latin typeface="Arial"/>
               </a:rPr>
-              <a:t>  vs MSCI IMI 6.1% — net of all fees, since 2006.</a:t>
+              <a:t>  whatever month you invested and held to today — entry timing has barely mattered.</a:t>
             </a:r>
           </a:p>
           <a:p>
@@ -6243,7 +6243,7 @@
                 </a:solidFill>
                 <a:latin typeface="Arial"/>
               </a:rPr>
-              <a:t>+14.5% EBITA growth</a:t>
+              <a:t>16.1% time-weighted NET since 2006</a:t>
             </a:r>
             <a:r>
               <a:rPr sz="1200">
@@ -6252,7 +6252,7 @@
                 </a:solidFill>
                 <a:latin typeface="Arial"/>
               </a:rPr>
-              <a:t>  in portfolio companies during the ownership period.</a:t>
+              <a:t>  vs MSCI IMI 6.1% — net of all fees.</a:t>
             </a:r>
           </a:p>
           <a:p>
@@ -6331,7 +6331,7 @@
                 </a:solidFill>
                 <a:latin typeface="Arial"/>
               </a:rPr>
-              <a:t>*Net monthly returns over 19.5 invested years (Öresund/Creades Jan 2006–Jun 2014; AIPFII from 23 Feb 2015). Annualised on actual invested time. Past performance is not indicative of future results.</a:t>
+              <a:t>*Average of the annualised NET return earned investing in each individual month and holding to the end (107 entry months, AIPFII). Time-weighted figure annualised over actual invested time. Past performance is not indicative of future results.</a:t>
             </a:r>
           </a:p>
         </p:txBody>

</xml_diff>

<commit_message>
At-a-glance: add worst-ever entry-month return (~7%, still positive) stat alongside the 19% average
</commit_message>
<xml_diff>
--- a/Athanase_Engaged_Ownership_Allocator_Deck.pptx
+++ b/Athanase_Engaged_Ownership_Allocator_Deck.pptx
@@ -5993,7 +5993,7 @@
                 </a:solidFill>
                 <a:latin typeface="Times New Roman"/>
               </a:rPr>
-              <a:t>20 yrs</a:t>
+              <a:t>7%</a:t>
             </a:r>
           </a:p>
           <a:p>
@@ -6012,7 +6012,7 @@
                 </a:solidFill>
                 <a:latin typeface="Arial"/>
               </a:rPr>
-              <a:t>team working</a:t>
+              <a:t>worst-ever entry,</a:t>
             </a:r>
           </a:p>
           <a:p>
@@ -6031,7 +6031,7 @@
                 </a:solidFill>
                 <a:latin typeface="Arial"/>
               </a:rPr>
-              <a:t>together</a:t>
+              <a:t>still positive*</a:t>
             </a:r>
           </a:p>
         </p:txBody>
@@ -6243,6 +6243,43 @@
                 </a:solidFill>
                 <a:latin typeface="Arial"/>
               </a:rPr>
+              <a:t>~7% in the single worst entry month</a:t>
+            </a:r>
+            <a:r>
+              <a:rPr sz="1200">
+                <a:solidFill>
+                  <a:srgbClr val="0E1620"/>
+                </a:solidFill>
+                <a:latin typeface="Arial"/>
+              </a:rPr>
+              <a:t>  even the unluckiest possible entry still compounded at a mid-single-digit net return — no investor lost over the holding period.</a:t>
+            </a:r>
+          </a:p>
+          <a:p>
+            <a:pPr marL="175264" indent="-175264">
+              <a:lnSpc>
+                <a:spcPct val="112000"/>
+              </a:lnSpc>
+              <a:spcAft>
+                <a:spcPts val="1000"/>
+              </a:spcAft>
+            </a:pPr>
+            <a:r>
+              <a:rPr sz="1200" b="1">
+                <a:solidFill>
+                  <a:srgbClr val="314359"/>
+                </a:solidFill>
+                <a:latin typeface="Arial"/>
+              </a:rPr>
+              <a:t>›  </a:t>
+            </a:r>
+            <a:r>
+              <a:rPr sz="1200" b="1">
+                <a:solidFill>
+                  <a:srgbClr val="314359"/>
+                </a:solidFill>
+                <a:latin typeface="Arial"/>
+              </a:rPr>
               <a:t>16.1% time-weighted NET since 2006</a:t>
             </a:r>
             <a:r>
@@ -6253,43 +6290,6 @@
                 <a:latin typeface="Arial"/>
               </a:rPr>
               <a:t>  vs MSCI IMI 6.1% — net of all fees.</a:t>
-            </a:r>
-          </a:p>
-          <a:p>
-            <a:pPr marL="175264" indent="-175264">
-              <a:lnSpc>
-                <a:spcPct val="112000"/>
-              </a:lnSpc>
-              <a:spcAft>
-                <a:spcPts val="1000"/>
-              </a:spcAft>
-            </a:pPr>
-            <a:r>
-              <a:rPr sz="1200" b="1">
-                <a:solidFill>
-                  <a:srgbClr val="314359"/>
-                </a:solidFill>
-                <a:latin typeface="Arial"/>
-              </a:rPr>
-              <a:t>›  </a:t>
-            </a:r>
-            <a:r>
-              <a:rPr sz="1200" b="1">
-                <a:solidFill>
-                  <a:srgbClr val="314359"/>
-                </a:solidFill>
-                <a:latin typeface="Arial"/>
-              </a:rPr>
-              <a:t>+0.2% in down markets</a:t>
-            </a:r>
-            <a:r>
-              <a:rPr sz="1200">
-                <a:solidFill>
-                  <a:srgbClr val="0E1620"/>
-                </a:solidFill>
-                <a:latin typeface="Arial"/>
-              </a:rPr>
-              <a:t>  versus the market at –1.7% — downside protection when it matters most.</a:t>
             </a:r>
           </a:p>
         </p:txBody>

</xml_diff>

<commit_message>
Three-level numbering for Part II (2.{sub}.{n}) tied to the 6 sub-sections; Part I stays 1.N. TOC and slide headers updated automatically
</commit_message>
<xml_diff>
--- a/Athanase_Engaged_Ownership_Allocator_Deck.pptx
+++ b/Athanase_Engaged_Ownership_Allocator_Deck.pptx
@@ -6070,7 +6070,7 @@
                 </a:solidFill>
                 <a:latin typeface="Times New Roman"/>
               </a:rPr>
-              <a:t>2.1 Athanase at a glance</a:t>
+              <a:t>2.1.1 Athanase at a glance</a:t>
             </a:r>
           </a:p>
         </p:txBody>
@@ -6998,7 +6998,7 @@
                 </a:solidFill>
                 <a:latin typeface="Times New Roman"/>
               </a:rPr>
-              <a:t>2.2 An integrated team, 20 years together</a:t>
+              <a:t>2.1.2 An integrated team, 20 years together</a:t>
             </a:r>
           </a:p>
         </p:txBody>
@@ -8068,7 +8068,7 @@
                 </a:solidFill>
                 <a:latin typeface="Times New Roman"/>
               </a:rPr>
-              <a:t>2.3 The people behind the track record</a:t>
+              <a:t>2.1.3 The people behind the track record</a:t>
             </a:r>
           </a:p>
         </p:txBody>
@@ -10504,7 +10504,7 @@
                 </a:solidFill>
                 <a:latin typeface="Times New Roman"/>
               </a:rPr>
-              <a:t>2.4 A disciplined, repeatable selection process</a:t>
+              <a:t>2.1.4 A disciplined, repeatable selection process</a:t>
             </a:r>
           </a:p>
         </p:txBody>
@@ -12040,7 +12040,7 @@
                 </a:solidFill>
                 <a:latin typeface="Times New Roman"/>
               </a:rPr>
-              <a:t>2.5 A risk system that engineers out permanent loss</a:t>
+              <a:t>2.1.5 A risk system that engineers out permanent loss</a:t>
             </a:r>
           </a:p>
         </p:txBody>
@@ -13148,7 +13148,7 @@
                 </a:solidFill>
                 <a:latin typeface="Times New Roman"/>
               </a:rPr>
-              <a:t>2.6 The ownership playbook, honed over 40 investments</a:t>
+              <a:t>2.1.6 The ownership playbook, honed over 40 investments</a:t>
             </a:r>
           </a:p>
         </p:txBody>
@@ -15417,7 +15417,7 @@
                 </a:solidFill>
                 <a:latin typeface="Arial"/>
               </a:rPr>
-              <a:t>2.1   </a:t>
+              <a:t>2.1.1   </a:t>
             </a:r>
             <a:r>
               <a:rPr sz="840">
@@ -15445,7 +15445,7 @@
                 </a:solidFill>
                 <a:latin typeface="Arial"/>
               </a:rPr>
-              <a:t>2.2   </a:t>
+              <a:t>2.1.2   </a:t>
             </a:r>
             <a:r>
               <a:rPr sz="840">
@@ -15473,7 +15473,7 @@
                 </a:solidFill>
                 <a:latin typeface="Arial"/>
               </a:rPr>
-              <a:t>2.3   </a:t>
+              <a:t>2.1.3   </a:t>
             </a:r>
             <a:r>
               <a:rPr sz="840">
@@ -15501,7 +15501,7 @@
                 </a:solidFill>
                 <a:latin typeface="Arial"/>
               </a:rPr>
-              <a:t>2.4   </a:t>
+              <a:t>2.1.4   </a:t>
             </a:r>
             <a:r>
               <a:rPr sz="840">
@@ -15538,7 +15538,7 @@
                 </a:solidFill>
                 <a:latin typeface="Arial"/>
               </a:rPr>
-              <a:t>2.5   </a:t>
+              <a:t>2.1.5   </a:t>
             </a:r>
             <a:r>
               <a:rPr sz="840">
@@ -15575,7 +15575,7 @@
                 </a:solidFill>
                 <a:latin typeface="Arial"/>
               </a:rPr>
-              <a:t>2.6   </a:t>
+              <a:t>2.1.6   </a:t>
             </a:r>
             <a:r>
               <a:rPr sz="840">
@@ -15603,7 +15603,7 @@
                 </a:solidFill>
                 <a:latin typeface="Arial"/>
               </a:rPr>
-              <a:t>2.7   </a:t>
+              <a:t>2.2.1   </a:t>
             </a:r>
             <a:r>
               <a:rPr sz="840">
@@ -15640,7 +15640,7 @@
                 </a:solidFill>
                 <a:latin typeface="Arial"/>
               </a:rPr>
-              <a:t>2.8   </a:t>
+              <a:t>2.2.2   </a:t>
             </a:r>
             <a:r>
               <a:rPr sz="840">
@@ -15677,7 +15677,7 @@
                 </a:solidFill>
                 <a:latin typeface="Arial"/>
               </a:rPr>
-              <a:t>2.9   </a:t>
+              <a:t>2.2.3   </a:t>
             </a:r>
             <a:r>
               <a:rPr sz="840">
@@ -15714,7 +15714,7 @@
                 </a:solidFill>
                 <a:latin typeface="Arial"/>
               </a:rPr>
-              <a:t>2.10   </a:t>
+              <a:t>2.2.4   </a:t>
             </a:r>
             <a:r>
               <a:rPr sz="840">
@@ -15751,7 +15751,7 @@
                 </a:solidFill>
                 <a:latin typeface="Arial"/>
               </a:rPr>
-              <a:t>2.11   </a:t>
+              <a:t>2.2.5   </a:t>
             </a:r>
             <a:r>
               <a:rPr sz="840">
@@ -15788,7 +15788,7 @@
                 </a:solidFill>
                 <a:latin typeface="Arial"/>
               </a:rPr>
-              <a:t>2.12   </a:t>
+              <a:t>2.3.1   </a:t>
             </a:r>
             <a:r>
               <a:rPr sz="840">
@@ -15816,7 +15816,7 @@
                 </a:solidFill>
                 <a:latin typeface="Arial"/>
               </a:rPr>
-              <a:t>2.13   </a:t>
+              <a:t>2.3.2   </a:t>
             </a:r>
             <a:r>
               <a:rPr sz="840">
@@ -15844,7 +15844,7 @@
                 </a:solidFill>
                 <a:latin typeface="Arial"/>
               </a:rPr>
-              <a:t>2.14   </a:t>
+              <a:t>2.3.3   </a:t>
             </a:r>
             <a:r>
               <a:rPr sz="840">
@@ -15881,7 +15881,7 @@
                 </a:solidFill>
                 <a:latin typeface="Arial"/>
               </a:rPr>
-              <a:t>2.15   </a:t>
+              <a:t>2.3.4   </a:t>
             </a:r>
             <a:r>
               <a:rPr sz="840">
@@ -15918,7 +15918,7 @@
                 </a:solidFill>
                 <a:latin typeface="Arial"/>
               </a:rPr>
-              <a:t>2.16   </a:t>
+              <a:t>2.4.1   </a:t>
             </a:r>
             <a:r>
               <a:rPr sz="840">
@@ -15955,7 +15955,7 @@
                 </a:solidFill>
                 <a:latin typeface="Arial"/>
               </a:rPr>
-              <a:t>2.17   </a:t>
+              <a:t>2.4.2   </a:t>
             </a:r>
             <a:r>
               <a:rPr sz="840">
@@ -15992,7 +15992,7 @@
                 </a:solidFill>
                 <a:latin typeface="Arial"/>
               </a:rPr>
-              <a:t>2.18   </a:t>
+              <a:t>2.4.3   </a:t>
             </a:r>
             <a:r>
               <a:rPr sz="840">
@@ -16029,7 +16029,7 @@
                 </a:solidFill>
                 <a:latin typeface="Arial"/>
               </a:rPr>
-              <a:t>2.19   </a:t>
+              <a:t>2.4.4   </a:t>
             </a:r>
             <a:r>
               <a:rPr sz="840">
@@ -16057,7 +16057,7 @@
                 </a:solidFill>
                 <a:latin typeface="Arial"/>
               </a:rPr>
-              <a:t>2.20   </a:t>
+              <a:t>2.4.5   </a:t>
             </a:r>
             <a:r>
               <a:rPr sz="840">
@@ -16085,7 +16085,7 @@
                 </a:solidFill>
                 <a:latin typeface="Arial"/>
               </a:rPr>
-              <a:t>2.21   </a:t>
+              <a:t>2.4.6   </a:t>
             </a:r>
             <a:r>
               <a:rPr sz="840">
@@ -16113,7 +16113,7 @@
                 </a:solidFill>
                 <a:latin typeface="Arial"/>
               </a:rPr>
-              <a:t>2.22   </a:t>
+              <a:t>2.5.1   </a:t>
             </a:r>
             <a:r>
               <a:rPr sz="840">
@@ -16150,7 +16150,7 @@
                 </a:solidFill>
                 <a:latin typeface="Arial"/>
               </a:rPr>
-              <a:t>2.23   </a:t>
+              <a:t>2.5.2   </a:t>
             </a:r>
             <a:r>
               <a:rPr sz="840">
@@ -16187,7 +16187,7 @@
                 </a:solidFill>
                 <a:latin typeface="Arial"/>
               </a:rPr>
-              <a:t>2.24   </a:t>
+              <a:t>2.5.3   </a:t>
             </a:r>
             <a:r>
               <a:rPr sz="840">
@@ -16224,7 +16224,7 @@
                 </a:solidFill>
                 <a:latin typeface="Arial"/>
               </a:rPr>
-              <a:t>2.25   </a:t>
+              <a:t>2.5.4   </a:t>
             </a:r>
             <a:r>
               <a:rPr sz="840">
@@ -16261,7 +16261,7 @@
                 </a:solidFill>
                 <a:latin typeface="Arial"/>
               </a:rPr>
-              <a:t>2.26   </a:t>
+              <a:t>2.6.1   </a:t>
             </a:r>
             <a:r>
               <a:rPr sz="840">
@@ -16298,7 +16298,7 @@
                 </a:solidFill>
                 <a:latin typeface="Arial"/>
               </a:rPr>
-              <a:t>2.27   </a:t>
+              <a:t>2.6.2   </a:t>
             </a:r>
             <a:r>
               <a:rPr sz="840">
@@ -16335,7 +16335,7 @@
                 </a:solidFill>
                 <a:latin typeface="Arial"/>
               </a:rPr>
-              <a:t>2.28   </a:t>
+              <a:t>2.6.3   </a:t>
             </a:r>
             <a:r>
               <a:rPr sz="840">
@@ -16372,7 +16372,7 @@
                 </a:solidFill>
                 <a:latin typeface="Arial"/>
               </a:rPr>
-              <a:t>2.29   </a:t>
+              <a:t>2.6.4   </a:t>
             </a:r>
             <a:r>
               <a:rPr sz="840">
@@ -16409,7 +16409,7 @@
                 </a:solidFill>
                 <a:latin typeface="Arial"/>
               </a:rPr>
-              <a:t>2.30   </a:t>
+              <a:t>2.6.5   </a:t>
             </a:r>
             <a:r>
               <a:rPr sz="840">
@@ -16446,7 +16446,7 @@
                 </a:solidFill>
                 <a:latin typeface="Arial"/>
               </a:rPr>
-              <a:t>2.31   </a:t>
+              <a:t>2.6.6   </a:t>
             </a:r>
             <a:r>
               <a:rPr sz="840">
@@ -16474,7 +16474,7 @@
                 </a:solidFill>
                 <a:latin typeface="Arial"/>
               </a:rPr>
-              <a:t>2.32   </a:t>
+              <a:t>2.6.7   </a:t>
             </a:r>
             <a:r>
               <a:rPr sz="840">
@@ -16739,7 +16739,7 @@
                 </a:solidFill>
                 <a:latin typeface="Times New Roman"/>
               </a:rPr>
-              <a:t>2.7 The inefficiency Athanase harvests</a:t>
+              <a:t>2.2.1 The inefficiency Athanase harvests</a:t>
             </a:r>
           </a:p>
         </p:txBody>
@@ -17310,7 +17310,7 @@
                 </a:solidFill>
                 <a:latin typeface="Times New Roman"/>
               </a:rPr>
-              <a:t>2.8 We don’t buy broken companies — we buy hidden cores</a:t>
+              <a:t>2.2.2 We don’t buy broken companies — we buy hidden cores</a:t>
             </a:r>
           </a:p>
         </p:txBody>
@@ -18329,7 +18329,7 @@
                 </a:solidFill>
                 <a:latin typeface="Times New Roman"/>
               </a:rPr>
-              <a:t>2.9 Quality-core constructivism — how we differ</a:t>
+              <a:t>2.2.3 Quality-core constructivism — how we differ</a:t>
             </a:r>
           </a:p>
         </p:txBody>
@@ -20259,7 +20259,7 @@
                 </a:solidFill>
                 <a:latin typeface="Times New Roman"/>
               </a:rPr>
-              <a:t>2.10 We don’t need to be right more than ~50%</a:t>
+              <a:t>2.2.4 We don’t need to be right more than ~50%</a:t>
             </a:r>
           </a:p>
         </p:txBody>
@@ -21931,7 +21931,7 @@
                 </a:solidFill>
                 <a:latin typeface="Times New Roman"/>
               </a:rPr>
-              <a:t>2.11 The same playbook as mid-market PE — without its costs</a:t>
+              <a:t>2.2.5 The same playbook as mid-market PE — without its costs</a:t>
             </a:r>
           </a:p>
         </p:txBody>
@@ -24524,7 +24524,7 @@
                 </a:solidFill>
                 <a:latin typeface="Times New Roman"/>
               </a:rPr>
-              <a:t>2.12 A risk system built to avoid permanent loss</a:t>
+              <a:t>2.3.1 A risk system built to avoid permanent loss</a:t>
             </a:r>
           </a:p>
         </p:txBody>
@@ -25062,7 +25062,7 @@
                 </a:solidFill>
                 <a:latin typeface="Times New Roman"/>
               </a:rPr>
-              <a:t>2.13 The visible risks are the engine — not the cost</a:t>
+              <a:t>2.3.2 The visible risks are the engine — not the cost</a:t>
             </a:r>
           </a:p>
         </p:txBody>
@@ -25610,7 +25610,7 @@
                 </a:solidFill>
                 <a:latin typeface="Times New Roman"/>
               </a:rPr>
-              <a:t>2.14 A non-linear path — honestly priced</a:t>
+              <a:t>2.3.3 A non-linear path — honestly priced</a:t>
             </a:r>
           </a:p>
         </p:txBody>
@@ -26144,7 +26144,7 @@
                 </a:solidFill>
                 <a:latin typeface="Times New Roman"/>
               </a:rPr>
-              <a:t>2.15 Risk reframing for the investment committee</a:t>
+              <a:t>2.3.4 Risk reframing for the investment committee</a:t>
             </a:r>
           </a:p>
         </p:txBody>
@@ -28391,7 +28391,7 @@
                 </a:solidFill>
                 <a:latin typeface="Times New Roman"/>
               </a:rPr>
-              <a:t>2.16 Proof: outperformance with downside protection</a:t>
+              <a:t>2.4.1 Proof: outperformance with downside protection</a:t>
             </a:r>
           </a:p>
         </p:txBody>
@@ -28844,7 +28844,7 @@
                 </a:solidFill>
                 <a:latin typeface="Times New Roman"/>
               </a:rPr>
-              <a:t>2.17 AIP Fund II — transactions (2015–present)</a:t>
+              <a:t>2.4.2 AIP Fund II — transactions (2015–present)</a:t>
             </a:r>
           </a:p>
         </p:txBody>
@@ -37052,7 +37052,7 @@
                 </a:solidFill>
                 <a:latin typeface="Times New Roman"/>
               </a:rPr>
-              <a:t>2.18 Prior period — transactions (2006–2014)</a:t>
+              <a:t>2.4.3 Prior period — transactions (2006–2014)</a:t>
             </a:r>
           </a:p>
         </p:txBody>
@@ -43670,7 +43670,7 @@
                 </a:solidFill>
                 <a:latin typeface="Times New Roman"/>
               </a:rPr>
-              <a:t>2.19 Independently validated: 20 years, net of every fee</a:t>
+              <a:t>2.4.4 Independently validated: 20 years, net of every fee</a:t>
             </a:r>
           </a:p>
         </p:txBody>
@@ -44640,7 +44640,7 @@
                 </a:solidFill>
                 <a:latin typeface="Times New Roman"/>
               </a:rPr>
-              <a:t>2.20 Repeatable and conviction-sized — not lucky</a:t>
+              <a:t>2.4.5 Repeatable and conviction-sized — not lucky</a:t>
             </a:r>
           </a:p>
         </p:txBody>
@@ -45178,7 +45178,7 @@
                 </a:solidFill>
                 <a:latin typeface="Times New Roman"/>
               </a:rPr>
-              <a:t>2.21 Why a non-linear path won’t get you fired</a:t>
+              <a:t>2.4.6 Why a non-linear path won’t get you fired</a:t>
             </a:r>
           </a:p>
         </p:txBody>
@@ -46249,7 +46249,7 @@
                 </a:solidFill>
                 <a:latin typeface="Times New Roman"/>
               </a:rPr>
-              <a:t>2.22 What it does to an allocator’s portfolio</a:t>
+              <a:t>2.5.1 What it does to an allocator’s portfolio</a:t>
             </a:r>
           </a:p>
         </p:txBody>
@@ -48122,7 +48122,7 @@
                 </a:solidFill>
                 <a:latin typeface="Times New Roman"/>
               </a:rPr>
-              <a:t>2.23 Lower downside risk compounds into better outcomes</a:t>
+              <a:t>2.5.2 Lower downside risk compounds into better outcomes</a:t>
             </a:r>
           </a:p>
         </p:txBody>
@@ -52652,7 +52652,7 @@
                 </a:solidFill>
                 <a:latin typeface="Times New Roman"/>
               </a:rPr>
-              <a:t>2.24 A complement to global equities, not a duplicate</a:t>
+              <a:t>2.5.3 A complement to global equities, not a duplicate</a:t>
             </a:r>
           </a:p>
         </p:txBody>
@@ -53654,7 +53654,7 @@
                 </a:solidFill>
                 <a:latin typeface="Times New Roman"/>
               </a:rPr>
-              <a:t>2.25 What a blend does to the whole portfolio</a:t>
+              <a:t>2.5.4 What a blend does to the whole portfolio</a:t>
             </a:r>
           </a:p>
         </p:txBody>
@@ -55029,7 +55029,7 @@
                 </a:solidFill>
                 <a:latin typeface="Times New Roman"/>
               </a:rPr>
-              <a:t>2.26 What allocators actually earn from private equity</a:t>
+              <a:t>2.6.1 What allocators actually earn from private equity</a:t>
             </a:r>
           </a:p>
         </p:txBody>
@@ -55905,7 +55905,7 @@
                 </a:solidFill>
                 <a:latin typeface="Times New Roman"/>
               </a:rPr>
-              <a:t>2.27 Switching a private-equity sleeve into Athanase</a:t>
+              <a:t>2.6.2 Switching a private-equity sleeve into Athanase</a:t>
             </a:r>
           </a:p>
         </p:txBody>
@@ -57289,7 +57289,7 @@
                 </a:solidFill>
                 <a:latin typeface="Times New Roman"/>
               </a:rPr>
-              <a:t>2.28 The volatility gap is settled in the literature</a:t>
+              <a:t>2.6.3 The volatility gap is settled in the literature</a:t>
             </a:r>
           </a:p>
         </p:txBody>
@@ -58293,7 +58293,7 @@
                 </a:solidFill>
                 <a:latin typeface="Times New Roman"/>
               </a:rPr>
-              <a:t>2.29 Same headline volatility — far lower real risk</a:t>
+              <a:t>2.6.4 Same headline volatility — far lower real risk</a:t>
             </a:r>
           </a:p>
         </p:txBody>
@@ -59195,7 +59195,7 @@
                 </a:solidFill>
                 <a:latin typeface="Times New Roman"/>
               </a:rPr>
-              <a:t>2.30 PE’s “diversification” is an artefact — Athanase’s is real</a:t>
+              <a:t>2.6.5 PE’s “diversification” is an artefact — Athanase’s is real</a:t>
             </a:r>
           </a:p>
         </p:txBody>
@@ -60029,7 +60029,7 @@
                 </a:solidFill>
                 <a:latin typeface="Times New Roman"/>
               </a:rPr>
-              <a:t>2.31 When the tide goes out: the drawdown trap</a:t>
+              <a:t>2.6.6 When the tide goes out: the drawdown trap</a:t>
             </a:r>
           </a:p>
         </p:txBody>
@@ -61307,7 +61307,7 @@
                 </a:solidFill>
                 <a:latin typeface="Times New Roman"/>
               </a:rPr>
-              <a:t>2.32 Responsible ownership, by construction</a:t>
+              <a:t>2.6.7 Responsible ownership, by construction</a:t>
             </a:r>
           </a:p>
         </p:txBody>

</xml_diff>

<commit_message>
Renumber deck: Part I uses 1-7, Part II uses sub.n (1.1-6.6)
Simplify the numbering scheme so the two Parts carry the part distinction
rather than a leading section digit. Part I sections are 1-7; Part II
sections are numbered {sub-section}.{n} (e.g. 1.1, 2.1) since there are
only two Parts and a 2.1.1 form would only make sense with a Part 3+.

The Contents page Part II column now shows the six sub-section group
headers with indented entries, using a denser layout so all 38 lines fit
on the slide.
</commit_message>
<xml_diff>
--- a/Athanase_Engaged_Ownership_Allocator_Deck.pptx
+++ b/Athanase_Engaged_Ownership_Allocator_Deck.pptx
@@ -4861,7 +4861,7 @@
                 </a:solidFill>
                 <a:latin typeface="Times New Roman"/>
               </a:rPr>
-              <a:t>1.7 What separates a great engaged owner</a:t>
+              <a:t>7 What separates a great engaged owner</a:t>
             </a:r>
           </a:p>
         </p:txBody>
@@ -6070,7 +6070,7 @@
                 </a:solidFill>
                 <a:latin typeface="Times New Roman"/>
               </a:rPr>
-              <a:t>2.1.1 Athanase at a glance</a:t>
+              <a:t>1.1 Athanase at a glance</a:t>
             </a:r>
           </a:p>
         </p:txBody>
@@ -6998,7 +6998,7 @@
                 </a:solidFill>
                 <a:latin typeface="Times New Roman"/>
               </a:rPr>
-              <a:t>2.1.2 An integrated team, 20 years together</a:t>
+              <a:t>1.2 An integrated team, 20 years together</a:t>
             </a:r>
           </a:p>
         </p:txBody>
@@ -8068,7 +8068,7 @@
                 </a:solidFill>
                 <a:latin typeface="Times New Roman"/>
               </a:rPr>
-              <a:t>2.1.3 The people behind the track record</a:t>
+              <a:t>1.3 The people behind the track record</a:t>
             </a:r>
           </a:p>
         </p:txBody>
@@ -10504,7 +10504,7 @@
                 </a:solidFill>
                 <a:latin typeface="Times New Roman"/>
               </a:rPr>
-              <a:t>2.1.4 A disciplined, repeatable selection process</a:t>
+              <a:t>1.4 A disciplined, repeatable selection process</a:t>
             </a:r>
           </a:p>
         </p:txBody>
@@ -12040,7 +12040,7 @@
                 </a:solidFill>
                 <a:latin typeface="Times New Roman"/>
               </a:rPr>
-              <a:t>2.1.5 A risk system that engineers out permanent loss</a:t>
+              <a:t>1.5 A risk system that engineers out permanent loss</a:t>
             </a:r>
           </a:p>
         </p:txBody>
@@ -13148,7 +13148,7 @@
                 </a:solidFill>
                 <a:latin typeface="Times New Roman"/>
               </a:rPr>
-              <a:t>2.1.6 The ownership playbook, honed over 40 investments</a:t>
+              <a:t>1.6 The ownership playbook, honed over 40 investments</a:t>
             </a:r>
           </a:p>
         </p:txBody>
@@ -15118,8 +15118,8 @@
         </p:nvSpPr>
         <p:spPr>
           <a:xfrm>
-            <a:off x="512076" y="2389632"/>
-            <a:ext cx="4279499" cy="4584192"/>
+            <a:off x="512076" y="2311603"/>
+            <a:ext cx="4279499" cy="5559552"/>
           </a:xfrm>
           <a:prstGeom prst="rect">
             <a:avLst/>
@@ -15134,7 +15134,7 @@
           <a:p>
             <a:pPr>
               <a:lnSpc>
-                <a:spcPct val="103000"/>
+                <a:spcPct val="102000"/>
               </a:lnSpc>
               <a:spcAft>
                 <a:spcPts val="700"/>
@@ -15147,7 +15147,7 @@
                 </a:solidFill>
                 <a:latin typeface="Arial"/>
               </a:rPr>
-              <a:t>1.1   </a:t>
+              <a:t>1   </a:t>
             </a:r>
             <a:r>
               <a:rPr sz="919">
@@ -15162,7 +15162,7 @@
           <a:p>
             <a:pPr>
               <a:lnSpc>
-                <a:spcPct val="103000"/>
+                <a:spcPct val="102000"/>
               </a:lnSpc>
               <a:spcAft>
                 <a:spcPts val="700"/>
@@ -15175,7 +15175,7 @@
                 </a:solidFill>
                 <a:latin typeface="Arial"/>
               </a:rPr>
-              <a:t>1.2   </a:t>
+              <a:t>2   </a:t>
             </a:r>
             <a:r>
               <a:rPr sz="919">
@@ -15190,7 +15190,7 @@
           <a:p>
             <a:pPr>
               <a:lnSpc>
-                <a:spcPct val="103000"/>
+                <a:spcPct val="102000"/>
               </a:lnSpc>
               <a:spcAft>
                 <a:spcPts val="700"/>
@@ -15203,7 +15203,7 @@
                 </a:solidFill>
                 <a:latin typeface="Arial"/>
               </a:rPr>
-              <a:t>1.3   </a:t>
+              <a:t>3   </a:t>
             </a:r>
             <a:r>
               <a:rPr sz="919">
@@ -15218,7 +15218,7 @@
           <a:p>
             <a:pPr>
               <a:lnSpc>
-                <a:spcPct val="103000"/>
+                <a:spcPct val="102000"/>
               </a:lnSpc>
               <a:spcAft>
                 <a:spcPts val="700"/>
@@ -15231,7 +15231,7 @@
                 </a:solidFill>
                 <a:latin typeface="Arial"/>
               </a:rPr>
-              <a:t>1.4   </a:t>
+              <a:t>4   </a:t>
             </a:r>
             <a:r>
               <a:rPr sz="919">
@@ -15246,7 +15246,7 @@
           <a:p>
             <a:pPr>
               <a:lnSpc>
-                <a:spcPct val="103000"/>
+                <a:spcPct val="102000"/>
               </a:lnSpc>
               <a:spcAft>
                 <a:spcPts val="700"/>
@@ -15259,7 +15259,7 @@
                 </a:solidFill>
                 <a:latin typeface="Arial"/>
               </a:rPr>
-              <a:t>1.5   </a:t>
+              <a:t>5   </a:t>
             </a:r>
             <a:r>
               <a:rPr sz="919">
@@ -15283,7 +15283,7 @@
           <a:p>
             <a:pPr>
               <a:lnSpc>
-                <a:spcPct val="103000"/>
+                <a:spcPct val="102000"/>
               </a:lnSpc>
               <a:spcAft>
                 <a:spcPts val="700"/>
@@ -15296,7 +15296,7 @@
                 </a:solidFill>
                 <a:latin typeface="Arial"/>
               </a:rPr>
-              <a:t>1.6   </a:t>
+              <a:t>6   </a:t>
             </a:r>
             <a:r>
               <a:rPr sz="919">
@@ -15311,7 +15311,7 @@
           <a:p>
             <a:pPr>
               <a:lnSpc>
-                <a:spcPct val="103000"/>
+                <a:spcPct val="102000"/>
               </a:lnSpc>
               <a:spcAft>
                 <a:spcPts val="700"/>
@@ -15324,7 +15324,7 @@
                 </a:solidFill>
                 <a:latin typeface="Arial"/>
               </a:rPr>
-              <a:t>1.7   </a:t>
+              <a:t>7   </a:t>
             </a:r>
             <a:r>
               <a:rPr sz="919">
@@ -15388,8 +15388,8 @@
         </p:nvSpPr>
         <p:spPr>
           <a:xfrm>
-            <a:off x="5157345" y="2389632"/>
-            <a:ext cx="4279499" cy="4584192"/>
+            <a:off x="5157345" y="2311603"/>
+            <a:ext cx="4279499" cy="5559552"/>
           </a:xfrm>
           <a:prstGeom prst="rect">
             <a:avLst/>
@@ -15404,51 +15404,73 @@
           <a:p>
             <a:pPr>
               <a:lnSpc>
-                <a:spcPct val="103000"/>
-              </a:lnSpc>
-              <a:spcAft>
-                <a:spcPts val="450"/>
-              </a:spcAft>
-            </a:pPr>
-            <a:r>
-              <a:rPr sz="840" b="1">
+                <a:spcPct val="100000"/>
+              </a:lnSpc>
+              <a:spcBef>
+                <a:spcPts val="0"/>
+              </a:spcBef>
+              <a:spcAft>
+                <a:spcPts val="150"/>
+              </a:spcAft>
+            </a:pPr>
+            <a:r>
+              <a:rPr sz="760" b="1">
                 <a:solidFill>
                   <a:srgbClr val="314359"/>
                 </a:solidFill>
-                <a:latin typeface="Arial"/>
-              </a:rPr>
-              <a:t>2.1.1   </a:t>
-            </a:r>
-            <a:r>
-              <a:rPr sz="840">
+                <a:latin typeface="Times New Roman"/>
+              </a:rPr>
+              <a:t>1   Team &amp; operations</a:t>
+            </a:r>
+          </a:p>
+          <a:p>
+            <a:pPr>
+              <a:lnSpc>
+                <a:spcPct val="100000"/>
+              </a:lnSpc>
+              <a:spcAft>
+                <a:spcPts val="150"/>
+              </a:spcAft>
+            </a:pPr>
+            <a:r>
+              <a:rPr sz="720" b="0">
                 <a:solidFill>
                   <a:srgbClr val="314359"/>
                 </a:solidFill>
                 <a:latin typeface="Arial"/>
               </a:rPr>
+              <a:t>      1.1   </a:t>
+            </a:r>
+            <a:r>
+              <a:rPr sz="720">
+                <a:solidFill>
+                  <a:srgbClr val="314359"/>
+                </a:solidFill>
+                <a:latin typeface="Arial"/>
+              </a:rPr>
               <a:t>Athanase at a glance</a:t>
             </a:r>
           </a:p>
           <a:p>
             <a:pPr>
               <a:lnSpc>
-                <a:spcPct val="103000"/>
-              </a:lnSpc>
-              <a:spcAft>
-                <a:spcPts val="450"/>
-              </a:spcAft>
-            </a:pPr>
-            <a:r>
-              <a:rPr sz="840" b="1">
+                <a:spcPct val="100000"/>
+              </a:lnSpc>
+              <a:spcAft>
+                <a:spcPts val="150"/>
+              </a:spcAft>
+            </a:pPr>
+            <a:r>
+              <a:rPr sz="720" b="0">
                 <a:solidFill>
                   <a:srgbClr val="314359"/>
                 </a:solidFill>
                 <a:latin typeface="Arial"/>
               </a:rPr>
-              <a:t>2.1.2   </a:t>
-            </a:r>
-            <a:r>
-              <a:rPr sz="840">
+              <a:t>      1.2   </a:t>
+            </a:r>
+            <a:r>
+              <a:rPr sz="720">
                 <a:solidFill>
                   <a:srgbClr val="314359"/>
                 </a:solidFill>
@@ -15460,23 +15482,23 @@
           <a:p>
             <a:pPr>
               <a:lnSpc>
-                <a:spcPct val="103000"/>
-              </a:lnSpc>
-              <a:spcAft>
-                <a:spcPts val="450"/>
-              </a:spcAft>
-            </a:pPr>
-            <a:r>
-              <a:rPr sz="840" b="1">
+                <a:spcPct val="100000"/>
+              </a:lnSpc>
+              <a:spcAft>
+                <a:spcPts val="150"/>
+              </a:spcAft>
+            </a:pPr>
+            <a:r>
+              <a:rPr sz="720" b="0">
                 <a:solidFill>
                   <a:srgbClr val="314359"/>
                 </a:solidFill>
                 <a:latin typeface="Arial"/>
               </a:rPr>
-              <a:t>2.1.3   </a:t>
-            </a:r>
-            <a:r>
-              <a:rPr sz="840">
+              <a:t>      1.3   </a:t>
+            </a:r>
+            <a:r>
+              <a:rPr sz="720">
                 <a:solidFill>
                   <a:srgbClr val="314359"/>
                 </a:solidFill>
@@ -15488,23 +15510,23 @@
           <a:p>
             <a:pPr>
               <a:lnSpc>
-                <a:spcPct val="103000"/>
-              </a:lnSpc>
-              <a:spcAft>
-                <a:spcPts val="450"/>
-              </a:spcAft>
-            </a:pPr>
-            <a:r>
-              <a:rPr sz="840" b="1">
+                <a:spcPct val="100000"/>
+              </a:lnSpc>
+              <a:spcAft>
+                <a:spcPts val="150"/>
+              </a:spcAft>
+            </a:pPr>
+            <a:r>
+              <a:rPr sz="720" b="0">
                 <a:solidFill>
                   <a:srgbClr val="314359"/>
                 </a:solidFill>
                 <a:latin typeface="Arial"/>
               </a:rPr>
-              <a:t>2.1.4   </a:t>
-            </a:r>
-            <a:r>
-              <a:rPr sz="840">
+              <a:t>      1.4   </a:t>
+            </a:r>
+            <a:r>
+              <a:rPr sz="720">
                 <a:solidFill>
                   <a:srgbClr val="314359"/>
                 </a:solidFill>
@@ -15513,7 +15535,7 @@
               <a:t>A disciplined, repeatable selection process</a:t>
             </a:r>
             <a:r>
-              <a:rPr sz="680" i="1">
+              <a:rPr sz="560" i="1">
                 <a:solidFill>
                   <a:srgbClr val="556A83"/>
                 </a:solidFill>
@@ -15525,23 +15547,23 @@
           <a:p>
             <a:pPr>
               <a:lnSpc>
-                <a:spcPct val="103000"/>
-              </a:lnSpc>
-              <a:spcAft>
-                <a:spcPts val="450"/>
-              </a:spcAft>
-            </a:pPr>
-            <a:r>
-              <a:rPr sz="840" b="1">
+                <a:spcPct val="100000"/>
+              </a:lnSpc>
+              <a:spcAft>
+                <a:spcPts val="150"/>
+              </a:spcAft>
+            </a:pPr>
+            <a:r>
+              <a:rPr sz="720" b="0">
                 <a:solidFill>
                   <a:srgbClr val="314359"/>
                 </a:solidFill>
                 <a:latin typeface="Arial"/>
               </a:rPr>
-              <a:t>2.1.5   </a:t>
-            </a:r>
-            <a:r>
-              <a:rPr sz="840">
+              <a:t>      1.5   </a:t>
+            </a:r>
+            <a:r>
+              <a:rPr sz="720">
                 <a:solidFill>
                   <a:srgbClr val="314359"/>
                 </a:solidFill>
@@ -15550,7 +15572,7 @@
               <a:t>A risk system that engineers out permanent loss</a:t>
             </a:r>
             <a:r>
-              <a:rPr sz="680" i="1">
+              <a:rPr sz="560" i="1">
                 <a:solidFill>
                   <a:srgbClr val="556A83"/>
                 </a:solidFill>
@@ -15562,23 +15584,23 @@
           <a:p>
             <a:pPr>
               <a:lnSpc>
-                <a:spcPct val="103000"/>
-              </a:lnSpc>
-              <a:spcAft>
-                <a:spcPts val="450"/>
-              </a:spcAft>
-            </a:pPr>
-            <a:r>
-              <a:rPr sz="840" b="1">
+                <a:spcPct val="100000"/>
+              </a:lnSpc>
+              <a:spcAft>
+                <a:spcPts val="150"/>
+              </a:spcAft>
+            </a:pPr>
+            <a:r>
+              <a:rPr sz="720" b="0">
                 <a:solidFill>
                   <a:srgbClr val="314359"/>
                 </a:solidFill>
                 <a:latin typeface="Arial"/>
               </a:rPr>
-              <a:t>2.1.6   </a:t>
-            </a:r>
-            <a:r>
-              <a:rPr sz="840">
+              <a:t>      1.6   </a:t>
+            </a:r>
+            <a:r>
+              <a:rPr sz="720">
                 <a:solidFill>
                   <a:srgbClr val="314359"/>
                 </a:solidFill>
@@ -15590,32 +15612,54 @@
           <a:p>
             <a:pPr>
               <a:lnSpc>
-                <a:spcPct val="103000"/>
-              </a:lnSpc>
-              <a:spcAft>
-                <a:spcPts val="450"/>
-              </a:spcAft>
-            </a:pPr>
-            <a:r>
-              <a:rPr sz="840" b="1">
+                <a:spcPct val="100000"/>
+              </a:lnSpc>
+              <a:spcBef>
+                <a:spcPts val="300"/>
+              </a:spcBef>
+              <a:spcAft>
+                <a:spcPts val="150"/>
+              </a:spcAft>
+            </a:pPr>
+            <a:r>
+              <a:rPr sz="760" b="1">
                 <a:solidFill>
                   <a:srgbClr val="314359"/>
                 </a:solidFill>
-                <a:latin typeface="Arial"/>
-              </a:rPr>
-              <a:t>2.2.1   </a:t>
-            </a:r>
-            <a:r>
-              <a:rPr sz="840">
+                <a:latin typeface="Times New Roman"/>
+              </a:rPr>
+              <a:t>2   The opportunity &amp; our edge</a:t>
+            </a:r>
+          </a:p>
+          <a:p>
+            <a:pPr>
+              <a:lnSpc>
+                <a:spcPct val="100000"/>
+              </a:lnSpc>
+              <a:spcAft>
+                <a:spcPts val="150"/>
+              </a:spcAft>
+            </a:pPr>
+            <a:r>
+              <a:rPr sz="720" b="0">
                 <a:solidFill>
                   <a:srgbClr val="314359"/>
                 </a:solidFill>
                 <a:latin typeface="Arial"/>
               </a:rPr>
+              <a:t>      2.1   </a:t>
+            </a:r>
+            <a:r>
+              <a:rPr sz="720">
+                <a:solidFill>
+                  <a:srgbClr val="314359"/>
+                </a:solidFill>
+                <a:latin typeface="Arial"/>
+              </a:rPr>
               <a:t>The inefficiency Athanase harvests</a:t>
             </a:r>
             <a:r>
-              <a:rPr sz="680" i="1">
+              <a:rPr sz="560" i="1">
                 <a:solidFill>
                   <a:srgbClr val="556A83"/>
                 </a:solidFill>
@@ -15627,23 +15671,23 @@
           <a:p>
             <a:pPr>
               <a:lnSpc>
-                <a:spcPct val="103000"/>
-              </a:lnSpc>
-              <a:spcAft>
-                <a:spcPts val="450"/>
-              </a:spcAft>
-            </a:pPr>
-            <a:r>
-              <a:rPr sz="840" b="1">
+                <a:spcPct val="100000"/>
+              </a:lnSpc>
+              <a:spcAft>
+                <a:spcPts val="150"/>
+              </a:spcAft>
+            </a:pPr>
+            <a:r>
+              <a:rPr sz="720" b="0">
                 <a:solidFill>
                   <a:srgbClr val="314359"/>
                 </a:solidFill>
                 <a:latin typeface="Arial"/>
               </a:rPr>
-              <a:t>2.2.2   </a:t>
-            </a:r>
-            <a:r>
-              <a:rPr sz="840">
+              <a:t>      2.2   </a:t>
+            </a:r>
+            <a:r>
+              <a:rPr sz="720">
                 <a:solidFill>
                   <a:srgbClr val="314359"/>
                 </a:solidFill>
@@ -15652,7 +15696,7 @@
               <a:t>We don’t buy broken companies — we buy hidden cores</a:t>
             </a:r>
             <a:r>
-              <a:rPr sz="680" i="1">
+              <a:rPr sz="560" i="1">
                 <a:solidFill>
                   <a:srgbClr val="556A83"/>
                 </a:solidFill>
@@ -15664,23 +15708,23 @@
           <a:p>
             <a:pPr>
               <a:lnSpc>
-                <a:spcPct val="103000"/>
-              </a:lnSpc>
-              <a:spcAft>
-                <a:spcPts val="450"/>
-              </a:spcAft>
-            </a:pPr>
-            <a:r>
-              <a:rPr sz="840" b="1">
+                <a:spcPct val="100000"/>
+              </a:lnSpc>
+              <a:spcAft>
+                <a:spcPts val="150"/>
+              </a:spcAft>
+            </a:pPr>
+            <a:r>
+              <a:rPr sz="720" b="0">
                 <a:solidFill>
                   <a:srgbClr val="314359"/>
                 </a:solidFill>
                 <a:latin typeface="Arial"/>
               </a:rPr>
-              <a:t>2.2.3   </a:t>
-            </a:r>
-            <a:r>
-              <a:rPr sz="840">
+              <a:t>      2.3   </a:t>
+            </a:r>
+            <a:r>
+              <a:rPr sz="720">
                 <a:solidFill>
                   <a:srgbClr val="314359"/>
                 </a:solidFill>
@@ -15689,7 +15733,7 @@
               <a:t>Quality-core constructivism — how we differ</a:t>
             </a:r>
             <a:r>
-              <a:rPr sz="680" i="1">
+              <a:rPr sz="560" i="1">
                 <a:solidFill>
                   <a:srgbClr val="556A83"/>
                 </a:solidFill>
@@ -15701,23 +15745,23 @@
           <a:p>
             <a:pPr>
               <a:lnSpc>
-                <a:spcPct val="103000"/>
-              </a:lnSpc>
-              <a:spcAft>
-                <a:spcPts val="450"/>
-              </a:spcAft>
-            </a:pPr>
-            <a:r>
-              <a:rPr sz="840" b="1">
+                <a:spcPct val="100000"/>
+              </a:lnSpc>
+              <a:spcAft>
+                <a:spcPts val="150"/>
+              </a:spcAft>
+            </a:pPr>
+            <a:r>
+              <a:rPr sz="720" b="0">
                 <a:solidFill>
                   <a:srgbClr val="314359"/>
                 </a:solidFill>
                 <a:latin typeface="Arial"/>
               </a:rPr>
-              <a:t>2.2.4   </a:t>
-            </a:r>
-            <a:r>
-              <a:rPr sz="840">
+              <a:t>      2.4   </a:t>
+            </a:r>
+            <a:r>
+              <a:rPr sz="720">
                 <a:solidFill>
                   <a:srgbClr val="314359"/>
                 </a:solidFill>
@@ -15726,7 +15770,7 @@
               <a:t>We don’t need to be right more than ~50%</a:t>
             </a:r>
             <a:r>
-              <a:rPr sz="680" i="1">
+              <a:rPr sz="560" i="1">
                 <a:solidFill>
                   <a:srgbClr val="556A83"/>
                 </a:solidFill>
@@ -15738,23 +15782,23 @@
           <a:p>
             <a:pPr>
               <a:lnSpc>
-                <a:spcPct val="103000"/>
-              </a:lnSpc>
-              <a:spcAft>
-                <a:spcPts val="450"/>
-              </a:spcAft>
-            </a:pPr>
-            <a:r>
-              <a:rPr sz="840" b="1">
+                <a:spcPct val="100000"/>
+              </a:lnSpc>
+              <a:spcAft>
+                <a:spcPts val="150"/>
+              </a:spcAft>
+            </a:pPr>
+            <a:r>
+              <a:rPr sz="720" b="0">
                 <a:solidFill>
                   <a:srgbClr val="314359"/>
                 </a:solidFill>
                 <a:latin typeface="Arial"/>
               </a:rPr>
-              <a:t>2.2.5   </a:t>
-            </a:r>
-            <a:r>
-              <a:rPr sz="840">
+              <a:t>      2.5   </a:t>
+            </a:r>
+            <a:r>
+              <a:rPr sz="720">
                 <a:solidFill>
                   <a:srgbClr val="314359"/>
                 </a:solidFill>
@@ -15763,7 +15807,7 @@
               <a:t>The same playbook as mid-market PE — without its costs</a:t>
             </a:r>
             <a:r>
-              <a:rPr sz="680" i="1">
+              <a:rPr sz="560" i="1">
                 <a:solidFill>
                   <a:srgbClr val="556A83"/>
                 </a:solidFill>
@@ -15775,51 +15819,73 @@
           <a:p>
             <a:pPr>
               <a:lnSpc>
-                <a:spcPct val="103000"/>
-              </a:lnSpc>
-              <a:spcAft>
-                <a:spcPts val="450"/>
-              </a:spcAft>
-            </a:pPr>
-            <a:r>
-              <a:rPr sz="840" b="1">
+                <a:spcPct val="100000"/>
+              </a:lnSpc>
+              <a:spcBef>
+                <a:spcPts val="300"/>
+              </a:spcBef>
+              <a:spcAft>
+                <a:spcPts val="150"/>
+              </a:spcAft>
+            </a:pPr>
+            <a:r>
+              <a:rPr sz="760" b="1">
                 <a:solidFill>
                   <a:srgbClr val="314359"/>
                 </a:solidFill>
-                <a:latin typeface="Arial"/>
-              </a:rPr>
-              <a:t>2.3.1   </a:t>
-            </a:r>
-            <a:r>
-              <a:rPr sz="840">
+                <a:latin typeface="Times New Roman"/>
+              </a:rPr>
+              <a:t>3   Risk, honestly</a:t>
+            </a:r>
+          </a:p>
+          <a:p>
+            <a:pPr>
+              <a:lnSpc>
+                <a:spcPct val="100000"/>
+              </a:lnSpc>
+              <a:spcAft>
+                <a:spcPts val="150"/>
+              </a:spcAft>
+            </a:pPr>
+            <a:r>
+              <a:rPr sz="720" b="0">
                 <a:solidFill>
                   <a:srgbClr val="314359"/>
                 </a:solidFill>
                 <a:latin typeface="Arial"/>
               </a:rPr>
+              <a:t>      3.1   </a:t>
+            </a:r>
+            <a:r>
+              <a:rPr sz="720">
+                <a:solidFill>
+                  <a:srgbClr val="314359"/>
+                </a:solidFill>
+                <a:latin typeface="Arial"/>
+              </a:rPr>
               <a:t>A risk system built to avoid permanent loss</a:t>
             </a:r>
           </a:p>
           <a:p>
             <a:pPr>
               <a:lnSpc>
-                <a:spcPct val="103000"/>
-              </a:lnSpc>
-              <a:spcAft>
-                <a:spcPts val="450"/>
-              </a:spcAft>
-            </a:pPr>
-            <a:r>
-              <a:rPr sz="840" b="1">
+                <a:spcPct val="100000"/>
+              </a:lnSpc>
+              <a:spcAft>
+                <a:spcPts val="150"/>
+              </a:spcAft>
+            </a:pPr>
+            <a:r>
+              <a:rPr sz="720" b="0">
                 <a:solidFill>
                   <a:srgbClr val="314359"/>
                 </a:solidFill>
                 <a:latin typeface="Arial"/>
               </a:rPr>
-              <a:t>2.3.2   </a:t>
-            </a:r>
-            <a:r>
-              <a:rPr sz="840">
+              <a:t>      3.2   </a:t>
+            </a:r>
+            <a:r>
+              <a:rPr sz="720">
                 <a:solidFill>
                   <a:srgbClr val="314359"/>
                 </a:solidFill>
@@ -15831,23 +15897,23 @@
           <a:p>
             <a:pPr>
               <a:lnSpc>
-                <a:spcPct val="103000"/>
-              </a:lnSpc>
-              <a:spcAft>
-                <a:spcPts val="450"/>
-              </a:spcAft>
-            </a:pPr>
-            <a:r>
-              <a:rPr sz="840" b="1">
+                <a:spcPct val="100000"/>
+              </a:lnSpc>
+              <a:spcAft>
+                <a:spcPts val="150"/>
+              </a:spcAft>
+            </a:pPr>
+            <a:r>
+              <a:rPr sz="720" b="0">
                 <a:solidFill>
                   <a:srgbClr val="314359"/>
                 </a:solidFill>
                 <a:latin typeface="Arial"/>
               </a:rPr>
-              <a:t>2.3.3   </a:t>
-            </a:r>
-            <a:r>
-              <a:rPr sz="840">
+              <a:t>      3.3   </a:t>
+            </a:r>
+            <a:r>
+              <a:rPr sz="720">
                 <a:solidFill>
                   <a:srgbClr val="314359"/>
                 </a:solidFill>
@@ -15856,7 +15922,7 @@
               <a:t>A non-linear path — honestly priced</a:t>
             </a:r>
             <a:r>
-              <a:rPr sz="680" i="1">
+              <a:rPr sz="560" i="1">
                 <a:solidFill>
                   <a:srgbClr val="556A83"/>
                 </a:solidFill>
@@ -15868,23 +15934,23 @@
           <a:p>
             <a:pPr>
               <a:lnSpc>
-                <a:spcPct val="103000"/>
-              </a:lnSpc>
-              <a:spcAft>
-                <a:spcPts val="450"/>
-              </a:spcAft>
-            </a:pPr>
-            <a:r>
-              <a:rPr sz="840" b="1">
+                <a:spcPct val="100000"/>
+              </a:lnSpc>
+              <a:spcAft>
+                <a:spcPts val="150"/>
+              </a:spcAft>
+            </a:pPr>
+            <a:r>
+              <a:rPr sz="720" b="0">
                 <a:solidFill>
                   <a:srgbClr val="314359"/>
                 </a:solidFill>
                 <a:latin typeface="Arial"/>
               </a:rPr>
-              <a:t>2.3.4   </a:t>
-            </a:r>
-            <a:r>
-              <a:rPr sz="840">
+              <a:t>      3.4   </a:t>
+            </a:r>
+            <a:r>
+              <a:rPr sz="720">
                 <a:solidFill>
                   <a:srgbClr val="314359"/>
                 </a:solidFill>
@@ -15893,7 +15959,7 @@
               <a:t>Risk reframing for the investment committee</a:t>
             </a:r>
             <a:r>
-              <a:rPr sz="680" i="1">
+              <a:rPr sz="560" i="1">
                 <a:solidFill>
                   <a:srgbClr val="556A83"/>
                 </a:solidFill>
@@ -15905,32 +15971,54 @@
           <a:p>
             <a:pPr>
               <a:lnSpc>
-                <a:spcPct val="103000"/>
-              </a:lnSpc>
-              <a:spcAft>
-                <a:spcPts val="450"/>
-              </a:spcAft>
-            </a:pPr>
-            <a:r>
-              <a:rPr sz="840" b="1">
+                <a:spcPct val="100000"/>
+              </a:lnSpc>
+              <a:spcBef>
+                <a:spcPts val="300"/>
+              </a:spcBef>
+              <a:spcAft>
+                <a:spcPts val="150"/>
+              </a:spcAft>
+            </a:pPr>
+            <a:r>
+              <a:rPr sz="760" b="1">
                 <a:solidFill>
                   <a:srgbClr val="314359"/>
                 </a:solidFill>
-                <a:latin typeface="Arial"/>
-              </a:rPr>
-              <a:t>2.4.1   </a:t>
-            </a:r>
-            <a:r>
-              <a:rPr sz="840">
+                <a:latin typeface="Times New Roman"/>
+              </a:rPr>
+              <a:t>4   The 20-year track record</a:t>
+            </a:r>
+          </a:p>
+          <a:p>
+            <a:pPr>
+              <a:lnSpc>
+                <a:spcPct val="100000"/>
+              </a:lnSpc>
+              <a:spcAft>
+                <a:spcPts val="150"/>
+              </a:spcAft>
+            </a:pPr>
+            <a:r>
+              <a:rPr sz="720" b="0">
                 <a:solidFill>
                   <a:srgbClr val="314359"/>
                 </a:solidFill>
                 <a:latin typeface="Arial"/>
               </a:rPr>
+              <a:t>      4.1   </a:t>
+            </a:r>
+            <a:r>
+              <a:rPr sz="720">
+                <a:solidFill>
+                  <a:srgbClr val="314359"/>
+                </a:solidFill>
+                <a:latin typeface="Arial"/>
+              </a:rPr>
               <a:t>Proof: outperformance with downside protection</a:t>
             </a:r>
             <a:r>
-              <a:rPr sz="680" i="1">
+              <a:rPr sz="560" i="1">
                 <a:solidFill>
                   <a:srgbClr val="556A83"/>
                 </a:solidFill>
@@ -15942,23 +16030,23 @@
           <a:p>
             <a:pPr>
               <a:lnSpc>
-                <a:spcPct val="103000"/>
-              </a:lnSpc>
-              <a:spcAft>
-                <a:spcPts val="450"/>
-              </a:spcAft>
-            </a:pPr>
-            <a:r>
-              <a:rPr sz="840" b="1">
+                <a:spcPct val="100000"/>
+              </a:lnSpc>
+              <a:spcAft>
+                <a:spcPts val="150"/>
+              </a:spcAft>
+            </a:pPr>
+            <a:r>
+              <a:rPr sz="720" b="0">
                 <a:solidFill>
                   <a:srgbClr val="314359"/>
                 </a:solidFill>
                 <a:latin typeface="Arial"/>
               </a:rPr>
-              <a:t>2.4.2   </a:t>
-            </a:r>
-            <a:r>
-              <a:rPr sz="840">
+              <a:t>      4.2   </a:t>
+            </a:r>
+            <a:r>
+              <a:rPr sz="720">
                 <a:solidFill>
                   <a:srgbClr val="314359"/>
                 </a:solidFill>
@@ -15967,7 +16055,7 @@
               <a:t>AIP Fund II — transactions (2015–present)</a:t>
             </a:r>
             <a:r>
-              <a:rPr sz="680" i="1">
+              <a:rPr sz="560" i="1">
                 <a:solidFill>
                   <a:srgbClr val="556A83"/>
                 </a:solidFill>
@@ -15979,23 +16067,23 @@
           <a:p>
             <a:pPr>
               <a:lnSpc>
-                <a:spcPct val="103000"/>
-              </a:lnSpc>
-              <a:spcAft>
-                <a:spcPts val="450"/>
-              </a:spcAft>
-            </a:pPr>
-            <a:r>
-              <a:rPr sz="840" b="1">
+                <a:spcPct val="100000"/>
+              </a:lnSpc>
+              <a:spcAft>
+                <a:spcPts val="150"/>
+              </a:spcAft>
+            </a:pPr>
+            <a:r>
+              <a:rPr sz="720" b="0">
                 <a:solidFill>
                   <a:srgbClr val="314359"/>
                 </a:solidFill>
                 <a:latin typeface="Arial"/>
               </a:rPr>
-              <a:t>2.4.3   </a:t>
-            </a:r>
-            <a:r>
-              <a:rPr sz="840">
+              <a:t>      4.3   </a:t>
+            </a:r>
+            <a:r>
+              <a:rPr sz="720">
                 <a:solidFill>
                   <a:srgbClr val="314359"/>
                 </a:solidFill>
@@ -16004,7 +16092,7 @@
               <a:t>Prior period — transactions (2006–2014)</a:t>
             </a:r>
             <a:r>
-              <a:rPr sz="680" i="1">
+              <a:rPr sz="560" i="1">
                 <a:solidFill>
                   <a:srgbClr val="556A83"/>
                 </a:solidFill>
@@ -16016,23 +16104,23 @@
           <a:p>
             <a:pPr>
               <a:lnSpc>
-                <a:spcPct val="103000"/>
-              </a:lnSpc>
-              <a:spcAft>
-                <a:spcPts val="450"/>
-              </a:spcAft>
-            </a:pPr>
-            <a:r>
-              <a:rPr sz="840" b="1">
+                <a:spcPct val="100000"/>
+              </a:lnSpc>
+              <a:spcAft>
+                <a:spcPts val="150"/>
+              </a:spcAft>
+            </a:pPr>
+            <a:r>
+              <a:rPr sz="720" b="0">
                 <a:solidFill>
                   <a:srgbClr val="314359"/>
                 </a:solidFill>
                 <a:latin typeface="Arial"/>
               </a:rPr>
-              <a:t>2.4.4   </a:t>
-            </a:r>
-            <a:r>
-              <a:rPr sz="840">
+              <a:t>      4.4   </a:t>
+            </a:r>
+            <a:r>
+              <a:rPr sz="720">
                 <a:solidFill>
                   <a:srgbClr val="314359"/>
                 </a:solidFill>
@@ -16044,23 +16132,23 @@
           <a:p>
             <a:pPr>
               <a:lnSpc>
-                <a:spcPct val="103000"/>
-              </a:lnSpc>
-              <a:spcAft>
-                <a:spcPts val="450"/>
-              </a:spcAft>
-            </a:pPr>
-            <a:r>
-              <a:rPr sz="840" b="1">
+                <a:spcPct val="100000"/>
+              </a:lnSpc>
+              <a:spcAft>
+                <a:spcPts val="150"/>
+              </a:spcAft>
+            </a:pPr>
+            <a:r>
+              <a:rPr sz="720" b="0">
                 <a:solidFill>
                   <a:srgbClr val="314359"/>
                 </a:solidFill>
                 <a:latin typeface="Arial"/>
               </a:rPr>
-              <a:t>2.4.5   </a:t>
-            </a:r>
-            <a:r>
-              <a:rPr sz="840">
+              <a:t>      4.5   </a:t>
+            </a:r>
+            <a:r>
+              <a:rPr sz="720">
                 <a:solidFill>
                   <a:srgbClr val="314359"/>
                 </a:solidFill>
@@ -16072,23 +16160,23 @@
           <a:p>
             <a:pPr>
               <a:lnSpc>
-                <a:spcPct val="103000"/>
-              </a:lnSpc>
-              <a:spcAft>
-                <a:spcPts val="450"/>
-              </a:spcAft>
-            </a:pPr>
-            <a:r>
-              <a:rPr sz="840" b="1">
+                <a:spcPct val="100000"/>
+              </a:lnSpc>
+              <a:spcAft>
+                <a:spcPts val="150"/>
+              </a:spcAft>
+            </a:pPr>
+            <a:r>
+              <a:rPr sz="720" b="0">
                 <a:solidFill>
                   <a:srgbClr val="314359"/>
                 </a:solidFill>
                 <a:latin typeface="Arial"/>
               </a:rPr>
-              <a:t>2.4.6   </a:t>
-            </a:r>
-            <a:r>
-              <a:rPr sz="840">
+              <a:t>      4.6   </a:t>
+            </a:r>
+            <a:r>
+              <a:rPr sz="720">
                 <a:solidFill>
                   <a:srgbClr val="314359"/>
                 </a:solidFill>
@@ -16100,32 +16188,54 @@
           <a:p>
             <a:pPr>
               <a:lnSpc>
-                <a:spcPct val="103000"/>
-              </a:lnSpc>
-              <a:spcAft>
-                <a:spcPts val="450"/>
-              </a:spcAft>
-            </a:pPr>
-            <a:r>
-              <a:rPr sz="840" b="1">
+                <a:spcPct val="100000"/>
+              </a:lnSpc>
+              <a:spcBef>
+                <a:spcPts val="300"/>
+              </a:spcBef>
+              <a:spcAft>
+                <a:spcPts val="150"/>
+              </a:spcAft>
+            </a:pPr>
+            <a:r>
+              <a:rPr sz="760" b="1">
                 <a:solidFill>
                   <a:srgbClr val="314359"/>
                 </a:solidFill>
-                <a:latin typeface="Arial"/>
-              </a:rPr>
-              <a:t>2.5.1   </a:t>
-            </a:r>
-            <a:r>
-              <a:rPr sz="840">
+                <a:latin typeface="Times New Roman"/>
+              </a:rPr>
+              <a:t>5   What it means for your portfolio</a:t>
+            </a:r>
+          </a:p>
+          <a:p>
+            <a:pPr>
+              <a:lnSpc>
+                <a:spcPct val="100000"/>
+              </a:lnSpc>
+              <a:spcAft>
+                <a:spcPts val="150"/>
+              </a:spcAft>
+            </a:pPr>
+            <a:r>
+              <a:rPr sz="720" b="0">
                 <a:solidFill>
                   <a:srgbClr val="314359"/>
                 </a:solidFill>
                 <a:latin typeface="Arial"/>
               </a:rPr>
+              <a:t>      5.1   </a:t>
+            </a:r>
+            <a:r>
+              <a:rPr sz="720">
+                <a:solidFill>
+                  <a:srgbClr val="314359"/>
+                </a:solidFill>
+                <a:latin typeface="Arial"/>
+              </a:rPr>
               <a:t>What it does to an allocator’s portfolio</a:t>
             </a:r>
             <a:r>
-              <a:rPr sz="680" i="1">
+              <a:rPr sz="560" i="1">
                 <a:solidFill>
                   <a:srgbClr val="556A83"/>
                 </a:solidFill>
@@ -16137,23 +16247,23 @@
           <a:p>
             <a:pPr>
               <a:lnSpc>
-                <a:spcPct val="103000"/>
-              </a:lnSpc>
-              <a:spcAft>
-                <a:spcPts val="450"/>
-              </a:spcAft>
-            </a:pPr>
-            <a:r>
-              <a:rPr sz="840" b="1">
+                <a:spcPct val="100000"/>
+              </a:lnSpc>
+              <a:spcAft>
+                <a:spcPts val="150"/>
+              </a:spcAft>
+            </a:pPr>
+            <a:r>
+              <a:rPr sz="720" b="0">
                 <a:solidFill>
                   <a:srgbClr val="314359"/>
                 </a:solidFill>
                 <a:latin typeface="Arial"/>
               </a:rPr>
-              <a:t>2.5.2   </a:t>
-            </a:r>
-            <a:r>
-              <a:rPr sz="840">
+              <a:t>      5.2   </a:t>
+            </a:r>
+            <a:r>
+              <a:rPr sz="720">
                 <a:solidFill>
                   <a:srgbClr val="314359"/>
                 </a:solidFill>
@@ -16162,7 +16272,7 @@
               <a:t>Lower downside risk compounds into better outcomes</a:t>
             </a:r>
             <a:r>
-              <a:rPr sz="680" i="1">
+              <a:rPr sz="560" i="1">
                 <a:solidFill>
                   <a:srgbClr val="556A83"/>
                 </a:solidFill>
@@ -16174,23 +16284,23 @@
           <a:p>
             <a:pPr>
               <a:lnSpc>
-                <a:spcPct val="103000"/>
-              </a:lnSpc>
-              <a:spcAft>
-                <a:spcPts val="450"/>
-              </a:spcAft>
-            </a:pPr>
-            <a:r>
-              <a:rPr sz="840" b="1">
+                <a:spcPct val="100000"/>
+              </a:lnSpc>
+              <a:spcAft>
+                <a:spcPts val="150"/>
+              </a:spcAft>
+            </a:pPr>
+            <a:r>
+              <a:rPr sz="720" b="0">
                 <a:solidFill>
                   <a:srgbClr val="314359"/>
                 </a:solidFill>
                 <a:latin typeface="Arial"/>
               </a:rPr>
-              <a:t>2.5.3   </a:t>
-            </a:r>
-            <a:r>
-              <a:rPr sz="840">
+              <a:t>      5.3   </a:t>
+            </a:r>
+            <a:r>
+              <a:rPr sz="720">
                 <a:solidFill>
                   <a:srgbClr val="314359"/>
                 </a:solidFill>
@@ -16199,7 +16309,7 @@
               <a:t>A complement to global equities, not a duplicate</a:t>
             </a:r>
             <a:r>
-              <a:rPr sz="680" i="1">
+              <a:rPr sz="560" i="1">
                 <a:solidFill>
                   <a:srgbClr val="556A83"/>
                 </a:solidFill>
@@ -16211,23 +16321,23 @@
           <a:p>
             <a:pPr>
               <a:lnSpc>
-                <a:spcPct val="103000"/>
-              </a:lnSpc>
-              <a:spcAft>
-                <a:spcPts val="450"/>
-              </a:spcAft>
-            </a:pPr>
-            <a:r>
-              <a:rPr sz="840" b="1">
+                <a:spcPct val="100000"/>
+              </a:lnSpc>
+              <a:spcAft>
+                <a:spcPts val="150"/>
+              </a:spcAft>
+            </a:pPr>
+            <a:r>
+              <a:rPr sz="720" b="0">
                 <a:solidFill>
                   <a:srgbClr val="314359"/>
                 </a:solidFill>
                 <a:latin typeface="Arial"/>
               </a:rPr>
-              <a:t>2.5.4   </a:t>
-            </a:r>
-            <a:r>
-              <a:rPr sz="840">
+              <a:t>      5.4   </a:t>
+            </a:r>
+            <a:r>
+              <a:rPr sz="720">
                 <a:solidFill>
                   <a:srgbClr val="314359"/>
                 </a:solidFill>
@@ -16236,7 +16346,7 @@
               <a:t>What a blend does to the whole portfolio</a:t>
             </a:r>
             <a:r>
-              <a:rPr sz="680" i="1">
+              <a:rPr sz="560" i="1">
                 <a:solidFill>
                   <a:srgbClr val="556A83"/>
                 </a:solidFill>
@@ -16248,32 +16358,54 @@
           <a:p>
             <a:pPr>
               <a:lnSpc>
-                <a:spcPct val="103000"/>
-              </a:lnSpc>
-              <a:spcAft>
-                <a:spcPts val="450"/>
-              </a:spcAft>
-            </a:pPr>
-            <a:r>
-              <a:rPr sz="840" b="1">
+                <a:spcPct val="100000"/>
+              </a:lnSpc>
+              <a:spcBef>
+                <a:spcPts val="300"/>
+              </a:spcBef>
+              <a:spcAft>
+                <a:spcPts val="150"/>
+              </a:spcAft>
+            </a:pPr>
+            <a:r>
+              <a:rPr sz="760" b="1">
                 <a:solidFill>
                   <a:srgbClr val="314359"/>
                 </a:solidFill>
-                <a:latin typeface="Arial"/>
-              </a:rPr>
-              <a:t>2.6.1   </a:t>
-            </a:r>
-            <a:r>
-              <a:rPr sz="840">
+                <a:latin typeface="Times New Roman"/>
+              </a:rPr>
+              <a:t>6   Versus private equity</a:t>
+            </a:r>
+          </a:p>
+          <a:p>
+            <a:pPr>
+              <a:lnSpc>
+                <a:spcPct val="100000"/>
+              </a:lnSpc>
+              <a:spcAft>
+                <a:spcPts val="150"/>
+              </a:spcAft>
+            </a:pPr>
+            <a:r>
+              <a:rPr sz="720" b="0">
                 <a:solidFill>
                   <a:srgbClr val="314359"/>
                 </a:solidFill>
                 <a:latin typeface="Arial"/>
               </a:rPr>
+              <a:t>      6.1   </a:t>
+            </a:r>
+            <a:r>
+              <a:rPr sz="720">
+                <a:solidFill>
+                  <a:srgbClr val="314359"/>
+                </a:solidFill>
+                <a:latin typeface="Arial"/>
+              </a:rPr>
               <a:t>What allocators actually earn from private equity</a:t>
             </a:r>
             <a:r>
-              <a:rPr sz="680" i="1">
+              <a:rPr sz="560" i="1">
                 <a:solidFill>
                   <a:srgbClr val="556A83"/>
                 </a:solidFill>
@@ -16285,23 +16417,23 @@
           <a:p>
             <a:pPr>
               <a:lnSpc>
-                <a:spcPct val="103000"/>
-              </a:lnSpc>
-              <a:spcAft>
-                <a:spcPts val="450"/>
-              </a:spcAft>
-            </a:pPr>
-            <a:r>
-              <a:rPr sz="840" b="1">
+                <a:spcPct val="100000"/>
+              </a:lnSpc>
+              <a:spcAft>
+                <a:spcPts val="150"/>
+              </a:spcAft>
+            </a:pPr>
+            <a:r>
+              <a:rPr sz="720" b="0">
                 <a:solidFill>
                   <a:srgbClr val="314359"/>
                 </a:solidFill>
                 <a:latin typeface="Arial"/>
               </a:rPr>
-              <a:t>2.6.2   </a:t>
-            </a:r>
-            <a:r>
-              <a:rPr sz="840">
+              <a:t>      6.2   </a:t>
+            </a:r>
+            <a:r>
+              <a:rPr sz="720">
                 <a:solidFill>
                   <a:srgbClr val="314359"/>
                 </a:solidFill>
@@ -16310,7 +16442,7 @@
               <a:t>Switching a private-equity sleeve into Athanase</a:t>
             </a:r>
             <a:r>
-              <a:rPr sz="680" i="1">
+              <a:rPr sz="560" i="1">
                 <a:solidFill>
                   <a:srgbClr val="556A83"/>
                 </a:solidFill>
@@ -16322,23 +16454,23 @@
           <a:p>
             <a:pPr>
               <a:lnSpc>
-                <a:spcPct val="103000"/>
-              </a:lnSpc>
-              <a:spcAft>
-                <a:spcPts val="450"/>
-              </a:spcAft>
-            </a:pPr>
-            <a:r>
-              <a:rPr sz="840" b="1">
+                <a:spcPct val="100000"/>
+              </a:lnSpc>
+              <a:spcAft>
+                <a:spcPts val="150"/>
+              </a:spcAft>
+            </a:pPr>
+            <a:r>
+              <a:rPr sz="720" b="0">
                 <a:solidFill>
                   <a:srgbClr val="314359"/>
                 </a:solidFill>
                 <a:latin typeface="Arial"/>
               </a:rPr>
-              <a:t>2.6.3   </a:t>
-            </a:r>
-            <a:r>
-              <a:rPr sz="840">
+              <a:t>      6.3   </a:t>
+            </a:r>
+            <a:r>
+              <a:rPr sz="720">
                 <a:solidFill>
                   <a:srgbClr val="314359"/>
                 </a:solidFill>
@@ -16347,7 +16479,7 @@
               <a:t>The volatility gap is settled in the literature</a:t>
             </a:r>
             <a:r>
-              <a:rPr sz="680" i="1">
+              <a:rPr sz="560" i="1">
                 <a:solidFill>
                   <a:srgbClr val="556A83"/>
                 </a:solidFill>
@@ -16359,23 +16491,23 @@
           <a:p>
             <a:pPr>
               <a:lnSpc>
-                <a:spcPct val="103000"/>
-              </a:lnSpc>
-              <a:spcAft>
-                <a:spcPts val="450"/>
-              </a:spcAft>
-            </a:pPr>
-            <a:r>
-              <a:rPr sz="840" b="1">
+                <a:spcPct val="100000"/>
+              </a:lnSpc>
+              <a:spcAft>
+                <a:spcPts val="150"/>
+              </a:spcAft>
+            </a:pPr>
+            <a:r>
+              <a:rPr sz="720" b="0">
                 <a:solidFill>
                   <a:srgbClr val="314359"/>
                 </a:solidFill>
                 <a:latin typeface="Arial"/>
               </a:rPr>
-              <a:t>2.6.4   </a:t>
-            </a:r>
-            <a:r>
-              <a:rPr sz="840">
+              <a:t>      6.4   </a:t>
+            </a:r>
+            <a:r>
+              <a:rPr sz="720">
                 <a:solidFill>
                   <a:srgbClr val="314359"/>
                 </a:solidFill>
@@ -16384,7 +16516,7 @@
               <a:t>Same headline volatility — far lower real risk</a:t>
             </a:r>
             <a:r>
-              <a:rPr sz="680" i="1">
+              <a:rPr sz="560" i="1">
                 <a:solidFill>
                   <a:srgbClr val="556A83"/>
                 </a:solidFill>
@@ -16396,23 +16528,23 @@
           <a:p>
             <a:pPr>
               <a:lnSpc>
-                <a:spcPct val="103000"/>
-              </a:lnSpc>
-              <a:spcAft>
-                <a:spcPts val="450"/>
-              </a:spcAft>
-            </a:pPr>
-            <a:r>
-              <a:rPr sz="840" b="1">
+                <a:spcPct val="100000"/>
+              </a:lnSpc>
+              <a:spcAft>
+                <a:spcPts val="150"/>
+              </a:spcAft>
+            </a:pPr>
+            <a:r>
+              <a:rPr sz="720" b="0">
                 <a:solidFill>
                   <a:srgbClr val="314359"/>
                 </a:solidFill>
                 <a:latin typeface="Arial"/>
               </a:rPr>
-              <a:t>2.6.5   </a:t>
-            </a:r>
-            <a:r>
-              <a:rPr sz="840">
+              <a:t>      6.5   </a:t>
+            </a:r>
+            <a:r>
+              <a:rPr sz="720">
                 <a:solidFill>
                   <a:srgbClr val="314359"/>
                 </a:solidFill>
@@ -16421,7 +16553,7 @@
               <a:t>PE’s “diversification” is an artefact — Athanase’s is real</a:t>
             </a:r>
             <a:r>
-              <a:rPr sz="680" i="1">
+              <a:rPr sz="560" i="1">
                 <a:solidFill>
                   <a:srgbClr val="556A83"/>
                 </a:solidFill>
@@ -16433,23 +16565,23 @@
           <a:p>
             <a:pPr>
               <a:lnSpc>
-                <a:spcPct val="103000"/>
-              </a:lnSpc>
-              <a:spcAft>
-                <a:spcPts val="450"/>
-              </a:spcAft>
-            </a:pPr>
-            <a:r>
-              <a:rPr sz="840" b="1">
+                <a:spcPct val="100000"/>
+              </a:lnSpc>
+              <a:spcAft>
+                <a:spcPts val="150"/>
+              </a:spcAft>
+            </a:pPr>
+            <a:r>
+              <a:rPr sz="720" b="0">
                 <a:solidFill>
                   <a:srgbClr val="314359"/>
                 </a:solidFill>
                 <a:latin typeface="Arial"/>
               </a:rPr>
-              <a:t>2.6.6   </a:t>
-            </a:r>
-            <a:r>
-              <a:rPr sz="840">
+              <a:t>      6.6   </a:t>
+            </a:r>
+            <a:r>
+              <a:rPr sz="720">
                 <a:solidFill>
                   <a:srgbClr val="314359"/>
                 </a:solidFill>
@@ -16461,23 +16593,23 @@
           <a:p>
             <a:pPr>
               <a:lnSpc>
-                <a:spcPct val="103000"/>
-              </a:lnSpc>
-              <a:spcAft>
-                <a:spcPts val="450"/>
-              </a:spcAft>
-            </a:pPr>
-            <a:r>
-              <a:rPr sz="840" b="1">
+                <a:spcPct val="100000"/>
+              </a:lnSpc>
+              <a:spcAft>
+                <a:spcPts val="150"/>
+              </a:spcAft>
+            </a:pPr>
+            <a:r>
+              <a:rPr sz="720" b="0">
                 <a:solidFill>
                   <a:srgbClr val="314359"/>
                 </a:solidFill>
                 <a:latin typeface="Arial"/>
               </a:rPr>
-              <a:t>2.6.7   </a:t>
-            </a:r>
-            <a:r>
-              <a:rPr sz="840">
+              <a:t>      6.7   </a:t>
+            </a:r>
+            <a:r>
+              <a:rPr sz="720">
                 <a:solidFill>
                   <a:srgbClr val="314359"/>
                 </a:solidFill>
@@ -16739,7 +16871,7 @@
                 </a:solidFill>
                 <a:latin typeface="Times New Roman"/>
               </a:rPr>
-              <a:t>2.2.1 The inefficiency Athanase harvests</a:t>
+              <a:t>2.1 The inefficiency Athanase harvests</a:t>
             </a:r>
           </a:p>
         </p:txBody>
@@ -17310,7 +17442,7 @@
                 </a:solidFill>
                 <a:latin typeface="Times New Roman"/>
               </a:rPr>
-              <a:t>2.2.2 We don’t buy broken companies — we buy hidden cores</a:t>
+              <a:t>2.2 We don’t buy broken companies — we buy hidden cores</a:t>
             </a:r>
           </a:p>
         </p:txBody>
@@ -18329,7 +18461,7 @@
                 </a:solidFill>
                 <a:latin typeface="Times New Roman"/>
               </a:rPr>
-              <a:t>2.2.3 Quality-core constructivism — how we differ</a:t>
+              <a:t>2.3 Quality-core constructivism — how we differ</a:t>
             </a:r>
           </a:p>
         </p:txBody>
@@ -20259,7 +20391,7 @@
                 </a:solidFill>
                 <a:latin typeface="Times New Roman"/>
               </a:rPr>
-              <a:t>2.2.4 We don’t need to be right more than ~50%</a:t>
+              <a:t>2.4 We don’t need to be right more than ~50%</a:t>
             </a:r>
           </a:p>
         </p:txBody>
@@ -21931,7 +22063,7 @@
                 </a:solidFill>
                 <a:latin typeface="Times New Roman"/>
               </a:rPr>
-              <a:t>2.2.5 The same playbook as mid-market PE — without its costs</a:t>
+              <a:t>2.5 The same playbook as mid-market PE — without its costs</a:t>
             </a:r>
           </a:p>
         </p:txBody>
@@ -24524,7 +24656,7 @@
                 </a:solidFill>
                 <a:latin typeface="Times New Roman"/>
               </a:rPr>
-              <a:t>2.3.1 A risk system built to avoid permanent loss</a:t>
+              <a:t>3.1 A risk system built to avoid permanent loss</a:t>
             </a:r>
           </a:p>
         </p:txBody>
@@ -25062,7 +25194,7 @@
                 </a:solidFill>
                 <a:latin typeface="Times New Roman"/>
               </a:rPr>
-              <a:t>2.3.2 The visible risks are the engine — not the cost</a:t>
+              <a:t>3.2 The visible risks are the engine — not the cost</a:t>
             </a:r>
           </a:p>
         </p:txBody>
@@ -25610,7 +25742,7 @@
                 </a:solidFill>
                 <a:latin typeface="Times New Roman"/>
               </a:rPr>
-              <a:t>2.3.3 A non-linear path — honestly priced</a:t>
+              <a:t>3.3 A non-linear path — honestly priced</a:t>
             </a:r>
           </a:p>
         </p:txBody>
@@ -26144,7 +26276,7 @@
                 </a:solidFill>
                 <a:latin typeface="Times New Roman"/>
               </a:rPr>
-              <a:t>2.3.4 Risk reframing for the investment committee</a:t>
+              <a:t>3.4 Risk reframing for the investment committee</a:t>
             </a:r>
           </a:p>
         </p:txBody>
@@ -28391,7 +28523,7 @@
                 </a:solidFill>
                 <a:latin typeface="Times New Roman"/>
               </a:rPr>
-              <a:t>2.4.1 Proof: outperformance with downside protection</a:t>
+              <a:t>4.1 Proof: outperformance with downside protection</a:t>
             </a:r>
           </a:p>
         </p:txBody>
@@ -28844,7 +28976,7 @@
                 </a:solidFill>
                 <a:latin typeface="Times New Roman"/>
               </a:rPr>
-              <a:t>2.4.2 AIP Fund II — transactions (2015–present)</a:t>
+              <a:t>4.2 AIP Fund II — transactions (2015–present)</a:t>
             </a:r>
           </a:p>
         </p:txBody>
@@ -37052,7 +37184,7 @@
                 </a:solidFill>
                 <a:latin typeface="Times New Roman"/>
               </a:rPr>
-              <a:t>2.4.3 Prior period — transactions (2006–2014)</a:t>
+              <a:t>4.3 Prior period — transactions (2006–2014)</a:t>
             </a:r>
           </a:p>
         </p:txBody>
@@ -43670,7 +43802,7 @@
                 </a:solidFill>
                 <a:latin typeface="Times New Roman"/>
               </a:rPr>
-              <a:t>2.4.4 Independently validated: 20 years, net of every fee</a:t>
+              <a:t>4.4 Independently validated: 20 years, net of every fee</a:t>
             </a:r>
           </a:p>
         </p:txBody>
@@ -44640,7 +44772,7 @@
                 </a:solidFill>
                 <a:latin typeface="Times New Roman"/>
               </a:rPr>
-              <a:t>2.4.5 Repeatable and conviction-sized — not lucky</a:t>
+              <a:t>4.5 Repeatable and conviction-sized — not lucky</a:t>
             </a:r>
           </a:p>
         </p:txBody>
@@ -45178,7 +45310,7 @@
                 </a:solidFill>
                 <a:latin typeface="Times New Roman"/>
               </a:rPr>
-              <a:t>2.4.6 Why a non-linear path won’t get you fired</a:t>
+              <a:t>4.6 Why a non-linear path won’t get you fired</a:t>
             </a:r>
           </a:p>
         </p:txBody>
@@ -46249,7 +46381,7 @@
                 </a:solidFill>
                 <a:latin typeface="Times New Roman"/>
               </a:rPr>
-              <a:t>2.5.1 What it does to an allocator’s portfolio</a:t>
+              <a:t>5.1 What it does to an allocator’s portfolio</a:t>
             </a:r>
           </a:p>
         </p:txBody>
@@ -48122,7 +48254,7 @@
                 </a:solidFill>
                 <a:latin typeface="Times New Roman"/>
               </a:rPr>
-              <a:t>2.5.2 Lower downside risk compounds into better outcomes</a:t>
+              <a:t>5.2 Lower downside risk compounds into better outcomes</a:t>
             </a:r>
           </a:p>
         </p:txBody>
@@ -52104,7 +52236,7 @@
                 </a:solidFill>
                 <a:latin typeface="Times New Roman"/>
               </a:rPr>
-              <a:t>1.1 A catalyst-driven source of return</a:t>
+              <a:t>1 A catalyst-driven source of return</a:t>
             </a:r>
           </a:p>
         </p:txBody>
@@ -52652,7 +52784,7 @@
                 </a:solidFill>
                 <a:latin typeface="Times New Roman"/>
               </a:rPr>
-              <a:t>2.5.3 A complement to global equities, not a duplicate</a:t>
+              <a:t>5.3 A complement to global equities, not a duplicate</a:t>
             </a:r>
           </a:p>
         </p:txBody>
@@ -53654,7 +53786,7 @@
                 </a:solidFill>
                 <a:latin typeface="Times New Roman"/>
               </a:rPr>
-              <a:t>2.5.4 What a blend does to the whole portfolio</a:t>
+              <a:t>5.4 What a blend does to the whole portfolio</a:t>
             </a:r>
           </a:p>
         </p:txBody>
@@ -55029,7 +55161,7 @@
                 </a:solidFill>
                 <a:latin typeface="Times New Roman"/>
               </a:rPr>
-              <a:t>2.6.1 What allocators actually earn from private equity</a:t>
+              <a:t>6.1 What allocators actually earn from private equity</a:t>
             </a:r>
           </a:p>
         </p:txBody>
@@ -55905,7 +56037,7 @@
                 </a:solidFill>
                 <a:latin typeface="Times New Roman"/>
               </a:rPr>
-              <a:t>2.6.2 Switching a private-equity sleeve into Athanase</a:t>
+              <a:t>6.2 Switching a private-equity sleeve into Athanase</a:t>
             </a:r>
           </a:p>
         </p:txBody>
@@ -57289,7 +57421,7 @@
                 </a:solidFill>
                 <a:latin typeface="Times New Roman"/>
               </a:rPr>
-              <a:t>2.6.3 The volatility gap is settled in the literature</a:t>
+              <a:t>6.3 The volatility gap is settled in the literature</a:t>
             </a:r>
           </a:p>
         </p:txBody>
@@ -58293,7 +58425,7 @@
                 </a:solidFill>
                 <a:latin typeface="Times New Roman"/>
               </a:rPr>
-              <a:t>2.6.4 Same headline volatility — far lower real risk</a:t>
+              <a:t>6.4 Same headline volatility — far lower real risk</a:t>
             </a:r>
           </a:p>
         </p:txBody>
@@ -59195,7 +59327,7 @@
                 </a:solidFill>
                 <a:latin typeface="Times New Roman"/>
               </a:rPr>
-              <a:t>2.6.5 PE’s “diversification” is an artefact — Athanase’s is real</a:t>
+              <a:t>6.5 PE’s “diversification” is an artefact — Athanase’s is real</a:t>
             </a:r>
           </a:p>
         </p:txBody>
@@ -60029,7 +60161,7 @@
                 </a:solidFill>
                 <a:latin typeface="Times New Roman"/>
               </a:rPr>
-              <a:t>2.6.6 When the tide goes out: the drawdown trap</a:t>
+              <a:t>6.6 When the tide goes out: the drawdown trap</a:t>
             </a:r>
           </a:p>
         </p:txBody>
@@ -61307,7 +61439,7 @@
                 </a:solidFill>
                 <a:latin typeface="Times New Roman"/>
               </a:rPr>
-              <a:t>2.6.7 Responsible ownership, by construction</a:t>
+              <a:t>6.7 Responsible ownership, by construction</a:t>
             </a:r>
           </a:p>
         </p:txBody>
@@ -61734,7 +61866,7 @@
                 </a:solidFill>
                 <a:latin typeface="Times New Roman"/>
               </a:rPr>
-              <a:t>1.2 Aligned with horizon and fiduciary duty</a:t>
+              <a:t>2 Aligned with horizon and fiduciary duty</a:t>
             </a:r>
           </a:p>
         </p:txBody>
@@ -64381,7 +64513,7 @@
                 </a:solidFill>
                 <a:latin typeface="Times New Roman"/>
               </a:rPr>
-              <a:t>1.3 Diversification and the total-portfolio view</a:t>
+              <a:t>3 Diversification and the total-portfolio view</a:t>
             </a:r>
           </a:p>
         </p:txBody>
@@ -64808,7 +64940,7 @@
                 </a:solidFill>
                 <a:latin typeface="Times New Roman"/>
               </a:rPr>
-              <a:t>1.4 Governance and the ESG synergy</a:t>
+              <a:t>4 Governance and the ESG synergy</a:t>
             </a:r>
           </a:p>
         </p:txBody>
@@ -65277,7 +65409,7 @@
                 </a:solidFill>
                 <a:latin typeface="Times New Roman"/>
               </a:rPr>
-              <a:t>1.5 Why mid-market is the sweet spot</a:t>
+              <a:t>5 Why mid-market is the sweet spot</a:t>
             </a:r>
           </a:p>
         </p:txBody>
@@ -67337,7 +67469,7 @@
                 </a:solidFill>
                 <a:latin typeface="Times New Roman"/>
               </a:rPr>
-              <a:t>1.6 Why mid-cap management listens</a:t>
+              <a:t>6 Why mid-cap management listens</a:t>
             </a:r>
           </a:p>
         </p:txBody>

</xml_diff>

<commit_message>
Fit Contents page: pull TOC columns up and tighten dense spacing
The Part II column ran to the page edge and clipped the last entry
(6.7 Responsible ownership). Start the columns ~0.12in higher and
reduce the dense-mode entry/sub-header spacing so all 38 lines fit with
a clear bottom margin; font size kept at 9pt for readability.
</commit_message>
<xml_diff>
--- a/Athanase_Engaged_Ownership_Allocator_Deck.pptx
+++ b/Athanase_Engaged_Ownership_Allocator_Deck.pptx
@@ -15212,7 +15212,7 @@
         </p:nvSpPr>
         <p:spPr>
           <a:xfrm>
-            <a:off x="512076" y="1901952"/>
+            <a:off x="512076" y="1784908"/>
             <a:ext cx="4279499" cy="390144"/>
           </a:xfrm>
           <a:prstGeom prst="rect">
@@ -15254,8 +15254,8 @@
         </p:nvSpPr>
         <p:spPr>
           <a:xfrm>
-            <a:off x="512076" y="2311603"/>
-            <a:ext cx="4279499" cy="5559552"/>
+            <a:off x="512076" y="2175052"/>
+            <a:ext cx="4279499" cy="5169408"/>
           </a:xfrm>
           <a:prstGeom prst="rect">
             <a:avLst/>
@@ -15510,7 +15510,7 @@
         </p:nvSpPr>
         <p:spPr>
           <a:xfrm>
-            <a:off x="5157345" y="1901952"/>
+            <a:off x="5157345" y="1784908"/>
             <a:ext cx="4279499" cy="390144"/>
           </a:xfrm>
           <a:prstGeom prst="rect">
@@ -15552,8 +15552,8 @@
         </p:nvSpPr>
         <p:spPr>
           <a:xfrm>
-            <a:off x="5157345" y="2311603"/>
-            <a:ext cx="4279499" cy="5559552"/>
+            <a:off x="5157345" y="2175052"/>
+            <a:ext cx="4279499" cy="5169408"/>
           </a:xfrm>
           <a:prstGeom prst="rect">
             <a:avLst/>
@@ -15574,7 +15574,7 @@
                 <a:spcPts val="0"/>
               </a:spcBef>
               <a:spcAft>
-                <a:spcPts val="150"/>
+                <a:spcPts val="100"/>
               </a:spcAft>
             </a:pPr>
             <a:r>
@@ -15593,7 +15593,7 @@
                 <a:spcPct val="100000"/>
               </a:lnSpc>
               <a:spcAft>
-                <a:spcPts val="150"/>
+                <a:spcPts val="80"/>
               </a:spcAft>
             </a:pPr>
             <a:r>
@@ -15621,7 +15621,7 @@
                 <a:spcPct val="100000"/>
               </a:lnSpc>
               <a:spcAft>
-                <a:spcPts val="150"/>
+                <a:spcPts val="80"/>
               </a:spcAft>
             </a:pPr>
             <a:r>
@@ -15649,7 +15649,7 @@
                 <a:spcPct val="100000"/>
               </a:lnSpc>
               <a:spcAft>
-                <a:spcPts val="150"/>
+                <a:spcPts val="80"/>
               </a:spcAft>
             </a:pPr>
             <a:r>
@@ -15677,7 +15677,7 @@
                 <a:spcPct val="100000"/>
               </a:lnSpc>
               <a:spcAft>
-                <a:spcPts val="150"/>
+                <a:spcPts val="80"/>
               </a:spcAft>
             </a:pPr>
             <a:r>
@@ -15714,7 +15714,7 @@
                 <a:spcPct val="100000"/>
               </a:lnSpc>
               <a:spcAft>
-                <a:spcPts val="150"/>
+                <a:spcPts val="80"/>
               </a:spcAft>
             </a:pPr>
             <a:r>
@@ -15751,7 +15751,7 @@
                 <a:spcPct val="100000"/>
               </a:lnSpc>
               <a:spcAft>
-                <a:spcPts val="150"/>
+                <a:spcPts val="80"/>
               </a:spcAft>
             </a:pPr>
             <a:r>
@@ -15779,10 +15779,10 @@
                 <a:spcPct val="100000"/>
               </a:lnSpc>
               <a:spcBef>
-                <a:spcPts val="300"/>
+                <a:spcPts val="200"/>
               </a:spcBef>
               <a:spcAft>
-                <a:spcPts val="150"/>
+                <a:spcPts val="100"/>
               </a:spcAft>
             </a:pPr>
             <a:r>
@@ -15801,7 +15801,7 @@
                 <a:spcPct val="100000"/>
               </a:lnSpc>
               <a:spcAft>
-                <a:spcPts val="150"/>
+                <a:spcPts val="80"/>
               </a:spcAft>
             </a:pPr>
             <a:r>
@@ -15838,7 +15838,7 @@
                 <a:spcPct val="100000"/>
               </a:lnSpc>
               <a:spcAft>
-                <a:spcPts val="150"/>
+                <a:spcPts val="80"/>
               </a:spcAft>
             </a:pPr>
             <a:r>
@@ -15875,7 +15875,7 @@
                 <a:spcPct val="100000"/>
               </a:lnSpc>
               <a:spcAft>
-                <a:spcPts val="150"/>
+                <a:spcPts val="80"/>
               </a:spcAft>
             </a:pPr>
             <a:r>
@@ -15912,7 +15912,7 @@
                 <a:spcPct val="100000"/>
               </a:lnSpc>
               <a:spcAft>
-                <a:spcPts val="150"/>
+                <a:spcPts val="80"/>
               </a:spcAft>
             </a:pPr>
             <a:r>
@@ -15949,7 +15949,7 @@
                 <a:spcPct val="100000"/>
               </a:lnSpc>
               <a:spcAft>
-                <a:spcPts val="150"/>
+                <a:spcPts val="80"/>
               </a:spcAft>
             </a:pPr>
             <a:r>
@@ -15986,10 +15986,10 @@
                 <a:spcPct val="100000"/>
               </a:lnSpc>
               <a:spcBef>
-                <a:spcPts val="300"/>
+                <a:spcPts val="200"/>
               </a:spcBef>
               <a:spcAft>
-                <a:spcPts val="150"/>
+                <a:spcPts val="100"/>
               </a:spcAft>
             </a:pPr>
             <a:r>
@@ -16008,7 +16008,7 @@
                 <a:spcPct val="100000"/>
               </a:lnSpc>
               <a:spcAft>
-                <a:spcPts val="150"/>
+                <a:spcPts val="80"/>
               </a:spcAft>
             </a:pPr>
             <a:r>
@@ -16036,7 +16036,7 @@
                 <a:spcPct val="100000"/>
               </a:lnSpc>
               <a:spcAft>
-                <a:spcPts val="150"/>
+                <a:spcPts val="80"/>
               </a:spcAft>
             </a:pPr>
             <a:r>
@@ -16064,7 +16064,7 @@
                 <a:spcPct val="100000"/>
               </a:lnSpc>
               <a:spcAft>
-                <a:spcPts val="150"/>
+                <a:spcPts val="80"/>
               </a:spcAft>
             </a:pPr>
             <a:r>
@@ -16101,7 +16101,7 @@
                 <a:spcPct val="100000"/>
               </a:lnSpc>
               <a:spcAft>
-                <a:spcPts val="150"/>
+                <a:spcPts val="80"/>
               </a:spcAft>
             </a:pPr>
             <a:r>
@@ -16138,10 +16138,10 @@
                 <a:spcPct val="100000"/>
               </a:lnSpc>
               <a:spcBef>
-                <a:spcPts val="300"/>
+                <a:spcPts val="200"/>
               </a:spcBef>
               <a:spcAft>
-                <a:spcPts val="150"/>
+                <a:spcPts val="100"/>
               </a:spcAft>
             </a:pPr>
             <a:r>
@@ -16160,7 +16160,7 @@
                 <a:spcPct val="100000"/>
               </a:lnSpc>
               <a:spcAft>
-                <a:spcPts val="150"/>
+                <a:spcPts val="80"/>
               </a:spcAft>
             </a:pPr>
             <a:r>
@@ -16197,7 +16197,7 @@
                 <a:spcPct val="100000"/>
               </a:lnSpc>
               <a:spcAft>
-                <a:spcPts val="150"/>
+                <a:spcPts val="80"/>
               </a:spcAft>
             </a:pPr>
             <a:r>
@@ -16234,7 +16234,7 @@
                 <a:spcPct val="100000"/>
               </a:lnSpc>
               <a:spcAft>
-                <a:spcPts val="150"/>
+                <a:spcPts val="80"/>
               </a:spcAft>
             </a:pPr>
             <a:r>
@@ -16271,7 +16271,7 @@
                 <a:spcPct val="100000"/>
               </a:lnSpc>
               <a:spcAft>
-                <a:spcPts val="150"/>
+                <a:spcPts val="80"/>
               </a:spcAft>
             </a:pPr>
             <a:r>
@@ -16299,7 +16299,7 @@
                 <a:spcPct val="100000"/>
               </a:lnSpc>
               <a:spcAft>
-                <a:spcPts val="150"/>
+                <a:spcPts val="80"/>
               </a:spcAft>
             </a:pPr>
             <a:r>
@@ -16327,7 +16327,7 @@
                 <a:spcPct val="100000"/>
               </a:lnSpc>
               <a:spcAft>
-                <a:spcPts val="150"/>
+                <a:spcPts val="80"/>
               </a:spcAft>
             </a:pPr>
             <a:r>
@@ -16355,10 +16355,10 @@
                 <a:spcPct val="100000"/>
               </a:lnSpc>
               <a:spcBef>
-                <a:spcPts val="300"/>
+                <a:spcPts val="200"/>
               </a:spcBef>
               <a:spcAft>
-                <a:spcPts val="150"/>
+                <a:spcPts val="100"/>
               </a:spcAft>
             </a:pPr>
             <a:r>
@@ -16377,7 +16377,7 @@
                 <a:spcPct val="100000"/>
               </a:lnSpc>
               <a:spcAft>
-                <a:spcPts val="150"/>
+                <a:spcPts val="80"/>
               </a:spcAft>
             </a:pPr>
             <a:r>
@@ -16414,7 +16414,7 @@
                 <a:spcPct val="100000"/>
               </a:lnSpc>
               <a:spcAft>
-                <a:spcPts val="150"/>
+                <a:spcPts val="80"/>
               </a:spcAft>
             </a:pPr>
             <a:r>
@@ -16451,7 +16451,7 @@
                 <a:spcPct val="100000"/>
               </a:lnSpc>
               <a:spcAft>
-                <a:spcPts val="150"/>
+                <a:spcPts val="80"/>
               </a:spcAft>
             </a:pPr>
             <a:r>
@@ -16488,7 +16488,7 @@
                 <a:spcPct val="100000"/>
               </a:lnSpc>
               <a:spcAft>
-                <a:spcPts val="150"/>
+                <a:spcPts val="80"/>
               </a:spcAft>
             </a:pPr>
             <a:r>
@@ -16525,10 +16525,10 @@
                 <a:spcPct val="100000"/>
               </a:lnSpc>
               <a:spcBef>
-                <a:spcPts val="300"/>
+                <a:spcPts val="200"/>
               </a:spcBef>
               <a:spcAft>
-                <a:spcPts val="150"/>
+                <a:spcPts val="100"/>
               </a:spcAft>
             </a:pPr>
             <a:r>
@@ -16547,7 +16547,7 @@
                 <a:spcPct val="100000"/>
               </a:lnSpc>
               <a:spcAft>
-                <a:spcPts val="150"/>
+                <a:spcPts val="80"/>
               </a:spcAft>
             </a:pPr>
             <a:r>
@@ -16584,7 +16584,7 @@
                 <a:spcPct val="100000"/>
               </a:lnSpc>
               <a:spcAft>
-                <a:spcPts val="150"/>
+                <a:spcPts val="80"/>
               </a:spcAft>
             </a:pPr>
             <a:r>
@@ -16621,7 +16621,7 @@
                 <a:spcPct val="100000"/>
               </a:lnSpc>
               <a:spcAft>
-                <a:spcPts val="150"/>
+                <a:spcPts val="80"/>
               </a:spcAft>
             </a:pPr>
             <a:r>
@@ -16658,7 +16658,7 @@
                 <a:spcPct val="100000"/>
               </a:lnSpc>
               <a:spcAft>
-                <a:spcPts val="150"/>
+                <a:spcPts val="80"/>
               </a:spcAft>
             </a:pPr>
             <a:r>
@@ -16695,7 +16695,7 @@
                 <a:spcPct val="100000"/>
               </a:lnSpc>
               <a:spcAft>
-                <a:spcPts val="150"/>
+                <a:spcPts val="80"/>
               </a:spcAft>
             </a:pPr>
             <a:r>
@@ -16732,7 +16732,7 @@
                 <a:spcPct val="100000"/>
               </a:lnSpc>
               <a:spcAft>
-                <a:spcPts val="150"/>
+                <a:spcPts val="80"/>
               </a:spcAft>
             </a:pPr>
             <a:r>
@@ -16760,7 +16760,7 @@
                 <a:spcPct val="100000"/>
               </a:lnSpc>
               <a:spcAft>
-                <a:spcPts val="150"/>
+                <a:spcPts val="80"/>
               </a:spcAft>
             </a:pPr>
             <a:r>

</xml_diff>